<commit_message>
Proposal and slides: published baselines measured on the same problems, with token costs
Section 7 (both languages) is a table: compute-optimal allocation by difficulty, always-high effort,
AlphaCode filter + cascade, Self-Debugging, CodeT / MBR-exec / majority vote / DeepConf, whole manual /
BM25 / DRoC, scope sentence / System 2 Attention, Dynamic Cheatsheet, Mixture-of-Thought cascade,
each against the recipe; new slide "Compared with published methods".

Co-Authored-By: Claude Opus 5.5 (1M context) <noreply@anthropic.com>
</commit_message>
<xml_diff>
--- a/PROPOSAL_slides.pptx
+++ b/PROPOSAL_slides.pptx
@@ -16,9 +16,10 @@
     <p:sldId id="264" r:id="rId10"/>
     <p:sldId id="265" r:id="rId11"/>
     <p:sldId id="266" r:id="rId12"/>
+    <p:sldId id="267" r:id="rId13"/>
   </p:sldIdLst>
   <p:notesMasterIdLst>
-    <p:notesMasterId r:id="rId13"/>
+    <p:notesMasterId r:id="rId14"/>
   </p:notesMasterIdLst>
   <p:sldSz cx="12192000" cy="6858000"/>
   <p:notesSz cx="6858000" cy="12192000"/>
@@ -117,7 +118,7 @@
   <p:extLst>
     <p:ext uri="{521415D9-36F7-43E2-AB2F-B90AF26B5E84}">
       <p14:sectionLst xmlns:p14="http://schemas.microsoft.com/office/powerpoint/2010/main">
-        <p14:section name="Problem" id="{b61c6c17-0363-0e3a-b8d6-5a6ecc99e6b5}">
+        <p14:section name="Problem" id="{b0ab158f-c131-2fb5-c383-8ee321e3c8d5}">
           <p14:sldIdLst>
             <p14:sldId id="256"/>
             <p14:sldId id="257"/>
@@ -125,7 +126,7 @@
             <p14:sldId id="259"/>
           </p14:sldIdLst>
         </p14:section>
-        <p14:section name="Recipe" id="{4210d64a-ac13-082c-fe9b-bf6e9030cfd5}">
+        <p14:section name="Recipe" id="{fe4e6d39-0737-afb3-2b93-d63e5c8cc178}">
           <p14:sldIdLst>
             <p14:sldId id="260"/>
             <p14:sldId id="261"/>
@@ -134,14 +135,15 @@
             <p14:sldId id="264"/>
           </p14:sldIdLst>
         </p14:section>
-        <p14:section name="Together" id="{3abf8020-5ecb-8e65-a42c-fce518509847}">
+        <p14:section name="Together" id="{62592785-e5cf-e356-0498-10aee6573684}">
           <p14:sldIdLst>
             <p14:sldId id="265"/>
+            <p14:sldId id="266"/>
           </p14:sldIdLst>
         </p14:section>
-        <p14:section name="Next" id="{7dd31ab7-d060-5386-cc00-1efbd75a3d24}">
+        <p14:section name="Next" id="{2f583e52-98ad-b156-02c8-e1bef2eb75df}">
           <p14:sldIdLst>
-            <p14:sldId id="266"/>
+            <p14:sldId id="267"/>
           </p14:sldIdLst>
         </p14:section>
       </p14:sectionLst>
@@ -1090,7 +1092,7 @@
           <a:p>
             <a:r>
               <a:rPr lang="en-US" dirty="0"/>
-              <a:t>Limits: for Lean proofs an invented lemma stands for a missing proof step (similar-name feedback fixes 2.7%, a fresh try 3.2%); for PopQA thinking adds 1.8-5 points at 70-200 times the tokens, only for well-known facts. Checks leak, which caps every policy. Facts were hand-written; BM25 retrieval recovers most of the gain. Next: SIZE-CC (gpt-oss-20b on contest geometry with check-gated escalation), X1-SIZE (competition math for Qwen3-4B/8B/14B), automatic facts, a closed API model, final report.</a:t>
+              <a:t>All baselines were run by us on our benchmarks. Models: U1 policies over Qwen3-8B / Qwen3-32B / Qwen3.6 (624 problems); contest geometry gpt-oss-120b (311); selection Qwen3-8B (300 geometry instances, 3 candidates); documentation Qwen3-32B on CVRP; tools Qwen3-32B on 5 geometry tasks; daily routing gpt-oss-120b on 48 held-out Solomon instances. Tokens are output tokens per problem. More rows (MBR-exec, majority vote, DeepConf, Self-Debugging, Mixture-of-Thought cascade, BM25 retrieval) are in PROPOSAL.md section 7.</a:t>
             </a:r>
             <a:endParaRPr lang="en-US" dirty="0"/>
           </a:p>
@@ -1114,6 +1116,94 @@
             <a:fld id="{F7021451-1387-4CA6-816F-3879F97B5CBC}" type="slidenum">
               <a:rPr lang="en-US"/>
               <a:t>11</a:t>
+            </a:fld>
+            <a:endParaRPr lang="en-US"/>
+          </a:p>
+        </p:txBody>
+      </p:sp>
+    </p:spTree>
+    <p:extLst>
+      <p:ext uri="{BB962C8B-B14F-4D97-AF65-F5344CB8AC3E}">
+        <p14:creationId xmlns:p14="http://schemas.microsoft.com/office/powerpoint/2010/main" val="1024086991"/>
+      </p:ext>
+    </p:extLst>
+  </p:cSld>
+  <p:clrMapOvr>
+    <a:masterClrMapping/>
+  </p:clrMapOvr>
+</p:notes>
+</file>
+
+<file path=ppt/notesSlides/notesSlide12.xml><?xml version="1.0" encoding="utf-8"?>
+<p:notes xmlns:a="http://schemas.openxmlformats.org/drawingml/2006/main" xmlns:r="http://schemas.openxmlformats.org/officeDocument/2006/relationships" xmlns:p="http://schemas.openxmlformats.org/presentationml/2006/main">
+  <p:cSld>
+    <p:spTree>
+      <p:nvGrpSpPr>
+        <p:cNvPr id="1" name=""/>
+        <p:cNvGrpSpPr/>
+        <p:nvPr/>
+      </p:nvGrpSpPr>
+      <p:grpSpPr>
+        <a:xfrm>
+          <a:off x="0" y="0"/>
+          <a:ext cx="0" cy="0"/>
+          <a:chOff x="0" y="0"/>
+          <a:chExt cx="0" cy="0"/>
+        </a:xfrm>
+      </p:grpSpPr>
+      <p:sp>
+        <p:nvSpPr>
+          <p:cNvPr id="2" name="Slide Image Placeholder 1"/>
+          <p:cNvSpPr>
+            <a:spLocks noGrp="1" noRot="1" noChangeAspect="1"/>
+          </p:cNvSpPr>
+          <p:nvPr>
+            <p:ph type="sldImg"/>
+          </p:nvPr>
+        </p:nvSpPr>
+        <p:spPr/>
+      </p:sp>
+      <p:sp>
+        <p:nvSpPr>
+          <p:cNvPr id="3" name="Notes Placeholder 2"/>
+          <p:cNvSpPr>
+            <a:spLocks noGrp="1"/>
+          </p:cNvSpPr>
+          <p:nvPr>
+            <p:ph type="body" idx="1"/>
+          </p:nvPr>
+        </p:nvSpPr>
+        <p:spPr/>
+        <p:txBody>
+          <a:bodyPr/>
+          <a:lstStyle/>
+          <a:p>
+            <a:r>
+              <a:rPr lang="en-US" dirty="0"/>
+              <a:t>Limits: for Lean proofs an invented lemma stands for a missing proof step (similar-name feedback fixes 2.7%, a fresh try 3.2%); for PopQA thinking adds 1.8-5 points at 70-200 times the tokens, only for well-known facts. Checks leak, which caps every policy. Facts were hand-written; BM25 retrieval recovers most of the gain. Next: SIZE-CC (gpt-oss-20b on contest geometry with check-gated escalation), X1-SIZE (competition math for Qwen3-4B/8B/14B), automatic facts, a closed API model, final report.</a:t>
+            </a:r>
+            <a:endParaRPr lang="en-US" dirty="0"/>
+          </a:p>
+        </p:txBody>
+      </p:sp>
+      <p:sp>
+        <p:nvSpPr>
+          <p:cNvPr id="4" name="Slide Number Placeholder 3"/>
+          <p:cNvSpPr>
+            <a:spLocks noGrp="1"/>
+          </p:cNvSpPr>
+          <p:nvPr>
+            <p:ph type="sldNum" sz="quarter" idx="10"/>
+          </p:nvPr>
+        </p:nvSpPr>
+        <p:spPr/>
+        <p:txBody>
+          <a:bodyPr/>
+          <a:lstStyle/>
+          <a:p>
+            <a:fld id="{F7021451-1387-4CA6-816F-3879F97B5CBC}" type="slidenum">
+              <a:rPr lang="en-US"/>
+              <a:t>12</a:t>
             </a:fld>
             <a:endParaRPr lang="en-US"/>
           </a:p>
@@ -3512,293 +3602,1697 @@
                   <a:schemeClr val="tx1"/>
                 </a:solidFill>
               </a:rPr>
-              <a:t>Where the recipe stops, and what is next</a:t>
+              <a:t>Compared with published methods</a:t>
             </a:r>
             <a:endParaRPr lang="en-US" sz="3600" dirty="0"/>
           </a:p>
         </p:txBody>
       </p:sp>
-      <p:sp>
-        <p:nvSpPr>
-          <p:cNvPr id="3" name="Where it stops"/>
-          <p:cNvSpPr/>
-          <p:nvPr/>
-        </p:nvSpPr>
-        <p:spPr>
-          <a:xfrm>
-            <a:off x="548640" y="1417320"/>
-            <a:ext cx="5440680" cy="3749040"/>
-          </a:xfrm>
-          <a:prstGeom prst="roundRect">
-            <a:avLst>
-              <a:gd name="adj" fmla="val 1951"/>
-            </a:avLst>
-          </a:prstGeom>
-          <a:solidFill>
-            <a:srgbClr val="F2F2F2"/>
-          </a:solidFill>
-          <a:ln w="9525">
-            <a:solidFill>
-              <a:srgbClr val="D9D9D9"/>
-            </a:solidFill>
-            <a:prstDash val="solid"/>
-          </a:ln>
-        </p:spPr>
-      </p:sp>
-      <p:sp>
-        <p:nvSpPr>
-          <p:cNvPr id="4" name="Text 2"/>
-          <p:cNvSpPr txBox="1"/>
-          <p:nvPr/>
-        </p:nvSpPr>
-        <p:spPr>
-          <a:xfrm>
-            <a:off x="822960" y="1554480"/>
-            <a:ext cx="4892040" cy="548640"/>
-          </a:xfrm>
-          <a:prstGeom prst="rect">
-            <a:avLst/>
-          </a:prstGeom>
-          <a:noFill/>
-          <a:ln/>
-        </p:spPr>
-        <p:txBody>
-          <a:bodyPr wrap="square" lIns="0" tIns="0" rIns="0" bIns="0" rtlCol="0" anchor="ctr"/>
-          <a:lstStyle/>
-          <a:p>
-            <a:pPr indent="0" marL="0">
-              <a:buNone/>
-            </a:pPr>
-            <a:r>
-              <a:rPr lang="en-US" sz="2600" b="1" dirty="0">
-                <a:solidFill>
-                  <a:srgbClr val="C00000"/>
-                </a:solidFill>
-              </a:rPr>
-              <a:t>Where it stops</a:t>
-            </a:r>
-            <a:endParaRPr lang="en-US" sz="2600" dirty="0"/>
-          </a:p>
-        </p:txBody>
-      </p:sp>
-      <p:sp>
-        <p:nvSpPr>
-          <p:cNvPr id="5" name="Text 3"/>
-          <p:cNvSpPr txBox="1"/>
-          <p:nvPr/>
-        </p:nvSpPr>
-        <p:spPr>
-          <a:xfrm>
-            <a:off x="822960" y="2194560"/>
-            <a:ext cx="4892040" cy="2834640"/>
-          </a:xfrm>
-          <a:prstGeom prst="rect">
-            <a:avLst/>
-          </a:prstGeom>
-          <a:noFill/>
-          <a:ln/>
-        </p:spPr>
-        <p:txBody>
-          <a:bodyPr wrap="square" lIns="635" tIns="635" rIns="635" bIns="635" rtlCol="0" anchor="t"/>
-          <a:lstStyle/>
-          <a:p>
-            <a:pPr marL="342900" indent="-342900">
-              <a:spcAft>
-                <a:spcPts val="800"/>
-              </a:spcAft>
-              <a:buSzPct val="100000"/>
-              <a:buChar char="•"/>
-            </a:pPr>
-            <a:r>
-              <a:rPr lang="en-US" sz="1700" dirty="0">
-                <a:solidFill>
-                  <a:schemeClr val="tx1"/>
-                </a:solidFill>
-              </a:rPr>
-              <a:t>Missing knowledge that is not a library fact: Lean proofs, factual questions. Thinking cannot add it (+2–5 points at 70–200× tokens)</a:t>
-            </a:r>
-            <a:endParaRPr lang="en-US" sz="1700" dirty="0"/>
-          </a:p>
-          <a:p>
-            <a:pPr marL="342900" indent="-342900">
-              <a:spcAft>
-                <a:spcPts val="800"/>
-              </a:spcAft>
-              <a:buSzPct val="100000"/>
-              <a:buChar char="•"/>
-            </a:pPr>
-            <a:r>
-              <a:rPr lang="en-US" sz="1700" dirty="0">
-                <a:solidFill>
-                  <a:schemeClr val="tx1"/>
-                </a:solidFill>
-              </a:rPr>
-              <a:t>Checks leak: 24–37% of wrong contest programs pass the examples</a:t>
-            </a:r>
-            <a:endParaRPr lang="en-US" sz="1700" dirty="0"/>
-          </a:p>
-          <a:p>
-            <a:pPr marL="342900" indent="-342900">
-              <a:spcAft>
-                <a:spcPts val="800"/>
-              </a:spcAft>
-              <a:buSzPct val="100000"/>
-              <a:buChar char="•"/>
-            </a:pPr>
-            <a:r>
-              <a:rPr lang="en-US" sz="1700" dirty="0">
-                <a:solidFill>
-                  <a:schemeClr val="tx1"/>
-                </a:solidFill>
-              </a:rPr>
-              <a:t>Facts were hand-written; automatic retrieval keeps most of the gain (84% vs 87%)</a:t>
-            </a:r>
-            <a:endParaRPr lang="en-US" sz="1700" dirty="0"/>
-          </a:p>
-        </p:txBody>
-      </p:sp>
-      <p:sp>
-        <p:nvSpPr>
-          <p:cNvPr id="6" name="Next"/>
-          <p:cNvSpPr/>
-          <p:nvPr/>
-        </p:nvSpPr>
-        <p:spPr>
-          <a:xfrm>
-            <a:off x="6172200" y="1417320"/>
-            <a:ext cx="5440680" cy="3749040"/>
-          </a:xfrm>
-          <a:prstGeom prst="roundRect">
-            <a:avLst>
-              <a:gd name="adj" fmla="val 1951"/>
-            </a:avLst>
-          </a:prstGeom>
-          <a:solidFill>
-            <a:srgbClr val="F2F2F2"/>
-          </a:solidFill>
-          <a:ln w="9525">
-            <a:solidFill>
-              <a:srgbClr val="D9D9D9"/>
-            </a:solidFill>
-            <a:prstDash val="solid"/>
-          </a:ln>
-        </p:spPr>
-      </p:sp>
-      <p:sp>
-        <p:nvSpPr>
-          <p:cNvPr id="7" name="Text 5"/>
-          <p:cNvSpPr txBox="1"/>
-          <p:nvPr/>
-        </p:nvSpPr>
-        <p:spPr>
-          <a:xfrm>
-            <a:off x="6446520" y="1554480"/>
-            <a:ext cx="4892040" cy="548640"/>
-          </a:xfrm>
-          <a:prstGeom prst="rect">
-            <a:avLst/>
-          </a:prstGeom>
-          <a:noFill/>
-          <a:ln/>
-        </p:spPr>
-        <p:txBody>
-          <a:bodyPr wrap="square" lIns="0" tIns="0" rIns="0" bIns="0" rtlCol="0" anchor="ctr"/>
-          <a:lstStyle/>
-          <a:p>
-            <a:pPr indent="0" marL="0">
-              <a:buNone/>
-            </a:pPr>
-            <a:r>
-              <a:rPr lang="en-US" sz="2600" b="1" dirty="0">
-                <a:solidFill>
-                  <a:srgbClr val="4472C4"/>
-                </a:solidFill>
-              </a:rPr>
-              <a:t>Next</a:t>
-            </a:r>
-            <a:endParaRPr lang="en-US" sz="2600" dirty="0"/>
-          </a:p>
-        </p:txBody>
-      </p:sp>
-      <p:sp>
-        <p:nvSpPr>
-          <p:cNvPr id="8" name="Text 6"/>
-          <p:cNvSpPr txBox="1"/>
-          <p:nvPr/>
-        </p:nvSpPr>
-        <p:spPr>
-          <a:xfrm>
-            <a:off x="6446520" y="2194560"/>
-            <a:ext cx="4892040" cy="2834640"/>
-          </a:xfrm>
-          <a:prstGeom prst="rect">
-            <a:avLst/>
-          </a:prstGeom>
-          <a:noFill/>
-          <a:ln/>
-        </p:spPr>
-        <p:txBody>
-          <a:bodyPr wrap="square" lIns="635" tIns="635" rIns="635" bIns="635" rtlCol="0" anchor="t"/>
-          <a:lstStyle/>
-          <a:p>
-            <a:pPr marL="342900" indent="-342900">
-              <a:spcAft>
-                <a:spcPts val="800"/>
-              </a:spcAft>
-              <a:buSzPct val="100000"/>
-              <a:buChar char="•"/>
-            </a:pPr>
-            <a:r>
-              <a:rPr lang="en-US" sz="1700" dirty="0">
-                <a:solidFill>
-                  <a:schemeClr val="tx1"/>
-                </a:solidFill>
-              </a:rPr>
-              <a:t>Contest geometry on one 24 GB GPU (gpt-oss-20b, running)</a:t>
-            </a:r>
-            <a:endParaRPr lang="en-US" sz="1700" dirty="0"/>
-          </a:p>
-          <a:p>
-            <a:pPr marL="342900" indent="-342900">
-              <a:spcAft>
-                <a:spcPts val="800"/>
-              </a:spcAft>
-              <a:buSzPct val="100000"/>
-              <a:buChar char="•"/>
-            </a:pPr>
-            <a:r>
-              <a:rPr lang="en-US" sz="1700" dirty="0">
-                <a:solidFill>
-                  <a:schemeClr val="tx1"/>
-                </a:solidFill>
-              </a:rPr>
-              <a:t>Competition math for small models (running)</a:t>
-            </a:r>
-            <a:endParaRPr lang="en-US" sz="1700" dirty="0"/>
-          </a:p>
-          <a:p>
-            <a:pPr marL="342900" indent="-342900">
-              <a:spcAft>
-                <a:spcPts val="800"/>
-              </a:spcAft>
-              <a:buSzPct val="100000"/>
-              <a:buChar char="•"/>
-            </a:pPr>
-            <a:r>
-              <a:rPr lang="en-US" sz="1700" dirty="0">
-                <a:solidFill>
-                  <a:schemeClr val="tx1"/>
-                </a:solidFill>
-              </a:rPr>
-              <a:t>Facts found automatically; a commercial model; final report</a:t>
-            </a:r>
-            <a:endParaRPr lang="en-US" sz="1700" dirty="0"/>
-          </a:p>
-        </p:txBody>
-      </p:sp>
-      <p:sp>
-        <p:nvSpPr>
-          <p:cNvPr id="9" name="Text 7"/>
+      <p:graphicFrame>
+        <p:nvGraphicFramePr>
+          <p:cNvPr id="12" name="Table 0"/>
+          <p:cNvGraphicFramePr>
+            <a:graphicFrameLocks noGrp="1"/>
+          </p:cNvGraphicFramePr>
+          <p:nvPr>
+            <p:extLst>
+              <p:ext uri="{D42A27DB-BD31-4B8C-83A1-F6EECF244321}">
+                <p14:modId xmlns:p14="http://schemas.microsoft.com/office/powerpoint/2010/main" val="1579011935"/>
+              </p:ext>
+            </p:extLst>
+          </p:nvPr>
+        </p:nvGraphicFramePr>
+        <p:xfrm>
+          <a:off x="548640" y="1325880"/>
+          <a:ext cx="11064240" cy="914400"/>
+        </p:xfrm>
+        <a:graphic>
+          <a:graphicData uri="http://schemas.openxmlformats.org/drawingml/2006/table">
+            <a:tbl>
+              <a:tblPr/>
+              <a:tblGrid>
+                <a:gridCol w="2103120"/>
+                <a:gridCol w="3566160"/>
+                <a:gridCol w="2011680"/>
+                <a:gridCol w="3383280"/>
+              </a:tblGrid>
+              <a:tr h="566928">
+                <a:tc>
+                  <a:txBody>
+                    <a:bodyPr/>
+                    <a:lstStyle/>
+                    <a:p>
+                      <a:pPr indent="0" marL="0">
+                        <a:buNone/>
+                      </a:pPr>
+                      <a:r>
+                        <a:rPr lang="en-US" sz="1500" b="1" dirty="0">
+                          <a:solidFill>
+                            <a:srgbClr val="FFFFFF"/>
+                          </a:solidFill>
+                        </a:rPr>
+                        <a:t>Task</a:t>
+                      </a:r>
+                      <a:endParaRPr lang="en-US" sz="1500" dirty="0"/>
+                    </a:p>
+                  </a:txBody>
+                  <a:tcPr marL="54864" marR="54864" marT="54864" marB="54864" anchor="ctr">
+                    <a:lnL w="9525" cap="flat" cmpd="sng" algn="ctr">
+                      <a:solidFill>
+                        <a:srgbClr val="BFBFBF"/>
+                      </a:solidFill>
+                      <a:prstDash val="solid"/>
+                      <a:round/>
+                      <a:headEnd type="none" w="med" len="med"/>
+                      <a:tailEnd type="none" w="med" len="med"/>
+                    </a:lnL>
+                    <a:lnR w="9525" cap="flat" cmpd="sng" algn="ctr">
+                      <a:solidFill>
+                        <a:srgbClr val="BFBFBF"/>
+                      </a:solidFill>
+                      <a:prstDash val="solid"/>
+                      <a:round/>
+                      <a:headEnd type="none" w="med" len="med"/>
+                      <a:tailEnd type="none" w="med" len="med"/>
+                    </a:lnR>
+                    <a:lnT w="9525" cap="flat" cmpd="sng" algn="ctr">
+                      <a:solidFill>
+                        <a:srgbClr val="BFBFBF"/>
+                      </a:solidFill>
+                      <a:prstDash val="solid"/>
+                      <a:round/>
+                      <a:headEnd type="none" w="med" len="med"/>
+                      <a:tailEnd type="none" w="med" len="med"/>
+                    </a:lnT>
+                    <a:lnB w="9525" cap="flat" cmpd="sng" algn="ctr">
+                      <a:solidFill>
+                        <a:srgbClr val="BFBFBF"/>
+                      </a:solidFill>
+                      <a:prstDash val="solid"/>
+                      <a:round/>
+                      <a:headEnd type="none" w="med" len="med"/>
+                      <a:tailEnd type="none" w="med" len="med"/>
+                    </a:lnB>
+                    <a:solidFill>
+                      <a:srgbClr val="4472C4"/>
+                    </a:solidFill>
+                  </a:tcPr>
+                </a:tc>
+                <a:tc>
+                  <a:txBody>
+                    <a:bodyPr/>
+                    <a:lstStyle/>
+                    <a:p>
+                      <a:pPr indent="0" marL="0">
+                        <a:buNone/>
+                      </a:pPr>
+                      <a:r>
+                        <a:rPr lang="en-US" sz="1500" b="1" dirty="0">
+                          <a:solidFill>
+                            <a:srgbClr val="FFFFFF"/>
+                          </a:solidFill>
+                        </a:rPr>
+                        <a:t>Published method</a:t>
+                      </a:r>
+                      <a:endParaRPr lang="en-US" sz="1500" dirty="0"/>
+                    </a:p>
+                  </a:txBody>
+                  <a:tcPr marL="54864" marR="54864" marT="54864" marB="54864" anchor="ctr">
+                    <a:lnL w="9525" cap="flat" cmpd="sng" algn="ctr">
+                      <a:solidFill>
+                        <a:srgbClr val="BFBFBF"/>
+                      </a:solidFill>
+                      <a:prstDash val="solid"/>
+                      <a:round/>
+                      <a:headEnd type="none" w="med" len="med"/>
+                      <a:tailEnd type="none" w="med" len="med"/>
+                    </a:lnL>
+                    <a:lnR w="9525" cap="flat" cmpd="sng" algn="ctr">
+                      <a:solidFill>
+                        <a:srgbClr val="BFBFBF"/>
+                      </a:solidFill>
+                      <a:prstDash val="solid"/>
+                      <a:round/>
+                      <a:headEnd type="none" w="med" len="med"/>
+                      <a:tailEnd type="none" w="med" len="med"/>
+                    </a:lnR>
+                    <a:lnT w="9525" cap="flat" cmpd="sng" algn="ctr">
+                      <a:solidFill>
+                        <a:srgbClr val="BFBFBF"/>
+                      </a:solidFill>
+                      <a:prstDash val="solid"/>
+                      <a:round/>
+                      <a:headEnd type="none" w="med" len="med"/>
+                      <a:tailEnd type="none" w="med" len="med"/>
+                    </a:lnT>
+                    <a:lnB w="9525" cap="flat" cmpd="sng" algn="ctr">
+                      <a:solidFill>
+                        <a:srgbClr val="BFBFBF"/>
+                      </a:solidFill>
+                      <a:prstDash val="solid"/>
+                      <a:round/>
+                      <a:headEnd type="none" w="med" len="med"/>
+                      <a:tailEnd type="none" w="med" len="med"/>
+                    </a:lnB>
+                    <a:solidFill>
+                      <a:srgbClr val="4472C4"/>
+                    </a:solidFill>
+                  </a:tcPr>
+                </a:tc>
+                <a:tc>
+                  <a:txBody>
+                    <a:bodyPr/>
+                    <a:lstStyle/>
+                    <a:p>
+                      <a:pPr indent="0" marL="0">
+                        <a:buNone/>
+                      </a:pPr>
+                      <a:r>
+                        <a:rPr lang="en-US" sz="1500" b="1" dirty="0">
+                          <a:solidFill>
+                            <a:srgbClr val="FFFFFF"/>
+                          </a:solidFill>
+                        </a:rPr>
+                        <a:t>Its result</a:t>
+                      </a:r>
+                      <a:endParaRPr lang="en-US" sz="1500" dirty="0"/>
+                    </a:p>
+                  </a:txBody>
+                  <a:tcPr marL="54864" marR="54864" marT="54864" marB="54864" anchor="ctr">
+                    <a:lnL w="9525" cap="flat" cmpd="sng" algn="ctr">
+                      <a:solidFill>
+                        <a:srgbClr val="BFBFBF"/>
+                      </a:solidFill>
+                      <a:prstDash val="solid"/>
+                      <a:round/>
+                      <a:headEnd type="none" w="med" len="med"/>
+                      <a:tailEnd type="none" w="med" len="med"/>
+                    </a:lnL>
+                    <a:lnR w="9525" cap="flat" cmpd="sng" algn="ctr">
+                      <a:solidFill>
+                        <a:srgbClr val="BFBFBF"/>
+                      </a:solidFill>
+                      <a:prstDash val="solid"/>
+                      <a:round/>
+                      <a:headEnd type="none" w="med" len="med"/>
+                      <a:tailEnd type="none" w="med" len="med"/>
+                    </a:lnR>
+                    <a:lnT w="9525" cap="flat" cmpd="sng" algn="ctr">
+                      <a:solidFill>
+                        <a:srgbClr val="BFBFBF"/>
+                      </a:solidFill>
+                      <a:prstDash val="solid"/>
+                      <a:round/>
+                      <a:headEnd type="none" w="med" len="med"/>
+                      <a:tailEnd type="none" w="med" len="med"/>
+                    </a:lnT>
+                    <a:lnB w="9525" cap="flat" cmpd="sng" algn="ctr">
+                      <a:solidFill>
+                        <a:srgbClr val="BFBFBF"/>
+                      </a:solidFill>
+                      <a:prstDash val="solid"/>
+                      <a:round/>
+                      <a:headEnd type="none" w="med" len="med"/>
+                      <a:tailEnd type="none" w="med" len="med"/>
+                    </a:lnB>
+                    <a:solidFill>
+                      <a:srgbClr val="4472C4"/>
+                    </a:solidFill>
+                  </a:tcPr>
+                </a:tc>
+                <a:tc>
+                  <a:txBody>
+                    <a:bodyPr/>
+                    <a:lstStyle/>
+                    <a:p>
+                      <a:pPr indent="0" marL="0">
+                        <a:buNone/>
+                      </a:pPr>
+                      <a:r>
+                        <a:rPr lang="en-US" sz="1500" b="1" dirty="0">
+                          <a:solidFill>
+                            <a:srgbClr val="FFFFFF"/>
+                          </a:solidFill>
+                        </a:rPr>
+                        <a:t>Ours (same problems)</a:t>
+                      </a:r>
+                      <a:endParaRPr lang="en-US" sz="1500" dirty="0"/>
+                    </a:p>
+                  </a:txBody>
+                  <a:tcPr marL="54864" marR="54864" marT="54864" marB="54864" anchor="ctr">
+                    <a:lnL w="9525" cap="flat" cmpd="sng" algn="ctr">
+                      <a:solidFill>
+                        <a:srgbClr val="BFBFBF"/>
+                      </a:solidFill>
+                      <a:prstDash val="solid"/>
+                      <a:round/>
+                      <a:headEnd type="none" w="med" len="med"/>
+                      <a:tailEnd type="none" w="med" len="med"/>
+                    </a:lnL>
+                    <a:lnR w="9525" cap="flat" cmpd="sng" algn="ctr">
+                      <a:solidFill>
+                        <a:srgbClr val="BFBFBF"/>
+                      </a:solidFill>
+                      <a:prstDash val="solid"/>
+                      <a:round/>
+                      <a:headEnd type="none" w="med" len="med"/>
+                      <a:tailEnd type="none" w="med" len="med"/>
+                    </a:lnR>
+                    <a:lnT w="9525" cap="flat" cmpd="sng" algn="ctr">
+                      <a:solidFill>
+                        <a:srgbClr val="BFBFBF"/>
+                      </a:solidFill>
+                      <a:prstDash val="solid"/>
+                      <a:round/>
+                      <a:headEnd type="none" w="med" len="med"/>
+                      <a:tailEnd type="none" w="med" len="med"/>
+                    </a:lnT>
+                    <a:lnB w="9525" cap="flat" cmpd="sng" algn="ctr">
+                      <a:solidFill>
+                        <a:srgbClr val="BFBFBF"/>
+                      </a:solidFill>
+                      <a:prstDash val="solid"/>
+                      <a:round/>
+                      <a:headEnd type="none" w="med" len="med"/>
+                      <a:tailEnd type="none" w="med" len="med"/>
+                    </a:lnB>
+                    <a:solidFill>
+                      <a:srgbClr val="4472C4"/>
+                    </a:solidFill>
+                  </a:tcPr>
+                </a:tc>
+              </a:tr>
+              <a:tr h="566928">
+                <a:tc>
+                  <a:txBody>
+                    <a:bodyPr/>
+                    <a:lstStyle/>
+                    <a:p>
+                      <a:pPr indent="0" marL="0">
+                        <a:buNone/>
+                      </a:pPr>
+                      <a:r>
+                        <a:rPr lang="en-US" sz="1500" dirty="0">
+                          <a:solidFill>
+                            <a:schemeClr val="tx1"/>
+                          </a:solidFill>
+                        </a:rPr>
+                        <a:t>Where to spend thinking</a:t>
+                      </a:r>
+                      <a:endParaRPr lang="en-US" sz="1500" dirty="0"/>
+                    </a:p>
+                  </a:txBody>
+                  <a:tcPr marL="54864" marR="54864" marT="54864" marB="54864" anchor="ctr">
+                    <a:lnL w="9525" cap="flat" cmpd="sng" algn="ctr">
+                      <a:solidFill>
+                        <a:srgbClr val="BFBFBF"/>
+                      </a:solidFill>
+                      <a:prstDash val="solid"/>
+                      <a:round/>
+                      <a:headEnd type="none" w="med" len="med"/>
+                      <a:tailEnd type="none" w="med" len="med"/>
+                    </a:lnL>
+                    <a:lnR w="9525" cap="flat" cmpd="sng" algn="ctr">
+                      <a:solidFill>
+                        <a:srgbClr val="BFBFBF"/>
+                      </a:solidFill>
+                      <a:prstDash val="solid"/>
+                      <a:round/>
+                      <a:headEnd type="none" w="med" len="med"/>
+                      <a:tailEnd type="none" w="med" len="med"/>
+                    </a:lnR>
+                    <a:lnT w="9525" cap="flat" cmpd="sng" algn="ctr">
+                      <a:solidFill>
+                        <a:srgbClr val="BFBFBF"/>
+                      </a:solidFill>
+                      <a:prstDash val="solid"/>
+                      <a:round/>
+                      <a:headEnd type="none" w="med" len="med"/>
+                      <a:tailEnd type="none" w="med" len="med"/>
+                    </a:lnT>
+                    <a:lnB w="9525" cap="flat" cmpd="sng" algn="ctr">
+                      <a:solidFill>
+                        <a:srgbClr val="BFBFBF"/>
+                      </a:solidFill>
+                      <a:prstDash val="solid"/>
+                      <a:round/>
+                      <a:headEnd type="none" w="med" len="med"/>
+                      <a:tailEnd type="none" w="med" len="med"/>
+                    </a:lnB>
+                  </a:tcPr>
+                </a:tc>
+                <a:tc>
+                  <a:txBody>
+                    <a:bodyPr/>
+                    <a:lstStyle/>
+                    <a:p>
+                      <a:pPr indent="0" marL="0">
+                        <a:buNone/>
+                      </a:pPr>
+                      <a:r>
+                        <a:rPr lang="en-US" sz="1500" dirty="0">
+                          <a:solidFill>
+                            <a:schemeClr val="tx1"/>
+                          </a:solidFill>
+                        </a:rPr>
+                        <a:t>think on the hardest-looking problems (Snell et al. 2025)</a:t>
+                      </a:r>
+                      <a:endParaRPr lang="en-US" sz="1500" dirty="0"/>
+                    </a:p>
+                  </a:txBody>
+                  <a:tcPr marL="54864" marR="54864" marT="54864" marB="54864" anchor="ctr">
+                    <a:lnL w="9525" cap="flat" cmpd="sng" algn="ctr">
+                      <a:solidFill>
+                        <a:srgbClr val="BFBFBF"/>
+                      </a:solidFill>
+                      <a:prstDash val="solid"/>
+                      <a:round/>
+                      <a:headEnd type="none" w="med" len="med"/>
+                      <a:tailEnd type="none" w="med" len="med"/>
+                    </a:lnL>
+                    <a:lnR w="9525" cap="flat" cmpd="sng" algn="ctr">
+                      <a:solidFill>
+                        <a:srgbClr val="BFBFBF"/>
+                      </a:solidFill>
+                      <a:prstDash val="solid"/>
+                      <a:round/>
+                      <a:headEnd type="none" w="med" len="med"/>
+                      <a:tailEnd type="none" w="med" len="med"/>
+                    </a:lnR>
+                    <a:lnT w="9525" cap="flat" cmpd="sng" algn="ctr">
+                      <a:solidFill>
+                        <a:srgbClr val="BFBFBF"/>
+                      </a:solidFill>
+                      <a:prstDash val="solid"/>
+                      <a:round/>
+                      <a:headEnd type="none" w="med" len="med"/>
+                      <a:tailEnd type="none" w="med" len="med"/>
+                    </a:lnT>
+                    <a:lnB w="9525" cap="flat" cmpd="sng" algn="ctr">
+                      <a:solidFill>
+                        <a:srgbClr val="BFBFBF"/>
+                      </a:solidFill>
+                      <a:prstDash val="solid"/>
+                      <a:round/>
+                      <a:headEnd type="none" w="med" len="med"/>
+                      <a:tailEnd type="none" w="med" len="med"/>
+                    </a:lnB>
+                  </a:tcPr>
+                </a:tc>
+                <a:tc>
+                  <a:txBody>
+                    <a:bodyPr/>
+                    <a:lstStyle/>
+                    <a:p>
+                      <a:pPr indent="0" marL="0">
+                        <a:buNone/>
+                      </a:pPr>
+                      <a:r>
+                        <a:rPr lang="en-US" sz="1500" dirty="0">
+                          <a:solidFill>
+                            <a:schemeClr val="tx1"/>
+                          </a:solidFill>
+                        </a:rPr>
+                        <a:t>74% · 4.1k</a:t>
+                      </a:r>
+                      <a:endParaRPr lang="en-US" sz="1500" dirty="0"/>
+                    </a:p>
+                  </a:txBody>
+                  <a:tcPr marL="54864" marR="54864" marT="54864" marB="54864" anchor="ctr">
+                    <a:lnL w="9525" cap="flat" cmpd="sng" algn="ctr">
+                      <a:solidFill>
+                        <a:srgbClr val="BFBFBF"/>
+                      </a:solidFill>
+                      <a:prstDash val="solid"/>
+                      <a:round/>
+                      <a:headEnd type="none" w="med" len="med"/>
+                      <a:tailEnd type="none" w="med" len="med"/>
+                    </a:lnL>
+                    <a:lnR w="9525" cap="flat" cmpd="sng" algn="ctr">
+                      <a:solidFill>
+                        <a:srgbClr val="BFBFBF"/>
+                      </a:solidFill>
+                      <a:prstDash val="solid"/>
+                      <a:round/>
+                      <a:headEnd type="none" w="med" len="med"/>
+                      <a:tailEnd type="none" w="med" len="med"/>
+                    </a:lnR>
+                    <a:lnT w="9525" cap="flat" cmpd="sng" algn="ctr">
+                      <a:solidFill>
+                        <a:srgbClr val="BFBFBF"/>
+                      </a:solidFill>
+                      <a:prstDash val="solid"/>
+                      <a:round/>
+                      <a:headEnd type="none" w="med" len="med"/>
+                      <a:tailEnd type="none" w="med" len="med"/>
+                    </a:lnT>
+                    <a:lnB w="9525" cap="flat" cmpd="sng" algn="ctr">
+                      <a:solidFill>
+                        <a:srgbClr val="BFBFBF"/>
+                      </a:solidFill>
+                      <a:prstDash val="solid"/>
+                      <a:round/>
+                      <a:headEnd type="none" w="med" len="med"/>
+                      <a:tailEnd type="none" w="med" len="med"/>
+                    </a:lnB>
+                  </a:tcPr>
+                </a:tc>
+                <a:tc>
+                  <a:txBody>
+                    <a:bodyPr/>
+                    <a:lstStyle/>
+                    <a:p>
+                      <a:pPr indent="0" marL="0">
+                        <a:buNone/>
+                      </a:pPr>
+                      <a:r>
+                        <a:rPr lang="en-US" sz="1500" b="1" dirty="0">
+                          <a:solidFill>
+                            <a:srgbClr val="38761D"/>
+                          </a:solidFill>
+                        </a:rPr>
+                        <a:t>fact first, think on failure: 87% · 2.5k</a:t>
+                      </a:r>
+                      <a:endParaRPr lang="en-US" sz="1500" dirty="0"/>
+                    </a:p>
+                  </a:txBody>
+                  <a:tcPr marL="54864" marR="54864" marT="54864" marB="54864" anchor="ctr">
+                    <a:lnL w="9525" cap="flat" cmpd="sng" algn="ctr">
+                      <a:solidFill>
+                        <a:srgbClr val="BFBFBF"/>
+                      </a:solidFill>
+                      <a:prstDash val="solid"/>
+                      <a:round/>
+                      <a:headEnd type="none" w="med" len="med"/>
+                      <a:tailEnd type="none" w="med" len="med"/>
+                    </a:lnL>
+                    <a:lnR w="9525" cap="flat" cmpd="sng" algn="ctr">
+                      <a:solidFill>
+                        <a:srgbClr val="BFBFBF"/>
+                      </a:solidFill>
+                      <a:prstDash val="solid"/>
+                      <a:round/>
+                      <a:headEnd type="none" w="med" len="med"/>
+                      <a:tailEnd type="none" w="med" len="med"/>
+                    </a:lnR>
+                    <a:lnT w="9525" cap="flat" cmpd="sng" algn="ctr">
+                      <a:solidFill>
+                        <a:srgbClr val="BFBFBF"/>
+                      </a:solidFill>
+                      <a:prstDash val="solid"/>
+                      <a:round/>
+                      <a:headEnd type="none" w="med" len="med"/>
+                      <a:tailEnd type="none" w="med" len="med"/>
+                    </a:lnT>
+                    <a:lnB w="9525" cap="flat" cmpd="sng" algn="ctr">
+                      <a:solidFill>
+                        <a:srgbClr val="BFBFBF"/>
+                      </a:solidFill>
+                      <a:prstDash val="solid"/>
+                      <a:round/>
+                      <a:headEnd type="none" w="med" len="med"/>
+                      <a:tailEnd type="none" w="med" len="med"/>
+                    </a:lnB>
+                  </a:tcPr>
+                </a:tc>
+              </a:tr>
+              <a:tr h="566928">
+                <a:tc>
+                  <a:txBody>
+                    <a:bodyPr/>
+                    <a:lstStyle/>
+                    <a:p>
+                      <a:pPr indent="0" marL="0">
+                        <a:buNone/>
+                      </a:pPr>
+                      <a:r>
+                        <a:rPr lang="en-US" sz="1500" dirty="0">
+                          <a:solidFill>
+                            <a:schemeClr val="tx1"/>
+                          </a:solidFill>
+                        </a:rPr>
+                        <a:t>Contest geometry</a:t>
+                      </a:r>
+                      <a:endParaRPr lang="en-US" sz="1500" dirty="0"/>
+                    </a:p>
+                  </a:txBody>
+                  <a:tcPr marL="54864" marR="54864" marT="54864" marB="54864" anchor="ctr">
+                    <a:lnL w="9525" cap="flat" cmpd="sng" algn="ctr">
+                      <a:solidFill>
+                        <a:srgbClr val="BFBFBF"/>
+                      </a:solidFill>
+                      <a:prstDash val="solid"/>
+                      <a:round/>
+                      <a:headEnd type="none" w="med" len="med"/>
+                      <a:tailEnd type="none" w="med" len="med"/>
+                    </a:lnL>
+                    <a:lnR w="9525" cap="flat" cmpd="sng" algn="ctr">
+                      <a:solidFill>
+                        <a:srgbClr val="BFBFBF"/>
+                      </a:solidFill>
+                      <a:prstDash val="solid"/>
+                      <a:round/>
+                      <a:headEnd type="none" w="med" len="med"/>
+                      <a:tailEnd type="none" w="med" len="med"/>
+                    </a:lnR>
+                    <a:lnT w="9525" cap="flat" cmpd="sng" algn="ctr">
+                      <a:solidFill>
+                        <a:srgbClr val="BFBFBF"/>
+                      </a:solidFill>
+                      <a:prstDash val="solid"/>
+                      <a:round/>
+                      <a:headEnd type="none" w="med" len="med"/>
+                      <a:tailEnd type="none" w="med" len="med"/>
+                    </a:lnT>
+                    <a:lnB w="9525" cap="flat" cmpd="sng" algn="ctr">
+                      <a:solidFill>
+                        <a:srgbClr val="BFBFBF"/>
+                      </a:solidFill>
+                      <a:prstDash val="solid"/>
+                      <a:round/>
+                      <a:headEnd type="none" w="med" len="med"/>
+                      <a:tailEnd type="none" w="med" len="med"/>
+                    </a:lnB>
+                  </a:tcPr>
+                </a:tc>
+                <a:tc>
+                  <a:txBody>
+                    <a:bodyPr/>
+                    <a:lstStyle/>
+                    <a:p>
+                      <a:pPr indent="0" marL="0">
+                        <a:buNone/>
+                      </a:pPr>
+                      <a:r>
+                        <a:rPr lang="en-US" sz="1500" dirty="0">
+                          <a:solidFill>
+                            <a:schemeClr val="tx1"/>
+                          </a:solidFill>
+                        </a:rPr>
+                        <a:t>always high effort (reasoning-model default)</a:t>
+                      </a:r>
+                      <a:endParaRPr lang="en-US" sz="1500" dirty="0"/>
+                    </a:p>
+                  </a:txBody>
+                  <a:tcPr marL="54864" marR="54864" marT="54864" marB="54864" anchor="ctr">
+                    <a:lnL w="9525" cap="flat" cmpd="sng" algn="ctr">
+                      <a:solidFill>
+                        <a:srgbClr val="BFBFBF"/>
+                      </a:solidFill>
+                      <a:prstDash val="solid"/>
+                      <a:round/>
+                      <a:headEnd type="none" w="med" len="med"/>
+                      <a:tailEnd type="none" w="med" len="med"/>
+                    </a:lnL>
+                    <a:lnR w="9525" cap="flat" cmpd="sng" algn="ctr">
+                      <a:solidFill>
+                        <a:srgbClr val="BFBFBF"/>
+                      </a:solidFill>
+                      <a:prstDash val="solid"/>
+                      <a:round/>
+                      <a:headEnd type="none" w="med" len="med"/>
+                      <a:tailEnd type="none" w="med" len="med"/>
+                    </a:lnR>
+                    <a:lnT w="9525" cap="flat" cmpd="sng" algn="ctr">
+                      <a:solidFill>
+                        <a:srgbClr val="BFBFBF"/>
+                      </a:solidFill>
+                      <a:prstDash val="solid"/>
+                      <a:round/>
+                      <a:headEnd type="none" w="med" len="med"/>
+                      <a:tailEnd type="none" w="med" len="med"/>
+                    </a:lnT>
+                    <a:lnB w="9525" cap="flat" cmpd="sng" algn="ctr">
+                      <a:solidFill>
+                        <a:srgbClr val="BFBFBF"/>
+                      </a:solidFill>
+                      <a:prstDash val="solid"/>
+                      <a:round/>
+                      <a:headEnd type="none" w="med" len="med"/>
+                      <a:tailEnd type="none" w="med" len="med"/>
+                    </a:lnB>
+                  </a:tcPr>
+                </a:tc>
+                <a:tc>
+                  <a:txBody>
+                    <a:bodyPr/>
+                    <a:lstStyle/>
+                    <a:p>
+                      <a:pPr indent="0" marL="0">
+                        <a:buNone/>
+                      </a:pPr>
+                      <a:r>
+                        <a:rPr lang="en-US" sz="1500" dirty="0">
+                          <a:solidFill>
+                            <a:schemeClr val="tx1"/>
+                          </a:solidFill>
+                        </a:rPr>
+                        <a:t>66.2% · 30.1k</a:t>
+                      </a:r>
+                      <a:endParaRPr lang="en-US" sz="1500" dirty="0"/>
+                    </a:p>
+                  </a:txBody>
+                  <a:tcPr marL="54864" marR="54864" marT="54864" marB="54864" anchor="ctr">
+                    <a:lnL w="9525" cap="flat" cmpd="sng" algn="ctr">
+                      <a:solidFill>
+                        <a:srgbClr val="BFBFBF"/>
+                      </a:solidFill>
+                      <a:prstDash val="solid"/>
+                      <a:round/>
+                      <a:headEnd type="none" w="med" len="med"/>
+                      <a:tailEnd type="none" w="med" len="med"/>
+                    </a:lnL>
+                    <a:lnR w="9525" cap="flat" cmpd="sng" algn="ctr">
+                      <a:solidFill>
+                        <a:srgbClr val="BFBFBF"/>
+                      </a:solidFill>
+                      <a:prstDash val="solid"/>
+                      <a:round/>
+                      <a:headEnd type="none" w="med" len="med"/>
+                      <a:tailEnd type="none" w="med" len="med"/>
+                    </a:lnR>
+                    <a:lnT w="9525" cap="flat" cmpd="sng" algn="ctr">
+                      <a:solidFill>
+                        <a:srgbClr val="BFBFBF"/>
+                      </a:solidFill>
+                      <a:prstDash val="solid"/>
+                      <a:round/>
+                      <a:headEnd type="none" w="med" len="med"/>
+                      <a:tailEnd type="none" w="med" len="med"/>
+                    </a:lnT>
+                    <a:lnB w="9525" cap="flat" cmpd="sng" algn="ctr">
+                      <a:solidFill>
+                        <a:srgbClr val="BFBFBF"/>
+                      </a:solidFill>
+                      <a:prstDash val="solid"/>
+                      <a:round/>
+                      <a:headEnd type="none" w="med" len="med"/>
+                      <a:tailEnd type="none" w="med" len="med"/>
+                    </a:lnB>
+                  </a:tcPr>
+                </a:tc>
+                <a:tc>
+                  <a:txBody>
+                    <a:bodyPr/>
+                    <a:lstStyle/>
+                    <a:p>
+                      <a:pPr indent="0" marL="0">
+                        <a:buNone/>
+                      </a:pPr>
+                      <a:r>
+                        <a:rPr lang="en-US" sz="1500" b="1" dirty="0">
+                          <a:solidFill>
+                            <a:srgbClr val="38761D"/>
+                          </a:solidFill>
+                        </a:rPr>
+                        <a:t>think only on a failed check: 66.3% · 24.7k</a:t>
+                      </a:r>
+                      <a:endParaRPr lang="en-US" sz="1500" dirty="0"/>
+                    </a:p>
+                  </a:txBody>
+                  <a:tcPr marL="54864" marR="54864" marT="54864" marB="54864" anchor="ctr">
+                    <a:lnL w="9525" cap="flat" cmpd="sng" algn="ctr">
+                      <a:solidFill>
+                        <a:srgbClr val="BFBFBF"/>
+                      </a:solidFill>
+                      <a:prstDash val="solid"/>
+                      <a:round/>
+                      <a:headEnd type="none" w="med" len="med"/>
+                      <a:tailEnd type="none" w="med" len="med"/>
+                    </a:lnL>
+                    <a:lnR w="9525" cap="flat" cmpd="sng" algn="ctr">
+                      <a:solidFill>
+                        <a:srgbClr val="BFBFBF"/>
+                      </a:solidFill>
+                      <a:prstDash val="solid"/>
+                      <a:round/>
+                      <a:headEnd type="none" w="med" len="med"/>
+                      <a:tailEnd type="none" w="med" len="med"/>
+                    </a:lnR>
+                    <a:lnT w="9525" cap="flat" cmpd="sng" algn="ctr">
+                      <a:solidFill>
+                        <a:srgbClr val="BFBFBF"/>
+                      </a:solidFill>
+                      <a:prstDash val="solid"/>
+                      <a:round/>
+                      <a:headEnd type="none" w="med" len="med"/>
+                      <a:tailEnd type="none" w="med" len="med"/>
+                    </a:lnT>
+                    <a:lnB w="9525" cap="flat" cmpd="sng" algn="ctr">
+                      <a:solidFill>
+                        <a:srgbClr val="BFBFBF"/>
+                      </a:solidFill>
+                      <a:prstDash val="solid"/>
+                      <a:round/>
+                      <a:headEnd type="none" w="med" len="med"/>
+                      <a:tailEnd type="none" w="med" len="med"/>
+                    </a:lnB>
+                  </a:tcPr>
+                </a:tc>
+              </a:tr>
+              <a:tr h="566928">
+                <a:tc>
+                  <a:txBody>
+                    <a:bodyPr/>
+                    <a:lstStyle/>
+                    <a:p>
+                      <a:pPr indent="0" marL="0">
+                        <a:buNone/>
+                      </a:pPr>
+                      <a:r>
+                        <a:rPr lang="en-US" sz="1500" dirty="0">
+                          <a:solidFill>
+                            <a:schemeClr val="tx1"/>
+                          </a:solidFill>
+                        </a:rPr>
+                        <a:t>Pick 1 of 3 programs</a:t>
+                      </a:r>
+                      <a:endParaRPr lang="en-US" sz="1500" dirty="0"/>
+                    </a:p>
+                  </a:txBody>
+                  <a:tcPr marL="54864" marR="54864" marT="54864" marB="54864" anchor="ctr">
+                    <a:lnL w="9525" cap="flat" cmpd="sng" algn="ctr">
+                      <a:solidFill>
+                        <a:srgbClr val="BFBFBF"/>
+                      </a:solidFill>
+                      <a:prstDash val="solid"/>
+                      <a:round/>
+                      <a:headEnd type="none" w="med" len="med"/>
+                      <a:tailEnd type="none" w="med" len="med"/>
+                    </a:lnL>
+                    <a:lnR w="9525" cap="flat" cmpd="sng" algn="ctr">
+                      <a:solidFill>
+                        <a:srgbClr val="BFBFBF"/>
+                      </a:solidFill>
+                      <a:prstDash val="solid"/>
+                      <a:round/>
+                      <a:headEnd type="none" w="med" len="med"/>
+                      <a:tailEnd type="none" w="med" len="med"/>
+                    </a:lnR>
+                    <a:lnT w="9525" cap="flat" cmpd="sng" algn="ctr">
+                      <a:solidFill>
+                        <a:srgbClr val="BFBFBF"/>
+                      </a:solidFill>
+                      <a:prstDash val="solid"/>
+                      <a:round/>
+                      <a:headEnd type="none" w="med" len="med"/>
+                      <a:tailEnd type="none" w="med" len="med"/>
+                    </a:lnT>
+                    <a:lnB w="9525" cap="flat" cmpd="sng" algn="ctr">
+                      <a:solidFill>
+                        <a:srgbClr val="BFBFBF"/>
+                      </a:solidFill>
+                      <a:prstDash val="solid"/>
+                      <a:round/>
+                      <a:headEnd type="none" w="med" len="med"/>
+                      <a:tailEnd type="none" w="med" len="med"/>
+                    </a:lnB>
+                  </a:tcPr>
+                </a:tc>
+                <a:tc>
+                  <a:txBody>
+                    <a:bodyPr/>
+                    <a:lstStyle/>
+                    <a:p>
+                      <a:pPr indent="0" marL="0">
+                        <a:buNone/>
+                      </a:pPr>
+                      <a:r>
+                        <a:rPr lang="en-US" sz="1500" dirty="0">
+                          <a:solidFill>
+                            <a:schemeClr val="tx1"/>
+                          </a:solidFill>
+                        </a:rPr>
+                        <a:t>CodeT: the model writes tests</a:t>
+                      </a:r>
+                      <a:endParaRPr lang="en-US" sz="1500" dirty="0"/>
+                    </a:p>
+                  </a:txBody>
+                  <a:tcPr marL="54864" marR="54864" marT="54864" marB="54864" anchor="ctr">
+                    <a:lnL w="9525" cap="flat" cmpd="sng" algn="ctr">
+                      <a:solidFill>
+                        <a:srgbClr val="BFBFBF"/>
+                      </a:solidFill>
+                      <a:prstDash val="solid"/>
+                      <a:round/>
+                      <a:headEnd type="none" w="med" len="med"/>
+                      <a:tailEnd type="none" w="med" len="med"/>
+                    </a:lnL>
+                    <a:lnR w="9525" cap="flat" cmpd="sng" algn="ctr">
+                      <a:solidFill>
+                        <a:srgbClr val="BFBFBF"/>
+                      </a:solidFill>
+                      <a:prstDash val="solid"/>
+                      <a:round/>
+                      <a:headEnd type="none" w="med" len="med"/>
+                      <a:tailEnd type="none" w="med" len="med"/>
+                    </a:lnR>
+                    <a:lnT w="9525" cap="flat" cmpd="sng" algn="ctr">
+                      <a:solidFill>
+                        <a:srgbClr val="BFBFBF"/>
+                      </a:solidFill>
+                      <a:prstDash val="solid"/>
+                      <a:round/>
+                      <a:headEnd type="none" w="med" len="med"/>
+                      <a:tailEnd type="none" w="med" len="med"/>
+                    </a:lnT>
+                    <a:lnB w="9525" cap="flat" cmpd="sng" algn="ctr">
+                      <a:solidFill>
+                        <a:srgbClr val="BFBFBF"/>
+                      </a:solidFill>
+                      <a:prstDash val="solid"/>
+                      <a:round/>
+                      <a:headEnd type="none" w="med" len="med"/>
+                      <a:tailEnd type="none" w="med" len="med"/>
+                    </a:lnB>
+                  </a:tcPr>
+                </a:tc>
+                <a:tc>
+                  <a:txBody>
+                    <a:bodyPr/>
+                    <a:lstStyle/>
+                    <a:p>
+                      <a:pPr indent="0" marL="0">
+                        <a:buNone/>
+                      </a:pPr>
+                      <a:r>
+                        <a:rPr lang="en-US" sz="1500" dirty="0">
+                          <a:solidFill>
+                            <a:schemeClr val="tx1"/>
+                          </a:solidFill>
+                        </a:rPr>
+                        <a:t>96.0% (+340 tokens)</a:t>
+                      </a:r>
+                      <a:endParaRPr lang="en-US" sz="1500" dirty="0"/>
+                    </a:p>
+                  </a:txBody>
+                  <a:tcPr marL="54864" marR="54864" marT="54864" marB="54864" anchor="ctr">
+                    <a:lnL w="9525" cap="flat" cmpd="sng" algn="ctr">
+                      <a:solidFill>
+                        <a:srgbClr val="BFBFBF"/>
+                      </a:solidFill>
+                      <a:prstDash val="solid"/>
+                      <a:round/>
+                      <a:headEnd type="none" w="med" len="med"/>
+                      <a:tailEnd type="none" w="med" len="med"/>
+                    </a:lnL>
+                    <a:lnR w="9525" cap="flat" cmpd="sng" algn="ctr">
+                      <a:solidFill>
+                        <a:srgbClr val="BFBFBF"/>
+                      </a:solidFill>
+                      <a:prstDash val="solid"/>
+                      <a:round/>
+                      <a:headEnd type="none" w="med" len="med"/>
+                      <a:tailEnd type="none" w="med" len="med"/>
+                    </a:lnR>
+                    <a:lnT w="9525" cap="flat" cmpd="sng" algn="ctr">
+                      <a:solidFill>
+                        <a:srgbClr val="BFBFBF"/>
+                      </a:solidFill>
+                      <a:prstDash val="solid"/>
+                      <a:round/>
+                      <a:headEnd type="none" w="med" len="med"/>
+                      <a:tailEnd type="none" w="med" len="med"/>
+                    </a:lnT>
+                    <a:lnB w="9525" cap="flat" cmpd="sng" algn="ctr">
+                      <a:solidFill>
+                        <a:srgbClr val="BFBFBF"/>
+                      </a:solidFill>
+                      <a:prstDash val="solid"/>
+                      <a:round/>
+                      <a:headEnd type="none" w="med" len="med"/>
+                      <a:tailEnd type="none" w="med" len="med"/>
+                    </a:lnB>
+                  </a:tcPr>
+                </a:tc>
+                <a:tc>
+                  <a:txBody>
+                    <a:bodyPr/>
+                    <a:lstStyle/>
+                    <a:p>
+                      <a:pPr indent="0" marL="0">
+                        <a:buNone/>
+                      </a:pPr>
+                      <a:r>
+                        <a:rPr lang="en-US" sz="1500" b="1" dirty="0">
+                          <a:solidFill>
+                            <a:srgbClr val="38761D"/>
+                          </a:solidFill>
+                        </a:rPr>
+                        <a:t>symmetry check: 99.7% (0 tokens)</a:t>
+                      </a:r>
+                      <a:endParaRPr lang="en-US" sz="1500" dirty="0"/>
+                    </a:p>
+                  </a:txBody>
+                  <a:tcPr marL="54864" marR="54864" marT="54864" marB="54864" anchor="ctr">
+                    <a:lnL w="9525" cap="flat" cmpd="sng" algn="ctr">
+                      <a:solidFill>
+                        <a:srgbClr val="BFBFBF"/>
+                      </a:solidFill>
+                      <a:prstDash val="solid"/>
+                      <a:round/>
+                      <a:headEnd type="none" w="med" len="med"/>
+                      <a:tailEnd type="none" w="med" len="med"/>
+                    </a:lnL>
+                    <a:lnR w="9525" cap="flat" cmpd="sng" algn="ctr">
+                      <a:solidFill>
+                        <a:srgbClr val="BFBFBF"/>
+                      </a:solidFill>
+                      <a:prstDash val="solid"/>
+                      <a:round/>
+                      <a:headEnd type="none" w="med" len="med"/>
+                      <a:tailEnd type="none" w="med" len="med"/>
+                    </a:lnR>
+                    <a:lnT w="9525" cap="flat" cmpd="sng" algn="ctr">
+                      <a:solidFill>
+                        <a:srgbClr val="BFBFBF"/>
+                      </a:solidFill>
+                      <a:prstDash val="solid"/>
+                      <a:round/>
+                      <a:headEnd type="none" w="med" len="med"/>
+                      <a:tailEnd type="none" w="med" len="med"/>
+                    </a:lnT>
+                    <a:lnB w="9525" cap="flat" cmpd="sng" algn="ctr">
+                      <a:solidFill>
+                        <a:srgbClr val="BFBFBF"/>
+                      </a:solidFill>
+                      <a:prstDash val="solid"/>
+                      <a:round/>
+                      <a:headEnd type="none" w="med" len="med"/>
+                      <a:tailEnd type="none" w="med" len="med"/>
+                    </a:lnB>
+                  </a:tcPr>
+                </a:tc>
+              </a:tr>
+              <a:tr h="566928">
+                <a:tc>
+                  <a:txBody>
+                    <a:bodyPr/>
+                    <a:lstStyle/>
+                    <a:p>
+                      <a:pPr indent="0" marL="0">
+                        <a:buNone/>
+                      </a:pPr>
+                      <a:r>
+                        <a:rPr lang="en-US" sz="1500" dirty="0">
+                          <a:solidFill>
+                            <a:schemeClr val="tx1"/>
+                          </a:solidFill>
+                        </a:rPr>
+                        <a:t>Library documentation</a:t>
+                      </a:r>
+                      <a:endParaRPr lang="en-US" sz="1500" dirty="0"/>
+                    </a:p>
+                  </a:txBody>
+                  <a:tcPr marL="54864" marR="54864" marT="54864" marB="54864" anchor="ctr">
+                    <a:lnL w="9525" cap="flat" cmpd="sng" algn="ctr">
+                      <a:solidFill>
+                        <a:srgbClr val="BFBFBF"/>
+                      </a:solidFill>
+                      <a:prstDash val="solid"/>
+                      <a:round/>
+                      <a:headEnd type="none" w="med" len="med"/>
+                      <a:tailEnd type="none" w="med" len="med"/>
+                    </a:lnL>
+                    <a:lnR w="9525" cap="flat" cmpd="sng" algn="ctr">
+                      <a:solidFill>
+                        <a:srgbClr val="BFBFBF"/>
+                      </a:solidFill>
+                      <a:prstDash val="solid"/>
+                      <a:round/>
+                      <a:headEnd type="none" w="med" len="med"/>
+                      <a:tailEnd type="none" w="med" len="med"/>
+                    </a:lnR>
+                    <a:lnT w="9525" cap="flat" cmpd="sng" algn="ctr">
+                      <a:solidFill>
+                        <a:srgbClr val="BFBFBF"/>
+                      </a:solidFill>
+                      <a:prstDash val="solid"/>
+                      <a:round/>
+                      <a:headEnd type="none" w="med" len="med"/>
+                      <a:tailEnd type="none" w="med" len="med"/>
+                    </a:lnT>
+                    <a:lnB w="9525" cap="flat" cmpd="sng" algn="ctr">
+                      <a:solidFill>
+                        <a:srgbClr val="BFBFBF"/>
+                      </a:solidFill>
+                      <a:prstDash val="solid"/>
+                      <a:round/>
+                      <a:headEnd type="none" w="med" len="med"/>
+                      <a:tailEnd type="none" w="med" len="med"/>
+                    </a:lnB>
+                  </a:tcPr>
+                </a:tc>
+                <a:tc>
+                  <a:txBody>
+                    <a:bodyPr/>
+                    <a:lstStyle/>
+                    <a:p>
+                      <a:pPr indent="0" marL="0">
+                        <a:buNone/>
+                      </a:pPr>
+                      <a:r>
+                        <a:rPr lang="en-US" sz="1500" dirty="0">
+                          <a:solidFill>
+                            <a:schemeClr val="tx1"/>
+                          </a:solidFill>
+                        </a:rPr>
+                        <a:t>DRoC: decompose, retrieve per constraint (ICLR 2025)</a:t>
+                      </a:r>
+                      <a:endParaRPr lang="en-US" sz="1500" dirty="0"/>
+                    </a:p>
+                  </a:txBody>
+                  <a:tcPr marL="54864" marR="54864" marT="54864" marB="54864" anchor="ctr">
+                    <a:lnL w="9525" cap="flat" cmpd="sng" algn="ctr">
+                      <a:solidFill>
+                        <a:srgbClr val="BFBFBF"/>
+                      </a:solidFill>
+                      <a:prstDash val="solid"/>
+                      <a:round/>
+                      <a:headEnd type="none" w="med" len="med"/>
+                      <a:tailEnd type="none" w="med" len="med"/>
+                    </a:lnL>
+                    <a:lnR w="9525" cap="flat" cmpd="sng" algn="ctr">
+                      <a:solidFill>
+                        <a:srgbClr val="BFBFBF"/>
+                      </a:solidFill>
+                      <a:prstDash val="solid"/>
+                      <a:round/>
+                      <a:headEnd type="none" w="med" len="med"/>
+                      <a:tailEnd type="none" w="med" len="med"/>
+                    </a:lnR>
+                    <a:lnT w="9525" cap="flat" cmpd="sng" algn="ctr">
+                      <a:solidFill>
+                        <a:srgbClr val="BFBFBF"/>
+                      </a:solidFill>
+                      <a:prstDash val="solid"/>
+                      <a:round/>
+                      <a:headEnd type="none" w="med" len="med"/>
+                      <a:tailEnd type="none" w="med" len="med"/>
+                    </a:lnT>
+                    <a:lnB w="9525" cap="flat" cmpd="sng" algn="ctr">
+                      <a:solidFill>
+                        <a:srgbClr val="BFBFBF"/>
+                      </a:solidFill>
+                      <a:prstDash val="solid"/>
+                      <a:round/>
+                      <a:headEnd type="none" w="med" len="med"/>
+                      <a:tailEnd type="none" w="med" len="med"/>
+                    </a:lnB>
+                  </a:tcPr>
+                </a:tc>
+                <a:tc>
+                  <a:txBody>
+                    <a:bodyPr/>
+                    <a:lstStyle/>
+                    <a:p>
+                      <a:pPr indent="0" marL="0">
+                        <a:buNone/>
+                      </a:pPr>
+                      <a:r>
+                        <a:rPr lang="en-US" sz="1500" dirty="0">
+                          <a:solidFill>
+                            <a:schemeClr val="tx1"/>
+                          </a:solidFill>
+                        </a:rPr>
+                        <a:t>72% · 2.1k</a:t>
+                      </a:r>
+                      <a:endParaRPr lang="en-US" sz="1500" dirty="0"/>
+                    </a:p>
+                  </a:txBody>
+                  <a:tcPr marL="54864" marR="54864" marT="54864" marB="54864" anchor="ctr">
+                    <a:lnL w="9525" cap="flat" cmpd="sng" algn="ctr">
+                      <a:solidFill>
+                        <a:srgbClr val="BFBFBF"/>
+                      </a:solidFill>
+                      <a:prstDash val="solid"/>
+                      <a:round/>
+                      <a:headEnd type="none" w="med" len="med"/>
+                      <a:tailEnd type="none" w="med" len="med"/>
+                    </a:lnL>
+                    <a:lnR w="9525" cap="flat" cmpd="sng" algn="ctr">
+                      <a:solidFill>
+                        <a:srgbClr val="BFBFBF"/>
+                      </a:solidFill>
+                      <a:prstDash val="solid"/>
+                      <a:round/>
+                      <a:headEnd type="none" w="med" len="med"/>
+                      <a:tailEnd type="none" w="med" len="med"/>
+                    </a:lnR>
+                    <a:lnT w="9525" cap="flat" cmpd="sng" algn="ctr">
+                      <a:solidFill>
+                        <a:srgbClr val="BFBFBF"/>
+                      </a:solidFill>
+                      <a:prstDash val="solid"/>
+                      <a:round/>
+                      <a:headEnd type="none" w="med" len="med"/>
+                      <a:tailEnd type="none" w="med" len="med"/>
+                    </a:lnT>
+                    <a:lnB w="9525" cap="flat" cmpd="sng" algn="ctr">
+                      <a:solidFill>
+                        <a:srgbClr val="BFBFBF"/>
+                      </a:solidFill>
+                      <a:prstDash val="solid"/>
+                      <a:round/>
+                      <a:headEnd type="none" w="med" len="med"/>
+                      <a:tailEnd type="none" w="med" len="med"/>
+                    </a:lnB>
+                  </a:tcPr>
+                </a:tc>
+                <a:tc>
+                  <a:txBody>
+                    <a:bodyPr/>
+                    <a:lstStyle/>
+                    <a:p>
+                      <a:pPr indent="0" marL="0">
+                        <a:buNone/>
+                      </a:pPr>
+                      <a:r>
+                        <a:rPr lang="en-US" sz="1500" b="1" dirty="0">
+                          <a:solidFill>
+                            <a:srgbClr val="38761D"/>
+                          </a:solidFill>
+                        </a:rPr>
+                        <a:t>exact 5-line snippet: 77% · 1.7k</a:t>
+                      </a:r>
+                      <a:endParaRPr lang="en-US" sz="1500" dirty="0"/>
+                    </a:p>
+                  </a:txBody>
+                  <a:tcPr marL="54864" marR="54864" marT="54864" marB="54864" anchor="ctr">
+                    <a:lnL w="9525" cap="flat" cmpd="sng" algn="ctr">
+                      <a:solidFill>
+                        <a:srgbClr val="BFBFBF"/>
+                      </a:solidFill>
+                      <a:prstDash val="solid"/>
+                      <a:round/>
+                      <a:headEnd type="none" w="med" len="med"/>
+                      <a:tailEnd type="none" w="med" len="med"/>
+                    </a:lnL>
+                    <a:lnR w="9525" cap="flat" cmpd="sng" algn="ctr">
+                      <a:solidFill>
+                        <a:srgbClr val="BFBFBF"/>
+                      </a:solidFill>
+                      <a:prstDash val="solid"/>
+                      <a:round/>
+                      <a:headEnd type="none" w="med" len="med"/>
+                      <a:tailEnd type="none" w="med" len="med"/>
+                    </a:lnR>
+                    <a:lnT w="9525" cap="flat" cmpd="sng" algn="ctr">
+                      <a:solidFill>
+                        <a:srgbClr val="BFBFBF"/>
+                      </a:solidFill>
+                      <a:prstDash val="solid"/>
+                      <a:round/>
+                      <a:headEnd type="none" w="med" len="med"/>
+                      <a:tailEnd type="none" w="med" len="med"/>
+                    </a:lnT>
+                    <a:lnB w="9525" cap="flat" cmpd="sng" algn="ctr">
+                      <a:solidFill>
+                        <a:srgbClr val="BFBFBF"/>
+                      </a:solidFill>
+                      <a:prstDash val="solid"/>
+                      <a:round/>
+                      <a:headEnd type="none" w="med" len="med"/>
+                      <a:tailEnd type="none" w="med" len="med"/>
+                    </a:lnB>
+                  </a:tcPr>
+                </a:tc>
+              </a:tr>
+              <a:tr h="566928">
+                <a:tc>
+                  <a:txBody>
+                    <a:bodyPr/>
+                    <a:lstStyle/>
+                    <a:p>
+                      <a:pPr indent="0" marL="0">
+                        <a:buNone/>
+                      </a:pPr>
+                      <a:r>
+                        <a:rPr lang="en-US" sz="1500" dirty="0">
+                          <a:solidFill>
+                            <a:schemeClr val="tx1"/>
+                          </a:solidFill>
+                        </a:rPr>
+                        <a:t>Unneeded tools</a:t>
+                      </a:r>
+                      <a:endParaRPr lang="en-US" sz="1500" dirty="0"/>
+                    </a:p>
+                  </a:txBody>
+                  <a:tcPr marL="54864" marR="54864" marT="54864" marB="54864" anchor="ctr">
+                    <a:lnL w="9525" cap="flat" cmpd="sng" algn="ctr">
+                      <a:solidFill>
+                        <a:srgbClr val="BFBFBF"/>
+                      </a:solidFill>
+                      <a:prstDash val="solid"/>
+                      <a:round/>
+                      <a:headEnd type="none" w="med" len="med"/>
+                      <a:tailEnd type="none" w="med" len="med"/>
+                    </a:lnL>
+                    <a:lnR w="9525" cap="flat" cmpd="sng" algn="ctr">
+                      <a:solidFill>
+                        <a:srgbClr val="BFBFBF"/>
+                      </a:solidFill>
+                      <a:prstDash val="solid"/>
+                      <a:round/>
+                      <a:headEnd type="none" w="med" len="med"/>
+                      <a:tailEnd type="none" w="med" len="med"/>
+                    </a:lnR>
+                    <a:lnT w="9525" cap="flat" cmpd="sng" algn="ctr">
+                      <a:solidFill>
+                        <a:srgbClr val="BFBFBF"/>
+                      </a:solidFill>
+                      <a:prstDash val="solid"/>
+                      <a:round/>
+                      <a:headEnd type="none" w="med" len="med"/>
+                      <a:tailEnd type="none" w="med" len="med"/>
+                    </a:lnT>
+                    <a:lnB w="9525" cap="flat" cmpd="sng" algn="ctr">
+                      <a:solidFill>
+                        <a:srgbClr val="BFBFBF"/>
+                      </a:solidFill>
+                      <a:prstDash val="solid"/>
+                      <a:round/>
+                      <a:headEnd type="none" w="med" len="med"/>
+                      <a:tailEnd type="none" w="med" len="med"/>
+                    </a:lnB>
+                  </a:tcPr>
+                </a:tc>
+                <a:tc>
+                  <a:txBody>
+                    <a:bodyPr/>
+                    <a:lstStyle/>
+                    <a:p>
+                      <a:pPr indent="0" marL="0">
+                        <a:buNone/>
+                      </a:pPr>
+                      <a:r>
+                        <a:rPr lang="en-US" sz="1500" dirty="0">
+                          <a:solidFill>
+                            <a:schemeClr val="tx1"/>
+                          </a:solidFill>
+                        </a:rPr>
+                        <a:t>System 2 Attention / a "use only if needed" sentence</a:t>
+                      </a:r>
+                      <a:endParaRPr lang="en-US" sz="1500" dirty="0"/>
+                    </a:p>
+                  </a:txBody>
+                  <a:tcPr marL="54864" marR="54864" marT="54864" marB="54864" anchor="ctr">
+                    <a:lnL w="9525" cap="flat" cmpd="sng" algn="ctr">
+                      <a:solidFill>
+                        <a:srgbClr val="BFBFBF"/>
+                      </a:solidFill>
+                      <a:prstDash val="solid"/>
+                      <a:round/>
+                      <a:headEnd type="none" w="med" len="med"/>
+                      <a:tailEnd type="none" w="med" len="med"/>
+                    </a:lnL>
+                    <a:lnR w="9525" cap="flat" cmpd="sng" algn="ctr">
+                      <a:solidFill>
+                        <a:srgbClr val="BFBFBF"/>
+                      </a:solidFill>
+                      <a:prstDash val="solid"/>
+                      <a:round/>
+                      <a:headEnd type="none" w="med" len="med"/>
+                      <a:tailEnd type="none" w="med" len="med"/>
+                    </a:lnR>
+                    <a:lnT w="9525" cap="flat" cmpd="sng" algn="ctr">
+                      <a:solidFill>
+                        <a:srgbClr val="BFBFBF"/>
+                      </a:solidFill>
+                      <a:prstDash val="solid"/>
+                      <a:round/>
+                      <a:headEnd type="none" w="med" len="med"/>
+                      <a:tailEnd type="none" w="med" len="med"/>
+                    </a:lnT>
+                    <a:lnB w="9525" cap="flat" cmpd="sng" algn="ctr">
+                      <a:solidFill>
+                        <a:srgbClr val="BFBFBF"/>
+                      </a:solidFill>
+                      <a:prstDash val="solid"/>
+                      <a:round/>
+                      <a:headEnd type="none" w="med" len="med"/>
+                      <a:tailEnd type="none" w="med" len="med"/>
+                    </a:lnB>
+                  </a:tcPr>
+                </a:tc>
+                <a:tc>
+                  <a:txBody>
+                    <a:bodyPr/>
+                    <a:lstStyle/>
+                    <a:p>
+                      <a:pPr indent="0" marL="0">
+                        <a:buNone/>
+                      </a:pPr>
+                      <a:r>
+                        <a:rPr lang="en-US" sz="1500" dirty="0">
+                          <a:solidFill>
+                            <a:schemeClr val="tx1"/>
+                          </a:solidFill>
+                        </a:rPr>
+                        <a:t>64% / 76%</a:t>
+                      </a:r>
+                      <a:endParaRPr lang="en-US" sz="1500" dirty="0"/>
+                    </a:p>
+                  </a:txBody>
+                  <a:tcPr marL="54864" marR="54864" marT="54864" marB="54864" anchor="ctr">
+                    <a:lnL w="9525" cap="flat" cmpd="sng" algn="ctr">
+                      <a:solidFill>
+                        <a:srgbClr val="BFBFBF"/>
+                      </a:solidFill>
+                      <a:prstDash val="solid"/>
+                      <a:round/>
+                      <a:headEnd type="none" w="med" len="med"/>
+                      <a:tailEnd type="none" w="med" len="med"/>
+                    </a:lnL>
+                    <a:lnR w="9525" cap="flat" cmpd="sng" algn="ctr">
+                      <a:solidFill>
+                        <a:srgbClr val="BFBFBF"/>
+                      </a:solidFill>
+                      <a:prstDash val="solid"/>
+                      <a:round/>
+                      <a:headEnd type="none" w="med" len="med"/>
+                      <a:tailEnd type="none" w="med" len="med"/>
+                    </a:lnR>
+                    <a:lnT w="9525" cap="flat" cmpd="sng" algn="ctr">
+                      <a:solidFill>
+                        <a:srgbClr val="BFBFBF"/>
+                      </a:solidFill>
+                      <a:prstDash val="solid"/>
+                      <a:round/>
+                      <a:headEnd type="none" w="med" len="med"/>
+                      <a:tailEnd type="none" w="med" len="med"/>
+                    </a:lnT>
+                    <a:lnB w="9525" cap="flat" cmpd="sng" algn="ctr">
+                      <a:solidFill>
+                        <a:srgbClr val="BFBFBF"/>
+                      </a:solidFill>
+                      <a:prstDash val="solid"/>
+                      <a:round/>
+                      <a:headEnd type="none" w="med" len="med"/>
+                      <a:tailEnd type="none" w="med" len="med"/>
+                    </a:lnB>
+                  </a:tcPr>
+                </a:tc>
+                <a:tc>
+                  <a:txBody>
+                    <a:bodyPr/>
+                    <a:lstStyle/>
+                    <a:p>
+                      <a:pPr indent="0" marL="0">
+                        <a:buNone/>
+                      </a:pPr>
+                      <a:r>
+                        <a:rPr lang="en-US" sz="1500" b="1" dirty="0">
+                          <a:solidFill>
+                            <a:srgbClr val="38761D"/>
+                          </a:solidFill>
+                        </a:rPr>
+                        <a:t>only the needed tools: 92%</a:t>
+                      </a:r>
+                      <a:endParaRPr lang="en-US" sz="1500" dirty="0"/>
+                    </a:p>
+                  </a:txBody>
+                  <a:tcPr marL="54864" marR="54864" marT="54864" marB="54864" anchor="ctr">
+                    <a:lnL w="9525" cap="flat" cmpd="sng" algn="ctr">
+                      <a:solidFill>
+                        <a:srgbClr val="BFBFBF"/>
+                      </a:solidFill>
+                      <a:prstDash val="solid"/>
+                      <a:round/>
+                      <a:headEnd type="none" w="med" len="med"/>
+                      <a:tailEnd type="none" w="med" len="med"/>
+                    </a:lnL>
+                    <a:lnR w="9525" cap="flat" cmpd="sng" algn="ctr">
+                      <a:solidFill>
+                        <a:srgbClr val="BFBFBF"/>
+                      </a:solidFill>
+                      <a:prstDash val="solid"/>
+                      <a:round/>
+                      <a:headEnd type="none" w="med" len="med"/>
+                      <a:tailEnd type="none" w="med" len="med"/>
+                    </a:lnR>
+                    <a:lnT w="9525" cap="flat" cmpd="sng" algn="ctr">
+                      <a:solidFill>
+                        <a:srgbClr val="BFBFBF"/>
+                      </a:solidFill>
+                      <a:prstDash val="solid"/>
+                      <a:round/>
+                      <a:headEnd type="none" w="med" len="med"/>
+                      <a:tailEnd type="none" w="med" len="med"/>
+                    </a:lnT>
+                    <a:lnB w="9525" cap="flat" cmpd="sng" algn="ctr">
+                      <a:solidFill>
+                        <a:srgbClr val="BFBFBF"/>
+                      </a:solidFill>
+                      <a:prstDash val="solid"/>
+                      <a:round/>
+                      <a:headEnd type="none" w="med" len="med"/>
+                      <a:tailEnd type="none" w="med" len="med"/>
+                    </a:lnB>
+                  </a:tcPr>
+                </a:tc>
+              </a:tr>
+              <a:tr h="566928">
+                <a:tc>
+                  <a:txBody>
+                    <a:bodyPr/>
+                    <a:lstStyle/>
+                    <a:p>
+                      <a:pPr indent="0" marL="0">
+                        <a:buNone/>
+                      </a:pPr>
+                      <a:r>
+                        <a:rPr lang="en-US" sz="1500" dirty="0">
+                          <a:solidFill>
+                            <a:schemeClr val="tx1"/>
+                          </a:solidFill>
+                        </a:rPr>
+                        <a:t>Daily routing</a:t>
+                      </a:r>
+                      <a:endParaRPr lang="en-US" sz="1500" dirty="0"/>
+                    </a:p>
+                  </a:txBody>
+                  <a:tcPr marL="54864" marR="54864" marT="54864" marB="54864" anchor="ctr">
+                    <a:lnL w="9525" cap="flat" cmpd="sng" algn="ctr">
+                      <a:solidFill>
+                        <a:srgbClr val="BFBFBF"/>
+                      </a:solidFill>
+                      <a:prstDash val="solid"/>
+                      <a:round/>
+                      <a:headEnd type="none" w="med" len="med"/>
+                      <a:tailEnd type="none" w="med" len="med"/>
+                    </a:lnL>
+                    <a:lnR w="9525" cap="flat" cmpd="sng" algn="ctr">
+                      <a:solidFill>
+                        <a:srgbClr val="BFBFBF"/>
+                      </a:solidFill>
+                      <a:prstDash val="solid"/>
+                      <a:round/>
+                      <a:headEnd type="none" w="med" len="med"/>
+                      <a:tailEnd type="none" w="med" len="med"/>
+                    </a:lnR>
+                    <a:lnT w="9525" cap="flat" cmpd="sng" algn="ctr">
+                      <a:solidFill>
+                        <a:srgbClr val="BFBFBF"/>
+                      </a:solidFill>
+                      <a:prstDash val="solid"/>
+                      <a:round/>
+                      <a:headEnd type="none" w="med" len="med"/>
+                      <a:tailEnd type="none" w="med" len="med"/>
+                    </a:lnT>
+                    <a:lnB w="9525" cap="flat" cmpd="sng" algn="ctr">
+                      <a:solidFill>
+                        <a:srgbClr val="BFBFBF"/>
+                      </a:solidFill>
+                      <a:prstDash val="solid"/>
+                      <a:round/>
+                      <a:headEnd type="none" w="med" len="med"/>
+                      <a:tailEnd type="none" w="med" len="med"/>
+                    </a:lnB>
+                  </a:tcPr>
+                </a:tc>
+                <a:tc>
+                  <a:txBody>
+                    <a:bodyPr/>
+                    <a:lstStyle/>
+                    <a:p>
+                      <a:pPr indent="0" marL="0">
+                        <a:buNone/>
+                      </a:pPr>
+                      <a:r>
+                        <a:rPr lang="en-US" sz="1500" dirty="0">
+                          <a:solidFill>
+                            <a:schemeClr val="tx1"/>
+                          </a:solidFill>
+                        </a:rPr>
+                        <a:t>Dynamic Cheatsheet: the model's own notes</a:t>
+                      </a:r>
+                      <a:endParaRPr lang="en-US" sz="1500" dirty="0"/>
+                    </a:p>
+                  </a:txBody>
+                  <a:tcPr marL="54864" marR="54864" marT="54864" marB="54864" anchor="ctr">
+                    <a:lnL w="9525" cap="flat" cmpd="sng" algn="ctr">
+                      <a:solidFill>
+                        <a:srgbClr val="BFBFBF"/>
+                      </a:solidFill>
+                      <a:prstDash val="solid"/>
+                      <a:round/>
+                      <a:headEnd type="none" w="med" len="med"/>
+                      <a:tailEnd type="none" w="med" len="med"/>
+                    </a:lnL>
+                    <a:lnR w="9525" cap="flat" cmpd="sng" algn="ctr">
+                      <a:solidFill>
+                        <a:srgbClr val="BFBFBF"/>
+                      </a:solidFill>
+                      <a:prstDash val="solid"/>
+                      <a:round/>
+                      <a:headEnd type="none" w="med" len="med"/>
+                      <a:tailEnd type="none" w="med" len="med"/>
+                    </a:lnR>
+                    <a:lnT w="9525" cap="flat" cmpd="sng" algn="ctr">
+                      <a:solidFill>
+                        <a:srgbClr val="BFBFBF"/>
+                      </a:solidFill>
+                      <a:prstDash val="solid"/>
+                      <a:round/>
+                      <a:headEnd type="none" w="med" len="med"/>
+                      <a:tailEnd type="none" w="med" len="med"/>
+                    </a:lnT>
+                    <a:lnB w="9525" cap="flat" cmpd="sng" algn="ctr">
+                      <a:solidFill>
+                        <a:srgbClr val="BFBFBF"/>
+                      </a:solidFill>
+                      <a:prstDash val="solid"/>
+                      <a:round/>
+                      <a:headEnd type="none" w="med" len="med"/>
+                      <a:tailEnd type="none" w="med" len="med"/>
+                    </a:lnB>
+                  </a:tcPr>
+                </a:tc>
+                <a:tc>
+                  <a:txBody>
+                    <a:bodyPr/>
+                    <a:lstStyle/>
+                    <a:p>
+                      <a:pPr indent="0" marL="0">
+                        <a:buNone/>
+                      </a:pPr>
+                      <a:r>
+                        <a:rPr lang="en-US" sz="1500" dirty="0">
+                          <a:solidFill>
+                            <a:schemeClr val="tx1"/>
+                          </a:solidFill>
+                        </a:rPr>
+                        <a:t>31–40%</a:t>
+                      </a:r>
+                      <a:endParaRPr lang="en-US" sz="1500" dirty="0"/>
+                    </a:p>
+                  </a:txBody>
+                  <a:tcPr marL="54864" marR="54864" marT="54864" marB="54864" anchor="ctr">
+                    <a:lnL w="9525" cap="flat" cmpd="sng" algn="ctr">
+                      <a:solidFill>
+                        <a:srgbClr val="BFBFBF"/>
+                      </a:solidFill>
+                      <a:prstDash val="solid"/>
+                      <a:round/>
+                      <a:headEnd type="none" w="med" len="med"/>
+                      <a:tailEnd type="none" w="med" len="med"/>
+                    </a:lnL>
+                    <a:lnR w="9525" cap="flat" cmpd="sng" algn="ctr">
+                      <a:solidFill>
+                        <a:srgbClr val="BFBFBF"/>
+                      </a:solidFill>
+                      <a:prstDash val="solid"/>
+                      <a:round/>
+                      <a:headEnd type="none" w="med" len="med"/>
+                      <a:tailEnd type="none" w="med" len="med"/>
+                    </a:lnR>
+                    <a:lnT w="9525" cap="flat" cmpd="sng" algn="ctr">
+                      <a:solidFill>
+                        <a:srgbClr val="BFBFBF"/>
+                      </a:solidFill>
+                      <a:prstDash val="solid"/>
+                      <a:round/>
+                      <a:headEnd type="none" w="med" len="med"/>
+                      <a:tailEnd type="none" w="med" len="med"/>
+                    </a:lnT>
+                    <a:lnB w="9525" cap="flat" cmpd="sng" algn="ctr">
+                      <a:solidFill>
+                        <a:srgbClr val="BFBFBF"/>
+                      </a:solidFill>
+                      <a:prstDash val="solid"/>
+                      <a:round/>
+                      <a:headEnd type="none" w="med" len="med"/>
+                      <a:tailEnd type="none" w="med" len="med"/>
+                    </a:lnB>
+                  </a:tcPr>
+                </a:tc>
+                <a:tc>
+                  <a:txBody>
+                    <a:bodyPr/>
+                    <a:lstStyle/>
+                    <a:p>
+                      <a:pPr indent="0" marL="0">
+                        <a:buNone/>
+                      </a:pPr>
+                      <a:r>
+                        <a:rPr lang="en-US" sz="1500" b="1" dirty="0">
+                          <a:solidFill>
+                            <a:srgbClr val="38761D"/>
+                          </a:solidFill>
+                        </a:rPr>
+                        <a:t>reuse a checked program: 94%</a:t>
+                      </a:r>
+                      <a:endParaRPr lang="en-US" sz="1500" dirty="0"/>
+                    </a:p>
+                  </a:txBody>
+                  <a:tcPr marL="54864" marR="54864" marT="54864" marB="54864" anchor="ctr">
+                    <a:lnL w="9525" cap="flat" cmpd="sng" algn="ctr">
+                      <a:solidFill>
+                        <a:srgbClr val="BFBFBF"/>
+                      </a:solidFill>
+                      <a:prstDash val="solid"/>
+                      <a:round/>
+                      <a:headEnd type="none" w="med" len="med"/>
+                      <a:tailEnd type="none" w="med" len="med"/>
+                    </a:lnL>
+                    <a:lnR w="9525" cap="flat" cmpd="sng" algn="ctr">
+                      <a:solidFill>
+                        <a:srgbClr val="BFBFBF"/>
+                      </a:solidFill>
+                      <a:prstDash val="solid"/>
+                      <a:round/>
+                      <a:headEnd type="none" w="med" len="med"/>
+                      <a:tailEnd type="none" w="med" len="med"/>
+                    </a:lnR>
+                    <a:lnT w="9525" cap="flat" cmpd="sng" algn="ctr">
+                      <a:solidFill>
+                        <a:srgbClr val="BFBFBF"/>
+                      </a:solidFill>
+                      <a:prstDash val="solid"/>
+                      <a:round/>
+                      <a:headEnd type="none" w="med" len="med"/>
+                      <a:tailEnd type="none" w="med" len="med"/>
+                    </a:lnT>
+                    <a:lnB w="9525" cap="flat" cmpd="sng" algn="ctr">
+                      <a:solidFill>
+                        <a:srgbClr val="BFBFBF"/>
+                      </a:solidFill>
+                      <a:prstDash val="solid"/>
+                      <a:round/>
+                      <a:headEnd type="none" w="med" len="med"/>
+                      <a:tailEnd type="none" w="med" len="med"/>
+                    </a:lnB>
+                  </a:tcPr>
+                </a:tc>
+              </a:tr>
+            </a:tbl>
+          </a:graphicData>
+        </a:graphic>
+      </p:graphicFrame>
+      <p:sp>
+        <p:nvSpPr>
+          <p:cNvPr id="4" name="Text 1"/>
           <p:cNvSpPr txBox="1"/>
           <p:nvPr/>
         </p:nvSpPr>
@@ -3826,7 +5320,7 @@
                   <a:schemeClr val="tx1"/>
                 </a:solidFill>
               </a:rPr>
-              <a:t>Every claim pre-registered and checked on 3 seeds; accuracy always reported with its token cost</a:t>
+              <a:t>Measured here with the same problems and models: the recipe is more accurate, cheaper, or both</a:t>
             </a:r>
             <a:endParaRPr lang="en-US" sz="2000" dirty="0"/>
           </a:p>
@@ -3872,6 +5366,428 @@
             <a:fld id="{F7021451-1387-4CA6-816F-3879F97B5CBC}" type="slidenum">
               <a:rPr b="0" lang="en-US"/>
               <a:t>11</a:t>
+            </a:fld>
+            <a:endParaRPr lang="en-US"/>
+          </a:p>
+        </p:txBody>
+      </p:sp>
+    </p:spTree>
+  </p:cSld>
+  <p:clrMapOvr>
+    <a:masterClrMapping/>
+  </p:clrMapOvr>
+</p:sld>
+</file>
+
+<file path=ppt/slides/slide12.xml><?xml version="1.0" encoding="utf-8"?>
+<p:sld xmlns:a="http://schemas.openxmlformats.org/drawingml/2006/main" xmlns:r="http://schemas.openxmlformats.org/officeDocument/2006/relationships" xmlns:p="http://schemas.openxmlformats.org/presentationml/2006/main">
+  <p:cSld name="Slide 12">
+    <p:spTree>
+      <p:nvGrpSpPr>
+        <p:cNvPr id="1" name=""/>
+        <p:cNvGrpSpPr/>
+        <p:nvPr/>
+      </p:nvGrpSpPr>
+      <p:grpSpPr>
+        <a:xfrm>
+          <a:off x="0" y="0"/>
+          <a:ext cx="0" cy="0"/>
+          <a:chOff x="0" y="0"/>
+          <a:chExt cx="0" cy="0"/>
+        </a:xfrm>
+      </p:grpSpPr>
+      <p:sp>
+        <p:nvSpPr>
+          <p:cNvPr id="2" name="Text 0"/>
+          <p:cNvSpPr/>
+          <p:nvPr>
+            <p:ph idx="100" type="title" hasCustomPrompt="1"/>
+          </p:nvPr>
+        </p:nvSpPr>
+        <p:spPr>
+          <a:xfrm>
+            <a:off x="548640" y="274320"/>
+            <a:ext cx="11064240" cy="914400"/>
+          </a:xfrm>
+          <a:prstGeom prst="rect">
+            <a:avLst/>
+          </a:prstGeom>
+          <a:noFill/>
+          <a:ln/>
+        </p:spPr>
+        <p:txBody>
+          <a:bodyPr wrap="square" rtlCol="0" anchor="ctr"/>
+          <a:lstStyle/>
+          <a:p>
+            <a:pPr algn="l" indent="0" marL="0">
+              <a:buNone/>
+            </a:pPr>
+            <a:r>
+              <a:rPr lang="en-US" sz="3600" dirty="0">
+                <a:solidFill>
+                  <a:schemeClr val="tx1"/>
+                </a:solidFill>
+              </a:rPr>
+              <a:t>Where the recipe stops, and what is next</a:t>
+            </a:r>
+            <a:endParaRPr lang="en-US" sz="3600" dirty="0"/>
+          </a:p>
+        </p:txBody>
+      </p:sp>
+      <p:sp>
+        <p:nvSpPr>
+          <p:cNvPr id="3" name="Where it stops"/>
+          <p:cNvSpPr/>
+          <p:nvPr/>
+        </p:nvSpPr>
+        <p:spPr>
+          <a:xfrm>
+            <a:off x="548640" y="1417320"/>
+            <a:ext cx="5440680" cy="3749040"/>
+          </a:xfrm>
+          <a:prstGeom prst="roundRect">
+            <a:avLst>
+              <a:gd name="adj" fmla="val 1951"/>
+            </a:avLst>
+          </a:prstGeom>
+          <a:solidFill>
+            <a:srgbClr val="F2F2F2"/>
+          </a:solidFill>
+          <a:ln w="9525">
+            <a:solidFill>
+              <a:srgbClr val="D9D9D9"/>
+            </a:solidFill>
+            <a:prstDash val="solid"/>
+          </a:ln>
+        </p:spPr>
+      </p:sp>
+      <p:sp>
+        <p:nvSpPr>
+          <p:cNvPr id="4" name="Text 2"/>
+          <p:cNvSpPr txBox="1"/>
+          <p:nvPr/>
+        </p:nvSpPr>
+        <p:spPr>
+          <a:xfrm>
+            <a:off x="822960" y="1554480"/>
+            <a:ext cx="4892040" cy="548640"/>
+          </a:xfrm>
+          <a:prstGeom prst="rect">
+            <a:avLst/>
+          </a:prstGeom>
+          <a:noFill/>
+          <a:ln/>
+        </p:spPr>
+        <p:txBody>
+          <a:bodyPr wrap="square" lIns="0" tIns="0" rIns="0" bIns="0" rtlCol="0" anchor="ctr"/>
+          <a:lstStyle/>
+          <a:p>
+            <a:pPr indent="0" marL="0">
+              <a:buNone/>
+            </a:pPr>
+            <a:r>
+              <a:rPr lang="en-US" sz="2600" b="1" dirty="0">
+                <a:solidFill>
+                  <a:srgbClr val="C00000"/>
+                </a:solidFill>
+              </a:rPr>
+              <a:t>Where it stops</a:t>
+            </a:r>
+            <a:endParaRPr lang="en-US" sz="2600" dirty="0"/>
+          </a:p>
+        </p:txBody>
+      </p:sp>
+      <p:sp>
+        <p:nvSpPr>
+          <p:cNvPr id="5" name="Text 3"/>
+          <p:cNvSpPr txBox="1"/>
+          <p:nvPr/>
+        </p:nvSpPr>
+        <p:spPr>
+          <a:xfrm>
+            <a:off x="822960" y="2194560"/>
+            <a:ext cx="4892040" cy="2834640"/>
+          </a:xfrm>
+          <a:prstGeom prst="rect">
+            <a:avLst/>
+          </a:prstGeom>
+          <a:noFill/>
+          <a:ln/>
+        </p:spPr>
+        <p:txBody>
+          <a:bodyPr wrap="square" lIns="635" tIns="635" rIns="635" bIns="635" rtlCol="0" anchor="t"/>
+          <a:lstStyle/>
+          <a:p>
+            <a:pPr marL="342900" indent="-342900">
+              <a:spcAft>
+                <a:spcPts val="800"/>
+              </a:spcAft>
+              <a:buSzPct val="100000"/>
+              <a:buChar char="•"/>
+            </a:pPr>
+            <a:r>
+              <a:rPr lang="en-US" sz="1700" dirty="0">
+                <a:solidFill>
+                  <a:schemeClr val="tx1"/>
+                </a:solidFill>
+              </a:rPr>
+              <a:t>Missing knowledge that is not a library fact: Lean proofs, factual questions. Thinking cannot add it (+2–5 points at 70–200× tokens)</a:t>
+            </a:r>
+            <a:endParaRPr lang="en-US" sz="1700" dirty="0"/>
+          </a:p>
+          <a:p>
+            <a:pPr marL="342900" indent="-342900">
+              <a:spcAft>
+                <a:spcPts val="800"/>
+              </a:spcAft>
+              <a:buSzPct val="100000"/>
+              <a:buChar char="•"/>
+            </a:pPr>
+            <a:r>
+              <a:rPr lang="en-US" sz="1700" dirty="0">
+                <a:solidFill>
+                  <a:schemeClr val="tx1"/>
+                </a:solidFill>
+              </a:rPr>
+              <a:t>Checks leak: 24–37% of wrong contest programs pass the examples</a:t>
+            </a:r>
+            <a:endParaRPr lang="en-US" sz="1700" dirty="0"/>
+          </a:p>
+          <a:p>
+            <a:pPr marL="342900" indent="-342900">
+              <a:spcAft>
+                <a:spcPts val="800"/>
+              </a:spcAft>
+              <a:buSzPct val="100000"/>
+              <a:buChar char="•"/>
+            </a:pPr>
+            <a:r>
+              <a:rPr lang="en-US" sz="1700" dirty="0">
+                <a:solidFill>
+                  <a:schemeClr val="tx1"/>
+                </a:solidFill>
+              </a:rPr>
+              <a:t>Facts were hand-written; automatic retrieval keeps most of the gain (84% vs 87%)</a:t>
+            </a:r>
+            <a:endParaRPr lang="en-US" sz="1700" dirty="0"/>
+          </a:p>
+        </p:txBody>
+      </p:sp>
+      <p:sp>
+        <p:nvSpPr>
+          <p:cNvPr id="6" name="Next"/>
+          <p:cNvSpPr/>
+          <p:nvPr/>
+        </p:nvSpPr>
+        <p:spPr>
+          <a:xfrm>
+            <a:off x="6172200" y="1417320"/>
+            <a:ext cx="5440680" cy="3749040"/>
+          </a:xfrm>
+          <a:prstGeom prst="roundRect">
+            <a:avLst>
+              <a:gd name="adj" fmla="val 1951"/>
+            </a:avLst>
+          </a:prstGeom>
+          <a:solidFill>
+            <a:srgbClr val="F2F2F2"/>
+          </a:solidFill>
+          <a:ln w="9525">
+            <a:solidFill>
+              <a:srgbClr val="D9D9D9"/>
+            </a:solidFill>
+            <a:prstDash val="solid"/>
+          </a:ln>
+        </p:spPr>
+      </p:sp>
+      <p:sp>
+        <p:nvSpPr>
+          <p:cNvPr id="7" name="Text 5"/>
+          <p:cNvSpPr txBox="1"/>
+          <p:nvPr/>
+        </p:nvSpPr>
+        <p:spPr>
+          <a:xfrm>
+            <a:off x="6446520" y="1554480"/>
+            <a:ext cx="4892040" cy="548640"/>
+          </a:xfrm>
+          <a:prstGeom prst="rect">
+            <a:avLst/>
+          </a:prstGeom>
+          <a:noFill/>
+          <a:ln/>
+        </p:spPr>
+        <p:txBody>
+          <a:bodyPr wrap="square" lIns="0" tIns="0" rIns="0" bIns="0" rtlCol="0" anchor="ctr"/>
+          <a:lstStyle/>
+          <a:p>
+            <a:pPr indent="0" marL="0">
+              <a:buNone/>
+            </a:pPr>
+            <a:r>
+              <a:rPr lang="en-US" sz="2600" b="1" dirty="0">
+                <a:solidFill>
+                  <a:srgbClr val="4472C4"/>
+                </a:solidFill>
+              </a:rPr>
+              <a:t>Next</a:t>
+            </a:r>
+            <a:endParaRPr lang="en-US" sz="2600" dirty="0"/>
+          </a:p>
+        </p:txBody>
+      </p:sp>
+      <p:sp>
+        <p:nvSpPr>
+          <p:cNvPr id="8" name="Text 6"/>
+          <p:cNvSpPr txBox="1"/>
+          <p:nvPr/>
+        </p:nvSpPr>
+        <p:spPr>
+          <a:xfrm>
+            <a:off x="6446520" y="2194560"/>
+            <a:ext cx="4892040" cy="2834640"/>
+          </a:xfrm>
+          <a:prstGeom prst="rect">
+            <a:avLst/>
+          </a:prstGeom>
+          <a:noFill/>
+          <a:ln/>
+        </p:spPr>
+        <p:txBody>
+          <a:bodyPr wrap="square" lIns="635" tIns="635" rIns="635" bIns="635" rtlCol="0" anchor="t"/>
+          <a:lstStyle/>
+          <a:p>
+            <a:pPr marL="342900" indent="-342900">
+              <a:spcAft>
+                <a:spcPts val="800"/>
+              </a:spcAft>
+              <a:buSzPct val="100000"/>
+              <a:buChar char="•"/>
+            </a:pPr>
+            <a:r>
+              <a:rPr lang="en-US" sz="1700" dirty="0">
+                <a:solidFill>
+                  <a:schemeClr val="tx1"/>
+                </a:solidFill>
+              </a:rPr>
+              <a:t>Contest geometry on one 24 GB GPU (gpt-oss-20b, running)</a:t>
+            </a:r>
+            <a:endParaRPr lang="en-US" sz="1700" dirty="0"/>
+          </a:p>
+          <a:p>
+            <a:pPr marL="342900" indent="-342900">
+              <a:spcAft>
+                <a:spcPts val="800"/>
+              </a:spcAft>
+              <a:buSzPct val="100000"/>
+              <a:buChar char="•"/>
+            </a:pPr>
+            <a:r>
+              <a:rPr lang="en-US" sz="1700" dirty="0">
+                <a:solidFill>
+                  <a:schemeClr val="tx1"/>
+                </a:solidFill>
+              </a:rPr>
+              <a:t>Competition math for small models (running)</a:t>
+            </a:r>
+            <a:endParaRPr lang="en-US" sz="1700" dirty="0"/>
+          </a:p>
+          <a:p>
+            <a:pPr marL="342900" indent="-342900">
+              <a:spcAft>
+                <a:spcPts val="800"/>
+              </a:spcAft>
+              <a:buSzPct val="100000"/>
+              <a:buChar char="•"/>
+            </a:pPr>
+            <a:r>
+              <a:rPr lang="en-US" sz="1700" dirty="0">
+                <a:solidFill>
+                  <a:schemeClr val="tx1"/>
+                </a:solidFill>
+              </a:rPr>
+              <a:t>Facts found automatically; a commercial model; final report</a:t>
+            </a:r>
+            <a:endParaRPr lang="en-US" sz="1700" dirty="0"/>
+          </a:p>
+        </p:txBody>
+      </p:sp>
+      <p:sp>
+        <p:nvSpPr>
+          <p:cNvPr id="9" name="Text 7"/>
+          <p:cNvSpPr txBox="1"/>
+          <p:nvPr/>
+        </p:nvSpPr>
+        <p:spPr>
+          <a:xfrm>
+            <a:off x="548640" y="5669280"/>
+            <a:ext cx="11064240" cy="548640"/>
+          </a:xfrm>
+          <a:prstGeom prst="rect">
+            <a:avLst/>
+          </a:prstGeom>
+          <a:noFill/>
+          <a:ln/>
+        </p:spPr>
+        <p:txBody>
+          <a:bodyPr wrap="square" lIns="0" tIns="0" rIns="0" bIns="0" rtlCol="0" anchor="ctr"/>
+          <a:lstStyle/>
+          <a:p>
+            <a:pPr algn="ctr" indent="0" marL="0">
+              <a:buNone/>
+            </a:pPr>
+            <a:r>
+              <a:rPr lang="en-US" sz="2000" dirty="0">
+                <a:solidFill>
+                  <a:schemeClr val="tx1"/>
+                </a:solidFill>
+              </a:rPr>
+              <a:t>Every claim pre-registered and checked on 3 seeds; accuracy always reported with its token cost</a:t>
+            </a:r>
+            <a:endParaRPr lang="en-US" sz="2000" dirty="0"/>
+          </a:p>
+        </p:txBody>
+      </p:sp>
+      <p:sp>
+        <p:nvSpPr>
+          <p:cNvPr id="25" name="Slide Number Placeholder 0"/>
+          <p:cNvSpPr>
+            <a:spLocks noGrp="1"/>
+          </p:cNvSpPr>
+          <p:nvPr>
+            <p:ph type="sldNum" sz="quarter" idx="4294967295"/>
+          </p:nvPr>
+        </p:nvSpPr>
+        <p:spPr>
+          <a:xfrm>
+            <a:off x="11155680" y="6355080"/>
+            <a:ext cx="731520" cy="320040"/>
+          </a:xfrm>
+          <a:prstGeom prst="rect">
+            <a:avLst/>
+          </a:prstGeom>
+          <a:extLst>
+            <a:ext uri="{C572A759-6A51-4108-AA02-DFA0A04FC94B}">
+              <ma14:wrappingTextBoxFlag xmlns:ma14="http://schemas.microsoft.com/office/mac/drawingml/2011/main" val="0"/>
+            </a:ext>
+          </a:extLst>
+        </p:spPr>
+        <p:txBody>
+          <a:bodyPr/>
+          <a:lstStyle>
+            <a:lvl1pPr>
+              <a:defRPr sz="1200">
+                <a:solidFill>
+                  <a:srgbClr val="8C8C8C"/>
+                </a:solidFill>
+              </a:defRPr>
+            </a:lvl1pPr>
+          </a:lstStyle>
+          <a:p>
+            <a:pPr algn="r"/>
+            <a:fld id="{F7021451-1387-4CA6-816F-3879F97B5CBC}" type="slidenum">
+              <a:rPr b="0" lang="en-US"/>
+              <a:t>12</a:t>
             </a:fld>
             <a:endParaRPr lang="en-US"/>
           </a:p>

</xml_diff>

<commit_message>
Proposal and slides: a real example and an example picture for every finding
- Findings 1-7 (both languages): real outputs as examples (Qwen3-1.7B's invented Solver.SUCCESS,
  Qwen3-14B hull 6 vs 0, Find Color passing the examples, Qwen3-8B MAMO crash fixed by its own mined
  program, Goedel vs Qwen3-32B on a miniF2F statement) and pictures exported from the slides
  (figs/ex_finding1-7.png, poc/export_slide_figs.py)
- a worked "one problem through the recipe" and how the 30-label policy choice works
- slides 10-11 show the Finding 6 and Finding 7 examples

Co-Authored-By: Claude Opus 5.5 (1M context) <noreply@anthropic.com>
</commit_message>
<xml_diff>
--- a/PROPOSAL_slides.pptx
+++ b/PROPOSAL_slides.pptx
@@ -121,14 +121,14 @@
   <p:extLst>
     <p:ext uri="{521415D9-36F7-43E2-AB2F-B90AF26B5E84}">
       <p14:sectionLst xmlns:p14="http://schemas.microsoft.com/office/powerpoint/2010/main">
-        <p14:section name="Problem" id="{4531564a-6ba8-2054-2d87-bc244cf19d14}">
+        <p14:section name="Problem" id="{99a347ab-6550-1287-97a9-bdb1ce8a384d}">
           <p14:sldIdLst>
             <p14:sldId id="256"/>
             <p14:sldId id="257"/>
             <p14:sldId id="258"/>
           </p14:sldIdLst>
         </p14:section>
-        <p14:section name="Findings" id="{94e9b725-0529-b868-a3d8-de53ca038228}">
+        <p14:section name="Findings" id="{bb1219d0-9c3b-d5be-56c3-897a83acd7d8}">
           <p14:sldIdLst>
             <p14:sldId id="259"/>
             <p14:sldId id="260"/>
@@ -140,14 +140,14 @@
             <p14:sldId id="266"/>
           </p14:sldIdLst>
         </p14:section>
-        <p14:section name="Method" id="{e8c8f24c-5ffa-4003-297c-203e028f56b7}">
+        <p14:section name="Method" id="{bf9f908b-e08a-1e2c-47ce-42be63ddd5b4}">
           <p14:sldIdLst>
             <p14:sldId id="267"/>
             <p14:sldId id="268"/>
             <p14:sldId id="269"/>
           </p14:sldIdLst>
         </p14:section>
-        <p14:section name="Next" id="{9784a0b6-b428-caf2-0744-c9b08dc62af9}">
+        <p14:section name="Next" id="{b8bec9de-2351-4136-19b2-f9b358c3cf4b}">
           <p14:sldIdLst>
             <p14:sldId id="270"/>
           </p14:sldIdLst>
@@ -539,7 +539,7 @@
           <a:lstStyle/>
           <a:p>
             <a:pPr>
-              <a:defRPr sz="1400" b="0" i="0" u="none" strike="noStrike">
+              <a:defRPr sz="1300" b="0" i="0" u="none" strike="noStrike">
                 <a:solidFill>
                   <a:srgbClr val="404040"/>
                 </a:solidFill>
@@ -547,13 +547,13 @@
               </a:defRPr>
             </a:pPr>
             <a:r>
-              <a:rPr sz="1400" b="0" i="0" u="none" strike="noStrike">
+              <a:rPr sz="1300" b="0" i="0" u="none" strike="noStrike">
                 <a:solidFill>
                   <a:srgbClr val="404040"/>
                 </a:solidFill>
                 <a:latin typeface="+mn-lt"/>
               </a:rPr>
-              <a:t>MAMO: 863 word problems we never used before (% solved)</a:t>
+              <a:t>MAMO, 863 problems never used before: % solved</a:t>
             </a:r>
           </a:p>
         </c:rich>
@@ -596,7 +596,7 @@
               <a:lstStyle/>
               <a:p>
                 <a:pPr>
-                  <a:defRPr b="0" i="0" strike="noStrike" sz="1200" u="none">
+                  <a:defRPr b="0" i="0" strike="noStrike" sz="1100" u="none">
                     <a:solidFill>
                       <a:srgbClr val="000000"/>
                     </a:solidFill>
@@ -623,7 +623,7 @@
                     <c:v>gpt-oss-20b</c:v>
                   </c:pt>
                   <c:pt idx="1">
-                    <c:v>Qwen3-14B (4-bit)</c:v>
+                    <c:v>Qwen3-14B</c:v>
                   </c:pt>
                   <c:pt idx="2">
                     <c:v>Qwen3-8B</c:v>
@@ -660,7 +660,7 @@
               <c:strCache>
                 <c:ptCount val="1"/>
                 <c:pt idx="0">
-                  <c:v>hand-written fact</c:v>
+                  <c:v>hand-written</c:v>
                 </c:pt>
               </c:strCache>
             </c:strRef>
@@ -679,7 +679,7 @@
               <a:lstStyle/>
               <a:p>
                 <a:pPr>
-                  <a:defRPr b="0" i="0" strike="noStrike" sz="1200" u="none">
+                  <a:defRPr b="0" i="0" strike="noStrike" sz="1100" u="none">
                     <a:solidFill>
                       <a:srgbClr val="000000"/>
                     </a:solidFill>
@@ -706,7 +706,7 @@
                     <c:v>gpt-oss-20b</c:v>
                   </c:pt>
                   <c:pt idx="1">
-                    <c:v>Qwen3-14B (4-bit)</c:v>
+                    <c:v>Qwen3-14B</c:v>
                   </c:pt>
                   <c:pt idx="2">
                     <c:v>Qwen3-8B</c:v>
@@ -743,7 +743,7 @@
               <c:strCache>
                 <c:ptCount val="1"/>
                 <c:pt idx="0">
-                  <c:v>found automatically</c:v>
+                  <c:v>automatic</c:v>
                 </c:pt>
               </c:strCache>
             </c:strRef>
@@ -762,7 +762,7 @@
               <a:lstStyle/>
               <a:p>
                 <a:pPr>
-                  <a:defRPr b="0" i="0" strike="noStrike" sz="1200" u="none">
+                  <a:defRPr b="0" i="0" strike="noStrike" sz="1100" u="none">
                     <a:solidFill>
                       <a:srgbClr val="000000"/>
                     </a:solidFill>
@@ -789,7 +789,7 @@
                     <c:v>gpt-oss-20b</c:v>
                   </c:pt>
                   <c:pt idx="1">
-                    <c:v>Qwen3-14B (4-bit)</c:v>
+                    <c:v>Qwen3-14B</c:v>
                   </c:pt>
                   <c:pt idx="2">
                     <c:v>Qwen3-8B</c:v>
@@ -824,7 +824,7 @@
             <a:lstStyle/>
             <a:p>
               <a:pPr>
-                <a:defRPr b="0" i="0" strike="noStrike" sz="1200" u="none">
+                <a:defRPr b="0" i="0" strike="noStrike" sz="1100" u="none">
                   <a:solidFill>
                     <a:srgbClr val="000000"/>
                   </a:solidFill>
@@ -872,7 +872,7 @@
           <a:lstStyle/>
           <a:p>
             <a:pPr>
-              <a:defRPr sz="1300" b="0" i="0" u="none" strike="noStrike">
+              <a:defRPr sz="1200" b="0" i="0" u="none" strike="noStrike">
                 <a:solidFill>
                   <a:srgbClr val="404040"/>
                 </a:solidFill>
@@ -926,7 +926,7 @@
           <a:lstStyle/>
           <a:p>
             <a:pPr>
-              <a:defRPr sz="1100" b="0" i="0" u="none" strike="noStrike">
+              <a:defRPr sz="1000" b="0" i="0" u="none" strike="noStrike">
                 <a:solidFill>
                   <a:srgbClr val="595959"/>
                 </a:solidFill>
@@ -956,7 +956,7 @@
         <a:lstStyle/>
         <a:p>
           <a:pPr>
-            <a:defRPr sz="1300">
+            <a:defRPr sz="1200">
               <a:latin typeface="+mn-lt"/>
               <a:cs typeface="+mn-lt"/>
             </a:defRPr>
@@ -1464,7 +1464,7 @@
           <a:p>
             <a:r>
               <a:rPr lang="en-US" dirty="0"/>
-              <a:t>X6-AUTO / X6-VER / X7. The fact is the model's own shortest program from NL4OPT / IndustryOR that passed the label-free check (it runs and prints a value); no answers, no human. On the held-out MAMO benchmark the recipe (two programs with this fact, think only if they disagree) matches the hand-written snippet: gpt-oss-20b 78.8 vs 78.9% (within 1.2 points on 3 seeds), Qwen3-14B-AWQ 71.7 vs 71.4%, Qwen3-8B 71.0 vs 72.0%. It stays within a problem family: a program of another problem type is 14-21 points below the hand-written fact on the optimization suite, and an introspected list of the library's names hurts (Qwen3-32B 66.2 to 56.1%).</a:t>
+              <a:t>Real outputs, Qwen3-8B on MAMO easy-189 (gold 20000). Without a fact it writes solver.Objective().Minimize() and crashes (AttributeError). The fact is chosen automatically: its own shortest program from NL4OPT (a vans-and-trucks problem) that passed the label-free check (it runs and prints a value); no answers, no human. With it, both programs write solver.Minimize(10*x + 15*y + 20*z) and print 20000 (316 + 312 tokens), they agree, so no thinking is needed (thinking alone: 5,323 tokens). Chart: on the held-out MAMO the automatic fact matches the hand-written one (gpt-oss-20b within 1.2 points on 3 seeds). It stays within a problem family: a program of another problem type is 14-21 points below the hand-written fact on the optimization suite, and an introspected list of names hurts (Qwen3-32B 66.2 to 56.1%).</a:t>
             </a:r>
             <a:endParaRPr lang="en-US" dirty="0"/>
           </a:p>
@@ -1552,7 +1552,7 @@
           <a:p>
             <a:r>
               <a:rPr lang="en-US" dirty="0"/>
-              <a:t>PREREG_PROOF. miniF2F test (244), 8 attempts, Lean 4 + Mathlib compiler as the exact check. Specialized provers that fit a 24 GB GPU prove the most and rarely invent lemma names (6-7% of failed attempts vs 22-40%). For general models a verified proof of the most similar statement (Qwen3.6 133 vs 133; gpt-oss-20b 65 vs 66), thinking (Qwen3.6 129), or a 10-line inequality toolkit (21 vs 24 of 50 bound statements) does not help; even for the provers, revising a failed proof from Lean's error lines proves half as many as a fresh attempt (Goedel 11 vs 22 of 107; DeepSeek 5 vs 13 of 112). Geometry: AlphaGeometry's DD+AR engine alone proves 12 of IMO-AG-30 and 187 of JGEX-AG-231; auxiliary points proposed by gpt-oss-20b add 13 JGEX problems; only IMO 2014 P4 is unlocked by any model's proposal.</a:t>
+              <a:t>Real outputs. miniF2F mathd_numbertheory_34 (9^-1 mod 100 = 89). Qwen3-32B's 8 attempts all fail; they cite lemmas that do not exist, e.g. Nat.ModEq_iff_modEq. Goedel-Prover-V2-8B proves it by checking every x below 100 (interval_cases, then norm_num and omega). Specialized provers rarely invent names (6-7% of failed attempts vs 22-40%). For general models a verified proof of the most similar statement, thinking, or an inequality toolkit does not help; even for provers, revising from Lean's errors proves half as many as a fresh attempt (Goedel 11 vs 22 of 107). Geometry: AlphaGeometry's DD+AR engine alone proves 12 of IMO-AG-30 and 187 of JGEX-AG-231; LLM auxiliary points add 13 JGEX problems and only IMO 2014 P4 (d = midpoint of b c).</a:t>
             </a:r>
             <a:endParaRPr lang="en-US" dirty="0"/>
           </a:p>
@@ -3572,19 +3572,89 @@
       </p:sp>
       <p:sp>
         <p:nvSpPr>
-          <p:cNvPr id="3" name="box solve other problems"/>
-          <p:cNvSpPr/>
-          <p:nvPr/>
-        </p:nvSpPr>
-        <p:spPr>
-          <a:xfrm>
-            <a:off x="548640" y="1325880"/>
-            <a:ext cx="3383280" cy="731520"/>
-          </a:xfrm>
-          <a:prstGeom prst="roundRect">
-            <a:avLst>
-              <a:gd name="adj" fmla="val 7500"/>
-            </a:avLst>
+          <p:cNvPr id="3" name="Text 1"/>
+          <p:cNvSpPr txBox="1"/>
+          <p:nvPr/>
+        </p:nvSpPr>
+        <p:spPr>
+          <a:xfrm>
+            <a:off x="548640" y="1188720"/>
+            <a:ext cx="11064240" cy="411480"/>
+          </a:xfrm>
+          <a:prstGeom prst="rect">
+            <a:avLst/>
+          </a:prstGeom>
+          <a:noFill/>
+          <a:ln/>
+        </p:spPr>
+        <p:txBody>
+          <a:bodyPr wrap="square" lIns="0" tIns="0" rIns="0" bIns="0" rtlCol="0" anchor="ctr"/>
+          <a:lstStyle/>
+          <a:p>
+            <a:pPr indent="0" marL="0">
+              <a:buNone/>
+            </a:pPr>
+            <a:r>
+              <a:rPr lang="en-US" sz="1600" dirty="0">
+                <a:solidFill>
+                  <a:schemeClr val="tx1"/>
+                </a:solidFill>
+              </a:rPr>
+              <a:t>Example (Qwen3-8B, MAMO): products X, Y, Z cost $10, $15, $20; X+Y ≤ 5000, Y+Z ≤ 4000, X+Z ≥ 2000. Minimum cost? (20000)</a:t>
+            </a:r>
+            <a:endParaRPr lang="en-US" sz="1600" dirty="0"/>
+          </a:p>
+        </p:txBody>
+      </p:sp>
+      <p:sp>
+        <p:nvSpPr>
+          <p:cNvPr id="4" name="Text 2"/>
+          <p:cNvSpPr txBox="1"/>
+          <p:nvPr/>
+        </p:nvSpPr>
+        <p:spPr>
+          <a:xfrm>
+            <a:off x="548640" y="1691640"/>
+            <a:ext cx="6126480" cy="320040"/>
+          </a:xfrm>
+          <a:prstGeom prst="rect">
+            <a:avLst/>
+          </a:prstGeom>
+          <a:noFill/>
+          <a:ln/>
+        </p:spPr>
+        <p:txBody>
+          <a:bodyPr wrap="square" lIns="0" tIns="0" rIns="0" bIns="0" rtlCol="0" anchor="ctr"/>
+          <a:lstStyle/>
+          <a:p>
+            <a:pPr indent="0" marL="0">
+              <a:buNone/>
+            </a:pPr>
+            <a:r>
+              <a:rPr lang="en-US" sz="1500" b="1" dirty="0">
+                <a:solidFill>
+                  <a:schemeClr val="tx1"/>
+                </a:solidFill>
+              </a:rPr>
+              <a:t>No fact</a:t>
+            </a:r>
+            <a:endParaRPr lang="en-US" sz="1500" dirty="0"/>
+          </a:p>
+        </p:txBody>
+      </p:sp>
+      <p:sp>
+        <p:nvSpPr>
+          <p:cNvPr id="5" name="code solver.Objective().M"/>
+          <p:cNvSpPr/>
+          <p:nvPr/>
+        </p:nvSpPr>
+        <p:spPr>
+          <a:xfrm>
+            <a:off x="548640" y="2011680"/>
+            <a:ext cx="4023360" cy="457200"/>
+          </a:xfrm>
+          <a:prstGeom prst="rect">
+            <a:avLst/>
           </a:prstGeom>
           <a:solidFill>
             <a:srgbClr val="FFFFFF"/>
@@ -3599,14 +3669,14 @@
       </p:sp>
       <p:sp>
         <p:nvSpPr>
-          <p:cNvPr id="4" name="Text 2"/>
-          <p:cNvSpPr txBox="1"/>
-          <p:nvPr/>
-        </p:nvSpPr>
-        <p:spPr>
-          <a:xfrm>
-            <a:off x="621792" y="1325880"/>
-            <a:ext cx="3236976" cy="731520"/>
+          <p:cNvPr id="6" name="Text 4"/>
+          <p:cNvSpPr txBox="1"/>
+          <p:nvPr/>
+        </p:nvSpPr>
+        <p:spPr>
+          <a:xfrm>
+            <a:off x="658368" y="2011680"/>
+            <a:ext cx="3803904" cy="457200"/>
           </a:xfrm>
           <a:prstGeom prst="rect">
             <a:avLst/>
@@ -3618,71 +3688,23 @@
           <a:bodyPr wrap="square" lIns="0" tIns="0" rIns="0" bIns="0" rtlCol="0" anchor="ctr"/>
           <a:lstStyle/>
           <a:p>
-            <a:pPr algn="ctr" indent="0" marL="0">
-              <a:buNone/>
-            </a:pPr>
-            <a:r>
-              <a:rPr lang="en-US" sz="1500" dirty="0">
-                <a:solidFill>
-                  <a:schemeClr val="tx1"/>
-                </a:solidFill>
-              </a:rPr>
-              <a:t>solve other problems of the same kind (another benchmark)</a:t>
-            </a:r>
-            <a:endParaRPr lang="en-US" sz="1500" dirty="0"/>
-          </a:p>
-        </p:txBody>
-      </p:sp>
-      <p:sp>
-        <p:nvSpPr>
-          <p:cNvPr id="5" name="Shape 3"/>
-          <p:cNvSpPr/>
-          <p:nvPr/>
-        </p:nvSpPr>
-        <p:spPr>
-          <a:xfrm>
-            <a:off x="3931920" y="1691640"/>
-            <a:ext cx="411480" cy="0"/>
-          </a:xfrm>
-          <a:prstGeom prst="line">
-            <a:avLst/>
-          </a:prstGeom>
-          <a:noFill/>
-          <a:ln w="25400">
-            <a:solidFill>
-              <a:srgbClr val="7F7F7F"/>
-            </a:solidFill>
-            <a:prstDash val="solid"/>
-            <a:tailEnd type="triangle"/>
-          </a:ln>
-        </p:spPr>
-      </p:sp>
-      <p:sp>
-        <p:nvSpPr>
-          <p:cNvPr id="6" name="box keep the model's sho"/>
-          <p:cNvSpPr/>
-          <p:nvPr/>
-        </p:nvSpPr>
-        <p:spPr>
-          <a:xfrm>
-            <a:off x="4343400" y="1325880"/>
-            <a:ext cx="3566160" cy="731520"/>
-          </a:xfrm>
-          <a:prstGeom prst="roundRect">
-            <a:avLst>
-              <a:gd name="adj" fmla="val 7500"/>
-            </a:avLst>
-          </a:prstGeom>
-          <a:solidFill>
-            <a:srgbClr val="DEEBF7"/>
-          </a:solidFill>
-          <a:ln w="9525">
-            <a:solidFill>
-              <a:srgbClr val="BFBFBF"/>
-            </a:solidFill>
-            <a:prstDash val="solid"/>
-          </a:ln>
-        </p:spPr>
+            <a:pPr indent="0" marL="0">
+              <a:buNone/>
+            </a:pPr>
+            <a:r>
+              <a:rPr lang="en-US" sz="1300" dirty="0">
+                <a:solidFill>
+                  <a:srgbClr val="C00000"/>
+                </a:solidFill>
+                <a:latin typeface="Courier New" pitchFamily="34" charset="0"/>
+                <a:ea typeface="Courier New" pitchFamily="34" charset="-122"/>
+                <a:cs typeface="Courier New" pitchFamily="34" charset="-120"/>
+              </a:rPr>
+              <a:t>solver.Objective().Minimize()</a:t>
+            </a:r>
+            <a:endParaRPr lang="en-US" sz="1300" dirty="0"/>
+          </a:p>
+        </p:txBody>
       </p:sp>
       <p:sp>
         <p:nvSpPr>
@@ -3692,8 +3714,8 @@
         </p:nvSpPr>
         <p:spPr>
           <a:xfrm>
-            <a:off x="4416552" y="1325880"/>
-            <a:ext cx="3419856" cy="731520"/>
+            <a:off x="4709160" y="2011680"/>
+            <a:ext cx="2011680" cy="457200"/>
           </a:xfrm>
           <a:prstGeom prst="rect">
             <a:avLst/>
@@ -3705,60 +3727,34 @@
           <a:bodyPr wrap="square" lIns="0" tIns="0" rIns="0" bIns="0" rtlCol="0" anchor="ctr"/>
           <a:lstStyle/>
           <a:p>
-            <a:pPr algn="ctr" indent="0" marL="0">
-              <a:buNone/>
-            </a:pPr>
-            <a:r>
-              <a:rPr lang="en-US" sz="1500" dirty="0">
-                <a:solidFill>
-                  <a:schemeClr val="tx1"/>
-                </a:solidFill>
-              </a:rPr>
-              <a:t>keep the model's shortest program that passed the free check</a:t>
-            </a:r>
-            <a:endParaRPr lang="en-US" sz="1500" dirty="0"/>
-          </a:p>
-        </p:txBody>
-      </p:sp>
-      <p:sp>
-        <p:nvSpPr>
-          <p:cNvPr id="8" name="Shape 6"/>
-          <p:cNvSpPr/>
-          <p:nvPr/>
-        </p:nvSpPr>
-        <p:spPr>
-          <a:xfrm>
-            <a:off x="7909560" y="1691640"/>
-            <a:ext cx="411480" cy="0"/>
-          </a:xfrm>
-          <a:prstGeom prst="line">
-            <a:avLst/>
-          </a:prstGeom>
-          <a:noFill/>
-          <a:ln w="25400">
-            <a:solidFill>
-              <a:srgbClr val="7F7F7F"/>
-            </a:solidFill>
-            <a:prstDash val="solid"/>
-            <a:tailEnd type="triangle"/>
-          </a:ln>
-        </p:spPr>
-      </p:sp>
-      <p:sp>
-        <p:nvSpPr>
-          <p:cNvPr id="9" name="box show it as the fact "/>
-          <p:cNvSpPr/>
-          <p:nvPr/>
-        </p:nvSpPr>
-        <p:spPr>
-          <a:xfrm>
-            <a:off x="8321040" y="1325880"/>
-            <a:ext cx="3291840" cy="731520"/>
-          </a:xfrm>
-          <a:prstGeom prst="roundRect">
-            <a:avLst>
-              <a:gd name="adj" fmla="val 7500"/>
-            </a:avLst>
+            <a:pPr indent="0" marL="0">
+              <a:buNone/>
+            </a:pPr>
+            <a:r>
+              <a:rPr lang="en-US" sz="1400" b="1" dirty="0">
+                <a:solidFill>
+                  <a:srgbClr val="C00000"/>
+                </a:solidFill>
+              </a:rPr>
+              <a:t>✗ crash: no such method</a:t>
+            </a:r>
+            <a:endParaRPr lang="en-US" sz="1400" dirty="0"/>
+          </a:p>
+        </p:txBody>
+      </p:sp>
+      <p:sp>
+        <p:nvSpPr>
+          <p:cNvPr id="8" name="prompt The fact: its own program for another problem (vans and trucks) that passed the free check"/>
+          <p:cNvSpPr/>
+          <p:nvPr/>
+        </p:nvSpPr>
+        <p:spPr>
+          <a:xfrm>
+            <a:off x="548640" y="2651760"/>
+            <a:ext cx="6126480" cy="1325880"/>
+          </a:xfrm>
+          <a:prstGeom prst="rect">
+            <a:avLst/>
           </a:prstGeom>
           <a:solidFill>
             <a:srgbClr val="E2F0D9"/>
@@ -3773,14 +3769,121 @@
       </p:sp>
       <p:sp>
         <p:nvSpPr>
+          <p:cNvPr id="9" name="Text 7"/>
+          <p:cNvSpPr txBox="1"/>
+          <p:nvPr/>
+        </p:nvSpPr>
+        <p:spPr>
+          <a:xfrm>
+            <a:off x="658368" y="2706624"/>
+            <a:ext cx="5907024" cy="1216152"/>
+          </a:xfrm>
+          <a:prstGeom prst="rect">
+            <a:avLst/>
+          </a:prstGeom>
+          <a:noFill/>
+          <a:ln/>
+        </p:spPr>
+        <p:txBody>
+          <a:bodyPr wrap="square" lIns="0" tIns="0" rIns="0" bIns="0" rtlCol="0" anchor="t"/>
+          <a:lstStyle/>
+          <a:p>
+            <a:pPr indent="0" marL="0">
+              <a:buNone/>
+            </a:pPr>
+            <a:r>
+              <a:rPr lang="en-US" sz="1400" b="1" dirty="0">
+                <a:solidFill>
+                  <a:schemeClr val="tx1"/>
+                </a:solidFill>
+                <a:latin typeface="Calibri" pitchFamily="34" charset="0"/>
+                <a:ea typeface="Calibri" pitchFamily="34" charset="-122"/>
+                <a:cs typeface="Calibri" pitchFamily="34" charset="-120"/>
+              </a:rPr>
+              <a:t>The fact: its own program for another problem (vans and trucks) that passed the free check</a:t>
+            </a:r>
+            <a:endParaRPr lang="en-US" sz="1150" dirty="0"/>
+          </a:p>
+          <a:p>
+            <a:pPr indent="0" marL="0">
+              <a:buNone/>
+            </a:pPr>
+            <a:r>
+              <a:rPr lang="en-US" sz="1150" dirty="0">
+                <a:solidFill>
+                  <a:schemeClr val="tx1"/>
+                </a:solidFill>
+                <a:latin typeface="Courier New" pitchFamily="34" charset="0"/>
+                <a:ea typeface="Courier New" pitchFamily="34" charset="-122"/>
+                <a:cs typeface="Courier New" pitchFamily="34" charset="-120"/>
+              </a:rPr>
+              <a:t>solver = pywraplp.Solver.CreateSolver('SCIP')</a:t>
+            </a:r>
+            <a:endParaRPr lang="en-US" sz="1150" dirty="0"/>
+          </a:p>
+          <a:p>
+            <a:pPr indent="0" marL="0">
+              <a:buNone/>
+            </a:pPr>
+            <a:r>
+              <a:rPr lang="en-US" sz="1150" dirty="0">
+                <a:solidFill>
+                  <a:schemeClr val="tx1"/>
+                </a:solidFill>
+                <a:latin typeface="Courier New" pitchFamily="34" charset="0"/>
+                <a:ea typeface="Courier New" pitchFamily="34" charset="-122"/>
+                <a:cs typeface="Courier New" pitchFamily="34" charset="-120"/>
+              </a:rPr>
+              <a:t>v = solver.IntVar(0, solver.infinity(), 'v')</a:t>
+            </a:r>
+            <a:endParaRPr lang="en-US" sz="1150" dirty="0"/>
+          </a:p>
+          <a:p>
+            <a:pPr indent="0" marL="0">
+              <a:buNone/>
+            </a:pPr>
+            <a:r>
+              <a:rPr lang="en-US" sz="1150" dirty="0">
+                <a:solidFill>
+                  <a:schemeClr val="tx1"/>
+                </a:solidFill>
+                <a:latin typeface="Courier New" pitchFamily="34" charset="0"/>
+                <a:ea typeface="Courier New" pitchFamily="34" charset="-122"/>
+                <a:cs typeface="Courier New" pitchFamily="34" charset="-120"/>
+              </a:rPr>
+              <a:t>solver.Minimize(v)</a:t>
+            </a:r>
+            <a:endParaRPr lang="en-US" sz="1150" dirty="0"/>
+          </a:p>
+          <a:p>
+            <a:pPr indent="0" marL="0">
+              <a:buNone/>
+            </a:pPr>
+            <a:r>
+              <a:rPr lang="en-US" sz="1150" dirty="0">
+                <a:solidFill>
+                  <a:schemeClr val="tx1"/>
+                </a:solidFill>
+                <a:latin typeface="Courier New" pitchFamily="34" charset="0"/>
+                <a:ea typeface="Courier New" pitchFamily="34" charset="-122"/>
+                <a:cs typeface="Courier New" pitchFamily="34" charset="-120"/>
+              </a:rPr>
+              <a:t>status = solver.Solve()</a:t>
+            </a:r>
+            <a:endParaRPr lang="en-US" sz="1150" dirty="0"/>
+          </a:p>
+        </p:txBody>
+      </p:sp>
+      <p:sp>
+        <p:nvSpPr>
           <p:cNvPr id="10" name="Text 8"/>
           <p:cNvSpPr txBox="1"/>
           <p:nvPr/>
         </p:nvSpPr>
         <p:spPr>
           <a:xfrm>
-            <a:off x="8394192" y="1325880"/>
-            <a:ext cx="3145536" cy="731520"/>
+            <a:off x="548640" y="4114800"/>
+            <a:ext cx="6126480" cy="320040"/>
           </a:xfrm>
           <a:prstGeom prst="rect">
             <a:avLst/>
@@ -3792,30 +3895,130 @@
           <a:bodyPr wrap="square" lIns="0" tIns="0" rIns="0" bIns="0" rtlCol="0" anchor="ctr"/>
           <a:lstStyle/>
           <a:p>
-            <a:pPr algn="ctr" indent="0" marL="0">
-              <a:buNone/>
-            </a:pPr>
-            <a:r>
-              <a:rPr lang="en-US" sz="1500" dirty="0">
+            <a:pPr indent="0" marL="0">
+              <a:buNone/>
+            </a:pPr>
+            <a:r>
+              <a:rPr lang="en-US" sz="1500" b="1" dirty="0">
                 <a:solidFill>
                   <a:schemeClr val="tx1"/>
                 </a:solidFill>
               </a:rPr>
-              <a:t>show it as the fact for new problems</a:t>
+              <a:t>With the fact (written twice; both agree, so no thinking)</a:t>
             </a:r>
             <a:endParaRPr lang="en-US" sz="1500" dirty="0"/>
+          </a:p>
+        </p:txBody>
+      </p:sp>
+      <p:sp>
+        <p:nvSpPr>
+          <p:cNvPr id="11" name="code solver.Minimize(10*x"/>
+          <p:cNvSpPr/>
+          <p:nvPr/>
+        </p:nvSpPr>
+        <p:spPr>
+          <a:xfrm>
+            <a:off x="548640" y="4434840"/>
+            <a:ext cx="4023360" cy="457200"/>
+          </a:xfrm>
+          <a:prstGeom prst="rect">
+            <a:avLst/>
+          </a:prstGeom>
+          <a:solidFill>
+            <a:srgbClr val="FFFFFF"/>
+          </a:solidFill>
+          <a:ln w="9525">
+            <a:solidFill>
+              <a:srgbClr val="BFBFBF"/>
+            </a:solidFill>
+            <a:prstDash val="solid"/>
+          </a:ln>
+        </p:spPr>
+      </p:sp>
+      <p:sp>
+        <p:nvSpPr>
+          <p:cNvPr id="12" name="Text 10"/>
+          <p:cNvSpPr txBox="1"/>
+          <p:nvPr/>
+        </p:nvSpPr>
+        <p:spPr>
+          <a:xfrm>
+            <a:off x="658368" y="4434840"/>
+            <a:ext cx="3803904" cy="457200"/>
+          </a:xfrm>
+          <a:prstGeom prst="rect">
+            <a:avLst/>
+          </a:prstGeom>
+          <a:noFill/>
+          <a:ln/>
+        </p:spPr>
+        <p:txBody>
+          <a:bodyPr wrap="square" lIns="0" tIns="0" rIns="0" bIns="0" rtlCol="0" anchor="ctr"/>
+          <a:lstStyle/>
+          <a:p>
+            <a:pPr indent="0" marL="0">
+              <a:buNone/>
+            </a:pPr>
+            <a:r>
+              <a:rPr lang="en-US" sz="1300" dirty="0">
+                <a:solidFill>
+                  <a:srgbClr val="70AD47"/>
+                </a:solidFill>
+                <a:latin typeface="Courier New" pitchFamily="34" charset="0"/>
+                <a:ea typeface="Courier New" pitchFamily="34" charset="-122"/>
+                <a:cs typeface="Courier New" pitchFamily="34" charset="-120"/>
+              </a:rPr>
+              <a:t>solver.Minimize(10*x + 15*y + 20*z)</a:t>
+            </a:r>
+            <a:endParaRPr lang="en-US" sz="1300" dirty="0"/>
+          </a:p>
+        </p:txBody>
+      </p:sp>
+      <p:sp>
+        <p:nvSpPr>
+          <p:cNvPr id="13" name="Text 11"/>
+          <p:cNvSpPr txBox="1"/>
+          <p:nvPr/>
+        </p:nvSpPr>
+        <p:spPr>
+          <a:xfrm>
+            <a:off x="4709160" y="4434840"/>
+            <a:ext cx="2194560" cy="457200"/>
+          </a:xfrm>
+          <a:prstGeom prst="rect">
+            <a:avLst/>
+          </a:prstGeom>
+          <a:noFill/>
+          <a:ln/>
+        </p:spPr>
+        <p:txBody>
+          <a:bodyPr wrap="square" lIns="0" tIns="0" rIns="0" bIns="0" rtlCol="0" anchor="ctr"/>
+          <a:lstStyle/>
+          <a:p>
+            <a:pPr indent="0" marL="0">
+              <a:buNone/>
+            </a:pPr>
+            <a:r>
+              <a:rPr lang="en-US" sz="1300" b="1" dirty="0">
+                <a:solidFill>
+                  <a:srgbClr val="70AD47"/>
+                </a:solidFill>
+              </a:rPr>
+              <a:t>✓ 20000 · 0.6k tokens (thinking: 5.3k)</a:t>
+            </a:r>
+            <a:endParaRPr lang="en-US" sz="1300" dirty="0"/>
           </a:p>
         </p:txBody>
       </p:sp>
       <p:graphicFrame>
         <p:nvGraphicFramePr>
-          <p:cNvPr id="11" name="automatic fact on held-out MAMO" descr=""/>
+          <p:cNvPr id="14" name="automatic fact on held-out MAMO" descr=""/>
           <p:cNvGraphicFramePr/>
           <p:nvPr/>
         </p:nvGraphicFramePr>
         <p:xfrm>
-          <a:off x="548640" y="2240280"/>
-          <a:ext cx="7040880" cy="3291840"/>
+          <a:off x="7040880" y="1691640"/>
+          <a:ext cx="4572000" cy="3291840"/>
         </p:xfrm>
         <a:graphic xmlns:a="http://schemas.openxmlformats.org/drawingml/2006/main">
           <a:graphicData uri="http://schemas.openxmlformats.org/drawingml/2006/chart">
@@ -3825,128 +4028,43 @@
       </p:graphicFrame>
       <p:sp>
         <p:nvSpPr>
-          <p:cNvPr id="12" name="what does not work"/>
-          <p:cNvSpPr/>
-          <p:nvPr/>
-        </p:nvSpPr>
-        <p:spPr>
-          <a:xfrm>
-            <a:off x="7863840" y="2331720"/>
-            <a:ext cx="3749040" cy="3154680"/>
-          </a:xfrm>
-          <a:prstGeom prst="roundRect">
-            <a:avLst>
-              <a:gd name="adj" fmla="val 2319"/>
-            </a:avLst>
-          </a:prstGeom>
-          <a:solidFill>
-            <a:srgbClr val="F2F2F2"/>
-          </a:solidFill>
-          <a:ln w="9525">
-            <a:solidFill>
-              <a:srgbClr val="D9D9D9"/>
-            </a:solidFill>
-            <a:prstDash val="solid"/>
-          </a:ln>
-        </p:spPr>
-      </p:sp>
-      <p:sp>
-        <p:nvSpPr>
-          <p:cNvPr id="13" name="Text 10"/>
-          <p:cNvSpPr txBox="1"/>
-          <p:nvPr/>
-        </p:nvSpPr>
-        <p:spPr>
-          <a:xfrm>
-            <a:off x="8092440" y="2468880"/>
-            <a:ext cx="3291840" cy="411480"/>
-          </a:xfrm>
-          <a:prstGeom prst="rect">
-            <a:avLst/>
-          </a:prstGeom>
-          <a:noFill/>
-          <a:ln/>
-        </p:spPr>
-        <p:txBody>
-          <a:bodyPr wrap="square" lIns="0" tIns="0" rIns="0" bIns="0" rtlCol="0" anchor="ctr"/>
+          <p:cNvPr id="15" name="Text 12"/>
+          <p:cNvSpPr txBox="1"/>
+          <p:nvPr/>
+        </p:nvSpPr>
+        <p:spPr>
+          <a:xfrm>
+            <a:off x="7040880" y="5029200"/>
+            <a:ext cx="4572000" cy="548640"/>
+          </a:xfrm>
+          <a:prstGeom prst="rect">
+            <a:avLst/>
+          </a:prstGeom>
+          <a:noFill/>
+          <a:ln/>
+        </p:spPr>
+        <p:txBody>
+          <a:bodyPr wrap="square" lIns="0" tIns="0" rIns="0" bIns="0" rtlCol="0" anchor="t"/>
           <a:lstStyle/>
           <a:p>
             <a:pPr indent="0" marL="0">
               <a:buNone/>
             </a:pPr>
             <a:r>
-              <a:rPr lang="en-US" sz="1800" b="1" dirty="0">
+              <a:rPr lang="en-US" sz="1300" dirty="0">
                 <a:solidFill>
                   <a:srgbClr val="C00000"/>
                 </a:solidFill>
               </a:rPr>
-              <a:t>What does not work</a:t>
-            </a:r>
-            <a:endParaRPr lang="en-US" sz="1800" dirty="0"/>
-          </a:p>
-        </p:txBody>
-      </p:sp>
-      <p:sp>
-        <p:nvSpPr>
-          <p:cNvPr id="14" name="Text 11"/>
-          <p:cNvSpPr txBox="1"/>
-          <p:nvPr/>
-        </p:nvSpPr>
-        <p:spPr>
-          <a:xfrm>
-            <a:off x="8092440" y="2971800"/>
-            <a:ext cx="3291840" cy="2377440"/>
-          </a:xfrm>
-          <a:prstGeom prst="rect">
-            <a:avLst/>
-          </a:prstGeom>
-          <a:noFill/>
-          <a:ln/>
-        </p:spPr>
-        <p:txBody>
-          <a:bodyPr wrap="square" lIns="635" tIns="635" rIns="635" bIns="635" rtlCol="0" anchor="t"/>
-          <a:lstStyle/>
-          <a:p>
-            <a:pPr marL="342900" indent="-342900">
-              <a:spcAft>
-                <a:spcPts val="800"/>
-              </a:spcAft>
-              <a:buSzPct val="100000"/>
-              <a:buChar char="•"/>
-            </a:pPr>
-            <a:r>
-              <a:rPr lang="en-US" sz="1600" dirty="0">
-                <a:solidFill>
-                  <a:schemeClr val="tx1"/>
-                </a:solidFill>
-              </a:rPr>
-              <a:t>a program from a different problem type: 14–21 points worse</a:t>
-            </a:r>
-            <a:endParaRPr lang="en-US" sz="1600" dirty="0"/>
-          </a:p>
-          <a:p>
-            <a:pPr marL="342900" indent="-342900">
-              <a:spcAft>
-                <a:spcPts val="800"/>
-              </a:spcAft>
-              <a:buSzPct val="100000"/>
-              <a:buChar char="•"/>
-            </a:pPr>
-            <a:r>
-              <a:rPr lang="en-US" sz="1600" dirty="0">
-                <a:solidFill>
-                  <a:schemeClr val="tx1"/>
-                </a:solidFill>
-              </a:rPr>
-              <a:t>a list of the library's names: Qwen3-32B 66% → 56%</a:t>
-            </a:r>
-            <a:endParaRPr lang="en-US" sz="1600" dirty="0"/>
-          </a:p>
-        </p:txBody>
-      </p:sp>
-      <p:sp>
-        <p:nvSpPr>
-          <p:cNvPr id="15" name="Text 12"/>
+              <a:t>Does not work: a program of a different problem type (−14 to −21 points); a list of the library's names (66% → 56%)</a:t>
+            </a:r>
+            <a:endParaRPr lang="en-US" sz="1300" dirty="0"/>
+          </a:p>
+        </p:txBody>
+      </p:sp>
+      <p:sp>
+        <p:nvSpPr>
+          <p:cNvPr id="16" name="Text 13"/>
           <p:cNvSpPr txBox="1"/>
           <p:nvPr/>
         </p:nvSpPr>
@@ -3974,7 +4092,7 @@
                   <a:schemeClr val="tx1"/>
                 </a:solidFill>
               </a:rPr>
-              <a:t>Automatic = hand-written within about 1 point, with no human in the loop</a:t>
+              <a:t>No human writes the fact: the model's own checked program shows the right call</a:t>
             </a:r>
             <a:endParaRPr lang="en-US" sz="2000" dirty="0"/>
           </a:p>
@@ -4096,8 +4214,8 @@
         </p:nvSpPr>
         <p:spPr>
           <a:xfrm>
-            <a:off x="548640" y="1234440"/>
-            <a:ext cx="7223760" cy="411480"/>
+            <a:off x="548640" y="1188720"/>
+            <a:ext cx="6035040" cy="411480"/>
           </a:xfrm>
           <a:prstGeom prst="rect">
             <a:avLst/>
@@ -4113,27 +4231,52 @@
               <a:buNone/>
             </a:pPr>
             <a:r>
-              <a:rPr lang="en-US" sz="1700" b="1" dirty="0">
+              <a:rPr lang="en-US" sz="1600" dirty="0">
                 <a:solidFill>
                   <a:schemeClr val="tx1"/>
                 </a:solidFill>
               </a:rPr>
-              <a:t>Lean 4 proofs of competition statements (miniF2F, 244), 8 tries each: % proved</a:t>
-            </a:r>
-            <a:endParaRPr lang="en-US" sz="1700" dirty="0"/>
-          </a:p>
-        </p:txBody>
-      </p:sp>
-      <p:sp>
-        <p:nvSpPr>
-          <p:cNvPr id="4" name="Text 2"/>
-          <p:cNvSpPr txBox="1"/>
-          <p:nvPr/>
-        </p:nvSpPr>
-        <p:spPr>
-          <a:xfrm>
-            <a:off x="548640" y="1737360"/>
-            <a:ext cx="2651760" cy="424282"/>
+              <a:t>Example (miniF2F): show that if x &lt; 100 and 9x mod 100 = 1, then x = 89</a:t>
+            </a:r>
+            <a:endParaRPr lang="en-US" sz="1600" dirty="0"/>
+          </a:p>
+        </p:txBody>
+      </p:sp>
+      <p:sp>
+        <p:nvSpPr>
+          <p:cNvPr id="4" name="code theorem (x : ℕ) (h₀ "/>
+          <p:cNvSpPr/>
+          <p:nvPr/>
+        </p:nvSpPr>
+        <p:spPr>
+          <a:xfrm>
+            <a:off x="548640" y="1645920"/>
+            <a:ext cx="6035040" cy="457200"/>
+          </a:xfrm>
+          <a:prstGeom prst="rect">
+            <a:avLst/>
+          </a:prstGeom>
+          <a:solidFill>
+            <a:srgbClr val="FFFFFF"/>
+          </a:solidFill>
+          <a:ln w="9525">
+            <a:solidFill>
+              <a:srgbClr val="BFBFBF"/>
+            </a:solidFill>
+            <a:prstDash val="solid"/>
+          </a:ln>
+        </p:spPr>
+      </p:sp>
+      <p:sp>
+        <p:nvSpPr>
+          <p:cNvPr id="5" name="Text 3"/>
+          <p:cNvSpPr txBox="1"/>
+          <p:nvPr/>
+        </p:nvSpPr>
+        <p:spPr>
+          <a:xfrm>
+            <a:off x="658368" y="1645920"/>
+            <a:ext cx="5815584" cy="457200"/>
           </a:xfrm>
           <a:prstGeom prst="rect">
             <a:avLst/>
@@ -4145,6 +4288,353 @@
           <a:bodyPr wrap="square" lIns="0" tIns="0" rIns="0" bIns="0" rtlCol="0" anchor="ctr"/>
           <a:lstStyle/>
           <a:p>
+            <a:pPr indent="0" marL="0">
+              <a:buNone/>
+            </a:pPr>
+            <a:r>
+              <a:rPr lang="en-US" sz="1200" dirty="0">
+                <a:solidFill>
+                  <a:schemeClr val="tx1"/>
+                </a:solidFill>
+                <a:latin typeface="Courier New" pitchFamily="34" charset="0"/>
+                <a:ea typeface="Courier New" pitchFamily="34" charset="-122"/>
+                <a:cs typeface="Courier New" pitchFamily="34" charset="-120"/>
+              </a:rPr>
+              <a:t>theorem (x : ℕ) (h₀ : x &lt; 100) (h₁ : x * 9 % 100 = 1) : x = 89</a:t>
+            </a:r>
+            <a:endParaRPr lang="en-US" sz="1200" dirty="0"/>
+          </a:p>
+        </p:txBody>
+      </p:sp>
+      <p:sp>
+        <p:nvSpPr>
+          <p:cNvPr id="6" name="Text 4"/>
+          <p:cNvSpPr txBox="1"/>
+          <p:nvPr/>
+        </p:nvSpPr>
+        <p:spPr>
+          <a:xfrm>
+            <a:off x="548640" y="2240280"/>
+            <a:ext cx="6035040" cy="320040"/>
+          </a:xfrm>
+          <a:prstGeom prst="rect">
+            <a:avLst/>
+          </a:prstGeom>
+          <a:noFill/>
+          <a:ln/>
+        </p:spPr>
+        <p:txBody>
+          <a:bodyPr wrap="square" lIns="0" tIns="0" rIns="0" bIns="0" rtlCol="0" anchor="ctr"/>
+          <a:lstStyle/>
+          <a:p>
+            <a:pPr indent="0" marL="0">
+              <a:buNone/>
+            </a:pPr>
+            <a:r>
+              <a:rPr lang="en-US" sz="1500" b="1" dirty="0">
+                <a:solidFill>
+                  <a:schemeClr val="tx1"/>
+                </a:solidFill>
+              </a:rPr>
+              <a:t>General model (Qwen3-32B)</a:t>
+            </a:r>
+            <a:endParaRPr lang="en-US" sz="1500" dirty="0"/>
+          </a:p>
+        </p:txBody>
+      </p:sp>
+      <p:sp>
+        <p:nvSpPr>
+          <p:cNvPr id="7" name="code ... Nat.ModEq_iff_mo"/>
+          <p:cNvSpPr/>
+          <p:nvPr/>
+        </p:nvSpPr>
+        <p:spPr>
+          <a:xfrm>
+            <a:off x="548640" y="2560320"/>
+            <a:ext cx="3291840" cy="457200"/>
+          </a:xfrm>
+          <a:prstGeom prst="rect">
+            <a:avLst/>
+          </a:prstGeom>
+          <a:solidFill>
+            <a:srgbClr val="FFFFFF"/>
+          </a:solidFill>
+          <a:ln w="9525">
+            <a:solidFill>
+              <a:srgbClr val="BFBFBF"/>
+            </a:solidFill>
+            <a:prstDash val="solid"/>
+          </a:ln>
+        </p:spPr>
+      </p:sp>
+      <p:sp>
+        <p:nvSpPr>
+          <p:cNvPr id="8" name="Text 6"/>
+          <p:cNvSpPr txBox="1"/>
+          <p:nvPr/>
+        </p:nvSpPr>
+        <p:spPr>
+          <a:xfrm>
+            <a:off x="658368" y="2560320"/>
+            <a:ext cx="3072384" cy="457200"/>
+          </a:xfrm>
+          <a:prstGeom prst="rect">
+            <a:avLst/>
+          </a:prstGeom>
+          <a:noFill/>
+          <a:ln/>
+        </p:spPr>
+        <p:txBody>
+          <a:bodyPr wrap="square" lIns="0" tIns="0" rIns="0" bIns="0" rtlCol="0" anchor="ctr"/>
+          <a:lstStyle/>
+          <a:p>
+            <a:pPr indent="0" marL="0">
+              <a:buNone/>
+            </a:pPr>
+            <a:r>
+              <a:rPr lang="en-US" sz="1300" dirty="0">
+                <a:solidFill>
+                  <a:srgbClr val="C00000"/>
+                </a:solidFill>
+                <a:latin typeface="Courier New" pitchFamily="34" charset="0"/>
+                <a:ea typeface="Courier New" pitchFamily="34" charset="-122"/>
+                <a:cs typeface="Courier New" pitchFamily="34" charset="-120"/>
+              </a:rPr>
+              <a:t>... Nat.ModEq_iff_modEq ...</a:t>
+            </a:r>
+            <a:endParaRPr lang="en-US" sz="1300" dirty="0"/>
+          </a:p>
+        </p:txBody>
+      </p:sp>
+      <p:sp>
+        <p:nvSpPr>
+          <p:cNvPr id="9" name="Text 7"/>
+          <p:cNvSpPr txBox="1"/>
+          <p:nvPr/>
+        </p:nvSpPr>
+        <p:spPr>
+          <a:xfrm>
+            <a:off x="3977640" y="2560320"/>
+            <a:ext cx="2651760" cy="457200"/>
+          </a:xfrm>
+          <a:prstGeom prst="rect">
+            <a:avLst/>
+          </a:prstGeom>
+          <a:noFill/>
+          <a:ln/>
+        </p:spPr>
+        <p:txBody>
+          <a:bodyPr wrap="square" lIns="0" tIns="0" rIns="0" bIns="0" rtlCol="0" anchor="ctr"/>
+          <a:lstStyle/>
+          <a:p>
+            <a:pPr indent="0" marL="0">
+              <a:buNone/>
+            </a:pPr>
+            <a:r>
+              <a:rPr lang="en-US" sz="1400" b="1" dirty="0">
+                <a:solidFill>
+                  <a:srgbClr val="C00000"/>
+                </a:solidFill>
+              </a:rPr>
+              <a:t>✗ no such lemma in the library</a:t>
+            </a:r>
+            <a:endParaRPr lang="en-US" sz="1400" dirty="0"/>
+          </a:p>
+        </p:txBody>
+      </p:sp>
+      <p:sp>
+        <p:nvSpPr>
+          <p:cNvPr id="10" name="Text 8"/>
+          <p:cNvSpPr txBox="1"/>
+          <p:nvPr/>
+        </p:nvSpPr>
+        <p:spPr>
+          <a:xfrm>
+            <a:off x="548640" y="3154680"/>
+            <a:ext cx="6035040" cy="320040"/>
+          </a:xfrm>
+          <a:prstGeom prst="rect">
+            <a:avLst/>
+          </a:prstGeom>
+          <a:noFill/>
+          <a:ln/>
+        </p:spPr>
+        <p:txBody>
+          <a:bodyPr wrap="square" lIns="0" tIns="0" rIns="0" bIns="0" rtlCol="0" anchor="ctr"/>
+          <a:lstStyle/>
+          <a:p>
+            <a:pPr indent="0" marL="0">
+              <a:buNone/>
+            </a:pPr>
+            <a:r>
+              <a:rPr lang="en-US" sz="1500" b="1" dirty="0">
+                <a:solidFill>
+                  <a:schemeClr val="tx1"/>
+                </a:solidFill>
+              </a:rPr>
+              <a:t>Specialized prover (Goedel-Prover-V2-8B)</a:t>
+            </a:r>
+            <a:endParaRPr lang="en-US" sz="1500" dirty="0"/>
+          </a:p>
+        </p:txBody>
+      </p:sp>
+      <p:sp>
+        <p:nvSpPr>
+          <p:cNvPr id="11" name="code interval_cases x &lt;;&gt;"/>
+          <p:cNvSpPr/>
+          <p:nvPr/>
+        </p:nvSpPr>
+        <p:spPr>
+          <a:xfrm>
+            <a:off x="548640" y="3474720"/>
+            <a:ext cx="4754880" cy="457200"/>
+          </a:xfrm>
+          <a:prstGeom prst="rect">
+            <a:avLst/>
+          </a:prstGeom>
+          <a:solidFill>
+            <a:srgbClr val="FFFFFF"/>
+          </a:solidFill>
+          <a:ln w="9525">
+            <a:solidFill>
+              <a:srgbClr val="BFBFBF"/>
+            </a:solidFill>
+            <a:prstDash val="solid"/>
+          </a:ln>
+        </p:spPr>
+      </p:sp>
+      <p:sp>
+        <p:nvSpPr>
+          <p:cNvPr id="12" name="Text 10"/>
+          <p:cNvSpPr txBox="1"/>
+          <p:nvPr/>
+        </p:nvSpPr>
+        <p:spPr>
+          <a:xfrm>
+            <a:off x="658368" y="3474720"/>
+            <a:ext cx="4535424" cy="457200"/>
+          </a:xfrm>
+          <a:prstGeom prst="rect">
+            <a:avLst/>
+          </a:prstGeom>
+          <a:noFill/>
+          <a:ln/>
+        </p:spPr>
+        <p:txBody>
+          <a:bodyPr wrap="square" lIns="0" tIns="0" rIns="0" bIns="0" rtlCol="0" anchor="ctr"/>
+          <a:lstStyle/>
+          <a:p>
+            <a:pPr indent="0" marL="0">
+              <a:buNone/>
+            </a:pPr>
+            <a:r>
+              <a:rPr lang="en-US" sz="1200" dirty="0">
+                <a:solidFill>
+                  <a:srgbClr val="70AD47"/>
+                </a:solidFill>
+                <a:latin typeface="Courier New" pitchFamily="34" charset="0"/>
+                <a:ea typeface="Courier New" pitchFamily="34" charset="-122"/>
+                <a:cs typeface="Courier New" pitchFamily="34" charset="-120"/>
+              </a:rPr>
+              <a:t>interval_cases x &lt;;&gt; norm_num at h₁ ⊢ &lt;;&gt; omega</a:t>
+            </a:r>
+            <a:endParaRPr lang="en-US" sz="1200" dirty="0"/>
+          </a:p>
+        </p:txBody>
+      </p:sp>
+      <p:sp>
+        <p:nvSpPr>
+          <p:cNvPr id="13" name="Text 11"/>
+          <p:cNvSpPr txBox="1"/>
+          <p:nvPr/>
+        </p:nvSpPr>
+        <p:spPr>
+          <a:xfrm>
+            <a:off x="5394960" y="3474720"/>
+            <a:ext cx="1371600" cy="457200"/>
+          </a:xfrm>
+          <a:prstGeom prst="rect">
+            <a:avLst/>
+          </a:prstGeom>
+          <a:noFill/>
+          <a:ln/>
+        </p:spPr>
+        <p:txBody>
+          <a:bodyPr wrap="square" lIns="0" tIns="0" rIns="0" bIns="0" rtlCol="0" anchor="ctr"/>
+          <a:lstStyle/>
+          <a:p>
+            <a:pPr indent="0" marL="0">
+              <a:buNone/>
+            </a:pPr>
+            <a:r>
+              <a:rPr lang="en-US" sz="1400" b="1" dirty="0">
+                <a:solidFill>
+                  <a:srgbClr val="70AD47"/>
+                </a:solidFill>
+              </a:rPr>
+              <a:t>✓ tries all 100 x</a:t>
+            </a:r>
+            <a:endParaRPr lang="en-US" sz="1400" dirty="0"/>
+          </a:p>
+        </p:txBody>
+      </p:sp>
+      <p:sp>
+        <p:nvSpPr>
+          <p:cNvPr id="14" name="Text 12"/>
+          <p:cNvSpPr txBox="1"/>
+          <p:nvPr/>
+        </p:nvSpPr>
+        <p:spPr>
+          <a:xfrm>
+            <a:off x="6949440" y="1188720"/>
+            <a:ext cx="4663440" cy="411480"/>
+          </a:xfrm>
+          <a:prstGeom prst="rect">
+            <a:avLst/>
+          </a:prstGeom>
+          <a:noFill/>
+          <a:ln/>
+        </p:spPr>
+        <p:txBody>
+          <a:bodyPr wrap="square" lIns="0" tIns="0" rIns="0" bIns="0" rtlCol="0" anchor="ctr"/>
+          <a:lstStyle/>
+          <a:p>
+            <a:pPr indent="0" marL="0">
+              <a:buNone/>
+            </a:pPr>
+            <a:r>
+              <a:rPr lang="en-US" sz="1500" b="1" dirty="0">
+                <a:solidFill>
+                  <a:schemeClr val="tx1"/>
+                </a:solidFill>
+              </a:rPr>
+              <a:t>244 statements, 8 tries each: % proved</a:t>
+            </a:r>
+            <a:endParaRPr lang="en-US" sz="1500" dirty="0"/>
+          </a:p>
+        </p:txBody>
+      </p:sp>
+      <p:sp>
+        <p:nvSpPr>
+          <p:cNvPr id="15" name="Text 13"/>
+          <p:cNvSpPr txBox="1"/>
+          <p:nvPr/>
+        </p:nvSpPr>
+        <p:spPr>
+          <a:xfrm>
+            <a:off x="6949440" y="1645920"/>
+            <a:ext cx="1828800" cy="365760"/>
+          </a:xfrm>
+          <a:prstGeom prst="rect">
+            <a:avLst/>
+          </a:prstGeom>
+          <a:noFill/>
+          <a:ln/>
+        </p:spPr>
+        <p:txBody>
+          <a:bodyPr wrap="square" lIns="0" tIns="0" rIns="0" bIns="0" rtlCol="0" anchor="ctr"/>
+          <a:lstStyle/>
+          <a:p>
             <a:pPr algn="r" indent="0" marL="0">
               <a:buNone/>
             </a:pPr>
@@ -4162,14 +4652,14 @@
       </p:sp>
       <p:sp>
         <p:nvSpPr>
-          <p:cNvPr id="5" name="bar Qwen3-32B"/>
-          <p:cNvSpPr/>
-          <p:nvPr/>
-        </p:nvSpPr>
-        <p:spPr>
-          <a:xfrm>
-            <a:off x="3337560" y="1816913"/>
-            <a:ext cx="441289" cy="265176"/>
+          <p:cNvPr id="16" name="bar Qwen3-32B"/>
+          <p:cNvSpPr/>
+          <p:nvPr/>
+        </p:nvSpPr>
+        <p:spPr>
+          <a:xfrm>
+            <a:off x="8915400" y="1714500"/>
+            <a:ext cx="249677" cy="228600"/>
           </a:xfrm>
           <a:prstGeom prst="rect">
             <a:avLst/>
@@ -4187,14 +4677,14 @@
       </p:sp>
       <p:sp>
         <p:nvSpPr>
-          <p:cNvPr id="6" name="Text 4"/>
-          <p:cNvSpPr txBox="1"/>
-          <p:nvPr/>
-        </p:nvSpPr>
-        <p:spPr>
-          <a:xfrm>
-            <a:off x="3870289" y="1737360"/>
-            <a:ext cx="914400" cy="424282"/>
+          <p:cNvPr id="17" name="Text 15"/>
+          <p:cNvSpPr txBox="1"/>
+          <p:nvPr/>
+        </p:nvSpPr>
+        <p:spPr>
+          <a:xfrm>
+            <a:off x="9256517" y="1645920"/>
+            <a:ext cx="685800" cy="365760"/>
           </a:xfrm>
           <a:prstGeom prst="rect">
             <a:avLst/>
@@ -4223,14 +4713,14 @@
       </p:sp>
       <p:sp>
         <p:nvSpPr>
-          <p:cNvPr id="7" name="Text 5"/>
-          <p:cNvSpPr txBox="1"/>
-          <p:nvPr/>
-        </p:nvSpPr>
-        <p:spPr>
-          <a:xfrm>
-            <a:off x="548640" y="2267712"/>
-            <a:ext cx="2651760" cy="424282"/>
+          <p:cNvPr id="18" name="Text 16"/>
+          <p:cNvSpPr txBox="1"/>
+          <p:nvPr/>
+        </p:nvSpPr>
+        <p:spPr>
+          <a:xfrm>
+            <a:off x="6949440" y="2103120"/>
+            <a:ext cx="1828800" cy="365760"/>
           </a:xfrm>
           <a:prstGeom prst="rect">
             <a:avLst/>
@@ -4259,14 +4749,14 @@
       </p:sp>
       <p:sp>
         <p:nvSpPr>
-          <p:cNvPr id="8" name="bar gpt-oss-20b"/>
-          <p:cNvSpPr/>
-          <p:nvPr/>
-        </p:nvSpPr>
-        <p:spPr>
-          <a:xfrm>
-            <a:off x="3337560" y="2347265"/>
-            <a:ext cx="938174" cy="265176"/>
+          <p:cNvPr id="19" name="bar gpt-oss-20b"/>
+          <p:cNvSpPr/>
+          <p:nvPr/>
+        </p:nvSpPr>
+        <p:spPr>
+          <a:xfrm>
+            <a:off x="8915400" y="2171700"/>
+            <a:ext cx="530809" cy="228600"/>
           </a:xfrm>
           <a:prstGeom prst="rect">
             <a:avLst/>
@@ -4284,14 +4774,14 @@
       </p:sp>
       <p:sp>
         <p:nvSpPr>
-          <p:cNvPr id="9" name="Text 7"/>
-          <p:cNvSpPr txBox="1"/>
-          <p:nvPr/>
-        </p:nvSpPr>
-        <p:spPr>
-          <a:xfrm>
-            <a:off x="4367174" y="2267712"/>
-            <a:ext cx="914400" cy="424282"/>
+          <p:cNvPr id="20" name="Text 18"/>
+          <p:cNvSpPr txBox="1"/>
+          <p:nvPr/>
+        </p:nvSpPr>
+        <p:spPr>
+          <a:xfrm>
+            <a:off x="9537649" y="2103120"/>
+            <a:ext cx="685800" cy="365760"/>
           </a:xfrm>
           <a:prstGeom prst="rect">
             <a:avLst/>
@@ -4320,14 +4810,14 @@
       </p:sp>
       <p:sp>
         <p:nvSpPr>
-          <p:cNvPr id="10" name="Text 8"/>
-          <p:cNvSpPr txBox="1"/>
-          <p:nvPr/>
-        </p:nvSpPr>
-        <p:spPr>
-          <a:xfrm>
-            <a:off x="548640" y="2798064"/>
-            <a:ext cx="2651760" cy="424282"/>
+          <p:cNvPr id="21" name="Text 19"/>
+          <p:cNvSpPr txBox="1"/>
+          <p:nvPr/>
+        </p:nvSpPr>
+        <p:spPr>
+          <a:xfrm>
+            <a:off x="6949440" y="2560320"/>
+            <a:ext cx="1828800" cy="365760"/>
           </a:xfrm>
           <a:prstGeom prst="rect">
             <a:avLst/>
@@ -4356,14 +4846,14 @@
       </p:sp>
       <p:sp>
         <p:nvSpPr>
-          <p:cNvPr id="11" name="bar Qwen3.6-35B"/>
-          <p:cNvSpPr/>
-          <p:nvPr/>
-        </p:nvSpPr>
-        <p:spPr>
-          <a:xfrm>
-            <a:off x="3337560" y="2877617"/>
-            <a:ext cx="1893722" cy="265176"/>
+          <p:cNvPr id="22" name="bar Qwen3.6-35B"/>
+          <p:cNvSpPr/>
+          <p:nvPr/>
+        </p:nvSpPr>
+        <p:spPr>
+          <a:xfrm>
+            <a:off x="8915400" y="2628900"/>
+            <a:ext cx="1071448" cy="228600"/>
           </a:xfrm>
           <a:prstGeom prst="rect">
             <a:avLst/>
@@ -4381,14 +4871,14 @@
       </p:sp>
       <p:sp>
         <p:nvSpPr>
-          <p:cNvPr id="12" name="Text 10"/>
-          <p:cNvSpPr txBox="1"/>
-          <p:nvPr/>
-        </p:nvSpPr>
-        <p:spPr>
-          <a:xfrm>
-            <a:off x="5322722" y="2798064"/>
-            <a:ext cx="914400" cy="424282"/>
+          <p:cNvPr id="23" name="Text 21"/>
+          <p:cNvSpPr txBox="1"/>
+          <p:nvPr/>
+        </p:nvSpPr>
+        <p:spPr>
+          <a:xfrm>
+            <a:off x="10078288" y="2560320"/>
+            <a:ext cx="685800" cy="365760"/>
           </a:xfrm>
           <a:prstGeom prst="rect">
             <a:avLst/>
@@ -4417,14 +4907,14 @@
       </p:sp>
       <p:sp>
         <p:nvSpPr>
-          <p:cNvPr id="13" name="Text 11"/>
-          <p:cNvSpPr txBox="1"/>
-          <p:nvPr/>
-        </p:nvSpPr>
-        <p:spPr>
-          <a:xfrm>
-            <a:off x="548640" y="3328416"/>
-            <a:ext cx="2651760" cy="424282"/>
+          <p:cNvPr id="24" name="Text 22"/>
+          <p:cNvSpPr txBox="1"/>
+          <p:nvPr/>
+        </p:nvSpPr>
+        <p:spPr>
+          <a:xfrm>
+            <a:off x="6949440" y="3017520"/>
+            <a:ext cx="1828800" cy="365760"/>
           </a:xfrm>
           <a:prstGeom prst="rect">
             <a:avLst/>
@@ -4445,7 +4935,7 @@
                   <a:schemeClr val="tx1"/>
                 </a:solidFill>
               </a:rPr>
-              <a:t>DeepSeek-Prover-V2-7B</a:t>
+              <a:t>DeepSeek-Prover-7B</a:t>
             </a:r>
             <a:endParaRPr lang="en-US" sz="1600" dirty="0"/>
           </a:p>
@@ -4453,14 +4943,14 @@
       </p:sp>
       <p:sp>
         <p:nvSpPr>
-          <p:cNvPr id="14" name="bar DeepSeek-Prover-V2-7B"/>
-          <p:cNvSpPr/>
-          <p:nvPr/>
-        </p:nvSpPr>
-        <p:spPr>
-          <a:xfrm>
-            <a:off x="3337560" y="3407969"/>
-            <a:ext cx="2348911" cy="265176"/>
+          <p:cNvPr id="25" name="bar DeepSeek-Prover-7B"/>
+          <p:cNvSpPr/>
+          <p:nvPr/>
+        </p:nvSpPr>
+        <p:spPr>
+          <a:xfrm>
+            <a:off x="8915400" y="3086100"/>
+            <a:ext cx="1328989" cy="228600"/>
           </a:xfrm>
           <a:prstGeom prst="rect">
             <a:avLst/>
@@ -4478,14 +4968,14 @@
       </p:sp>
       <p:sp>
         <p:nvSpPr>
-          <p:cNvPr id="15" name="Text 13"/>
-          <p:cNvSpPr txBox="1"/>
-          <p:nvPr/>
-        </p:nvSpPr>
-        <p:spPr>
-          <a:xfrm>
-            <a:off x="5777911" y="3328416"/>
-            <a:ext cx="914400" cy="424282"/>
+          <p:cNvPr id="26" name="Text 24"/>
+          <p:cNvSpPr txBox="1"/>
+          <p:nvPr/>
+        </p:nvSpPr>
+        <p:spPr>
+          <a:xfrm>
+            <a:off x="10335829" y="3017520"/>
+            <a:ext cx="685800" cy="365760"/>
           </a:xfrm>
           <a:prstGeom prst="rect">
             <a:avLst/>
@@ -4514,14 +5004,14 @@
       </p:sp>
       <p:sp>
         <p:nvSpPr>
-          <p:cNvPr id="16" name="Text 14"/>
-          <p:cNvSpPr txBox="1"/>
-          <p:nvPr/>
-        </p:nvSpPr>
-        <p:spPr>
-          <a:xfrm>
-            <a:off x="548640" y="3858768"/>
-            <a:ext cx="2651760" cy="424282"/>
+          <p:cNvPr id="27" name="Text 25"/>
+          <p:cNvSpPr txBox="1"/>
+          <p:nvPr/>
+        </p:nvSpPr>
+        <p:spPr>
+          <a:xfrm>
+            <a:off x="6949440" y="3474720"/>
+            <a:ext cx="1828800" cy="365760"/>
           </a:xfrm>
           <a:prstGeom prst="rect">
             <a:avLst/>
@@ -4542,7 +5032,7 @@
                   <a:schemeClr val="tx1"/>
                 </a:solidFill>
               </a:rPr>
-              <a:t>Goedel-Prover-V2-8B</a:t>
+              <a:t>Goedel-Prover-8B</a:t>
             </a:r>
             <a:endParaRPr lang="en-US" sz="1600" dirty="0"/>
           </a:p>
@@ -4550,14 +5040,14 @@
       </p:sp>
       <p:sp>
         <p:nvSpPr>
-          <p:cNvPr id="17" name="bar Goedel-Prover-V2-8B"/>
-          <p:cNvSpPr/>
-          <p:nvPr/>
-        </p:nvSpPr>
-        <p:spPr>
-          <a:xfrm>
-            <a:off x="3337560" y="3938321"/>
-            <a:ext cx="2564343" cy="265176"/>
+          <p:cNvPr id="28" name="bar Goedel-Prover-8B"/>
+          <p:cNvSpPr/>
+          <p:nvPr/>
+        </p:nvSpPr>
+        <p:spPr>
+          <a:xfrm>
+            <a:off x="8915400" y="3543300"/>
+            <a:ext cx="1450878" cy="228600"/>
           </a:xfrm>
           <a:prstGeom prst="rect">
             <a:avLst/>
@@ -4575,14 +5065,14 @@
       </p:sp>
       <p:sp>
         <p:nvSpPr>
-          <p:cNvPr id="18" name="Text 16"/>
-          <p:cNvSpPr txBox="1"/>
-          <p:nvPr/>
-        </p:nvSpPr>
-        <p:spPr>
-          <a:xfrm>
-            <a:off x="5993343" y="3858768"/>
-            <a:ext cx="914400" cy="424282"/>
+          <p:cNvPr id="29" name="Text 27"/>
+          <p:cNvSpPr txBox="1"/>
+          <p:nvPr/>
+        </p:nvSpPr>
+        <p:spPr>
+          <a:xfrm>
+            <a:off x="10457718" y="3474720"/>
+            <a:ext cx="685800" cy="365760"/>
           </a:xfrm>
           <a:prstGeom prst="rect">
             <a:avLst/>
@@ -4611,112 +5101,63 @@
       </p:sp>
       <p:sp>
         <p:nvSpPr>
-          <p:cNvPr id="19" name="nothing in the recipe helps"/>
-          <p:cNvSpPr/>
-          <p:nvPr/>
-        </p:nvSpPr>
-        <p:spPr>
-          <a:xfrm>
-            <a:off x="8046720" y="1280160"/>
-            <a:ext cx="3566160" cy="3017520"/>
-          </a:xfrm>
-          <a:prstGeom prst="roundRect">
-            <a:avLst>
-              <a:gd name="adj" fmla="val 2424"/>
-            </a:avLst>
-          </a:prstGeom>
-          <a:solidFill>
-            <a:srgbClr val="F2F2F2"/>
-          </a:solidFill>
-          <a:ln w="9525">
-            <a:solidFill>
-              <a:srgbClr val="D9D9D9"/>
-            </a:solidFill>
-            <a:prstDash val="solid"/>
-          </a:ln>
-        </p:spPr>
-      </p:sp>
-      <p:sp>
-        <p:nvSpPr>
-          <p:cNvPr id="20" name="Text 18"/>
-          <p:cNvSpPr txBox="1"/>
-          <p:nvPr/>
-        </p:nvSpPr>
-        <p:spPr>
-          <a:xfrm>
-            <a:off x="8229600" y="1371600"/>
-            <a:ext cx="3200400" cy="685800"/>
-          </a:xfrm>
-          <a:prstGeom prst="rect">
-            <a:avLst/>
-          </a:prstGeom>
-          <a:noFill/>
-          <a:ln/>
-        </p:spPr>
-        <p:txBody>
-          <a:bodyPr wrap="square" lIns="0" tIns="0" rIns="0" bIns="0" rtlCol="0" anchor="t"/>
+          <p:cNvPr id="30" name="Text 28"/>
+          <p:cNvSpPr txBox="1"/>
+          <p:nvPr/>
+        </p:nvSpPr>
+        <p:spPr>
+          <a:xfrm>
+            <a:off x="548640" y="4206240"/>
+            <a:ext cx="11064240" cy="640080"/>
+          </a:xfrm>
+          <a:prstGeom prst="rect">
+            <a:avLst/>
+          </a:prstGeom>
+          <a:noFill/>
+          <a:ln/>
+        </p:spPr>
+        <p:txBody>
+          <a:bodyPr wrap="square" lIns="0" tIns="0" rIns="0" bIns="0" rtlCol="0" anchor="ctr"/>
           <a:lstStyle/>
           <a:p>
             <a:pPr indent="0" marL="0">
               <a:buNone/>
             </a:pPr>
             <a:r>
-              <a:rPr lang="en-US" sz="1700" b="1" dirty="0">
-                <a:solidFill>
-                  <a:srgbClr val="C00000"/>
-                </a:solidFill>
-              </a:rPr>
-              <a:t>For general models, no step helps</a:t>
-            </a:r>
-            <a:endParaRPr lang="en-US" sz="1700" dirty="0"/>
-          </a:p>
-        </p:txBody>
-      </p:sp>
-      <p:sp>
-        <p:nvSpPr>
-          <p:cNvPr id="21" name="Text 19"/>
-          <p:cNvSpPr txBox="1"/>
-          <p:nvPr/>
-        </p:nvSpPr>
-        <p:spPr>
-          <a:xfrm>
-            <a:off x="8229600" y="2057400"/>
-            <a:ext cx="3200400" cy="2194560"/>
-          </a:xfrm>
-          <a:prstGeom prst="rect">
-            <a:avLst/>
-          </a:prstGeom>
-          <a:noFill/>
-          <a:ln/>
-        </p:spPr>
-        <p:txBody>
-          <a:bodyPr wrap="square" lIns="635" tIns="635" rIns="635" bIns="635" rtlCol="0" anchor="t"/>
-          <a:lstStyle/>
-          <a:p>
-            <a:pPr marL="342900" indent="-342900">
-              <a:spcAft>
-                <a:spcPts val="800"/>
-              </a:spcAft>
-              <a:buSzPct val="100000"/>
-              <a:buChar char="•"/>
-            </a:pPr>
-            <a:r>
               <a:rPr lang="en-US" sz="1500" dirty="0">
                 <a:solidFill>
                   <a:schemeClr val="tx1"/>
                 </a:solidFill>
               </a:rPr>
-              <a:t>a verified similar proof: 133 → 133</a:t>
+              <a:t>For general models no step helps: a similar verified proof 133 → 133 · thinking 133 → 129 · an inequality fact sheet 24 → 21; fixing a proof from Lean's errors works half as well as a fresh try</a:t>
             </a:r>
             <a:endParaRPr lang="en-US" sz="1500" dirty="0"/>
           </a:p>
-          <a:p>
-            <a:pPr marL="342900" indent="-342900">
-              <a:spcAft>
-                <a:spcPts val="800"/>
-              </a:spcAft>
-              <a:buSzPct val="100000"/>
-              <a:buChar char="•"/>
+        </p:txBody>
+      </p:sp>
+      <p:sp>
+        <p:nvSpPr>
+          <p:cNvPr id="31" name="Text 29"/>
+          <p:cNvSpPr txBox="1"/>
+          <p:nvPr/>
+        </p:nvSpPr>
+        <p:spPr>
+          <a:xfrm>
+            <a:off x="548640" y="4892040"/>
+            <a:ext cx="11064240" cy="640080"/>
+          </a:xfrm>
+          <a:prstGeom prst="rect">
+            <a:avLst/>
+          </a:prstGeom>
+          <a:noFill/>
+          <a:ln/>
+        </p:spPr>
+        <p:txBody>
+          <a:bodyPr wrap="square" lIns="0" tIns="0" rIns="0" bIns="0" rtlCol="0" anchor="ctr"/>
+          <a:lstStyle/>
+          <a:p>
+            <a:pPr indent="0" marL="0">
+              <a:buNone/>
             </a:pPr>
             <a:r>
               <a:rPr lang="en-US" sz="1500" dirty="0">
@@ -4724,87 +5165,15 @@
                   <a:schemeClr val="tx1"/>
                 </a:solidFill>
               </a:rPr>
-              <a:t>thinking: 133 → 129</a:t>
+              <a:t>Geometry proofs (AlphaGeometry's solver + LLM-proposed points): IMO 12 → 13 of 30 (only 2014 P4: "take the midpoint of BC"); easier JGEX 187 → 200 of 231</a:t>
             </a:r>
             <a:endParaRPr lang="en-US" sz="1500" dirty="0"/>
           </a:p>
-          <a:p>
-            <a:pPr marL="342900" indent="-342900">
-              <a:spcAft>
-                <a:spcPts val="800"/>
-              </a:spcAft>
-              <a:buSzPct val="100000"/>
-              <a:buChar char="•"/>
-            </a:pPr>
-            <a:r>
-              <a:rPr lang="en-US" sz="1500" dirty="0">
-                <a:solidFill>
-                  <a:schemeClr val="tx1"/>
-                </a:solidFill>
-              </a:rPr>
-              <a:t>inequality fact sheet: 24 → 21 (of 50)</a:t>
-            </a:r>
-            <a:endParaRPr lang="en-US" sz="1500" dirty="0"/>
-          </a:p>
-          <a:p>
-            <a:pPr marL="342900" indent="-342900">
-              <a:spcAft>
-                <a:spcPts val="800"/>
-              </a:spcAft>
-              <a:buSzPct val="100000"/>
-              <a:buChar char="•"/>
-            </a:pPr>
-            <a:r>
-              <a:rPr lang="en-US" sz="1500" dirty="0">
-                <a:solidFill>
-                  <a:schemeClr val="tx1"/>
-                </a:solidFill>
-              </a:rPr>
-              <a:t>fixing from Lean's errors: half as good as a fresh try</a:t>
-            </a:r>
-            <a:endParaRPr lang="en-US" sz="1500" dirty="0"/>
-          </a:p>
-        </p:txBody>
-      </p:sp>
-      <p:sp>
-        <p:nvSpPr>
-          <p:cNvPr id="22" name="Text 20"/>
-          <p:cNvSpPr txBox="1"/>
-          <p:nvPr/>
-        </p:nvSpPr>
-        <p:spPr>
-          <a:xfrm>
-            <a:off x="548640" y="4572000"/>
-            <a:ext cx="11064240" cy="731520"/>
-          </a:xfrm>
-          <a:prstGeom prst="rect">
-            <a:avLst/>
-          </a:prstGeom>
-          <a:noFill/>
-          <a:ln/>
-        </p:spPr>
-        <p:txBody>
-          <a:bodyPr wrap="square" lIns="0" tIns="0" rIns="0" bIns="0" rtlCol="0" anchor="ctr"/>
-          <a:lstStyle/>
-          <a:p>
-            <a:pPr indent="0" marL="0">
-              <a:buNone/>
-            </a:pPr>
-            <a:r>
-              <a:rPr lang="en-US" sz="1600" dirty="0">
-                <a:solidFill>
-                  <a:schemeClr val="tx1"/>
-                </a:solidFill>
-              </a:rPr>
-              <a:t>Geometry proofs (AlphaGeometry's symbolic engine): IMO 12 of 30 alone → 13 with LLM-proposed points; easier JGEX 187 of 231 → 200</a:t>
-            </a:r>
-            <a:endParaRPr lang="en-US" sz="1600" dirty="0"/>
-          </a:p>
-        </p:txBody>
-      </p:sp>
-      <p:sp>
-        <p:nvSpPr>
-          <p:cNvPr id="23" name="Text 21"/>
+        </p:txBody>
+      </p:sp>
+      <p:sp>
+        <p:nvSpPr>
+          <p:cNvPr id="32" name="Text 30"/>
           <p:cNvSpPr txBox="1"/>
           <p:nvPr/>
         </p:nvSpPr>

</xml_diff>

<commit_message>
Slide 3 made compact and visual: two problem panels, why-it-matters chips, the question as three options
Co-Authored-By: Claude Opus 5.5 (1M context) <noreply@anthropic.com>
</commit_message>
<xml_diff>
--- a/PROPOSAL_slides.pptx
+++ b/PROPOSAL_slides.pptx
@@ -126,7 +126,7 @@
   <p:extLst>
     <p:ext uri="{521415D9-36F7-43E2-AB2F-B90AF26B5E84}">
       <p14:sectionLst xmlns:p14="http://schemas.microsoft.com/office/powerpoint/2010/main">
-        <p14:section name="Talk" id="{e30113c8-e756-054e-1f56-503bfca798db}">
+        <p14:section name="Talk" id="{935ba9ee-8c38-1691-e2ec-2b68de764fd1}">
           <p14:sldIdLst>
             <p14:sldId id="256"/>
             <p14:sldId id="257"/>
@@ -139,7 +139,7 @@
             <p14:sldId id="264"/>
           </p14:sldIdLst>
         </p14:section>
-        <p14:section name="Extra pages" id="{8e98d422-60a6-0750-4f85-f985b8029527}">
+        <p14:section name="Extra pages" id="{ad808c57-82de-12b8-1626-a082ddab02cc}">
           <p14:sldIdLst>
             <p14:sldId id="265"/>
             <p14:sldId id="266"/>
@@ -2522,7 +2522,7 @@
           <a:p>
             <a:r>
               <a:rPr lang="en-US" dirty="0"/>
-              <a:t>(35 s) Two problems: (1) programs fail silently: with extra helper functions Qwen3-14B's convex-hull program prints 0 corners instead of 6, with no error; 24-37% of gpt-oss-120b's wrong contest programs pass the examples printed in the problem. (2) Thinking is expensive: on 311 Codeforces geometry problems gpt-oss-120b solves 57% at medium effort (6.8k tokens per problem) and 66% at high effort (30k), 4.4 times the tokens for 9 more points. Why it matters: agents already write such code; tokens are cost and latency; most teams have one small GPU. Our question and plan: compare cheap fixes (a fact, a check, reuse) with thinking longer on real benchmarks, priced in tokens, and combine what works.</a:t>
+              <a:t>(35 s) Two problems. (1) Programs fail silently: for the same task (how many corners does the rubber band around 10 points have?) Qwen3-14B's program prints 6 with only the task, and 0 when the prompt also offers 8 unneeded helper functions, with no error message; and 24-37% of gpt-oss-120b's wrong contest programs pass the examples printed in the problem. (2) Thinking longer is expensive: on 311 Codeforces geometry problems gpt-oss-120b solves 57% at medium effort (6.8k tokens per problem) and 66% at high effort (30k), 4.4 times the tokens for 9 more points. Why it matters: agents already write route planners, schedulers and geometry code; tokens are cost and latency; most teams have one small GPU. Our question: where should extra effort go, a missing fact, a free check, or more thinking? We test each on seven kinds of problems, counting accuracy and tokens, and combine what works.</a:t>
             </a:r>
             <a:endParaRPr lang="en-US" dirty="0"/>
           </a:p>
@@ -19952,11 +19952,11 @@
         <p:spPr>
           <a:xfrm>
             <a:off x="548640" y="1280160"/>
-            <a:ext cx="3566160" cy="3154680"/>
+            <a:ext cx="5440680" cy="2743200"/>
           </a:xfrm>
           <a:prstGeom prst="roundRect">
             <a:avLst>
-              <a:gd name="adj" fmla="val 2319"/>
+              <a:gd name="adj" fmla="val 2667"/>
             </a:avLst>
           </a:prstGeom>
           <a:solidFill>
@@ -19978,8 +19978,8 @@
         </p:nvSpPr>
         <p:spPr>
           <a:xfrm>
-            <a:off x="731520" y="1371600"/>
-            <a:ext cx="3200400" cy="457200"/>
+            <a:off x="777240" y="1371600"/>
+            <a:ext cx="4983480" cy="502920"/>
           </a:xfrm>
           <a:prstGeom prst="rect">
             <a:avLst/>
@@ -19995,14 +19995,14 @@
               <a:buNone/>
             </a:pPr>
             <a:r>
-              <a:rPr lang="en-US" sz="1900" b="1" dirty="0">
+              <a:rPr lang="en-US" sz="2200" b="1" dirty="0">
                 <a:solidFill>
                   <a:srgbClr val="C00000"/>
                 </a:solidFill>
               </a:rPr>
               <a:t>1. Programs fail silently</a:t>
             </a:r>
-            <a:endParaRPr lang="en-US" sz="1900" dirty="0"/>
+            <a:endParaRPr lang="en-US" sz="2200" dirty="0"/>
           </a:p>
         </p:txBody>
       </p:sp>
@@ -20014,8 +20014,8 @@
         </p:nvSpPr>
         <p:spPr>
           <a:xfrm>
-            <a:off x="731520" y="1874520"/>
-            <a:ext cx="3200400" cy="320040"/>
+            <a:off x="777240" y="1828800"/>
+            <a:ext cx="5029200" cy="274320"/>
           </a:xfrm>
           <a:prstGeom prst="rect">
             <a:avLst/>
@@ -20031,37 +20031,39 @@
               <a:buNone/>
             </a:pPr>
             <a:r>
-              <a:rPr lang="en-US" sz="1400" dirty="0">
-                <a:solidFill>
-                  <a:schemeClr val="tx1"/>
-                </a:solidFill>
-              </a:rPr>
-              <a:t>a convex-hull program (Qwen3-14B, 10 points):</a:t>
-            </a:r>
-            <a:endParaRPr lang="en-US" sz="1400" dirty="0"/>
-          </a:p>
-        </p:txBody>
-      </p:sp>
-      <p:sp>
-        <p:nvSpPr>
-          <p:cNvPr id="6" name="code output: 0      (righ"/>
+              <a:rPr lang="en-US" sz="1300" dirty="0">
+                <a:solidFill>
+                  <a:schemeClr val="tx2"/>
+                </a:solidFill>
+              </a:rPr>
+              <a:t>Same task (corners around 10 points), two programs:</a:t>
+            </a:r>
+            <a:endParaRPr lang="en-US" sz="1300" dirty="0"/>
+          </a:p>
+        </p:txBody>
+      </p:sp>
+      <p:sp>
+        <p:nvSpPr>
+          <p:cNvPr id="6" name="answer 6 ✓"/>
           <p:cNvSpPr/>
           <p:nvPr/>
         </p:nvSpPr>
         <p:spPr>
           <a:xfrm>
-            <a:off x="731520" y="2212848"/>
-            <a:ext cx="3200400" cy="457200"/>
-          </a:xfrm>
-          <a:prstGeom prst="rect">
-            <a:avLst/>
+            <a:off x="914400" y="2194560"/>
+            <a:ext cx="1554480" cy="548640"/>
+          </a:xfrm>
+          <a:prstGeom prst="roundRect">
+            <a:avLst>
+              <a:gd name="adj" fmla="val 16667"/>
+            </a:avLst>
           </a:prstGeom>
           <a:solidFill>
-            <a:srgbClr val="FFFFFF"/>
+            <a:srgbClr val="E2F0D9"/>
           </a:solidFill>
-          <a:ln w="9525">
+          <a:ln w="12700">
             <a:solidFill>
-              <a:srgbClr val="BFBFBF"/>
+              <a:srgbClr val="70AD47"/>
             </a:solidFill>
             <a:prstDash val="solid"/>
           </a:ln>
@@ -20075,8 +20077,8 @@
         </p:nvSpPr>
         <p:spPr>
           <a:xfrm>
-            <a:off x="841248" y="2212848"/>
-            <a:ext cx="2980944" cy="457200"/>
+            <a:off x="914400" y="2194560"/>
+            <a:ext cx="1554480" cy="548640"/>
           </a:xfrm>
           <a:prstGeom prst="rect">
             <a:avLst/>
@@ -20088,21 +20090,18 @@
           <a:bodyPr wrap="square" lIns="0" tIns="0" rIns="0" bIns="0" rtlCol="0" anchor="ctr"/>
           <a:lstStyle/>
           <a:p>
-            <a:pPr indent="0" marL="0">
-              <a:buNone/>
-            </a:pPr>
-            <a:r>
-              <a:rPr lang="en-US" sz="1400" dirty="0">
-                <a:solidFill>
-                  <a:srgbClr val="C00000"/>
-                </a:solidFill>
-                <a:latin typeface="Courier New" pitchFamily="34" charset="0"/>
-                <a:ea typeface="Courier New" pitchFamily="34" charset="-122"/>
-                <a:cs typeface="Courier New" pitchFamily="34" charset="-120"/>
-              </a:rPr>
-              <a:t>output: 0      (right answer: 6)</a:t>
-            </a:r>
-            <a:endParaRPr lang="en-US" sz="1400" dirty="0"/>
+            <a:pPr algn="ctr" indent="0" marL="0">
+              <a:buNone/>
+            </a:pPr>
+            <a:r>
+              <a:rPr lang="en-US" sz="2200" b="1" dirty="0">
+                <a:solidFill>
+                  <a:srgbClr val="38761D"/>
+                </a:solidFill>
+              </a:rPr>
+              <a:t>6 ✓</a:t>
+            </a:r>
+            <a:endParaRPr lang="en-US" sz="2200" dirty="0"/>
           </a:p>
         </p:txBody>
       </p:sp>
@@ -20114,8 +20113,8 @@
         </p:nvSpPr>
         <p:spPr>
           <a:xfrm>
-            <a:off x="731520" y="2697480"/>
-            <a:ext cx="3200400" cy="320040"/>
+            <a:off x="777240" y="2761488"/>
+            <a:ext cx="1554480" cy="274320"/>
           </a:xfrm>
           <a:prstGeom prst="rect">
             <a:avLst/>
@@ -20127,85 +20126,181 @@
           <a:bodyPr wrap="square" lIns="0" tIns="0" rIns="0" bIns="0" rtlCol="0" anchor="ctr"/>
           <a:lstStyle/>
           <a:p>
-            <a:pPr indent="0" marL="0">
-              <a:buNone/>
-            </a:pPr>
-            <a:r>
-              <a:rPr lang="en-US" sz="1400" dirty="0">
-                <a:solidFill>
-                  <a:srgbClr val="C00000"/>
-                </a:solidFill>
-              </a:rPr>
-              <a:t>no error message, just a wrong number</a:t>
-            </a:r>
-            <a:endParaRPr lang="en-US" sz="1400" dirty="0"/>
-          </a:p>
-        </p:txBody>
-      </p:sp>
-      <p:sp>
-        <p:nvSpPr>
-          <p:cNvPr id="9" name="Text 7"/>
-          <p:cNvSpPr txBox="1"/>
-          <p:nvPr/>
-        </p:nvSpPr>
-        <p:spPr>
-          <a:xfrm>
-            <a:off x="731520" y="3154680"/>
-            <a:ext cx="3200400" cy="1188720"/>
-          </a:xfrm>
-          <a:prstGeom prst="rect">
-            <a:avLst/>
-          </a:prstGeom>
-          <a:noFill/>
-          <a:ln/>
-        </p:spPr>
-        <p:txBody>
-          <a:bodyPr wrap="square" lIns="0" tIns="0" rIns="0" bIns="0" rtlCol="0" anchor="t"/>
-          <a:lstStyle/>
-          <a:p>
-            <a:pPr indent="0" marL="0">
-              <a:buNone/>
-            </a:pPr>
-            <a:r>
-              <a:rPr lang="en-US" sz="2400" b="1" dirty="0">
-                <a:solidFill>
-                  <a:srgbClr val="C00000"/>
-                </a:solidFill>
-              </a:rPr>
-              <a:t>24–37%</a:t>
-            </a:r>
-            <a:endParaRPr lang="en-US" sz="1400" dirty="0"/>
-          </a:p>
-          <a:p>
-            <a:pPr indent="0" marL="0">
-              <a:buNone/>
-            </a:pPr>
-            <a:r>
-              <a:rPr lang="en-US" sz="1400" dirty="0">
-                <a:solidFill>
-                  <a:schemeClr val="tx1"/>
-                </a:solidFill>
-              </a:rPr>
-              <a:t>of wrong contest programs still pass the examples in the problem</a:t>
-            </a:r>
-            <a:endParaRPr lang="en-US" sz="1400" dirty="0"/>
-          </a:p>
-        </p:txBody>
-      </p:sp>
-      <p:sp>
-        <p:nvSpPr>
-          <p:cNvPr id="10" name="why 2. Thinking is expensive"/>
+            <a:pPr algn="ctr" indent="0" marL="0">
+              <a:buNone/>
+            </a:pPr>
+            <a:r>
+              <a:rPr lang="en-US" sz="1300" dirty="0">
+                <a:solidFill>
+                  <a:schemeClr val="tx2"/>
+                </a:solidFill>
+              </a:rPr>
+              <a:t>program A</a:t>
+            </a:r>
+            <a:endParaRPr lang="en-US" sz="1300" dirty="0"/>
+          </a:p>
+        </p:txBody>
+      </p:sp>
+      <p:sp>
+        <p:nvSpPr>
+          <p:cNvPr id="9" name="answer 0 ✗"/>
           <p:cNvSpPr/>
           <p:nvPr/>
         </p:nvSpPr>
         <p:spPr>
           <a:xfrm>
-            <a:off x="4297680" y="1280160"/>
-            <a:ext cx="3566160" cy="3154680"/>
+            <a:off x="2834640" y="2194560"/>
+            <a:ext cx="1554480" cy="548640"/>
           </a:xfrm>
           <a:prstGeom prst="roundRect">
             <a:avLst>
-              <a:gd name="adj" fmla="val 2319"/>
+              <a:gd name="adj" fmla="val 16667"/>
+            </a:avLst>
+          </a:prstGeom>
+          <a:solidFill>
+            <a:srgbClr val="FADBD8"/>
+          </a:solidFill>
+          <a:ln w="12700">
+            <a:solidFill>
+              <a:srgbClr val="C00000"/>
+            </a:solidFill>
+            <a:prstDash val="solid"/>
+          </a:ln>
+        </p:spPr>
+      </p:sp>
+      <p:sp>
+        <p:nvSpPr>
+          <p:cNvPr id="10" name="Text 8"/>
+          <p:cNvSpPr txBox="1"/>
+          <p:nvPr/>
+        </p:nvSpPr>
+        <p:spPr>
+          <a:xfrm>
+            <a:off x="2834640" y="2194560"/>
+            <a:ext cx="1554480" cy="548640"/>
+          </a:xfrm>
+          <a:prstGeom prst="rect">
+            <a:avLst/>
+          </a:prstGeom>
+          <a:noFill/>
+          <a:ln/>
+        </p:spPr>
+        <p:txBody>
+          <a:bodyPr wrap="square" lIns="0" tIns="0" rIns="0" bIns="0" rtlCol="0" anchor="ctr"/>
+          <a:lstStyle/>
+          <a:p>
+            <a:pPr algn="ctr" indent="0" marL="0">
+              <a:buNone/>
+            </a:pPr>
+            <a:r>
+              <a:rPr lang="en-US" sz="2200" b="1" dirty="0">
+                <a:solidFill>
+                  <a:srgbClr val="C00000"/>
+                </a:solidFill>
+              </a:rPr>
+              <a:t>0 ✗</a:t>
+            </a:r>
+            <a:endParaRPr lang="en-US" sz="2200" dirty="0"/>
+          </a:p>
+        </p:txBody>
+      </p:sp>
+      <p:sp>
+        <p:nvSpPr>
+          <p:cNvPr id="11" name="Text 9"/>
+          <p:cNvSpPr txBox="1"/>
+          <p:nvPr/>
+        </p:nvSpPr>
+        <p:spPr>
+          <a:xfrm>
+            <a:off x="2423160" y="2761488"/>
+            <a:ext cx="2286000" cy="274320"/>
+          </a:xfrm>
+          <a:prstGeom prst="rect">
+            <a:avLst/>
+          </a:prstGeom>
+          <a:noFill/>
+          <a:ln/>
+        </p:spPr>
+        <p:txBody>
+          <a:bodyPr wrap="square" lIns="0" tIns="0" rIns="0" bIns="0" rtlCol="0" anchor="ctr"/>
+          <a:lstStyle/>
+          <a:p>
+            <a:pPr algn="ctr" indent="0" marL="0">
+              <a:buNone/>
+            </a:pPr>
+            <a:r>
+              <a:rPr lang="en-US" sz="1300" dirty="0">
+                <a:solidFill>
+                  <a:schemeClr val="tx2"/>
+                </a:solidFill>
+              </a:rPr>
+              <a:t>program B: no error, just wrong</a:t>
+            </a:r>
+            <a:endParaRPr lang="en-US" sz="1300" dirty="0"/>
+          </a:p>
+        </p:txBody>
+      </p:sp>
+      <p:sp>
+        <p:nvSpPr>
+          <p:cNvPr id="12" name="Text 10"/>
+          <p:cNvSpPr txBox="1"/>
+          <p:nvPr/>
+        </p:nvSpPr>
+        <p:spPr>
+          <a:xfrm>
+            <a:off x="777240" y="3108960"/>
+            <a:ext cx="5029200" cy="777240"/>
+          </a:xfrm>
+          <a:prstGeom prst="rect">
+            <a:avLst/>
+          </a:prstGeom>
+          <a:noFill/>
+          <a:ln/>
+        </p:spPr>
+        <p:txBody>
+          <a:bodyPr wrap="square" lIns="0" tIns="0" rIns="0" bIns="0" rtlCol="0" anchor="ctr"/>
+          <a:lstStyle/>
+          <a:p>
+            <a:pPr indent="0" marL="0">
+              <a:buNone/>
+            </a:pPr>
+            <a:r>
+              <a:rPr lang="en-US" sz="2800" b="1" dirty="0">
+                <a:solidFill>
+                  <a:srgbClr val="C00000"/>
+                </a:solidFill>
+              </a:rPr>
+              <a:t>24–37%</a:t>
+            </a:r>
+            <a:pPr indent="0" marL="0">
+              <a:buNone/>
+            </a:pPr>
+            <a:r>
+              <a:rPr lang="en-US" sz="1500" dirty="0">
+                <a:solidFill>
+                  <a:schemeClr val="tx1"/>
+                </a:solidFill>
+              </a:rPr>
+              <a:t>  of wrong programs pass the problem's examples</a:t>
+            </a:r>
+            <a:endParaRPr lang="en-US" sz="1600" dirty="0"/>
+          </a:p>
+        </p:txBody>
+      </p:sp>
+      <p:sp>
+        <p:nvSpPr>
+          <p:cNvPr id="13" name="why 2. Thinking longer is expensive"/>
+          <p:cNvSpPr/>
+          <p:nvPr/>
+        </p:nvSpPr>
+        <p:spPr>
+          <a:xfrm>
+            <a:off x="6172200" y="1280160"/>
+            <a:ext cx="5440680" cy="2743200"/>
+          </a:xfrm>
+          <a:prstGeom prst="roundRect">
+            <a:avLst>
+              <a:gd name="adj" fmla="val 2667"/>
             </a:avLst>
           </a:prstGeom>
           <a:solidFill>
@@ -20221,14 +20316,14 @@
       </p:sp>
       <p:sp>
         <p:nvSpPr>
-          <p:cNvPr id="11" name="Text 9"/>
-          <p:cNvSpPr txBox="1"/>
-          <p:nvPr/>
-        </p:nvSpPr>
-        <p:spPr>
-          <a:xfrm>
-            <a:off x="4480560" y="1371600"/>
-            <a:ext cx="3200400" cy="457200"/>
+          <p:cNvPr id="14" name="Text 12"/>
+          <p:cNvSpPr txBox="1"/>
+          <p:nvPr/>
+        </p:nvSpPr>
+        <p:spPr>
+          <a:xfrm>
+            <a:off x="6400800" y="1371600"/>
+            <a:ext cx="4983480" cy="502920"/>
           </a:xfrm>
           <a:prstGeom prst="rect">
             <a:avLst/>
@@ -20244,27 +20339,27 @@
               <a:buNone/>
             </a:pPr>
             <a:r>
-              <a:rPr lang="en-US" sz="1900" b="1" dirty="0">
+              <a:rPr lang="en-US" sz="2200" b="1" dirty="0">
                 <a:solidFill>
                   <a:srgbClr val="ED7D31"/>
                 </a:solidFill>
               </a:rPr>
-              <a:t>2. Thinking is expensive</a:t>
-            </a:r>
-            <a:endParaRPr lang="en-US" sz="1900" dirty="0"/>
-          </a:p>
-        </p:txBody>
-      </p:sp>
-      <p:sp>
-        <p:nvSpPr>
-          <p:cNvPr id="12" name="Text 10"/>
-          <p:cNvSpPr txBox="1"/>
-          <p:nvPr/>
-        </p:nvSpPr>
-        <p:spPr>
-          <a:xfrm>
-            <a:off x="4480560" y="1874520"/>
-            <a:ext cx="3200400" cy="320040"/>
+              <a:t>2. Thinking longer is expensive</a:t>
+            </a:r>
+            <a:endParaRPr lang="en-US" sz="2200" dirty="0"/>
+          </a:p>
+        </p:txBody>
+      </p:sp>
+      <p:sp>
+        <p:nvSpPr>
+          <p:cNvPr id="15" name="Text 13"/>
+          <p:cNvSpPr txBox="1"/>
+          <p:nvPr/>
+        </p:nvSpPr>
+        <p:spPr>
+          <a:xfrm>
+            <a:off x="6400800" y="1828800"/>
+            <a:ext cx="5029200" cy="274320"/>
           </a:xfrm>
           <a:prstGeom prst="rect">
             <a:avLst/>
@@ -20280,63 +20375,63 @@
               <a:buNone/>
             </a:pPr>
             <a:r>
-              <a:rPr lang="en-US" sz="1400" dirty="0">
+              <a:rPr lang="en-US" sz="1300" dirty="0">
+                <a:solidFill>
+                  <a:schemeClr val="tx2"/>
+                </a:solidFill>
+              </a:rPr>
+              <a:t>311 contest problems (gpt-oss-120b), by effort:</a:t>
+            </a:r>
+            <a:endParaRPr lang="en-US" sz="1300" dirty="0"/>
+          </a:p>
+        </p:txBody>
+      </p:sp>
+      <p:sp>
+        <p:nvSpPr>
+          <p:cNvPr id="16" name="Text 14"/>
+          <p:cNvSpPr txBox="1"/>
+          <p:nvPr/>
+        </p:nvSpPr>
+        <p:spPr>
+          <a:xfrm>
+            <a:off x="6355080" y="2194560"/>
+            <a:ext cx="822960" cy="365760"/>
+          </a:xfrm>
+          <a:prstGeom prst="rect">
+            <a:avLst/>
+          </a:prstGeom>
+          <a:noFill/>
+          <a:ln/>
+        </p:spPr>
+        <p:txBody>
+          <a:bodyPr wrap="square" lIns="0" tIns="0" rIns="0" bIns="0" rtlCol="0" anchor="ctr"/>
+          <a:lstStyle/>
+          <a:p>
+            <a:pPr algn="r" indent="0" marL="0">
+              <a:buNone/>
+            </a:pPr>
+            <a:r>
+              <a:rPr lang="en-US" sz="1500" dirty="0">
                 <a:solidFill>
                   <a:schemeClr val="tx1"/>
                 </a:solidFill>
               </a:rPr>
-              <a:t>311 contest problems (gpt-oss-120b)</a:t>
-            </a:r>
-            <a:endParaRPr lang="en-US" sz="1400" dirty="0"/>
-          </a:p>
-        </p:txBody>
-      </p:sp>
-      <p:sp>
-        <p:nvSpPr>
-          <p:cNvPr id="13" name="Text 11"/>
-          <p:cNvSpPr txBox="1"/>
-          <p:nvPr/>
-        </p:nvSpPr>
-        <p:spPr>
-          <a:xfrm>
-            <a:off x="4389120" y="2286000"/>
-            <a:ext cx="1188720" cy="365760"/>
-          </a:xfrm>
-          <a:prstGeom prst="rect">
-            <a:avLst/>
-          </a:prstGeom>
-          <a:noFill/>
-          <a:ln/>
-        </p:spPr>
-        <p:txBody>
-          <a:bodyPr wrap="square" lIns="0" tIns="0" rIns="0" bIns="0" rtlCol="0" anchor="ctr"/>
-          <a:lstStyle/>
-          <a:p>
-            <a:pPr algn="r" indent="0" marL="0">
-              <a:buNone/>
-            </a:pPr>
-            <a:r>
-              <a:rPr lang="en-US" sz="1400" dirty="0">
-                <a:solidFill>
-                  <a:schemeClr val="tx1"/>
-                </a:solidFill>
-              </a:rPr>
-              <a:t>medium effort</a:t>
-            </a:r>
-            <a:endParaRPr lang="en-US" sz="1400" dirty="0"/>
-          </a:p>
-        </p:txBody>
-      </p:sp>
-      <p:sp>
-        <p:nvSpPr>
-          <p:cNvPr id="14" name="effort medium effort"/>
+              <a:t>medium</a:t>
+            </a:r>
+            <a:endParaRPr lang="en-US" sz="1500" dirty="0"/>
+          </a:p>
+        </p:txBody>
+      </p:sp>
+      <p:sp>
+        <p:nvSpPr>
+          <p:cNvPr id="17" name="effort medium"/>
           <p:cNvSpPr/>
           <p:nvPr/>
         </p:nvSpPr>
         <p:spPr>
           <a:xfrm>
-            <a:off x="5669280" y="2350008"/>
-            <a:ext cx="987136" cy="256032"/>
+            <a:off x="7269480" y="2258568"/>
+            <a:ext cx="619726" cy="274320"/>
           </a:xfrm>
           <a:prstGeom prst="rect">
             <a:avLst/>
@@ -20354,14 +20449,14 @@
       </p:sp>
       <p:sp>
         <p:nvSpPr>
-          <p:cNvPr id="15" name="Text 13"/>
-          <p:cNvSpPr txBox="1"/>
-          <p:nvPr/>
-        </p:nvSpPr>
-        <p:spPr>
-          <a:xfrm>
-            <a:off x="6702136" y="2286000"/>
-            <a:ext cx="1051560" cy="365760"/>
+          <p:cNvPr id="18" name="Text 16"/>
+          <p:cNvSpPr txBox="1"/>
+          <p:nvPr/>
+        </p:nvSpPr>
+        <p:spPr>
+          <a:xfrm>
+            <a:off x="7980646" y="2194560"/>
+            <a:ext cx="1737360" cy="365760"/>
           </a:xfrm>
           <a:prstGeom prst="rect">
             <a:avLst/>
@@ -20377,27 +20472,27 @@
               <a:buNone/>
             </a:pPr>
             <a:r>
-              <a:rPr lang="en-US" sz="1400" b="1" dirty="0">
+              <a:rPr lang="en-US" sz="1300" b="1" dirty="0">
                 <a:solidFill>
                   <a:srgbClr val="595959"/>
                 </a:solidFill>
               </a:rPr>
-              <a:t>57% · 6.8k</a:t>
-            </a:r>
-            <a:endParaRPr lang="en-US" sz="1400" dirty="0"/>
-          </a:p>
-        </p:txBody>
-      </p:sp>
-      <p:sp>
-        <p:nvSpPr>
-          <p:cNvPr id="16" name="Text 14"/>
-          <p:cNvSpPr txBox="1"/>
-          <p:nvPr/>
-        </p:nvSpPr>
-        <p:spPr>
-          <a:xfrm>
-            <a:off x="4389120" y="2788920"/>
-            <a:ext cx="1188720" cy="365760"/>
+              <a:t>57% · 6.8k tokens</a:t>
+            </a:r>
+            <a:endParaRPr lang="en-US" sz="1300" dirty="0"/>
+          </a:p>
+        </p:txBody>
+      </p:sp>
+      <p:sp>
+        <p:nvSpPr>
+          <p:cNvPr id="19" name="Text 17"/>
+          <p:cNvSpPr txBox="1"/>
+          <p:nvPr/>
+        </p:nvSpPr>
+        <p:spPr>
+          <a:xfrm>
+            <a:off x="6355080" y="2651760"/>
+            <a:ext cx="822960" cy="365760"/>
           </a:xfrm>
           <a:prstGeom prst="rect">
             <a:avLst/>
@@ -20413,27 +20508,27 @@
               <a:buNone/>
             </a:pPr>
             <a:r>
-              <a:rPr lang="en-US" sz="1400" dirty="0">
+              <a:rPr lang="en-US" sz="1500" dirty="0">
                 <a:solidFill>
                   <a:schemeClr val="tx1"/>
                 </a:solidFill>
               </a:rPr>
-              <a:t>high effort</a:t>
-            </a:r>
-            <a:endParaRPr lang="en-US" sz="1400" dirty="0"/>
-          </a:p>
-        </p:txBody>
-      </p:sp>
-      <p:sp>
-        <p:nvSpPr>
-          <p:cNvPr id="17" name="effort high effort"/>
+              <a:t>high</a:t>
+            </a:r>
+            <a:endParaRPr lang="en-US" sz="1500" dirty="0"/>
+          </a:p>
+        </p:txBody>
+      </p:sp>
+      <p:sp>
+        <p:nvSpPr>
+          <p:cNvPr id="20" name="effort high"/>
           <p:cNvSpPr/>
           <p:nvPr/>
         </p:nvSpPr>
         <p:spPr>
           <a:xfrm>
-            <a:off x="5669280" y="2852928"/>
-            <a:ext cx="1143000" cy="256032"/>
+            <a:off x="7269480" y="2715768"/>
+            <a:ext cx="2743200" cy="274320"/>
           </a:xfrm>
           <a:prstGeom prst="rect">
             <a:avLst/>
@@ -20451,14 +20546,14 @@
       </p:sp>
       <p:sp>
         <p:nvSpPr>
-          <p:cNvPr id="18" name="Text 16"/>
-          <p:cNvSpPr txBox="1"/>
-          <p:nvPr/>
-        </p:nvSpPr>
-        <p:spPr>
-          <a:xfrm>
-            <a:off x="6858000" y="2788920"/>
-            <a:ext cx="1051560" cy="365760"/>
+          <p:cNvPr id="21" name="Text 19"/>
+          <p:cNvSpPr txBox="1"/>
+          <p:nvPr/>
+        </p:nvSpPr>
+        <p:spPr>
+          <a:xfrm>
+            <a:off x="10104120" y="2651760"/>
+            <a:ext cx="1737360" cy="365760"/>
           </a:xfrm>
           <a:prstGeom prst="rect">
             <a:avLst/>
@@ -20474,220 +20569,114 @@
               <a:buNone/>
             </a:pPr>
             <a:r>
-              <a:rPr lang="en-US" sz="1400" b="1" dirty="0">
+              <a:rPr lang="en-US" sz="1300" b="1" dirty="0">
                 <a:solidFill>
                   <a:srgbClr val="ED7D31"/>
                 </a:solidFill>
               </a:rPr>
-              <a:t>66% · 30k</a:t>
-            </a:r>
-            <a:endParaRPr lang="en-US" sz="1400" dirty="0"/>
-          </a:p>
-        </p:txBody>
-      </p:sp>
-      <p:sp>
-        <p:nvSpPr>
-          <p:cNvPr id="19" name="Text 17"/>
-          <p:cNvSpPr txBox="1"/>
-          <p:nvPr/>
-        </p:nvSpPr>
-        <p:spPr>
-          <a:xfrm>
-            <a:off x="4480560" y="3291840"/>
-            <a:ext cx="3200400" cy="1097280"/>
-          </a:xfrm>
-          <a:prstGeom prst="rect">
-            <a:avLst/>
-          </a:prstGeom>
-          <a:noFill/>
-          <a:ln/>
-        </p:spPr>
-        <p:txBody>
-          <a:bodyPr wrap="square" lIns="0" tIns="0" rIns="0" bIns="0" rtlCol="0" anchor="t"/>
+              <a:t>66% · 30k tokens</a:t>
+            </a:r>
+            <a:endParaRPr lang="en-US" sz="1300" dirty="0"/>
+          </a:p>
+        </p:txBody>
+      </p:sp>
+      <p:sp>
+        <p:nvSpPr>
+          <p:cNvPr id="22" name="Text 20"/>
+          <p:cNvSpPr txBox="1"/>
+          <p:nvPr/>
+        </p:nvSpPr>
+        <p:spPr>
+          <a:xfrm>
+            <a:off x="6400800" y="3108960"/>
+            <a:ext cx="5029200" cy="777240"/>
+          </a:xfrm>
+          <a:prstGeom prst="rect">
+            <a:avLst/>
+          </a:prstGeom>
+          <a:noFill/>
+          <a:ln/>
+        </p:spPr>
+        <p:txBody>
+          <a:bodyPr wrap="square" lIns="0" tIns="0" rIns="0" bIns="0" rtlCol="0" anchor="ctr"/>
           <a:lstStyle/>
           <a:p>
             <a:pPr indent="0" marL="0">
               <a:buNone/>
             </a:pPr>
             <a:r>
-              <a:rPr lang="en-US" sz="2400" b="1" dirty="0">
+              <a:rPr lang="en-US" sz="2800" b="1" dirty="0">
                 <a:solidFill>
                   <a:srgbClr val="ED7D31"/>
                 </a:solidFill>
               </a:rPr>
-              <a:t>4.4× the tokens</a:t>
-            </a:r>
-            <a:endParaRPr lang="en-US" sz="1400" dirty="0"/>
-          </a:p>
-          <a:p>
+              <a:t>4.4× tokens</a:t>
+            </a:r>
             <a:pPr indent="0" marL="0">
               <a:buNone/>
             </a:pPr>
             <a:r>
-              <a:rPr lang="en-US" sz="1400" dirty="0">
+              <a:rPr lang="en-US" sz="1500" dirty="0">
                 <a:solidFill>
                   <a:schemeClr val="tx1"/>
                 </a:solidFill>
               </a:rPr>
-              <a:t>for 9 more points</a:t>
-            </a:r>
-            <a:endParaRPr lang="en-US" sz="1400" dirty="0"/>
-          </a:p>
-        </p:txBody>
-      </p:sp>
-      <p:sp>
-        <p:nvSpPr>
-          <p:cNvPr id="20" name="why 3. Why it matters"/>
+              <a:t>  for only 9 more points</a:t>
+            </a:r>
+            <a:endParaRPr lang="en-US" sz="1600" dirty="0"/>
+          </a:p>
+        </p:txBody>
+      </p:sp>
+      <p:sp>
+        <p:nvSpPr>
+          <p:cNvPr id="23" name="Text 21"/>
+          <p:cNvSpPr txBox="1"/>
+          <p:nvPr/>
+        </p:nvSpPr>
+        <p:spPr>
+          <a:xfrm>
+            <a:off x="548640" y="4206240"/>
+            <a:ext cx="1828800" cy="457200"/>
+          </a:xfrm>
+          <a:prstGeom prst="rect">
+            <a:avLst/>
+          </a:prstGeom>
+          <a:noFill/>
+          <a:ln/>
+        </p:spPr>
+        <p:txBody>
+          <a:bodyPr wrap="square" lIns="0" tIns="0" rIns="0" bIns="0" rtlCol="0" anchor="ctr"/>
+          <a:lstStyle/>
+          <a:p>
+            <a:pPr indent="0" marL="0">
+              <a:buNone/>
+            </a:pPr>
+            <a:r>
+              <a:rPr lang="en-US" sz="1600" b="1" dirty="0">
+                <a:solidFill>
+                  <a:schemeClr val="tx1"/>
+                </a:solidFill>
+              </a:rPr>
+              <a:t>Why it matters:</a:t>
+            </a:r>
+            <a:endParaRPr lang="en-US" sz="1600" dirty="0"/>
+          </a:p>
+        </p:txBody>
+      </p:sp>
+      <p:sp>
+        <p:nvSpPr>
+          <p:cNvPr id="24" name="box agents already write"/>
           <p:cNvSpPr/>
           <p:nvPr/>
         </p:nvSpPr>
         <p:spPr>
           <a:xfrm>
-            <a:off x="8046720" y="1280160"/>
-            <a:ext cx="3566160" cy="3154680"/>
+            <a:off x="2377440" y="4206240"/>
+            <a:ext cx="2971800" cy="457200"/>
           </a:xfrm>
           <a:prstGeom prst="roundRect">
             <a:avLst>
-              <a:gd name="adj" fmla="val 2319"/>
-            </a:avLst>
-          </a:prstGeom>
-          <a:solidFill>
-            <a:srgbClr val="EEF3FB"/>
-          </a:solidFill>
-          <a:ln w="12700">
-            <a:solidFill>
-              <a:srgbClr val="4472C4"/>
-            </a:solidFill>
-            <a:prstDash val="solid"/>
-          </a:ln>
-        </p:spPr>
-      </p:sp>
-      <p:sp>
-        <p:nvSpPr>
-          <p:cNvPr id="21" name="Text 19"/>
-          <p:cNvSpPr txBox="1"/>
-          <p:nvPr/>
-        </p:nvSpPr>
-        <p:spPr>
-          <a:xfrm>
-            <a:off x="8229600" y="1371600"/>
-            <a:ext cx="3200400" cy="457200"/>
-          </a:xfrm>
-          <a:prstGeom prst="rect">
-            <a:avLst/>
-          </a:prstGeom>
-          <a:noFill/>
-          <a:ln/>
-        </p:spPr>
-        <p:txBody>
-          <a:bodyPr wrap="square" lIns="0" tIns="0" rIns="0" bIns="0" rtlCol="0" anchor="ctr"/>
-          <a:lstStyle/>
-          <a:p>
-            <a:pPr indent="0" marL="0">
-              <a:buNone/>
-            </a:pPr>
-            <a:r>
-              <a:rPr lang="en-US" sz="1900" b="1" dirty="0">
-                <a:solidFill>
-                  <a:srgbClr val="4472C4"/>
-                </a:solidFill>
-              </a:rPr>
-              <a:t>3. Why it matters</a:t>
-            </a:r>
-            <a:endParaRPr lang="en-US" sz="1900" dirty="0"/>
-          </a:p>
-        </p:txBody>
-      </p:sp>
-      <p:sp>
-        <p:nvSpPr>
-          <p:cNvPr id="22" name="Text 20"/>
-          <p:cNvSpPr txBox="1"/>
-          <p:nvPr/>
-        </p:nvSpPr>
-        <p:spPr>
-          <a:xfrm>
-            <a:off x="8229600" y="1874520"/>
-            <a:ext cx="3200400" cy="2468880"/>
-          </a:xfrm>
-          <a:prstGeom prst="rect">
-            <a:avLst/>
-          </a:prstGeom>
-          <a:noFill/>
-          <a:ln/>
-        </p:spPr>
-        <p:txBody>
-          <a:bodyPr wrap="square" lIns="635" tIns="635" rIns="635" bIns="635" rtlCol="0" anchor="t"/>
-          <a:lstStyle/>
-          <a:p>
-            <a:pPr marL="342900" indent="-342900">
-              <a:spcAft>
-                <a:spcPts val="800"/>
-              </a:spcAft>
-              <a:buSzPct val="100000"/>
-              <a:buChar char="•"/>
-            </a:pPr>
-            <a:r>
-              <a:rPr lang="en-US" sz="1500" dirty="0">
-                <a:solidFill>
-                  <a:schemeClr val="tx1"/>
-                </a:solidFill>
-              </a:rPr>
-              <a:t>coding agents already write route planners, schedulers and geometry code</a:t>
-            </a:r>
-            <a:endParaRPr lang="en-US" sz="1500" dirty="0"/>
-          </a:p>
-          <a:p>
-            <a:pPr marL="342900" indent="-342900">
-              <a:spcAft>
-                <a:spcPts val="800"/>
-              </a:spcAft>
-              <a:buSzPct val="100000"/>
-              <a:buChar char="•"/>
-            </a:pPr>
-            <a:r>
-              <a:rPr lang="en-US" sz="1500" dirty="0">
-                <a:solidFill>
-                  <a:schemeClr val="tx1"/>
-                </a:solidFill>
-              </a:rPr>
-              <a:t>tokens are the cost and the waiting time</a:t>
-            </a:r>
-            <a:endParaRPr lang="en-US" sz="1500" dirty="0"/>
-          </a:p>
-          <a:p>
-            <a:pPr marL="342900" indent="-342900">
-              <a:spcAft>
-                <a:spcPts val="800"/>
-              </a:spcAft>
-              <a:buSzPct val="100000"/>
-              <a:buChar char="•"/>
-            </a:pPr>
-            <a:r>
-              <a:rPr lang="en-US" sz="1500" dirty="0">
-                <a:solidFill>
-                  <a:schemeClr val="tx1"/>
-                </a:solidFill>
-              </a:rPr>
-              <a:t>many teams have one 24 GB GPU, not a 120B model</a:t>
-            </a:r>
-            <a:endParaRPr lang="en-US" sz="1500" dirty="0"/>
-          </a:p>
-        </p:txBody>
-      </p:sp>
-      <p:sp>
-        <p:nvSpPr>
-          <p:cNvPr id="23" name="what we do"/>
-          <p:cNvSpPr/>
-          <p:nvPr/>
-        </p:nvSpPr>
-        <p:spPr>
-          <a:xfrm>
-            <a:off x="548640" y="4617720"/>
-            <a:ext cx="11064240" cy="1417320"/>
-          </a:xfrm>
-          <a:prstGeom prst="roundRect">
-            <a:avLst>
-              <a:gd name="adj" fmla="val 5161"/>
+              <a:gd name="adj" fmla="val 12000"/>
             </a:avLst>
           </a:prstGeom>
           <a:solidFill>
@@ -20695,7 +20684,7 @@
           </a:solidFill>
           <a:ln w="9525">
             <a:solidFill>
-              <a:srgbClr val="D9D9D9"/>
+              <a:srgbClr val="BFBFBF"/>
             </a:solidFill>
             <a:prstDash val="solid"/>
           </a:ln>
@@ -20703,14 +20692,14 @@
       </p:sp>
       <p:sp>
         <p:nvSpPr>
-          <p:cNvPr id="24" name="Text 22"/>
-          <p:cNvSpPr txBox="1"/>
-          <p:nvPr/>
-        </p:nvSpPr>
-        <p:spPr>
-          <a:xfrm>
-            <a:off x="777240" y="4663440"/>
-            <a:ext cx="10607040" cy="1325880"/>
+          <p:cNvPr id="25" name="Text 23"/>
+          <p:cNvSpPr txBox="1"/>
+          <p:nvPr/>
+        </p:nvSpPr>
+        <p:spPr>
+          <a:xfrm>
+            <a:off x="2450592" y="4206240"/>
+            <a:ext cx="2825496" cy="457200"/>
           </a:xfrm>
           <a:prstGeom prst="rect">
             <a:avLst/>
@@ -20722,54 +20711,432 @@
           <a:bodyPr wrap="square" lIns="0" tIns="0" rIns="0" bIns="0" rtlCol="0" anchor="ctr"/>
           <a:lstStyle/>
           <a:p>
+            <a:pPr algn="ctr" indent="0" marL="0">
+              <a:buNone/>
+            </a:pPr>
+            <a:r>
+              <a:rPr lang="en-US" sz="1500" dirty="0">
+                <a:solidFill>
+                  <a:schemeClr val="tx1"/>
+                </a:solidFill>
+              </a:rPr>
+              <a:t>agents already write this code</a:t>
+            </a:r>
+            <a:endParaRPr lang="en-US" sz="1500" dirty="0"/>
+          </a:p>
+        </p:txBody>
+      </p:sp>
+      <p:sp>
+        <p:nvSpPr>
+          <p:cNvPr id="26" name="box tokens = cost and wa"/>
+          <p:cNvSpPr/>
+          <p:nvPr/>
+        </p:nvSpPr>
+        <p:spPr>
+          <a:xfrm>
+            <a:off x="5486400" y="4206240"/>
+            <a:ext cx="2971800" cy="457200"/>
+          </a:xfrm>
+          <a:prstGeom prst="roundRect">
+            <a:avLst>
+              <a:gd name="adj" fmla="val 12000"/>
+            </a:avLst>
+          </a:prstGeom>
+          <a:solidFill>
+            <a:srgbClr val="F2F2F2"/>
+          </a:solidFill>
+          <a:ln w="9525">
+            <a:solidFill>
+              <a:srgbClr val="BFBFBF"/>
+            </a:solidFill>
+            <a:prstDash val="solid"/>
+          </a:ln>
+        </p:spPr>
+      </p:sp>
+      <p:sp>
+        <p:nvSpPr>
+          <p:cNvPr id="27" name="Text 25"/>
+          <p:cNvSpPr txBox="1"/>
+          <p:nvPr/>
+        </p:nvSpPr>
+        <p:spPr>
+          <a:xfrm>
+            <a:off x="5559552" y="4206240"/>
+            <a:ext cx="2825496" cy="457200"/>
+          </a:xfrm>
+          <a:prstGeom prst="rect">
+            <a:avLst/>
+          </a:prstGeom>
+          <a:noFill/>
+          <a:ln/>
+        </p:spPr>
+        <p:txBody>
+          <a:bodyPr wrap="square" lIns="0" tIns="0" rIns="0" bIns="0" rtlCol="0" anchor="ctr"/>
+          <a:lstStyle/>
+          <a:p>
+            <a:pPr algn="ctr" indent="0" marL="0">
+              <a:buNone/>
+            </a:pPr>
+            <a:r>
+              <a:rPr lang="en-US" sz="1500" dirty="0">
+                <a:solidFill>
+                  <a:schemeClr val="tx1"/>
+                </a:solidFill>
+              </a:rPr>
+              <a:t>tokens = cost and waiting time</a:t>
+            </a:r>
+            <a:endParaRPr lang="en-US" sz="1500" dirty="0"/>
+          </a:p>
+        </p:txBody>
+      </p:sp>
+      <p:sp>
+        <p:nvSpPr>
+          <p:cNvPr id="28" name="box most teams have one "/>
+          <p:cNvSpPr/>
+          <p:nvPr/>
+        </p:nvSpPr>
+        <p:spPr>
+          <a:xfrm>
+            <a:off x="8595360" y="4206240"/>
+            <a:ext cx="2971800" cy="457200"/>
+          </a:xfrm>
+          <a:prstGeom prst="roundRect">
+            <a:avLst>
+              <a:gd name="adj" fmla="val 12000"/>
+            </a:avLst>
+          </a:prstGeom>
+          <a:solidFill>
+            <a:srgbClr val="F2F2F2"/>
+          </a:solidFill>
+          <a:ln w="9525">
+            <a:solidFill>
+              <a:srgbClr val="BFBFBF"/>
+            </a:solidFill>
+            <a:prstDash val="solid"/>
+          </a:ln>
+        </p:spPr>
+      </p:sp>
+      <p:sp>
+        <p:nvSpPr>
+          <p:cNvPr id="29" name="Text 27"/>
+          <p:cNvSpPr txBox="1"/>
+          <p:nvPr/>
+        </p:nvSpPr>
+        <p:spPr>
+          <a:xfrm>
+            <a:off x="8668512" y="4206240"/>
+            <a:ext cx="2825496" cy="457200"/>
+          </a:xfrm>
+          <a:prstGeom prst="rect">
+            <a:avLst/>
+          </a:prstGeom>
+          <a:noFill/>
+          <a:ln/>
+        </p:spPr>
+        <p:txBody>
+          <a:bodyPr wrap="square" lIns="0" tIns="0" rIns="0" bIns="0" rtlCol="0" anchor="ctr"/>
+          <a:lstStyle/>
+          <a:p>
+            <a:pPr algn="ctr" indent="0" marL="0">
+              <a:buNone/>
+            </a:pPr>
+            <a:r>
+              <a:rPr lang="en-US" sz="1500" dirty="0">
+                <a:solidFill>
+                  <a:schemeClr val="tx1"/>
+                </a:solidFill>
+              </a:rPr>
+              <a:t>most teams have one 24 GB GPU</a:t>
+            </a:r>
+            <a:endParaRPr lang="en-US" sz="1500" dirty="0"/>
+          </a:p>
+        </p:txBody>
+      </p:sp>
+      <p:sp>
+        <p:nvSpPr>
+          <p:cNvPr id="30" name="our question"/>
+          <p:cNvSpPr/>
+          <p:nvPr/>
+        </p:nvSpPr>
+        <p:spPr>
+          <a:xfrm>
+            <a:off x="548640" y="4892040"/>
+            <a:ext cx="11064240" cy="1097280"/>
+          </a:xfrm>
+          <a:prstGeom prst="roundRect">
+            <a:avLst>
+              <a:gd name="adj" fmla="val 6667"/>
+            </a:avLst>
+          </a:prstGeom>
+          <a:solidFill>
+            <a:srgbClr val="DEEBF7"/>
+          </a:solidFill>
+          <a:ln w="9525">
+            <a:solidFill>
+              <a:srgbClr val="BDD7EE"/>
+            </a:solidFill>
+            <a:prstDash val="solid"/>
+          </a:ln>
+        </p:spPr>
+      </p:sp>
+      <p:sp>
+        <p:nvSpPr>
+          <p:cNvPr id="31" name="Text 29"/>
+          <p:cNvSpPr txBox="1"/>
+          <p:nvPr/>
+        </p:nvSpPr>
+        <p:spPr>
+          <a:xfrm>
+            <a:off x="777240" y="4983480"/>
+            <a:ext cx="3931920" cy="548640"/>
+          </a:xfrm>
+          <a:prstGeom prst="rect">
+            <a:avLst/>
+          </a:prstGeom>
+          <a:noFill/>
+          <a:ln/>
+        </p:spPr>
+        <p:txBody>
+          <a:bodyPr wrap="square" lIns="0" tIns="0" rIns="0" bIns="0" rtlCol="0" anchor="ctr"/>
+          <a:lstStyle/>
+          <a:p>
             <a:pPr indent="0" marL="0">
               <a:buNone/>
             </a:pPr>
             <a:r>
+              <a:rPr lang="en-US" sz="2000" b="1" dirty="0">
+                <a:solidFill>
+                  <a:srgbClr val="4472C4"/>
+                </a:solidFill>
+              </a:rPr>
+              <a:t>Where should extra effort go?</a:t>
+            </a:r>
+            <a:endParaRPr lang="en-US" sz="2000" dirty="0"/>
+          </a:p>
+        </p:txBody>
+      </p:sp>
+      <p:sp>
+        <p:nvSpPr>
+          <p:cNvPr id="32" name="option a missing fact"/>
+          <p:cNvSpPr/>
+          <p:nvPr/>
+        </p:nvSpPr>
+        <p:spPr>
+          <a:xfrm>
+            <a:off x="4846320" y="5029200"/>
+            <a:ext cx="2057400" cy="457200"/>
+          </a:xfrm>
+          <a:prstGeom prst="roundRect">
+            <a:avLst>
+              <a:gd name="adj" fmla="val 40000"/>
+            </a:avLst>
+          </a:prstGeom>
+          <a:solidFill>
+            <a:srgbClr val="E2F0D9"/>
+          </a:solidFill>
+          <a:ln w="12700">
+            <a:solidFill>
+              <a:srgbClr val="38761D"/>
+            </a:solidFill>
+            <a:prstDash val="solid"/>
+          </a:ln>
+        </p:spPr>
+      </p:sp>
+      <p:sp>
+        <p:nvSpPr>
+          <p:cNvPr id="33" name="Text 31"/>
+          <p:cNvSpPr txBox="1"/>
+          <p:nvPr/>
+        </p:nvSpPr>
+        <p:spPr>
+          <a:xfrm>
+            <a:off x="4846320" y="5029200"/>
+            <a:ext cx="2057400" cy="457200"/>
+          </a:xfrm>
+          <a:prstGeom prst="rect">
+            <a:avLst/>
+          </a:prstGeom>
+          <a:noFill/>
+          <a:ln/>
+        </p:spPr>
+        <p:txBody>
+          <a:bodyPr wrap="square" lIns="0" tIns="0" rIns="0" bIns="0" rtlCol="0" anchor="ctr"/>
+          <a:lstStyle/>
+          <a:p>
+            <a:pPr algn="ctr" indent="0" marL="0">
+              <a:buNone/>
+            </a:pPr>
+            <a:r>
               <a:rPr lang="en-US" sz="1600" b="1" dirty="0">
                 <a:solidFill>
-                  <a:srgbClr val="4472C4"/>
-                </a:solidFill>
-              </a:rPr>
-              <a:t>Our question: </a:t>
-            </a:r>
+                  <a:srgbClr val="38761D"/>
+                </a:solidFill>
+              </a:rPr>
+              <a:t>a missing fact</a:t>
+            </a:r>
+            <a:endParaRPr lang="en-US" sz="1600" dirty="0"/>
+          </a:p>
+        </p:txBody>
+      </p:sp>
+      <p:sp>
+        <p:nvSpPr>
+          <p:cNvPr id="34" name="option a free check"/>
+          <p:cNvSpPr/>
+          <p:nvPr/>
+        </p:nvSpPr>
+        <p:spPr>
+          <a:xfrm>
+            <a:off x="7086600" y="5029200"/>
+            <a:ext cx="2057400" cy="457200"/>
+          </a:xfrm>
+          <a:prstGeom prst="roundRect">
+            <a:avLst>
+              <a:gd name="adj" fmla="val 40000"/>
+            </a:avLst>
+          </a:prstGeom>
+          <a:solidFill>
+            <a:srgbClr val="E2F0D9"/>
+          </a:solidFill>
+          <a:ln w="12700">
+            <a:solidFill>
+              <a:srgbClr val="38761D"/>
+            </a:solidFill>
+            <a:prstDash val="solid"/>
+          </a:ln>
+        </p:spPr>
+      </p:sp>
+      <p:sp>
+        <p:nvSpPr>
+          <p:cNvPr id="35" name="Text 33"/>
+          <p:cNvSpPr txBox="1"/>
+          <p:nvPr/>
+        </p:nvSpPr>
+        <p:spPr>
+          <a:xfrm>
+            <a:off x="7086600" y="5029200"/>
+            <a:ext cx="2057400" cy="457200"/>
+          </a:xfrm>
+          <a:prstGeom prst="rect">
+            <a:avLst/>
+          </a:prstGeom>
+          <a:noFill/>
+          <a:ln/>
+        </p:spPr>
+        <p:txBody>
+          <a:bodyPr wrap="square" lIns="0" tIns="0" rIns="0" bIns="0" rtlCol="0" anchor="ctr"/>
+          <a:lstStyle/>
+          <a:p>
+            <a:pPr algn="ctr" indent="0" marL="0">
+              <a:buNone/>
+            </a:pPr>
+            <a:r>
+              <a:rPr lang="en-US" sz="1600" b="1" dirty="0">
+                <a:solidFill>
+                  <a:srgbClr val="38761D"/>
+                </a:solidFill>
+              </a:rPr>
+              <a:t>a free check</a:t>
+            </a:r>
+            <a:endParaRPr lang="en-US" sz="1600" dirty="0"/>
+          </a:p>
+        </p:txBody>
+      </p:sp>
+      <p:sp>
+        <p:nvSpPr>
+          <p:cNvPr id="36" name="option more thinking"/>
+          <p:cNvSpPr/>
+          <p:nvPr/>
+        </p:nvSpPr>
+        <p:spPr>
+          <a:xfrm>
+            <a:off x="9326880" y="5029200"/>
+            <a:ext cx="2057400" cy="457200"/>
+          </a:xfrm>
+          <a:prstGeom prst="roundRect">
+            <a:avLst>
+              <a:gd name="adj" fmla="val 40000"/>
+            </a:avLst>
+          </a:prstGeom>
+          <a:solidFill>
+            <a:srgbClr val="FADBD8"/>
+          </a:solidFill>
+          <a:ln w="12700">
+            <a:solidFill>
+              <a:srgbClr val="C00000"/>
+            </a:solidFill>
+            <a:prstDash val="solid"/>
+          </a:ln>
+        </p:spPr>
+      </p:sp>
+      <p:sp>
+        <p:nvSpPr>
+          <p:cNvPr id="37" name="Text 35"/>
+          <p:cNvSpPr txBox="1"/>
+          <p:nvPr/>
+        </p:nvSpPr>
+        <p:spPr>
+          <a:xfrm>
+            <a:off x="9326880" y="5029200"/>
+            <a:ext cx="2057400" cy="457200"/>
+          </a:xfrm>
+          <a:prstGeom prst="rect">
+            <a:avLst/>
+          </a:prstGeom>
+          <a:noFill/>
+          <a:ln/>
+        </p:spPr>
+        <p:txBody>
+          <a:bodyPr wrap="square" lIns="0" tIns="0" rIns="0" bIns="0" rtlCol="0" anchor="ctr"/>
+          <a:lstStyle/>
+          <a:p>
+            <a:pPr algn="ctr" indent="0" marL="0">
+              <a:buNone/>
+            </a:pPr>
+            <a:r>
+              <a:rPr lang="en-US" sz="1600" b="1" dirty="0">
+                <a:solidFill>
+                  <a:srgbClr val="C00000"/>
+                </a:solidFill>
+              </a:rPr>
+              <a:t>more thinking</a:t>
+            </a:r>
+            <a:endParaRPr lang="en-US" sz="1600" dirty="0"/>
+          </a:p>
+        </p:txBody>
+      </p:sp>
+      <p:sp>
+        <p:nvSpPr>
+          <p:cNvPr id="38" name="Text 36"/>
+          <p:cNvSpPr txBox="1"/>
+          <p:nvPr/>
+        </p:nvSpPr>
+        <p:spPr>
+          <a:xfrm>
+            <a:off x="777240" y="5532120"/>
+            <a:ext cx="10607040" cy="384048"/>
+          </a:xfrm>
+          <a:prstGeom prst="rect">
+            <a:avLst/>
+          </a:prstGeom>
+          <a:noFill/>
+          <a:ln/>
+        </p:spPr>
+        <p:txBody>
+          <a:bodyPr wrap="square" lIns="0" tIns="0" rIns="0" bIns="0" rtlCol="0" anchor="ctr"/>
+          <a:lstStyle/>
+          <a:p>
             <a:pPr indent="0" marL="0">
               <a:buNone/>
             </a:pPr>
             <a:r>
-              <a:rPr lang="en-US" sz="1600" dirty="0">
-                <a:solidFill>
-                  <a:schemeClr val="tx1"/>
-                </a:solidFill>
-              </a:rPr>
-              <a:t>where should the extra effort go: give a missing fact, run a cheap check, or think longer?</a:t>
-            </a:r>
-            <a:endParaRPr lang="en-US" sz="1600" dirty="0"/>
-          </a:p>
-          <a:p>
-            <a:pPr indent="0" marL="0">
-              <a:buNone/>
-            </a:pPr>
-            <a:r>
-              <a:rPr lang="en-US" sz="1600" b="1" dirty="0">
-                <a:solidFill>
-                  <a:srgbClr val="4472C4"/>
-                </a:solidFill>
-              </a:rPr>
-              <a:t>What we do: </a:t>
-            </a:r>
-            <a:pPr indent="0" marL="0">
-              <a:buNone/>
-            </a:pPr>
-            <a:r>
-              <a:rPr lang="en-US" sz="1600" dirty="0">
-                <a:solidFill>
-                  <a:schemeClr val="tx1"/>
-                </a:solidFill>
-              </a:rPr>
-              <a:t>test each fix on geometry, routing, scheduling, contest problems, word problems, competition math and proofs, with open models, scoring accuracy and tokens; then combine the winners into one recipe.</a:t>
-            </a:r>
-            <a:endParaRPr lang="en-US" sz="1600" dirty="0"/>
+              <a:rPr lang="en-US" sz="1400" dirty="0">
+                <a:solidFill>
+                  <a:schemeClr val="tx2"/>
+                </a:solidFill>
+              </a:rPr>
+              <a:t>We test each on geometry, routing, scheduling, contest, word problems, math and proofs, counting accuracy and tokens.</a:t>
+            </a:r>
+            <a:endParaRPr lang="en-US" sz="1400" dirty="0"/>
           </a:p>
         </p:txBody>
       </p:sp>

</xml_diff>

<commit_message>
Slide 3 with pictures and examples: the hull and two real program runs, token cost drawn as pages, icons
Co-Authored-By: Claude Opus 5.5 (1M context) <noreply@anthropic.com>
</commit_message>
<xml_diff>
--- a/PROPOSAL_slides.pptx
+++ b/PROPOSAL_slides.pptx
@@ -126,7 +126,7 @@
   <p:extLst>
     <p:ext uri="{521415D9-36F7-43E2-AB2F-B90AF26B5E84}">
       <p14:sectionLst xmlns:p14="http://schemas.microsoft.com/office/powerpoint/2010/main">
-        <p14:section name="Talk" id="{935ba9ee-8c38-1691-e2ec-2b68de764fd1}">
+        <p14:section name="Talk" id="{2c5bb3fc-ff7e-a0df-1471-7ed9d84b178d}">
           <p14:sldIdLst>
             <p14:sldId id="256"/>
             <p14:sldId id="257"/>
@@ -139,7 +139,7 @@
             <p14:sldId id="264"/>
           </p14:sldIdLst>
         </p14:section>
-        <p14:section name="Extra pages" id="{ad808c57-82de-12b8-1626-a082ddab02cc}">
+        <p14:section name="Extra pages" id="{4002e3c2-9c1a-a10a-4eaf-416591ad2cd7}">
           <p14:sldIdLst>
             <p14:sldId id="265"/>
             <p14:sldId id="266"/>
@@ -2522,7 +2522,7 @@
           <a:p>
             <a:r>
               <a:rPr lang="en-US" dirty="0"/>
-              <a:t>(35 s) Two problems. (1) Programs fail silently: for the same task (how many corners does the rubber band around 10 points have?) Qwen3-14B's program prints 6 with only the task, and 0 when the prompt also offers 8 unneeded helper functions, with no error message; and 24-37% of gpt-oss-120b's wrong contest programs pass the examples printed in the problem. (2) Thinking longer is expensive: on 311 Codeforces geometry problems gpt-oss-120b solves 57% at medium effort (6.8k tokens per problem) and 66% at high effort (30k), 4.4 times the tokens for 9 more points. Why it matters: agents already write route planners, schedulers and geometry code; tokens are cost and latency; most teams have one small GPU. Our question: where should extra effort go, a missing fact, a free check, or more thinking? We test each on seven kinds of problems, counting accuracy and tokens, and combine what works.</a:t>
+              <a:t>(35 s) Two problems. (1) Programs fail silently: for the same task (how many corners does the rubber band around these 10 points have?) Qwen3-14B's program prints 6 with only the task, and 0 when the prompt also offers 8 unneeded helper functions, with no error message. Even the examples in a contest problem miss such bugs: a program for 'Find Color' passes all 3 and fails hidden test 11; 24-37% of gpt-oss-120b's wrong contest programs pass the examples. (2) Thinking longer is expensive: on 311 Codeforces geometry problems gpt-oss-120b uses 6.8k tokens per problem at medium effort (about 10 pages) and solves 57%, and 30k tokens at high effort (about 43 pages) for 66%: 4.4 times the tokens for 9 more points. Why it matters: agents already write route planners, schedulers and geometry code; tokens are cost and latency; most teams have one small GPU. Our question: where should extra effort go, a missing fact, a free check, or more thinking? We test each on geometry, routing, scheduling, contest problems, word problems, math and proofs, counting accuracy and tokens.</a:t>
             </a:r>
             <a:endParaRPr lang="en-US" dirty="0"/>
           </a:p>
@@ -19951,12 +19951,12 @@
         </p:nvSpPr>
         <p:spPr>
           <a:xfrm>
-            <a:off x="548640" y="1280160"/>
-            <a:ext cx="5440680" cy="2743200"/>
+            <a:off x="548640" y="1234440"/>
+            <a:ext cx="5440680" cy="3017520"/>
           </a:xfrm>
           <a:prstGeom prst="roundRect">
             <a:avLst>
-              <a:gd name="adj" fmla="val 2667"/>
+              <a:gd name="adj" fmla="val 2424"/>
             </a:avLst>
           </a:prstGeom>
           <a:solidFill>
@@ -19978,8 +19978,8 @@
         </p:nvSpPr>
         <p:spPr>
           <a:xfrm>
-            <a:off x="777240" y="1371600"/>
-            <a:ext cx="4983480" cy="502920"/>
+            <a:off x="777240" y="1307592"/>
+            <a:ext cx="4983480" cy="457200"/>
           </a:xfrm>
           <a:prstGeom prst="rect">
             <a:avLst/>
@@ -19995,27 +19995,51 @@
               <a:buNone/>
             </a:pPr>
             <a:r>
-              <a:rPr lang="en-US" sz="2200" b="1" dirty="0">
+              <a:rPr lang="en-US" sz="2100" b="1" dirty="0">
                 <a:solidFill>
                   <a:srgbClr val="C00000"/>
                 </a:solidFill>
               </a:rPr>
               <a:t>1. Programs fail silently</a:t>
             </a:r>
-            <a:endParaRPr lang="en-US" sz="2200" dirty="0"/>
-          </a:p>
-        </p:txBody>
-      </p:sp>
-      <p:sp>
-        <p:nvSpPr>
-          <p:cNvPr id="5" name="Text 3"/>
-          <p:cNvSpPr txBox="1"/>
-          <p:nvPr/>
-        </p:nvSpPr>
-        <p:spPr>
-          <a:xfrm>
-            <a:off x="777240" y="1828800"/>
-            <a:ext cx="5029200" cy="274320"/>
+            <a:endParaRPr lang="en-US" sz="2100" dirty="0"/>
+          </a:p>
+        </p:txBody>
+      </p:sp>
+      <p:pic>
+        <p:nvPicPr>
+          <p:cNvPr id="5" name="ten points and their hull" descr="10 points; the rubber band touches 6 of them">    </p:cNvPr>
+          <p:cNvPicPr>
+            <a:picLocks noChangeAspect="1"/>
+          </p:cNvPicPr>
+          <p:nvPr/>
+        </p:nvPicPr>
+        <p:blipFill>
+          <a:blip r:embed="rId1"/>
+          <a:stretch>
+            <a:fillRect/>
+          </a:stretch>
+        </p:blipFill>
+        <p:spPr>
+          <a:xfrm>
+            <a:off x="731520" y="1828800"/>
+            <a:ext cx="1325880" cy="1325880"/>
+          </a:xfrm>
+          <a:prstGeom prst="rect">
+            <a:avLst/>
+          </a:prstGeom>
+        </p:spPr>
+      </p:pic>
+      <p:sp>
+        <p:nvSpPr>
+          <p:cNvPr id="6" name="Text 3"/>
+          <p:cNvSpPr txBox="1"/>
+          <p:nvPr/>
+        </p:nvSpPr>
+        <p:spPr>
+          <a:xfrm>
+            <a:off x="594360" y="3154680"/>
+            <a:ext cx="1600200" cy="274320"/>
           </a:xfrm>
           <a:prstGeom prst="rect">
             <a:avLst/>
@@ -20027,35 +20051,2138 @@
           <a:bodyPr wrap="square" lIns="0" tIns="0" rIns="0" bIns="0" rtlCol="0" anchor="ctr"/>
           <a:lstStyle/>
           <a:p>
-            <a:pPr indent="0" marL="0">
-              <a:buNone/>
-            </a:pPr>
-            <a:r>
-              <a:rPr lang="en-US" sz="1300" dirty="0">
-                <a:solidFill>
-                  <a:schemeClr val="tx2"/>
-                </a:solidFill>
-              </a:rPr>
-              <a:t>Same task (corners around 10 points), two programs:</a:t>
-            </a:r>
-            <a:endParaRPr lang="en-US" sz="1300" dirty="0"/>
-          </a:p>
-        </p:txBody>
-      </p:sp>
-      <p:sp>
-        <p:nvSpPr>
-          <p:cNvPr id="6" name="answer 6 ✓"/>
+            <a:pPr algn="ctr" indent="0" marL="0">
+              <a:buNone/>
+            </a:pPr>
+            <a:r>
+              <a:rPr lang="en-US" sz="1200" b="1" dirty="0">
+                <a:solidFill>
+                  <a:srgbClr val="70AD47"/>
+                </a:solidFill>
+              </a:rPr>
+              <a:t>10 points: 6 corners</a:t>
+            </a:r>
+            <a:endParaRPr lang="en-US" sz="1200" dirty="0"/>
+          </a:p>
+        </p:txBody>
+      </p:sp>
+      <p:sp>
+        <p:nvSpPr>
+          <p:cNvPr id="7" name="terminal"/>
           <p:cNvSpPr/>
           <p:nvPr/>
         </p:nvSpPr>
         <p:spPr>
           <a:xfrm>
-            <a:off x="914400" y="2194560"/>
-            <a:ext cx="1554480" cy="548640"/>
+            <a:off x="2240280" y="1828800"/>
+            <a:ext cx="3611880" cy="1417320"/>
           </a:xfrm>
           <a:prstGeom prst="roundRect">
             <a:avLst>
-              <a:gd name="adj" fmla="val 16667"/>
+              <a:gd name="adj" fmla="val 3226"/>
+            </a:avLst>
+          </a:prstGeom>
+          <a:solidFill>
+            <a:srgbClr val="262626"/>
+          </a:solidFill>
+          <a:ln w="12700">
+            <a:solidFill>
+              <a:srgbClr val="262626"/>
+            </a:solidFill>
+            <a:prstDash val="solid"/>
+          </a:ln>
+        </p:spPr>
+      </p:sp>
+      <p:sp>
+        <p:nvSpPr>
+          <p:cNvPr id="8" name="Text 5"/>
+          <p:cNvSpPr txBox="1"/>
+          <p:nvPr/>
+        </p:nvSpPr>
+        <p:spPr>
+          <a:xfrm>
+            <a:off x="2377440" y="1874520"/>
+            <a:ext cx="3383280" cy="1325880"/>
+          </a:xfrm>
+          <a:prstGeom prst="rect">
+            <a:avLst/>
+          </a:prstGeom>
+          <a:noFill/>
+          <a:ln/>
+        </p:spPr>
+        <p:txBody>
+          <a:bodyPr wrap="square" lIns="0" tIns="0" rIns="0" bIns="0" rtlCol="0" anchor="ctr"/>
+          <a:lstStyle/>
+          <a:p>
+            <a:pPr indent="0" marL="0">
+              <a:buNone/>
+            </a:pPr>
+            <a:r>
+              <a:rPr lang="en-US" sz="1250" dirty="0">
+                <a:solidFill>
+                  <a:srgbClr val="BFBFBF"/>
+                </a:solidFill>
+                <a:latin typeface="Courier New" pitchFamily="34" charset="0"/>
+                <a:ea typeface="Courier New" pitchFamily="34" charset="-122"/>
+                <a:cs typeface="Courier New" pitchFamily="34" charset="-120"/>
+              </a:rPr>
+              <a:t>$ python hull_A.py   # task only</a:t>
+            </a:r>
+            <a:endParaRPr lang="en-US" sz="1250" dirty="0"/>
+          </a:p>
+          <a:p>
+            <a:pPr indent="0" marL="0">
+              <a:buNone/>
+            </a:pPr>
+            <a:r>
+              <a:rPr lang="en-US" sz="1250" b="1" dirty="0">
+                <a:solidFill>
+                  <a:srgbClr val="8FD16A"/>
+                </a:solidFill>
+                <a:latin typeface="Courier New" pitchFamily="34" charset="0"/>
+                <a:ea typeface="Courier New" pitchFamily="34" charset="-122"/>
+                <a:cs typeface="Courier New" pitchFamily="34" charset="-120"/>
+              </a:rPr>
+              <a:t>6</a:t>
+            </a:r>
+            <a:endParaRPr lang="en-US" sz="1250" dirty="0"/>
+          </a:p>
+          <a:p>
+            <a:pPr indent="0" marL="0">
+              <a:buNone/>
+            </a:pPr>
+            <a:r>
+              <a:rPr lang="en-US" sz="1250" dirty="0">
+                <a:solidFill>
+                  <a:srgbClr val="BFBFBF"/>
+                </a:solidFill>
+                <a:latin typeface="Courier New" pitchFamily="34" charset="0"/>
+                <a:ea typeface="Courier New" pitchFamily="34" charset="-122"/>
+                <a:cs typeface="Courier New" pitchFamily="34" charset="-120"/>
+              </a:rPr>
+              <a:t>$ python hull_B.py   # + 8 helpers</a:t>
+            </a:r>
+            <a:endParaRPr lang="en-US" sz="1250" dirty="0"/>
+          </a:p>
+          <a:p>
+            <a:pPr indent="0" marL="0">
+              <a:buNone/>
+            </a:pPr>
+            <a:r>
+              <a:rPr lang="en-US" sz="1250" b="1" dirty="0">
+                <a:solidFill>
+                  <a:srgbClr val="FF7B7B"/>
+                </a:solidFill>
+                <a:latin typeface="Courier New" pitchFamily="34" charset="0"/>
+                <a:ea typeface="Courier New" pitchFamily="34" charset="-122"/>
+                <a:cs typeface="Courier New" pitchFamily="34" charset="-120"/>
+              </a:rPr>
+              <a:t>0    ← no error, just wrong</a:t>
+            </a:r>
+            <a:endParaRPr lang="en-US" sz="1250" dirty="0"/>
+          </a:p>
+        </p:txBody>
+      </p:sp>
+      <p:pic>
+        <p:nvPicPr>
+          <p:cNvPr id="9" name="warning icon" descr="/NAS/SJ/POSTECH/nlp/figs/icons/warn.png">    </p:cNvPr>
+          <p:cNvPicPr>
+            <a:picLocks noChangeAspect="1"/>
+          </p:cNvPicPr>
+          <p:nvPr/>
+        </p:nvPicPr>
+        <p:blipFill>
+          <a:blip r:embed="rId2"/>
+          <a:stretch>
+            <a:fillRect/>
+          </a:stretch>
+        </p:blipFill>
+        <p:spPr>
+          <a:xfrm>
+            <a:off x="777240" y="3593592"/>
+            <a:ext cx="320040" cy="320040"/>
+          </a:xfrm>
+          <a:prstGeom prst="rect">
+            <a:avLst/>
+          </a:prstGeom>
+        </p:spPr>
+      </p:pic>
+      <p:sp>
+        <p:nvSpPr>
+          <p:cNvPr id="10" name="Text 6"/>
+          <p:cNvSpPr txBox="1"/>
+          <p:nvPr/>
+        </p:nvSpPr>
+        <p:spPr>
+          <a:xfrm>
+            <a:off x="1188720" y="3520440"/>
+            <a:ext cx="4663440" cy="548640"/>
+          </a:xfrm>
+          <a:prstGeom prst="rect">
+            <a:avLst/>
+          </a:prstGeom>
+          <a:noFill/>
+          <a:ln/>
+        </p:spPr>
+        <p:txBody>
+          <a:bodyPr wrap="square" lIns="0" tIns="0" rIns="0" bIns="0" rtlCol="0" anchor="ctr"/>
+          <a:lstStyle/>
+          <a:p>
+            <a:pPr indent="0" marL="0">
+              <a:buNone/>
+            </a:pPr>
+            <a:r>
+              <a:rPr lang="en-US" sz="1300" dirty="0">
+                <a:solidFill>
+                  <a:schemeClr val="tx1"/>
+                </a:solidFill>
+              </a:rPr>
+              <a:t>The problem's own examples miss it too: "Find Color" passes all 3, then fails hidden test 11</a:t>
+            </a:r>
+            <a:endParaRPr lang="en-US" sz="1300" dirty="0"/>
+          </a:p>
+        </p:txBody>
+      </p:sp>
+      <p:sp>
+        <p:nvSpPr>
+          <p:cNvPr id="11" name="why 2. Thinking longer is expensive"/>
+          <p:cNvSpPr/>
+          <p:nvPr/>
+        </p:nvSpPr>
+        <p:spPr>
+          <a:xfrm>
+            <a:off x="6172200" y="1234440"/>
+            <a:ext cx="5440680" cy="3017520"/>
+          </a:xfrm>
+          <a:prstGeom prst="roundRect">
+            <a:avLst>
+              <a:gd name="adj" fmla="val 2424"/>
+            </a:avLst>
+          </a:prstGeom>
+          <a:solidFill>
+            <a:srgbClr val="FDF0E6"/>
+          </a:solidFill>
+          <a:ln w="12700">
+            <a:solidFill>
+              <a:srgbClr val="ED7D31"/>
+            </a:solidFill>
+            <a:prstDash val="solid"/>
+          </a:ln>
+        </p:spPr>
+      </p:sp>
+      <p:sp>
+        <p:nvSpPr>
+          <p:cNvPr id="12" name="Text 8"/>
+          <p:cNvSpPr txBox="1"/>
+          <p:nvPr/>
+        </p:nvSpPr>
+        <p:spPr>
+          <a:xfrm>
+            <a:off x="6400800" y="1307592"/>
+            <a:ext cx="4983480" cy="457200"/>
+          </a:xfrm>
+          <a:prstGeom prst="rect">
+            <a:avLst/>
+          </a:prstGeom>
+          <a:noFill/>
+          <a:ln/>
+        </p:spPr>
+        <p:txBody>
+          <a:bodyPr wrap="square" lIns="0" tIns="0" rIns="0" bIns="0" rtlCol="0" anchor="ctr"/>
+          <a:lstStyle/>
+          <a:p>
+            <a:pPr indent="0" marL="0">
+              <a:buNone/>
+            </a:pPr>
+            <a:r>
+              <a:rPr lang="en-US" sz="2100" b="1" dirty="0">
+                <a:solidFill>
+                  <a:srgbClr val="ED7D31"/>
+                </a:solidFill>
+              </a:rPr>
+              <a:t>2. Thinking longer is expensive</a:t>
+            </a:r>
+            <a:endParaRPr lang="en-US" sz="2100" dirty="0"/>
+          </a:p>
+        </p:txBody>
+      </p:sp>
+      <p:sp>
+        <p:nvSpPr>
+          <p:cNvPr id="13" name="Text 9"/>
+          <p:cNvSpPr txBox="1"/>
+          <p:nvPr/>
+        </p:nvSpPr>
+        <p:spPr>
+          <a:xfrm>
+            <a:off x="6400800" y="1783080"/>
+            <a:ext cx="5029200" cy="274320"/>
+          </a:xfrm>
+          <a:prstGeom prst="rect">
+            <a:avLst/>
+          </a:prstGeom>
+          <a:noFill/>
+          <a:ln/>
+        </p:spPr>
+        <p:txBody>
+          <a:bodyPr wrap="square" lIns="0" tIns="0" rIns="0" bIns="0" rtlCol="0" anchor="ctr"/>
+          <a:lstStyle/>
+          <a:p>
+            <a:pPr indent="0" marL="0">
+              <a:buNone/>
+            </a:pPr>
+            <a:r>
+              <a:rPr lang="en-US" sz="1250" dirty="0">
+                <a:solidFill>
+                  <a:schemeClr val="tx2"/>
+                </a:solidFill>
+              </a:rPr>
+              <a:t>tokens per contest problem (gpt-oss-120b); one page ≈ 700 tokens</a:t>
+            </a:r>
+            <a:endParaRPr lang="en-US" sz="1250" dirty="0"/>
+          </a:p>
+        </p:txBody>
+      </p:sp>
+      <p:sp>
+        <p:nvSpPr>
+          <p:cNvPr id="14" name="Text 10"/>
+          <p:cNvSpPr txBox="1"/>
+          <p:nvPr/>
+        </p:nvSpPr>
+        <p:spPr>
+          <a:xfrm>
+            <a:off x="6400800" y="2148840"/>
+            <a:ext cx="1417320" cy="457200"/>
+          </a:xfrm>
+          <a:prstGeom prst="rect">
+            <a:avLst/>
+          </a:prstGeom>
+          <a:noFill/>
+          <a:ln/>
+        </p:spPr>
+        <p:txBody>
+          <a:bodyPr wrap="square" lIns="0" tIns="0" rIns="0" bIns="0" rtlCol="0" anchor="ctr"/>
+          <a:lstStyle/>
+          <a:p>
+            <a:pPr indent="0" marL="0">
+              <a:buNone/>
+            </a:pPr>
+            <a:r>
+              <a:rPr lang="en-US" sz="1300" b="1" dirty="0">
+                <a:solidFill>
+                  <a:schemeClr val="tx1"/>
+                </a:solidFill>
+              </a:rPr>
+              <a:t>medium effort</a:t>
+            </a:r>
+            <a:endParaRPr lang="en-US" sz="1300" dirty="0"/>
+          </a:p>
+          <a:p>
+            <a:pPr indent="0" marL="0">
+              <a:buNone/>
+            </a:pPr>
+            <a:r>
+              <a:rPr lang="en-US" sz="1300" dirty="0">
+                <a:solidFill>
+                  <a:schemeClr val="tx1"/>
+                </a:solidFill>
+              </a:rPr>
+              <a:t>57% solved</a:t>
+            </a:r>
+            <a:endParaRPr lang="en-US" sz="1300" dirty="0"/>
+          </a:p>
+        </p:txBody>
+      </p:sp>
+      <p:pic>
+        <p:nvPicPr>
+          <p:cNvPr id="15" name="medium effort page 0" descr="/NAS/SJ/POSTECH/nlp/figs/icons/page.png">    </p:cNvPr>
+          <p:cNvPicPr>
+            <a:picLocks noChangeAspect="1"/>
+          </p:cNvPicPr>
+          <p:nvPr/>
+        </p:nvPicPr>
+        <p:blipFill>
+          <a:blip r:embed="rId3"/>
+          <a:stretch>
+            <a:fillRect/>
+          </a:stretch>
+        </p:blipFill>
+        <p:spPr>
+          <a:xfrm>
+            <a:off x="7863840" y="2148840"/>
+            <a:ext cx="173736" cy="201168"/>
+          </a:xfrm>
+          <a:prstGeom prst="rect">
+            <a:avLst/>
+          </a:prstGeom>
+        </p:spPr>
+      </p:pic>
+      <p:pic>
+        <p:nvPicPr>
+          <p:cNvPr id="16" name="medium effort page 1" descr="/NAS/SJ/POSTECH/nlp/figs/icons/page.png">    </p:cNvPr>
+          <p:cNvPicPr>
+            <a:picLocks noChangeAspect="1"/>
+          </p:cNvPicPr>
+          <p:nvPr/>
+        </p:nvPicPr>
+        <p:blipFill>
+          <a:blip r:embed="rId4"/>
+          <a:stretch>
+            <a:fillRect/>
+          </a:stretch>
+        </p:blipFill>
+        <p:spPr>
+          <a:xfrm>
+            <a:off x="8042148" y="2148840"/>
+            <a:ext cx="173736" cy="201168"/>
+          </a:xfrm>
+          <a:prstGeom prst="rect">
+            <a:avLst/>
+          </a:prstGeom>
+        </p:spPr>
+      </p:pic>
+      <p:pic>
+        <p:nvPicPr>
+          <p:cNvPr id="17" name="medium effort page 2" descr="/NAS/SJ/POSTECH/nlp/figs/icons/page.png">    </p:cNvPr>
+          <p:cNvPicPr>
+            <a:picLocks noChangeAspect="1"/>
+          </p:cNvPicPr>
+          <p:nvPr/>
+        </p:nvPicPr>
+        <p:blipFill>
+          <a:blip r:embed="rId5"/>
+          <a:stretch>
+            <a:fillRect/>
+          </a:stretch>
+        </p:blipFill>
+        <p:spPr>
+          <a:xfrm>
+            <a:off x="8220456" y="2148840"/>
+            <a:ext cx="173736" cy="201168"/>
+          </a:xfrm>
+          <a:prstGeom prst="rect">
+            <a:avLst/>
+          </a:prstGeom>
+        </p:spPr>
+      </p:pic>
+      <p:pic>
+        <p:nvPicPr>
+          <p:cNvPr id="18" name="medium effort page 3" descr="/NAS/SJ/POSTECH/nlp/figs/icons/page.png">    </p:cNvPr>
+          <p:cNvPicPr>
+            <a:picLocks noChangeAspect="1"/>
+          </p:cNvPicPr>
+          <p:nvPr/>
+        </p:nvPicPr>
+        <p:blipFill>
+          <a:blip r:embed="rId6"/>
+          <a:stretch>
+            <a:fillRect/>
+          </a:stretch>
+        </p:blipFill>
+        <p:spPr>
+          <a:xfrm>
+            <a:off x="8398764" y="2148840"/>
+            <a:ext cx="173736" cy="201168"/>
+          </a:xfrm>
+          <a:prstGeom prst="rect">
+            <a:avLst/>
+          </a:prstGeom>
+        </p:spPr>
+      </p:pic>
+      <p:pic>
+        <p:nvPicPr>
+          <p:cNvPr id="19" name="medium effort page 4" descr="/NAS/SJ/POSTECH/nlp/figs/icons/page.png">    </p:cNvPr>
+          <p:cNvPicPr>
+            <a:picLocks noChangeAspect="1"/>
+          </p:cNvPicPr>
+          <p:nvPr/>
+        </p:nvPicPr>
+        <p:blipFill>
+          <a:blip r:embed="rId7"/>
+          <a:stretch>
+            <a:fillRect/>
+          </a:stretch>
+        </p:blipFill>
+        <p:spPr>
+          <a:xfrm>
+            <a:off x="8577072" y="2148840"/>
+            <a:ext cx="173736" cy="201168"/>
+          </a:xfrm>
+          <a:prstGeom prst="rect">
+            <a:avLst/>
+          </a:prstGeom>
+        </p:spPr>
+      </p:pic>
+      <p:pic>
+        <p:nvPicPr>
+          <p:cNvPr id="20" name="medium effort page 5" descr="/NAS/SJ/POSTECH/nlp/figs/icons/page.png">    </p:cNvPr>
+          <p:cNvPicPr>
+            <a:picLocks noChangeAspect="1"/>
+          </p:cNvPicPr>
+          <p:nvPr/>
+        </p:nvPicPr>
+        <p:blipFill>
+          <a:blip r:embed="rId8"/>
+          <a:stretch>
+            <a:fillRect/>
+          </a:stretch>
+        </p:blipFill>
+        <p:spPr>
+          <a:xfrm>
+            <a:off x="8755380" y="2148840"/>
+            <a:ext cx="173736" cy="201168"/>
+          </a:xfrm>
+          <a:prstGeom prst="rect">
+            <a:avLst/>
+          </a:prstGeom>
+        </p:spPr>
+      </p:pic>
+      <p:pic>
+        <p:nvPicPr>
+          <p:cNvPr id="21" name="medium effort page 6" descr="/NAS/SJ/POSTECH/nlp/figs/icons/page.png">    </p:cNvPr>
+          <p:cNvPicPr>
+            <a:picLocks noChangeAspect="1"/>
+          </p:cNvPicPr>
+          <p:nvPr/>
+        </p:nvPicPr>
+        <p:blipFill>
+          <a:blip r:embed="rId9"/>
+          <a:stretch>
+            <a:fillRect/>
+          </a:stretch>
+        </p:blipFill>
+        <p:spPr>
+          <a:xfrm>
+            <a:off x="8933688" y="2148840"/>
+            <a:ext cx="173736" cy="201168"/>
+          </a:xfrm>
+          <a:prstGeom prst="rect">
+            <a:avLst/>
+          </a:prstGeom>
+        </p:spPr>
+      </p:pic>
+      <p:pic>
+        <p:nvPicPr>
+          <p:cNvPr id="22" name="medium effort page 7" descr="/NAS/SJ/POSTECH/nlp/figs/icons/page.png">    </p:cNvPr>
+          <p:cNvPicPr>
+            <a:picLocks noChangeAspect="1"/>
+          </p:cNvPicPr>
+          <p:nvPr/>
+        </p:nvPicPr>
+        <p:blipFill>
+          <a:blip r:embed="rId10"/>
+          <a:stretch>
+            <a:fillRect/>
+          </a:stretch>
+        </p:blipFill>
+        <p:spPr>
+          <a:xfrm>
+            <a:off x="9111996" y="2148840"/>
+            <a:ext cx="173736" cy="201168"/>
+          </a:xfrm>
+          <a:prstGeom prst="rect">
+            <a:avLst/>
+          </a:prstGeom>
+        </p:spPr>
+      </p:pic>
+      <p:pic>
+        <p:nvPicPr>
+          <p:cNvPr id="23" name="medium effort page 8" descr="/NAS/SJ/POSTECH/nlp/figs/icons/page.png">    </p:cNvPr>
+          <p:cNvPicPr>
+            <a:picLocks noChangeAspect="1"/>
+          </p:cNvPicPr>
+          <p:nvPr/>
+        </p:nvPicPr>
+        <p:blipFill>
+          <a:blip r:embed="rId11"/>
+          <a:stretch>
+            <a:fillRect/>
+          </a:stretch>
+        </p:blipFill>
+        <p:spPr>
+          <a:xfrm>
+            <a:off x="9290304" y="2148840"/>
+            <a:ext cx="173736" cy="201168"/>
+          </a:xfrm>
+          <a:prstGeom prst="rect">
+            <a:avLst/>
+          </a:prstGeom>
+        </p:spPr>
+      </p:pic>
+      <p:pic>
+        <p:nvPicPr>
+          <p:cNvPr id="24" name="medium effort page 9" descr="/NAS/SJ/POSTECH/nlp/figs/icons/page.png">    </p:cNvPr>
+          <p:cNvPicPr>
+            <a:picLocks noChangeAspect="1"/>
+          </p:cNvPicPr>
+          <p:nvPr/>
+        </p:nvPicPr>
+        <p:blipFill>
+          <a:blip r:embed="rId12"/>
+          <a:stretch>
+            <a:fillRect/>
+          </a:stretch>
+        </p:blipFill>
+        <p:spPr>
+          <a:xfrm>
+            <a:off x="9468612" y="2148840"/>
+            <a:ext cx="173736" cy="201168"/>
+          </a:xfrm>
+          <a:prstGeom prst="rect">
+            <a:avLst/>
+          </a:prstGeom>
+        </p:spPr>
+      </p:pic>
+      <p:sp>
+        <p:nvSpPr>
+          <p:cNvPr id="25" name="Text 11"/>
+          <p:cNvSpPr txBox="1"/>
+          <p:nvPr/>
+        </p:nvSpPr>
+        <p:spPr>
+          <a:xfrm>
+            <a:off x="6400800" y="2651760"/>
+            <a:ext cx="1417320" cy="457200"/>
+          </a:xfrm>
+          <a:prstGeom prst="rect">
+            <a:avLst/>
+          </a:prstGeom>
+          <a:noFill/>
+          <a:ln/>
+        </p:spPr>
+        <p:txBody>
+          <a:bodyPr wrap="square" lIns="0" tIns="0" rIns="0" bIns="0" rtlCol="0" anchor="ctr"/>
+          <a:lstStyle/>
+          <a:p>
+            <a:pPr indent="0" marL="0">
+              <a:buNone/>
+            </a:pPr>
+            <a:r>
+              <a:rPr lang="en-US" sz="1300" b="1" dirty="0">
+                <a:solidFill>
+                  <a:schemeClr val="tx1"/>
+                </a:solidFill>
+              </a:rPr>
+              <a:t>high effort</a:t>
+            </a:r>
+            <a:endParaRPr lang="en-US" sz="1300" dirty="0"/>
+          </a:p>
+          <a:p>
+            <a:pPr indent="0" marL="0">
+              <a:buNone/>
+            </a:pPr>
+            <a:r>
+              <a:rPr lang="en-US" sz="1300" dirty="0">
+                <a:solidFill>
+                  <a:schemeClr val="tx1"/>
+                </a:solidFill>
+              </a:rPr>
+              <a:t>66% solved</a:t>
+            </a:r>
+            <a:endParaRPr lang="en-US" sz="1300" dirty="0"/>
+          </a:p>
+        </p:txBody>
+      </p:sp>
+      <p:pic>
+        <p:nvPicPr>
+          <p:cNvPr id="26" name="high effort page 0" descr="/NAS/SJ/POSTECH/nlp/figs/icons/pagehot.png">    </p:cNvPr>
+          <p:cNvPicPr>
+            <a:picLocks noChangeAspect="1"/>
+          </p:cNvPicPr>
+          <p:nvPr/>
+        </p:nvPicPr>
+        <p:blipFill>
+          <a:blip r:embed="rId13"/>
+          <a:stretch>
+            <a:fillRect/>
+          </a:stretch>
+        </p:blipFill>
+        <p:spPr>
+          <a:xfrm>
+            <a:off x="7863840" y="2651760"/>
+            <a:ext cx="173736" cy="201168"/>
+          </a:xfrm>
+          <a:prstGeom prst="rect">
+            <a:avLst/>
+          </a:prstGeom>
+        </p:spPr>
+      </p:pic>
+      <p:pic>
+        <p:nvPicPr>
+          <p:cNvPr id="27" name="high effort page 1" descr="/NAS/SJ/POSTECH/nlp/figs/icons/pagehot.png">    </p:cNvPr>
+          <p:cNvPicPr>
+            <a:picLocks noChangeAspect="1"/>
+          </p:cNvPicPr>
+          <p:nvPr/>
+        </p:nvPicPr>
+        <p:blipFill>
+          <a:blip r:embed="rId14"/>
+          <a:stretch>
+            <a:fillRect/>
+          </a:stretch>
+        </p:blipFill>
+        <p:spPr>
+          <a:xfrm>
+            <a:off x="8042148" y="2651760"/>
+            <a:ext cx="173736" cy="201168"/>
+          </a:xfrm>
+          <a:prstGeom prst="rect">
+            <a:avLst/>
+          </a:prstGeom>
+        </p:spPr>
+      </p:pic>
+      <p:pic>
+        <p:nvPicPr>
+          <p:cNvPr id="28" name="high effort page 2" descr="/NAS/SJ/POSTECH/nlp/figs/icons/pagehot.png">    </p:cNvPr>
+          <p:cNvPicPr>
+            <a:picLocks noChangeAspect="1"/>
+          </p:cNvPicPr>
+          <p:nvPr/>
+        </p:nvPicPr>
+        <p:blipFill>
+          <a:blip r:embed="rId15"/>
+          <a:stretch>
+            <a:fillRect/>
+          </a:stretch>
+        </p:blipFill>
+        <p:spPr>
+          <a:xfrm>
+            <a:off x="8220456" y="2651760"/>
+            <a:ext cx="173736" cy="201168"/>
+          </a:xfrm>
+          <a:prstGeom prst="rect">
+            <a:avLst/>
+          </a:prstGeom>
+        </p:spPr>
+      </p:pic>
+      <p:pic>
+        <p:nvPicPr>
+          <p:cNvPr id="29" name="high effort page 3" descr="/NAS/SJ/POSTECH/nlp/figs/icons/pagehot.png">    </p:cNvPr>
+          <p:cNvPicPr>
+            <a:picLocks noChangeAspect="1"/>
+          </p:cNvPicPr>
+          <p:nvPr/>
+        </p:nvPicPr>
+        <p:blipFill>
+          <a:blip r:embed="rId16"/>
+          <a:stretch>
+            <a:fillRect/>
+          </a:stretch>
+        </p:blipFill>
+        <p:spPr>
+          <a:xfrm>
+            <a:off x="8398764" y="2651760"/>
+            <a:ext cx="173736" cy="201168"/>
+          </a:xfrm>
+          <a:prstGeom prst="rect">
+            <a:avLst/>
+          </a:prstGeom>
+        </p:spPr>
+      </p:pic>
+      <p:pic>
+        <p:nvPicPr>
+          <p:cNvPr id="30" name="high effort page 4" descr="/NAS/SJ/POSTECH/nlp/figs/icons/pagehot.png">    </p:cNvPr>
+          <p:cNvPicPr>
+            <a:picLocks noChangeAspect="1"/>
+          </p:cNvPicPr>
+          <p:nvPr/>
+        </p:nvPicPr>
+        <p:blipFill>
+          <a:blip r:embed="rId17"/>
+          <a:stretch>
+            <a:fillRect/>
+          </a:stretch>
+        </p:blipFill>
+        <p:spPr>
+          <a:xfrm>
+            <a:off x="8577072" y="2651760"/>
+            <a:ext cx="173736" cy="201168"/>
+          </a:xfrm>
+          <a:prstGeom prst="rect">
+            <a:avLst/>
+          </a:prstGeom>
+        </p:spPr>
+      </p:pic>
+      <p:pic>
+        <p:nvPicPr>
+          <p:cNvPr id="31" name="high effort page 5" descr="/NAS/SJ/POSTECH/nlp/figs/icons/pagehot.png">    </p:cNvPr>
+          <p:cNvPicPr>
+            <a:picLocks noChangeAspect="1"/>
+          </p:cNvPicPr>
+          <p:nvPr/>
+        </p:nvPicPr>
+        <p:blipFill>
+          <a:blip r:embed="rId18"/>
+          <a:stretch>
+            <a:fillRect/>
+          </a:stretch>
+        </p:blipFill>
+        <p:spPr>
+          <a:xfrm>
+            <a:off x="8755380" y="2651760"/>
+            <a:ext cx="173736" cy="201168"/>
+          </a:xfrm>
+          <a:prstGeom prst="rect">
+            <a:avLst/>
+          </a:prstGeom>
+        </p:spPr>
+      </p:pic>
+      <p:pic>
+        <p:nvPicPr>
+          <p:cNvPr id="32" name="high effort page 6" descr="/NAS/SJ/POSTECH/nlp/figs/icons/pagehot.png">    </p:cNvPr>
+          <p:cNvPicPr>
+            <a:picLocks noChangeAspect="1"/>
+          </p:cNvPicPr>
+          <p:nvPr/>
+        </p:nvPicPr>
+        <p:blipFill>
+          <a:blip r:embed="rId19"/>
+          <a:stretch>
+            <a:fillRect/>
+          </a:stretch>
+        </p:blipFill>
+        <p:spPr>
+          <a:xfrm>
+            <a:off x="8933688" y="2651760"/>
+            <a:ext cx="173736" cy="201168"/>
+          </a:xfrm>
+          <a:prstGeom prst="rect">
+            <a:avLst/>
+          </a:prstGeom>
+        </p:spPr>
+      </p:pic>
+      <p:pic>
+        <p:nvPicPr>
+          <p:cNvPr id="33" name="high effort page 7" descr="/NAS/SJ/POSTECH/nlp/figs/icons/pagehot.png">    </p:cNvPr>
+          <p:cNvPicPr>
+            <a:picLocks noChangeAspect="1"/>
+          </p:cNvPicPr>
+          <p:nvPr/>
+        </p:nvPicPr>
+        <p:blipFill>
+          <a:blip r:embed="rId20"/>
+          <a:stretch>
+            <a:fillRect/>
+          </a:stretch>
+        </p:blipFill>
+        <p:spPr>
+          <a:xfrm>
+            <a:off x="9111996" y="2651760"/>
+            <a:ext cx="173736" cy="201168"/>
+          </a:xfrm>
+          <a:prstGeom prst="rect">
+            <a:avLst/>
+          </a:prstGeom>
+        </p:spPr>
+      </p:pic>
+      <p:pic>
+        <p:nvPicPr>
+          <p:cNvPr id="34" name="high effort page 8" descr="/NAS/SJ/POSTECH/nlp/figs/icons/pagehot.png">    </p:cNvPr>
+          <p:cNvPicPr>
+            <a:picLocks noChangeAspect="1"/>
+          </p:cNvPicPr>
+          <p:nvPr/>
+        </p:nvPicPr>
+        <p:blipFill>
+          <a:blip r:embed="rId21"/>
+          <a:stretch>
+            <a:fillRect/>
+          </a:stretch>
+        </p:blipFill>
+        <p:spPr>
+          <a:xfrm>
+            <a:off x="9290304" y="2651760"/>
+            <a:ext cx="173736" cy="201168"/>
+          </a:xfrm>
+          <a:prstGeom prst="rect">
+            <a:avLst/>
+          </a:prstGeom>
+        </p:spPr>
+      </p:pic>
+      <p:pic>
+        <p:nvPicPr>
+          <p:cNvPr id="35" name="high effort page 9" descr="/NAS/SJ/POSTECH/nlp/figs/icons/pagehot.png">    </p:cNvPr>
+          <p:cNvPicPr>
+            <a:picLocks noChangeAspect="1"/>
+          </p:cNvPicPr>
+          <p:nvPr/>
+        </p:nvPicPr>
+        <p:blipFill>
+          <a:blip r:embed="rId22"/>
+          <a:stretch>
+            <a:fillRect/>
+          </a:stretch>
+        </p:blipFill>
+        <p:spPr>
+          <a:xfrm>
+            <a:off x="9468612" y="2651760"/>
+            <a:ext cx="173736" cy="201168"/>
+          </a:xfrm>
+          <a:prstGeom prst="rect">
+            <a:avLst/>
+          </a:prstGeom>
+        </p:spPr>
+      </p:pic>
+      <p:pic>
+        <p:nvPicPr>
+          <p:cNvPr id="36" name="high effort page 10" descr="/NAS/SJ/POSTECH/nlp/figs/icons/pagehot.png">    </p:cNvPr>
+          <p:cNvPicPr>
+            <a:picLocks noChangeAspect="1"/>
+          </p:cNvPicPr>
+          <p:nvPr/>
+        </p:nvPicPr>
+        <p:blipFill>
+          <a:blip r:embed="rId23"/>
+          <a:stretch>
+            <a:fillRect/>
+          </a:stretch>
+        </p:blipFill>
+        <p:spPr>
+          <a:xfrm>
+            <a:off x="9646920" y="2651760"/>
+            <a:ext cx="173736" cy="201168"/>
+          </a:xfrm>
+          <a:prstGeom prst="rect">
+            <a:avLst/>
+          </a:prstGeom>
+        </p:spPr>
+      </p:pic>
+      <p:pic>
+        <p:nvPicPr>
+          <p:cNvPr id="37" name="high effort page 11" descr="/NAS/SJ/POSTECH/nlp/figs/icons/pagehot.png">    </p:cNvPr>
+          <p:cNvPicPr>
+            <a:picLocks noChangeAspect="1"/>
+          </p:cNvPicPr>
+          <p:nvPr/>
+        </p:nvPicPr>
+        <p:blipFill>
+          <a:blip r:embed="rId24"/>
+          <a:stretch>
+            <a:fillRect/>
+          </a:stretch>
+        </p:blipFill>
+        <p:spPr>
+          <a:xfrm>
+            <a:off x="9825228" y="2651760"/>
+            <a:ext cx="173736" cy="201168"/>
+          </a:xfrm>
+          <a:prstGeom prst="rect">
+            <a:avLst/>
+          </a:prstGeom>
+        </p:spPr>
+      </p:pic>
+      <p:pic>
+        <p:nvPicPr>
+          <p:cNvPr id="38" name="high effort page 12" descr="/NAS/SJ/POSTECH/nlp/figs/icons/pagehot.png">    </p:cNvPr>
+          <p:cNvPicPr>
+            <a:picLocks noChangeAspect="1"/>
+          </p:cNvPicPr>
+          <p:nvPr/>
+        </p:nvPicPr>
+        <p:blipFill>
+          <a:blip r:embed="rId25"/>
+          <a:stretch>
+            <a:fillRect/>
+          </a:stretch>
+        </p:blipFill>
+        <p:spPr>
+          <a:xfrm>
+            <a:off x="10003536" y="2651760"/>
+            <a:ext cx="173736" cy="201168"/>
+          </a:xfrm>
+          <a:prstGeom prst="rect">
+            <a:avLst/>
+          </a:prstGeom>
+        </p:spPr>
+      </p:pic>
+      <p:pic>
+        <p:nvPicPr>
+          <p:cNvPr id="39" name="high effort page 13" descr="/NAS/SJ/POSTECH/nlp/figs/icons/pagehot.png">    </p:cNvPr>
+          <p:cNvPicPr>
+            <a:picLocks noChangeAspect="1"/>
+          </p:cNvPicPr>
+          <p:nvPr/>
+        </p:nvPicPr>
+        <p:blipFill>
+          <a:blip r:embed="rId26"/>
+          <a:stretch>
+            <a:fillRect/>
+          </a:stretch>
+        </p:blipFill>
+        <p:spPr>
+          <a:xfrm>
+            <a:off x="10181844" y="2651760"/>
+            <a:ext cx="173736" cy="201168"/>
+          </a:xfrm>
+          <a:prstGeom prst="rect">
+            <a:avLst/>
+          </a:prstGeom>
+        </p:spPr>
+      </p:pic>
+      <p:pic>
+        <p:nvPicPr>
+          <p:cNvPr id="40" name="high effort page 14" descr="/NAS/SJ/POSTECH/nlp/figs/icons/pagehot.png">    </p:cNvPr>
+          <p:cNvPicPr>
+            <a:picLocks noChangeAspect="1"/>
+          </p:cNvPicPr>
+          <p:nvPr/>
+        </p:nvPicPr>
+        <p:blipFill>
+          <a:blip r:embed="rId27"/>
+          <a:stretch>
+            <a:fillRect/>
+          </a:stretch>
+        </p:blipFill>
+        <p:spPr>
+          <a:xfrm>
+            <a:off x="10360152" y="2651760"/>
+            <a:ext cx="173736" cy="201168"/>
+          </a:xfrm>
+          <a:prstGeom prst="rect">
+            <a:avLst/>
+          </a:prstGeom>
+        </p:spPr>
+      </p:pic>
+      <p:pic>
+        <p:nvPicPr>
+          <p:cNvPr id="41" name="high effort page 15" descr="/NAS/SJ/POSTECH/nlp/figs/icons/pagehot.png">    </p:cNvPr>
+          <p:cNvPicPr>
+            <a:picLocks noChangeAspect="1"/>
+          </p:cNvPicPr>
+          <p:nvPr/>
+        </p:nvPicPr>
+        <p:blipFill>
+          <a:blip r:embed="rId28"/>
+          <a:stretch>
+            <a:fillRect/>
+          </a:stretch>
+        </p:blipFill>
+        <p:spPr>
+          <a:xfrm>
+            <a:off x="10538460" y="2651760"/>
+            <a:ext cx="173736" cy="201168"/>
+          </a:xfrm>
+          <a:prstGeom prst="rect">
+            <a:avLst/>
+          </a:prstGeom>
+        </p:spPr>
+      </p:pic>
+      <p:pic>
+        <p:nvPicPr>
+          <p:cNvPr id="42" name="high effort page 16" descr="/NAS/SJ/POSTECH/nlp/figs/icons/pagehot.png">    </p:cNvPr>
+          <p:cNvPicPr>
+            <a:picLocks noChangeAspect="1"/>
+          </p:cNvPicPr>
+          <p:nvPr/>
+        </p:nvPicPr>
+        <p:blipFill>
+          <a:blip r:embed="rId29"/>
+          <a:stretch>
+            <a:fillRect/>
+          </a:stretch>
+        </p:blipFill>
+        <p:spPr>
+          <a:xfrm>
+            <a:off x="10716768" y="2651760"/>
+            <a:ext cx="173736" cy="201168"/>
+          </a:xfrm>
+          <a:prstGeom prst="rect">
+            <a:avLst/>
+          </a:prstGeom>
+        </p:spPr>
+      </p:pic>
+      <p:pic>
+        <p:nvPicPr>
+          <p:cNvPr id="43" name="high effort page 17" descr="/NAS/SJ/POSTECH/nlp/figs/icons/pagehot.png">    </p:cNvPr>
+          <p:cNvPicPr>
+            <a:picLocks noChangeAspect="1"/>
+          </p:cNvPicPr>
+          <p:nvPr/>
+        </p:nvPicPr>
+        <p:blipFill>
+          <a:blip r:embed="rId30"/>
+          <a:stretch>
+            <a:fillRect/>
+          </a:stretch>
+        </p:blipFill>
+        <p:spPr>
+          <a:xfrm>
+            <a:off x="10895076" y="2651760"/>
+            <a:ext cx="173736" cy="201168"/>
+          </a:xfrm>
+          <a:prstGeom prst="rect">
+            <a:avLst/>
+          </a:prstGeom>
+        </p:spPr>
+      </p:pic>
+      <p:pic>
+        <p:nvPicPr>
+          <p:cNvPr id="44" name="high effort page 18" descr="/NAS/SJ/POSTECH/nlp/figs/icons/pagehot.png">    </p:cNvPr>
+          <p:cNvPicPr>
+            <a:picLocks noChangeAspect="1"/>
+          </p:cNvPicPr>
+          <p:nvPr/>
+        </p:nvPicPr>
+        <p:blipFill>
+          <a:blip r:embed="rId31"/>
+          <a:stretch>
+            <a:fillRect/>
+          </a:stretch>
+        </p:blipFill>
+        <p:spPr>
+          <a:xfrm>
+            <a:off x="11073384" y="2651760"/>
+            <a:ext cx="173736" cy="201168"/>
+          </a:xfrm>
+          <a:prstGeom prst="rect">
+            <a:avLst/>
+          </a:prstGeom>
+        </p:spPr>
+      </p:pic>
+      <p:pic>
+        <p:nvPicPr>
+          <p:cNvPr id="45" name="high effort page 19" descr="/NAS/SJ/POSTECH/nlp/figs/icons/pagehot.png">    </p:cNvPr>
+          <p:cNvPicPr>
+            <a:picLocks noChangeAspect="1"/>
+          </p:cNvPicPr>
+          <p:nvPr/>
+        </p:nvPicPr>
+        <p:blipFill>
+          <a:blip r:embed="rId32"/>
+          <a:stretch>
+            <a:fillRect/>
+          </a:stretch>
+        </p:blipFill>
+        <p:spPr>
+          <a:xfrm>
+            <a:off x="11251692" y="2651760"/>
+            <a:ext cx="173736" cy="201168"/>
+          </a:xfrm>
+          <a:prstGeom prst="rect">
+            <a:avLst/>
+          </a:prstGeom>
+        </p:spPr>
+      </p:pic>
+      <p:pic>
+        <p:nvPicPr>
+          <p:cNvPr id="46" name="high effort page 20" descr="/NAS/SJ/POSTECH/nlp/figs/icons/pagehot.png">    </p:cNvPr>
+          <p:cNvPicPr>
+            <a:picLocks noChangeAspect="1"/>
+          </p:cNvPicPr>
+          <p:nvPr/>
+        </p:nvPicPr>
+        <p:blipFill>
+          <a:blip r:embed="rId33"/>
+          <a:stretch>
+            <a:fillRect/>
+          </a:stretch>
+        </p:blipFill>
+        <p:spPr>
+          <a:xfrm>
+            <a:off x="7863840" y="2871216"/>
+            <a:ext cx="173736" cy="201168"/>
+          </a:xfrm>
+          <a:prstGeom prst="rect">
+            <a:avLst/>
+          </a:prstGeom>
+        </p:spPr>
+      </p:pic>
+      <p:pic>
+        <p:nvPicPr>
+          <p:cNvPr id="47" name="high effort page 21" descr="/NAS/SJ/POSTECH/nlp/figs/icons/pagehot.png">    </p:cNvPr>
+          <p:cNvPicPr>
+            <a:picLocks noChangeAspect="1"/>
+          </p:cNvPicPr>
+          <p:nvPr/>
+        </p:nvPicPr>
+        <p:blipFill>
+          <a:blip r:embed="rId34"/>
+          <a:stretch>
+            <a:fillRect/>
+          </a:stretch>
+        </p:blipFill>
+        <p:spPr>
+          <a:xfrm>
+            <a:off x="8042148" y="2871216"/>
+            <a:ext cx="173736" cy="201168"/>
+          </a:xfrm>
+          <a:prstGeom prst="rect">
+            <a:avLst/>
+          </a:prstGeom>
+        </p:spPr>
+      </p:pic>
+      <p:pic>
+        <p:nvPicPr>
+          <p:cNvPr id="48" name="high effort page 22" descr="/NAS/SJ/POSTECH/nlp/figs/icons/pagehot.png">    </p:cNvPr>
+          <p:cNvPicPr>
+            <a:picLocks noChangeAspect="1"/>
+          </p:cNvPicPr>
+          <p:nvPr/>
+        </p:nvPicPr>
+        <p:blipFill>
+          <a:blip r:embed="rId35"/>
+          <a:stretch>
+            <a:fillRect/>
+          </a:stretch>
+        </p:blipFill>
+        <p:spPr>
+          <a:xfrm>
+            <a:off x="8220456" y="2871216"/>
+            <a:ext cx="173736" cy="201168"/>
+          </a:xfrm>
+          <a:prstGeom prst="rect">
+            <a:avLst/>
+          </a:prstGeom>
+        </p:spPr>
+      </p:pic>
+      <p:pic>
+        <p:nvPicPr>
+          <p:cNvPr id="49" name="high effort page 23" descr="/NAS/SJ/POSTECH/nlp/figs/icons/pagehot.png">    </p:cNvPr>
+          <p:cNvPicPr>
+            <a:picLocks noChangeAspect="1"/>
+          </p:cNvPicPr>
+          <p:nvPr/>
+        </p:nvPicPr>
+        <p:blipFill>
+          <a:blip r:embed="rId36"/>
+          <a:stretch>
+            <a:fillRect/>
+          </a:stretch>
+        </p:blipFill>
+        <p:spPr>
+          <a:xfrm>
+            <a:off x="8398764" y="2871216"/>
+            <a:ext cx="173736" cy="201168"/>
+          </a:xfrm>
+          <a:prstGeom prst="rect">
+            <a:avLst/>
+          </a:prstGeom>
+        </p:spPr>
+      </p:pic>
+      <p:pic>
+        <p:nvPicPr>
+          <p:cNvPr id="50" name="high effort page 24" descr="/NAS/SJ/POSTECH/nlp/figs/icons/pagehot.png">    </p:cNvPr>
+          <p:cNvPicPr>
+            <a:picLocks noChangeAspect="1"/>
+          </p:cNvPicPr>
+          <p:nvPr/>
+        </p:nvPicPr>
+        <p:blipFill>
+          <a:blip r:embed="rId37"/>
+          <a:stretch>
+            <a:fillRect/>
+          </a:stretch>
+        </p:blipFill>
+        <p:spPr>
+          <a:xfrm>
+            <a:off x="8577072" y="2871216"/>
+            <a:ext cx="173736" cy="201168"/>
+          </a:xfrm>
+          <a:prstGeom prst="rect">
+            <a:avLst/>
+          </a:prstGeom>
+        </p:spPr>
+      </p:pic>
+      <p:pic>
+        <p:nvPicPr>
+          <p:cNvPr id="51" name="high effort page 25" descr="/NAS/SJ/POSTECH/nlp/figs/icons/pagehot.png">    </p:cNvPr>
+          <p:cNvPicPr>
+            <a:picLocks noChangeAspect="1"/>
+          </p:cNvPicPr>
+          <p:nvPr/>
+        </p:nvPicPr>
+        <p:blipFill>
+          <a:blip r:embed="rId38"/>
+          <a:stretch>
+            <a:fillRect/>
+          </a:stretch>
+        </p:blipFill>
+        <p:spPr>
+          <a:xfrm>
+            <a:off x="8755380" y="2871216"/>
+            <a:ext cx="173736" cy="201168"/>
+          </a:xfrm>
+          <a:prstGeom prst="rect">
+            <a:avLst/>
+          </a:prstGeom>
+        </p:spPr>
+      </p:pic>
+      <p:pic>
+        <p:nvPicPr>
+          <p:cNvPr id="52" name="high effort page 26" descr="/NAS/SJ/POSTECH/nlp/figs/icons/pagehot.png">    </p:cNvPr>
+          <p:cNvPicPr>
+            <a:picLocks noChangeAspect="1"/>
+          </p:cNvPicPr>
+          <p:nvPr/>
+        </p:nvPicPr>
+        <p:blipFill>
+          <a:blip r:embed="rId39"/>
+          <a:stretch>
+            <a:fillRect/>
+          </a:stretch>
+        </p:blipFill>
+        <p:spPr>
+          <a:xfrm>
+            <a:off x="8933688" y="2871216"/>
+            <a:ext cx="173736" cy="201168"/>
+          </a:xfrm>
+          <a:prstGeom prst="rect">
+            <a:avLst/>
+          </a:prstGeom>
+        </p:spPr>
+      </p:pic>
+      <p:pic>
+        <p:nvPicPr>
+          <p:cNvPr id="53" name="high effort page 27" descr="/NAS/SJ/POSTECH/nlp/figs/icons/pagehot.png">    </p:cNvPr>
+          <p:cNvPicPr>
+            <a:picLocks noChangeAspect="1"/>
+          </p:cNvPicPr>
+          <p:nvPr/>
+        </p:nvPicPr>
+        <p:blipFill>
+          <a:blip r:embed="rId40"/>
+          <a:stretch>
+            <a:fillRect/>
+          </a:stretch>
+        </p:blipFill>
+        <p:spPr>
+          <a:xfrm>
+            <a:off x="9111996" y="2871216"/>
+            <a:ext cx="173736" cy="201168"/>
+          </a:xfrm>
+          <a:prstGeom prst="rect">
+            <a:avLst/>
+          </a:prstGeom>
+        </p:spPr>
+      </p:pic>
+      <p:pic>
+        <p:nvPicPr>
+          <p:cNvPr id="54" name="high effort page 28" descr="/NAS/SJ/POSTECH/nlp/figs/icons/pagehot.png">    </p:cNvPr>
+          <p:cNvPicPr>
+            <a:picLocks noChangeAspect="1"/>
+          </p:cNvPicPr>
+          <p:nvPr/>
+        </p:nvPicPr>
+        <p:blipFill>
+          <a:blip r:embed="rId41"/>
+          <a:stretch>
+            <a:fillRect/>
+          </a:stretch>
+        </p:blipFill>
+        <p:spPr>
+          <a:xfrm>
+            <a:off x="9290304" y="2871216"/>
+            <a:ext cx="173736" cy="201168"/>
+          </a:xfrm>
+          <a:prstGeom prst="rect">
+            <a:avLst/>
+          </a:prstGeom>
+        </p:spPr>
+      </p:pic>
+      <p:pic>
+        <p:nvPicPr>
+          <p:cNvPr id="55" name="high effort page 29" descr="/NAS/SJ/POSTECH/nlp/figs/icons/pagehot.png">    </p:cNvPr>
+          <p:cNvPicPr>
+            <a:picLocks noChangeAspect="1"/>
+          </p:cNvPicPr>
+          <p:nvPr/>
+        </p:nvPicPr>
+        <p:blipFill>
+          <a:blip r:embed="rId42"/>
+          <a:stretch>
+            <a:fillRect/>
+          </a:stretch>
+        </p:blipFill>
+        <p:spPr>
+          <a:xfrm>
+            <a:off x="9468612" y="2871216"/>
+            <a:ext cx="173736" cy="201168"/>
+          </a:xfrm>
+          <a:prstGeom prst="rect">
+            <a:avLst/>
+          </a:prstGeom>
+        </p:spPr>
+      </p:pic>
+      <p:pic>
+        <p:nvPicPr>
+          <p:cNvPr id="56" name="high effort page 30" descr="/NAS/SJ/POSTECH/nlp/figs/icons/pagehot.png">    </p:cNvPr>
+          <p:cNvPicPr>
+            <a:picLocks noChangeAspect="1"/>
+          </p:cNvPicPr>
+          <p:nvPr/>
+        </p:nvPicPr>
+        <p:blipFill>
+          <a:blip r:embed="rId43"/>
+          <a:stretch>
+            <a:fillRect/>
+          </a:stretch>
+        </p:blipFill>
+        <p:spPr>
+          <a:xfrm>
+            <a:off x="9646920" y="2871216"/>
+            <a:ext cx="173736" cy="201168"/>
+          </a:xfrm>
+          <a:prstGeom prst="rect">
+            <a:avLst/>
+          </a:prstGeom>
+        </p:spPr>
+      </p:pic>
+      <p:pic>
+        <p:nvPicPr>
+          <p:cNvPr id="57" name="high effort page 31" descr="/NAS/SJ/POSTECH/nlp/figs/icons/pagehot.png">    </p:cNvPr>
+          <p:cNvPicPr>
+            <a:picLocks noChangeAspect="1"/>
+          </p:cNvPicPr>
+          <p:nvPr/>
+        </p:nvPicPr>
+        <p:blipFill>
+          <a:blip r:embed="rId44"/>
+          <a:stretch>
+            <a:fillRect/>
+          </a:stretch>
+        </p:blipFill>
+        <p:spPr>
+          <a:xfrm>
+            <a:off x="9825228" y="2871216"/>
+            <a:ext cx="173736" cy="201168"/>
+          </a:xfrm>
+          <a:prstGeom prst="rect">
+            <a:avLst/>
+          </a:prstGeom>
+        </p:spPr>
+      </p:pic>
+      <p:pic>
+        <p:nvPicPr>
+          <p:cNvPr id="58" name="high effort page 32" descr="/NAS/SJ/POSTECH/nlp/figs/icons/pagehot.png">    </p:cNvPr>
+          <p:cNvPicPr>
+            <a:picLocks noChangeAspect="1"/>
+          </p:cNvPicPr>
+          <p:nvPr/>
+        </p:nvPicPr>
+        <p:blipFill>
+          <a:blip r:embed="rId45"/>
+          <a:stretch>
+            <a:fillRect/>
+          </a:stretch>
+        </p:blipFill>
+        <p:spPr>
+          <a:xfrm>
+            <a:off x="10003536" y="2871216"/>
+            <a:ext cx="173736" cy="201168"/>
+          </a:xfrm>
+          <a:prstGeom prst="rect">
+            <a:avLst/>
+          </a:prstGeom>
+        </p:spPr>
+      </p:pic>
+      <p:pic>
+        <p:nvPicPr>
+          <p:cNvPr id="59" name="high effort page 33" descr="/NAS/SJ/POSTECH/nlp/figs/icons/pagehot.png">    </p:cNvPr>
+          <p:cNvPicPr>
+            <a:picLocks noChangeAspect="1"/>
+          </p:cNvPicPr>
+          <p:nvPr/>
+        </p:nvPicPr>
+        <p:blipFill>
+          <a:blip r:embed="rId46"/>
+          <a:stretch>
+            <a:fillRect/>
+          </a:stretch>
+        </p:blipFill>
+        <p:spPr>
+          <a:xfrm>
+            <a:off x="10181844" y="2871216"/>
+            <a:ext cx="173736" cy="201168"/>
+          </a:xfrm>
+          <a:prstGeom prst="rect">
+            <a:avLst/>
+          </a:prstGeom>
+        </p:spPr>
+      </p:pic>
+      <p:pic>
+        <p:nvPicPr>
+          <p:cNvPr id="60" name="high effort page 34" descr="/NAS/SJ/POSTECH/nlp/figs/icons/pagehot.png">    </p:cNvPr>
+          <p:cNvPicPr>
+            <a:picLocks noChangeAspect="1"/>
+          </p:cNvPicPr>
+          <p:nvPr/>
+        </p:nvPicPr>
+        <p:blipFill>
+          <a:blip r:embed="rId47"/>
+          <a:stretch>
+            <a:fillRect/>
+          </a:stretch>
+        </p:blipFill>
+        <p:spPr>
+          <a:xfrm>
+            <a:off x="10360152" y="2871216"/>
+            <a:ext cx="173736" cy="201168"/>
+          </a:xfrm>
+          <a:prstGeom prst="rect">
+            <a:avLst/>
+          </a:prstGeom>
+        </p:spPr>
+      </p:pic>
+      <p:pic>
+        <p:nvPicPr>
+          <p:cNvPr id="61" name="high effort page 35" descr="/NAS/SJ/POSTECH/nlp/figs/icons/pagehot.png">    </p:cNvPr>
+          <p:cNvPicPr>
+            <a:picLocks noChangeAspect="1"/>
+          </p:cNvPicPr>
+          <p:nvPr/>
+        </p:nvPicPr>
+        <p:blipFill>
+          <a:blip r:embed="rId48"/>
+          <a:stretch>
+            <a:fillRect/>
+          </a:stretch>
+        </p:blipFill>
+        <p:spPr>
+          <a:xfrm>
+            <a:off x="10538460" y="2871216"/>
+            <a:ext cx="173736" cy="201168"/>
+          </a:xfrm>
+          <a:prstGeom prst="rect">
+            <a:avLst/>
+          </a:prstGeom>
+        </p:spPr>
+      </p:pic>
+      <p:pic>
+        <p:nvPicPr>
+          <p:cNvPr id="62" name="high effort page 36" descr="/NAS/SJ/POSTECH/nlp/figs/icons/pagehot.png">    </p:cNvPr>
+          <p:cNvPicPr>
+            <a:picLocks noChangeAspect="1"/>
+          </p:cNvPicPr>
+          <p:nvPr/>
+        </p:nvPicPr>
+        <p:blipFill>
+          <a:blip r:embed="rId49"/>
+          <a:stretch>
+            <a:fillRect/>
+          </a:stretch>
+        </p:blipFill>
+        <p:spPr>
+          <a:xfrm>
+            <a:off x="10716768" y="2871216"/>
+            <a:ext cx="173736" cy="201168"/>
+          </a:xfrm>
+          <a:prstGeom prst="rect">
+            <a:avLst/>
+          </a:prstGeom>
+        </p:spPr>
+      </p:pic>
+      <p:pic>
+        <p:nvPicPr>
+          <p:cNvPr id="63" name="high effort page 37" descr="/NAS/SJ/POSTECH/nlp/figs/icons/pagehot.png">    </p:cNvPr>
+          <p:cNvPicPr>
+            <a:picLocks noChangeAspect="1"/>
+          </p:cNvPicPr>
+          <p:nvPr/>
+        </p:nvPicPr>
+        <p:blipFill>
+          <a:blip r:embed="rId50"/>
+          <a:stretch>
+            <a:fillRect/>
+          </a:stretch>
+        </p:blipFill>
+        <p:spPr>
+          <a:xfrm>
+            <a:off x="10895076" y="2871216"/>
+            <a:ext cx="173736" cy="201168"/>
+          </a:xfrm>
+          <a:prstGeom prst="rect">
+            <a:avLst/>
+          </a:prstGeom>
+        </p:spPr>
+      </p:pic>
+      <p:pic>
+        <p:nvPicPr>
+          <p:cNvPr id="64" name="high effort page 38" descr="/NAS/SJ/POSTECH/nlp/figs/icons/pagehot.png">    </p:cNvPr>
+          <p:cNvPicPr>
+            <a:picLocks noChangeAspect="1"/>
+          </p:cNvPicPr>
+          <p:nvPr/>
+        </p:nvPicPr>
+        <p:blipFill>
+          <a:blip r:embed="rId51"/>
+          <a:stretch>
+            <a:fillRect/>
+          </a:stretch>
+        </p:blipFill>
+        <p:spPr>
+          <a:xfrm>
+            <a:off x="11073384" y="2871216"/>
+            <a:ext cx="173736" cy="201168"/>
+          </a:xfrm>
+          <a:prstGeom prst="rect">
+            <a:avLst/>
+          </a:prstGeom>
+        </p:spPr>
+      </p:pic>
+      <p:pic>
+        <p:nvPicPr>
+          <p:cNvPr id="65" name="high effort page 39" descr="/NAS/SJ/POSTECH/nlp/figs/icons/pagehot.png">    </p:cNvPr>
+          <p:cNvPicPr>
+            <a:picLocks noChangeAspect="1"/>
+          </p:cNvPicPr>
+          <p:nvPr/>
+        </p:nvPicPr>
+        <p:blipFill>
+          <a:blip r:embed="rId52"/>
+          <a:stretch>
+            <a:fillRect/>
+          </a:stretch>
+        </p:blipFill>
+        <p:spPr>
+          <a:xfrm>
+            <a:off x="11251692" y="2871216"/>
+            <a:ext cx="173736" cy="201168"/>
+          </a:xfrm>
+          <a:prstGeom prst="rect">
+            <a:avLst/>
+          </a:prstGeom>
+        </p:spPr>
+      </p:pic>
+      <p:pic>
+        <p:nvPicPr>
+          <p:cNvPr id="66" name="high effort page 40" descr="/NAS/SJ/POSTECH/nlp/figs/icons/pagehot.png">    </p:cNvPr>
+          <p:cNvPicPr>
+            <a:picLocks noChangeAspect="1"/>
+          </p:cNvPicPr>
+          <p:nvPr/>
+        </p:nvPicPr>
+        <p:blipFill>
+          <a:blip r:embed="rId53"/>
+          <a:stretch>
+            <a:fillRect/>
+          </a:stretch>
+        </p:blipFill>
+        <p:spPr>
+          <a:xfrm>
+            <a:off x="7863840" y="3090672"/>
+            <a:ext cx="173736" cy="201168"/>
+          </a:xfrm>
+          <a:prstGeom prst="rect">
+            <a:avLst/>
+          </a:prstGeom>
+        </p:spPr>
+      </p:pic>
+      <p:pic>
+        <p:nvPicPr>
+          <p:cNvPr id="67" name="high effort page 41" descr="/NAS/SJ/POSTECH/nlp/figs/icons/pagehot.png">    </p:cNvPr>
+          <p:cNvPicPr>
+            <a:picLocks noChangeAspect="1"/>
+          </p:cNvPicPr>
+          <p:nvPr/>
+        </p:nvPicPr>
+        <p:blipFill>
+          <a:blip r:embed="rId54"/>
+          <a:stretch>
+            <a:fillRect/>
+          </a:stretch>
+        </p:blipFill>
+        <p:spPr>
+          <a:xfrm>
+            <a:off x="8042148" y="3090672"/>
+            <a:ext cx="173736" cy="201168"/>
+          </a:xfrm>
+          <a:prstGeom prst="rect">
+            <a:avLst/>
+          </a:prstGeom>
+        </p:spPr>
+      </p:pic>
+      <p:pic>
+        <p:nvPicPr>
+          <p:cNvPr id="68" name="high effort page 42" descr="/NAS/SJ/POSTECH/nlp/figs/icons/pagehot.png">    </p:cNvPr>
+          <p:cNvPicPr>
+            <a:picLocks noChangeAspect="1"/>
+          </p:cNvPicPr>
+          <p:nvPr/>
+        </p:nvPicPr>
+        <p:blipFill>
+          <a:blip r:embed="rId55"/>
+          <a:stretch>
+            <a:fillRect/>
+          </a:stretch>
+        </p:blipFill>
+        <p:spPr>
+          <a:xfrm>
+            <a:off x="8220456" y="3090672"/>
+            <a:ext cx="173736" cy="201168"/>
+          </a:xfrm>
+          <a:prstGeom prst="rect">
+            <a:avLst/>
+          </a:prstGeom>
+        </p:spPr>
+      </p:pic>
+      <p:sp>
+        <p:nvSpPr>
+          <p:cNvPr id="69" name="Text 12"/>
+          <p:cNvSpPr txBox="1"/>
+          <p:nvPr/>
+        </p:nvSpPr>
+        <p:spPr>
+          <a:xfrm>
+            <a:off x="6400800" y="3520440"/>
+            <a:ext cx="5029200" cy="548640"/>
+          </a:xfrm>
+          <a:prstGeom prst="rect">
+            <a:avLst/>
+          </a:prstGeom>
+          <a:noFill/>
+          <a:ln/>
+        </p:spPr>
+        <p:txBody>
+          <a:bodyPr wrap="square" lIns="0" tIns="0" rIns="0" bIns="0" rtlCol="0" anchor="ctr"/>
+          <a:lstStyle/>
+          <a:p>
+            <a:pPr indent="0" marL="0">
+              <a:buNone/>
+            </a:pPr>
+            <a:r>
+              <a:rPr lang="en-US" sz="2200" b="1" dirty="0">
+                <a:solidFill>
+                  <a:srgbClr val="ED7D31"/>
+                </a:solidFill>
+              </a:rPr>
+              <a:t>4.4× the pages</a:t>
+            </a:r>
+            <a:pPr indent="0" marL="0">
+              <a:buNone/>
+            </a:pPr>
+            <a:r>
+              <a:rPr lang="en-US" sz="1500" dirty="0">
+                <a:solidFill>
+                  <a:schemeClr val="tx1"/>
+                </a:solidFill>
+              </a:rPr>
+              <a:t>  for only 9 more points</a:t>
+            </a:r>
+            <a:endParaRPr lang="en-US" sz="1600" dirty="0"/>
+          </a:p>
+        </p:txBody>
+      </p:sp>
+      <p:sp>
+        <p:nvSpPr>
+          <p:cNvPr id="70" name="box "/>
+          <p:cNvSpPr/>
+          <p:nvPr/>
+        </p:nvSpPr>
+        <p:spPr>
+          <a:xfrm>
+            <a:off x="548640" y="4407408"/>
+            <a:ext cx="3566160" cy="502920"/>
+          </a:xfrm>
+          <a:prstGeom prst="roundRect">
+            <a:avLst>
+              <a:gd name="adj" fmla="val 10909"/>
+            </a:avLst>
+          </a:prstGeom>
+          <a:solidFill>
+            <a:srgbClr val="F2F2F2"/>
+          </a:solidFill>
+          <a:ln w="9525">
+            <a:solidFill>
+              <a:srgbClr val="BFBFBF"/>
+            </a:solidFill>
+            <a:prstDash val="solid"/>
+          </a:ln>
+        </p:spPr>
+      </p:sp>
+      <p:sp>
+        <p:nvSpPr>
+          <p:cNvPr id="71" name="Text 14"/>
+          <p:cNvSpPr txBox="1"/>
+          <p:nvPr/>
+        </p:nvSpPr>
+        <p:spPr>
+          <a:xfrm>
+            <a:off x="621792" y="4407408"/>
+            <a:ext cx="3419856" cy="502920"/>
+          </a:xfrm>
+          <a:prstGeom prst="rect">
+            <a:avLst/>
+          </a:prstGeom>
+          <a:noFill/>
+          <a:ln/>
+        </p:spPr>
+        <p:txBody>
+          <a:bodyPr wrap="square" lIns="0" tIns="0" rIns="0" bIns="0" rtlCol="0" anchor="ctr"/>
+          <a:lstStyle/>
+          <a:p>
+            <a:pPr algn="ctr" indent="0" marL="0">
+              <a:buNone/>
+            </a:pPr>
+            <a:endParaRPr lang="en-US" sz="1500" dirty="0"/>
+          </a:p>
+        </p:txBody>
+      </p:sp>
+      <p:pic>
+        <p:nvPicPr>
+          <p:cNvPr id="72" name="icon robot" descr="/NAS/SJ/POSTECH/nlp/figs/icons/robot.png">    </p:cNvPr>
+          <p:cNvPicPr>
+            <a:picLocks noChangeAspect="1"/>
+          </p:cNvPicPr>
+          <p:nvPr/>
+        </p:nvPicPr>
+        <p:blipFill>
+          <a:blip r:embed="rId56"/>
+          <a:stretch>
+            <a:fillRect/>
+          </a:stretch>
+        </p:blipFill>
+        <p:spPr>
+          <a:xfrm>
+            <a:off x="685800" y="4462272"/>
+            <a:ext cx="384048" cy="384048"/>
+          </a:xfrm>
+          <a:prstGeom prst="rect">
+            <a:avLst/>
+          </a:prstGeom>
+        </p:spPr>
+      </p:pic>
+      <p:sp>
+        <p:nvSpPr>
+          <p:cNvPr id="73" name="Text 15"/>
+          <p:cNvSpPr txBox="1"/>
+          <p:nvPr/>
+        </p:nvSpPr>
+        <p:spPr>
+          <a:xfrm>
+            <a:off x="1188720" y="4407408"/>
+            <a:ext cx="2834640" cy="502920"/>
+          </a:xfrm>
+          <a:prstGeom prst="rect">
+            <a:avLst/>
+          </a:prstGeom>
+          <a:noFill/>
+          <a:ln/>
+        </p:spPr>
+        <p:txBody>
+          <a:bodyPr wrap="square" lIns="0" tIns="0" rIns="0" bIns="0" rtlCol="0" anchor="ctr"/>
+          <a:lstStyle/>
+          <a:p>
+            <a:pPr indent="0" marL="0">
+              <a:buNone/>
+            </a:pPr>
+            <a:r>
+              <a:rPr lang="en-US" sz="1500" dirty="0">
+                <a:solidFill>
+                  <a:schemeClr val="tx1"/>
+                </a:solidFill>
+              </a:rPr>
+              <a:t>agents already write this code</a:t>
+            </a:r>
+            <a:endParaRPr lang="en-US" sz="1500" dirty="0"/>
+          </a:p>
+        </p:txBody>
+      </p:sp>
+      <p:sp>
+        <p:nvSpPr>
+          <p:cNvPr id="74" name="box "/>
+          <p:cNvSpPr/>
+          <p:nvPr/>
+        </p:nvSpPr>
+        <p:spPr>
+          <a:xfrm>
+            <a:off x="4297680" y="4407408"/>
+            <a:ext cx="3566160" cy="502920"/>
+          </a:xfrm>
+          <a:prstGeom prst="roundRect">
+            <a:avLst>
+              <a:gd name="adj" fmla="val 10909"/>
+            </a:avLst>
+          </a:prstGeom>
+          <a:solidFill>
+            <a:srgbClr val="F2F2F2"/>
+          </a:solidFill>
+          <a:ln w="9525">
+            <a:solidFill>
+              <a:srgbClr val="BFBFBF"/>
+            </a:solidFill>
+            <a:prstDash val="solid"/>
+          </a:ln>
+        </p:spPr>
+      </p:sp>
+      <p:sp>
+        <p:nvSpPr>
+          <p:cNvPr id="75" name="Text 17"/>
+          <p:cNvSpPr txBox="1"/>
+          <p:nvPr/>
+        </p:nvSpPr>
+        <p:spPr>
+          <a:xfrm>
+            <a:off x="4370832" y="4407408"/>
+            <a:ext cx="3419856" cy="502920"/>
+          </a:xfrm>
+          <a:prstGeom prst="rect">
+            <a:avLst/>
+          </a:prstGeom>
+          <a:noFill/>
+          <a:ln/>
+        </p:spPr>
+        <p:txBody>
+          <a:bodyPr wrap="square" lIns="0" tIns="0" rIns="0" bIns="0" rtlCol="0" anchor="ctr"/>
+          <a:lstStyle/>
+          <a:p>
+            <a:pPr algn="ctr" indent="0" marL="0">
+              <a:buNone/>
+            </a:pPr>
+            <a:endParaRPr lang="en-US" sz="1500" dirty="0"/>
+          </a:p>
+        </p:txBody>
+      </p:sp>
+      <p:pic>
+        <p:nvPicPr>
+          <p:cNvPr id="76" name="icon coins" descr="/NAS/SJ/POSTECH/nlp/figs/icons/coins.png">    </p:cNvPr>
+          <p:cNvPicPr>
+            <a:picLocks noChangeAspect="1"/>
+          </p:cNvPicPr>
+          <p:nvPr/>
+        </p:nvPicPr>
+        <p:blipFill>
+          <a:blip r:embed="rId57"/>
+          <a:stretch>
+            <a:fillRect/>
+          </a:stretch>
+        </p:blipFill>
+        <p:spPr>
+          <a:xfrm>
+            <a:off x="4434840" y="4462272"/>
+            <a:ext cx="384048" cy="384048"/>
+          </a:xfrm>
+          <a:prstGeom prst="rect">
+            <a:avLst/>
+          </a:prstGeom>
+        </p:spPr>
+      </p:pic>
+      <p:sp>
+        <p:nvSpPr>
+          <p:cNvPr id="77" name="Text 18"/>
+          <p:cNvSpPr txBox="1"/>
+          <p:nvPr/>
+        </p:nvSpPr>
+        <p:spPr>
+          <a:xfrm>
+            <a:off x="4937760" y="4407408"/>
+            <a:ext cx="2834640" cy="502920"/>
+          </a:xfrm>
+          <a:prstGeom prst="rect">
+            <a:avLst/>
+          </a:prstGeom>
+          <a:noFill/>
+          <a:ln/>
+        </p:spPr>
+        <p:txBody>
+          <a:bodyPr wrap="square" lIns="0" tIns="0" rIns="0" bIns="0" rtlCol="0" anchor="ctr"/>
+          <a:lstStyle/>
+          <a:p>
+            <a:pPr indent="0" marL="0">
+              <a:buNone/>
+            </a:pPr>
+            <a:r>
+              <a:rPr lang="en-US" sz="1500" dirty="0">
+                <a:solidFill>
+                  <a:schemeClr val="tx1"/>
+                </a:solidFill>
+              </a:rPr>
+              <a:t>tokens cost money and time</a:t>
+            </a:r>
+            <a:endParaRPr lang="en-US" sz="1500" dirty="0"/>
+          </a:p>
+        </p:txBody>
+      </p:sp>
+      <p:sp>
+        <p:nvSpPr>
+          <p:cNvPr id="78" name="box "/>
+          <p:cNvSpPr/>
+          <p:nvPr/>
+        </p:nvSpPr>
+        <p:spPr>
+          <a:xfrm>
+            <a:off x="8046720" y="4407408"/>
+            <a:ext cx="3566160" cy="502920"/>
+          </a:xfrm>
+          <a:prstGeom prst="roundRect">
+            <a:avLst>
+              <a:gd name="adj" fmla="val 10909"/>
+            </a:avLst>
+          </a:prstGeom>
+          <a:solidFill>
+            <a:srgbClr val="F2F2F2"/>
+          </a:solidFill>
+          <a:ln w="9525">
+            <a:solidFill>
+              <a:srgbClr val="BFBFBF"/>
+            </a:solidFill>
+            <a:prstDash val="solid"/>
+          </a:ln>
+        </p:spPr>
+      </p:sp>
+      <p:sp>
+        <p:nvSpPr>
+          <p:cNvPr id="79" name="Text 20"/>
+          <p:cNvSpPr txBox="1"/>
+          <p:nvPr/>
+        </p:nvSpPr>
+        <p:spPr>
+          <a:xfrm>
+            <a:off x="8119872" y="4407408"/>
+            <a:ext cx="3419856" cy="502920"/>
+          </a:xfrm>
+          <a:prstGeom prst="rect">
+            <a:avLst/>
+          </a:prstGeom>
+          <a:noFill/>
+          <a:ln/>
+        </p:spPr>
+        <p:txBody>
+          <a:bodyPr wrap="square" lIns="0" tIns="0" rIns="0" bIns="0" rtlCol="0" anchor="ctr"/>
+          <a:lstStyle/>
+          <a:p>
+            <a:pPr algn="ctr" indent="0" marL="0">
+              <a:buNone/>
+            </a:pPr>
+            <a:endParaRPr lang="en-US" sz="1500" dirty="0"/>
+          </a:p>
+        </p:txBody>
+      </p:sp>
+      <p:pic>
+        <p:nvPicPr>
+          <p:cNvPr id="80" name="icon gpu" descr="/NAS/SJ/POSTECH/nlp/figs/icons/gpu.png">    </p:cNvPr>
+          <p:cNvPicPr>
+            <a:picLocks noChangeAspect="1"/>
+          </p:cNvPicPr>
+          <p:nvPr/>
+        </p:nvPicPr>
+        <p:blipFill>
+          <a:blip r:embed="rId58"/>
+          <a:stretch>
+            <a:fillRect/>
+          </a:stretch>
+        </p:blipFill>
+        <p:spPr>
+          <a:xfrm>
+            <a:off x="8183880" y="4462272"/>
+            <a:ext cx="384048" cy="384048"/>
+          </a:xfrm>
+          <a:prstGeom prst="rect">
+            <a:avLst/>
+          </a:prstGeom>
+        </p:spPr>
+      </p:pic>
+      <p:sp>
+        <p:nvSpPr>
+          <p:cNvPr id="81" name="Text 21"/>
+          <p:cNvSpPr txBox="1"/>
+          <p:nvPr/>
+        </p:nvSpPr>
+        <p:spPr>
+          <a:xfrm>
+            <a:off x="8686800" y="4407408"/>
+            <a:ext cx="2834640" cy="502920"/>
+          </a:xfrm>
+          <a:prstGeom prst="rect">
+            <a:avLst/>
+          </a:prstGeom>
+          <a:noFill/>
+          <a:ln/>
+        </p:spPr>
+        <p:txBody>
+          <a:bodyPr wrap="square" lIns="0" tIns="0" rIns="0" bIns="0" rtlCol="0" anchor="ctr"/>
+          <a:lstStyle/>
+          <a:p>
+            <a:pPr indent="0" marL="0">
+              <a:buNone/>
+            </a:pPr>
+            <a:r>
+              <a:rPr lang="en-US" sz="1500" dirty="0">
+                <a:solidFill>
+                  <a:schemeClr val="tx1"/>
+                </a:solidFill>
+              </a:rPr>
+              <a:t>most teams have one 24 GB GPU</a:t>
+            </a:r>
+            <a:endParaRPr lang="en-US" sz="1500" dirty="0"/>
+          </a:p>
+        </p:txBody>
+      </p:sp>
+      <p:sp>
+        <p:nvSpPr>
+          <p:cNvPr id="82" name="our question"/>
+          <p:cNvSpPr/>
+          <p:nvPr/>
+        </p:nvSpPr>
+        <p:spPr>
+          <a:xfrm>
+            <a:off x="548640" y="5074920"/>
+            <a:ext cx="11064240" cy="960120"/>
+          </a:xfrm>
+          <a:prstGeom prst="roundRect">
+            <a:avLst>
+              <a:gd name="adj" fmla="val 7619"/>
+            </a:avLst>
+          </a:prstGeom>
+          <a:solidFill>
+            <a:srgbClr val="DEEBF7"/>
+          </a:solidFill>
+          <a:ln w="9525">
+            <a:solidFill>
+              <a:srgbClr val="BDD7EE"/>
+            </a:solidFill>
+            <a:prstDash val="solid"/>
+          </a:ln>
+        </p:spPr>
+      </p:sp>
+      <p:sp>
+        <p:nvSpPr>
+          <p:cNvPr id="83" name="Text 23"/>
+          <p:cNvSpPr txBox="1"/>
+          <p:nvPr/>
+        </p:nvSpPr>
+        <p:spPr>
+          <a:xfrm>
+            <a:off x="777240" y="5120640"/>
+            <a:ext cx="4023360" cy="868680"/>
+          </a:xfrm>
+          <a:prstGeom prst="rect">
+            <a:avLst/>
+          </a:prstGeom>
+          <a:noFill/>
+          <a:ln/>
+        </p:spPr>
+        <p:txBody>
+          <a:bodyPr wrap="square" lIns="0" tIns="0" rIns="0" bIns="0" rtlCol="0" anchor="ctr"/>
+          <a:lstStyle/>
+          <a:p>
+            <a:pPr indent="0" marL="0">
+              <a:buNone/>
+            </a:pPr>
+            <a:r>
+              <a:rPr lang="en-US" sz="2000" b="1" dirty="0">
+                <a:solidFill>
+                  <a:srgbClr val="4472C4"/>
+                </a:solidFill>
+              </a:rPr>
+              <a:t>Where should extra effort go?</a:t>
+            </a:r>
+            <a:endParaRPr lang="en-US" sz="2000" dirty="0"/>
+          </a:p>
+        </p:txBody>
+      </p:sp>
+      <p:sp>
+        <p:nvSpPr>
+          <p:cNvPr id="84" name="option a missing fact"/>
+          <p:cNvSpPr/>
+          <p:nvPr/>
+        </p:nvSpPr>
+        <p:spPr>
+          <a:xfrm>
+            <a:off x="4846320" y="5303520"/>
+            <a:ext cx="2103120" cy="502920"/>
+          </a:xfrm>
+          <a:prstGeom prst="roundRect">
+            <a:avLst>
+              <a:gd name="adj" fmla="val 36364"/>
             </a:avLst>
           </a:prstGeom>
           <a:solidFill>
@@ -20063,22 +22190,46 @@
           </a:solidFill>
           <a:ln w="12700">
             <a:solidFill>
-              <a:srgbClr val="70AD47"/>
+              <a:srgbClr val="38761D"/>
             </a:solidFill>
             <a:prstDash val="solid"/>
           </a:ln>
         </p:spPr>
       </p:sp>
-      <p:sp>
-        <p:nvSpPr>
-          <p:cNvPr id="7" name="Text 5"/>
-          <p:cNvSpPr txBox="1"/>
-          <p:nvPr/>
-        </p:nvSpPr>
-        <p:spPr>
-          <a:xfrm>
-            <a:off x="914400" y="2194560"/>
-            <a:ext cx="1554480" cy="548640"/>
+      <p:pic>
+        <p:nvPicPr>
+          <p:cNvPr id="85" name="icon fact" descr="/NAS/SJ/POSTECH/nlp/figs/icons/fact.png">    </p:cNvPr>
+          <p:cNvPicPr>
+            <a:picLocks noChangeAspect="1"/>
+          </p:cNvPicPr>
+          <p:nvPr/>
+        </p:nvPicPr>
+        <p:blipFill>
+          <a:blip r:embed="rId59"/>
+          <a:stretch>
+            <a:fillRect/>
+          </a:stretch>
+        </p:blipFill>
+        <p:spPr>
+          <a:xfrm>
+            <a:off x="4974336" y="5385816"/>
+            <a:ext cx="329184" cy="329184"/>
+          </a:xfrm>
+          <a:prstGeom prst="rect">
+            <a:avLst/>
+          </a:prstGeom>
+        </p:spPr>
+      </p:pic>
+      <p:sp>
+        <p:nvSpPr>
+          <p:cNvPr id="86" name="Text 25"/>
+          <p:cNvSpPr txBox="1"/>
+          <p:nvPr/>
+        </p:nvSpPr>
+        <p:spPr>
+          <a:xfrm>
+            <a:off x="5413248" y="5303520"/>
+            <a:ext cx="1508760" cy="502920"/>
           </a:xfrm>
           <a:prstGeom prst="rect">
             <a:avLst/>
@@ -20090,71 +22241,122 @@
           <a:bodyPr wrap="square" lIns="0" tIns="0" rIns="0" bIns="0" rtlCol="0" anchor="ctr"/>
           <a:lstStyle/>
           <a:p>
-            <a:pPr algn="ctr" indent="0" marL="0">
-              <a:buNone/>
-            </a:pPr>
-            <a:r>
-              <a:rPr lang="en-US" sz="2200" b="1" dirty="0">
+            <a:pPr indent="0" marL="0">
+              <a:buNone/>
+            </a:pPr>
+            <a:r>
+              <a:rPr lang="en-US" sz="1600" b="1" dirty="0">
                 <a:solidFill>
                   <a:srgbClr val="38761D"/>
                 </a:solidFill>
               </a:rPr>
-              <a:t>6 ✓</a:t>
-            </a:r>
-            <a:endParaRPr lang="en-US" sz="2200" dirty="0"/>
-          </a:p>
-        </p:txBody>
-      </p:sp>
-      <p:sp>
-        <p:nvSpPr>
-          <p:cNvPr id="8" name="Text 6"/>
-          <p:cNvSpPr txBox="1"/>
-          <p:nvPr/>
-        </p:nvSpPr>
-        <p:spPr>
-          <a:xfrm>
-            <a:off x="777240" y="2761488"/>
-            <a:ext cx="1554480" cy="274320"/>
-          </a:xfrm>
-          <a:prstGeom prst="rect">
-            <a:avLst/>
-          </a:prstGeom>
-          <a:noFill/>
-          <a:ln/>
-        </p:spPr>
-        <p:txBody>
-          <a:bodyPr wrap="square" lIns="0" tIns="0" rIns="0" bIns="0" rtlCol="0" anchor="ctr"/>
-          <a:lstStyle/>
-          <a:p>
-            <a:pPr algn="ctr" indent="0" marL="0">
-              <a:buNone/>
-            </a:pPr>
-            <a:r>
-              <a:rPr lang="en-US" sz="1300" dirty="0">
-                <a:solidFill>
-                  <a:schemeClr val="tx2"/>
-                </a:solidFill>
-              </a:rPr>
-              <a:t>program A</a:t>
-            </a:r>
-            <a:endParaRPr lang="en-US" sz="1300" dirty="0"/>
-          </a:p>
-        </p:txBody>
-      </p:sp>
-      <p:sp>
-        <p:nvSpPr>
-          <p:cNvPr id="9" name="answer 0 ✗"/>
+              <a:t>a missing fact</a:t>
+            </a:r>
+            <a:endParaRPr lang="en-US" sz="1600" dirty="0"/>
+          </a:p>
+        </p:txBody>
+      </p:sp>
+      <p:sp>
+        <p:nvSpPr>
+          <p:cNvPr id="87" name="option a free check"/>
           <p:cNvSpPr/>
           <p:nvPr/>
         </p:nvSpPr>
         <p:spPr>
           <a:xfrm>
-            <a:off x="2834640" y="2194560"/>
-            <a:ext cx="1554480" cy="548640"/>
+            <a:off x="7086600" y="5303520"/>
+            <a:ext cx="2103120" cy="502920"/>
           </a:xfrm>
           <a:prstGeom prst="roundRect">
             <a:avLst>
-              <a:gd name="adj" fmla="val 16667"/>
+              <a:gd name="adj" fmla="val 36364"/>
+            </a:avLst>
+          </a:prstGeom>
+          <a:solidFill>
+            <a:srgbClr val="E2F0D9"/>
+          </a:solidFill>
+          <a:ln w="12700">
+            <a:solidFill>
+              <a:srgbClr val="38761D"/>
+            </a:solidFill>
+            <a:prstDash val="solid"/>
+          </a:ln>
+        </p:spPr>
+      </p:sp>
+      <p:pic>
+        <p:nvPicPr>
+          <p:cNvPr id="88" name="icon check" descr="/NAS/SJ/POSTECH/nlp/figs/icons/check.png">    </p:cNvPr>
+          <p:cNvPicPr>
+            <a:picLocks noChangeAspect="1"/>
+          </p:cNvPicPr>
+          <p:nvPr/>
+        </p:nvPicPr>
+        <p:blipFill>
+          <a:blip r:embed="rId60"/>
+          <a:stretch>
+            <a:fillRect/>
+          </a:stretch>
+        </p:blipFill>
+        <p:spPr>
+          <a:xfrm>
+            <a:off x="7214616" y="5385816"/>
+            <a:ext cx="329184" cy="329184"/>
+          </a:xfrm>
+          <a:prstGeom prst="rect">
+            <a:avLst/>
+          </a:prstGeom>
+        </p:spPr>
+      </p:pic>
+      <p:sp>
+        <p:nvSpPr>
+          <p:cNvPr id="89" name="Text 27"/>
+          <p:cNvSpPr txBox="1"/>
+          <p:nvPr/>
+        </p:nvSpPr>
+        <p:spPr>
+          <a:xfrm>
+            <a:off x="7653528" y="5303520"/>
+            <a:ext cx="1508760" cy="502920"/>
+          </a:xfrm>
+          <a:prstGeom prst="rect">
+            <a:avLst/>
+          </a:prstGeom>
+          <a:noFill/>
+          <a:ln/>
+        </p:spPr>
+        <p:txBody>
+          <a:bodyPr wrap="square" lIns="0" tIns="0" rIns="0" bIns="0" rtlCol="0" anchor="ctr"/>
+          <a:lstStyle/>
+          <a:p>
+            <a:pPr indent="0" marL="0">
+              <a:buNone/>
+            </a:pPr>
+            <a:r>
+              <a:rPr lang="en-US" sz="1600" b="1" dirty="0">
+                <a:solidFill>
+                  <a:srgbClr val="38761D"/>
+                </a:solidFill>
+              </a:rPr>
+              <a:t>a free check</a:t>
+            </a:r>
+            <a:endParaRPr lang="en-US" sz="1600" dirty="0"/>
+          </a:p>
+        </p:txBody>
+      </p:sp>
+      <p:sp>
+        <p:nvSpPr>
+          <p:cNvPr id="90" name="option more thinking"/>
+          <p:cNvSpPr/>
+          <p:nvPr/>
+        </p:nvSpPr>
+        <p:spPr>
+          <a:xfrm>
+            <a:off x="9326880" y="5303520"/>
+            <a:ext cx="2103120" cy="502920"/>
+          </a:xfrm>
+          <a:prstGeom prst="roundRect">
+            <a:avLst>
+              <a:gd name="adj" fmla="val 36364"/>
             </a:avLst>
           </a:prstGeom>
           <a:solidFill>
@@ -20168,16 +22370,40 @@
           </a:ln>
         </p:spPr>
       </p:sp>
-      <p:sp>
-        <p:nvSpPr>
-          <p:cNvPr id="10" name="Text 8"/>
-          <p:cNvSpPr txBox="1"/>
-          <p:nvPr/>
-        </p:nvSpPr>
-        <p:spPr>
-          <a:xfrm>
-            <a:off x="2834640" y="2194560"/>
-            <a:ext cx="1554480" cy="548640"/>
+      <p:pic>
+        <p:nvPicPr>
+          <p:cNvPr id="91" name="icon brain" descr="/NAS/SJ/POSTECH/nlp/figs/icons/brain.png">    </p:cNvPr>
+          <p:cNvPicPr>
+            <a:picLocks noChangeAspect="1"/>
+          </p:cNvPicPr>
+          <p:nvPr/>
+        </p:nvPicPr>
+        <p:blipFill>
+          <a:blip r:embed="rId61"/>
+          <a:stretch>
+            <a:fillRect/>
+          </a:stretch>
+        </p:blipFill>
+        <p:spPr>
+          <a:xfrm>
+            <a:off x="9454896" y="5385816"/>
+            <a:ext cx="329184" cy="329184"/>
+          </a:xfrm>
+          <a:prstGeom prst="rect">
+            <a:avLst/>
+          </a:prstGeom>
+        </p:spPr>
+      </p:pic>
+      <p:sp>
+        <p:nvSpPr>
+          <p:cNvPr id="92" name="Text 29"/>
+          <p:cNvSpPr txBox="1"/>
+          <p:nvPr/>
+        </p:nvSpPr>
+        <p:spPr>
+          <a:xfrm>
+            <a:off x="9893808" y="5303520"/>
+            <a:ext cx="1508760" cy="502920"/>
           </a:xfrm>
           <a:prstGeom prst="rect">
             <a:avLst/>
@@ -20189,954 +22415,18 @@
           <a:bodyPr wrap="square" lIns="0" tIns="0" rIns="0" bIns="0" rtlCol="0" anchor="ctr"/>
           <a:lstStyle/>
           <a:p>
-            <a:pPr algn="ctr" indent="0" marL="0">
-              <a:buNone/>
-            </a:pPr>
-            <a:r>
-              <a:rPr lang="en-US" sz="2200" b="1" dirty="0">
+            <a:pPr indent="0" marL="0">
+              <a:buNone/>
+            </a:pPr>
+            <a:r>
+              <a:rPr lang="en-US" sz="1600" b="1" dirty="0">
                 <a:solidFill>
                   <a:srgbClr val="C00000"/>
                 </a:solidFill>
               </a:rPr>
-              <a:t>0 ✗</a:t>
-            </a:r>
-            <a:endParaRPr lang="en-US" sz="2200" dirty="0"/>
-          </a:p>
-        </p:txBody>
-      </p:sp>
-      <p:sp>
-        <p:nvSpPr>
-          <p:cNvPr id="11" name="Text 9"/>
-          <p:cNvSpPr txBox="1"/>
-          <p:nvPr/>
-        </p:nvSpPr>
-        <p:spPr>
-          <a:xfrm>
-            <a:off x="2423160" y="2761488"/>
-            <a:ext cx="2286000" cy="274320"/>
-          </a:xfrm>
-          <a:prstGeom prst="rect">
-            <a:avLst/>
-          </a:prstGeom>
-          <a:noFill/>
-          <a:ln/>
-        </p:spPr>
-        <p:txBody>
-          <a:bodyPr wrap="square" lIns="0" tIns="0" rIns="0" bIns="0" rtlCol="0" anchor="ctr"/>
-          <a:lstStyle/>
-          <a:p>
-            <a:pPr algn="ctr" indent="0" marL="0">
-              <a:buNone/>
-            </a:pPr>
-            <a:r>
-              <a:rPr lang="en-US" sz="1300" dirty="0">
-                <a:solidFill>
-                  <a:schemeClr val="tx2"/>
-                </a:solidFill>
-              </a:rPr>
-              <a:t>program B: no error, just wrong</a:t>
-            </a:r>
-            <a:endParaRPr lang="en-US" sz="1300" dirty="0"/>
-          </a:p>
-        </p:txBody>
-      </p:sp>
-      <p:sp>
-        <p:nvSpPr>
-          <p:cNvPr id="12" name="Text 10"/>
-          <p:cNvSpPr txBox="1"/>
-          <p:nvPr/>
-        </p:nvSpPr>
-        <p:spPr>
-          <a:xfrm>
-            <a:off x="777240" y="3108960"/>
-            <a:ext cx="5029200" cy="777240"/>
-          </a:xfrm>
-          <a:prstGeom prst="rect">
-            <a:avLst/>
-          </a:prstGeom>
-          <a:noFill/>
-          <a:ln/>
-        </p:spPr>
-        <p:txBody>
-          <a:bodyPr wrap="square" lIns="0" tIns="0" rIns="0" bIns="0" rtlCol="0" anchor="ctr"/>
-          <a:lstStyle/>
-          <a:p>
-            <a:pPr indent="0" marL="0">
-              <a:buNone/>
-            </a:pPr>
-            <a:r>
-              <a:rPr lang="en-US" sz="2800" b="1" dirty="0">
-                <a:solidFill>
-                  <a:srgbClr val="C00000"/>
-                </a:solidFill>
-              </a:rPr>
-              <a:t>24–37%</a:t>
-            </a:r>
-            <a:pPr indent="0" marL="0">
-              <a:buNone/>
-            </a:pPr>
-            <a:r>
-              <a:rPr lang="en-US" sz="1500" dirty="0">
-                <a:solidFill>
-                  <a:schemeClr val="tx1"/>
-                </a:solidFill>
-              </a:rPr>
-              <a:t>  of wrong programs pass the problem's examples</a:t>
+              <a:t>more thinking</a:t>
             </a:r>
             <a:endParaRPr lang="en-US" sz="1600" dirty="0"/>
-          </a:p>
-        </p:txBody>
-      </p:sp>
-      <p:sp>
-        <p:nvSpPr>
-          <p:cNvPr id="13" name="why 2. Thinking longer is expensive"/>
-          <p:cNvSpPr/>
-          <p:nvPr/>
-        </p:nvSpPr>
-        <p:spPr>
-          <a:xfrm>
-            <a:off x="6172200" y="1280160"/>
-            <a:ext cx="5440680" cy="2743200"/>
-          </a:xfrm>
-          <a:prstGeom prst="roundRect">
-            <a:avLst>
-              <a:gd name="adj" fmla="val 2667"/>
-            </a:avLst>
-          </a:prstGeom>
-          <a:solidFill>
-            <a:srgbClr val="FDF0E6"/>
-          </a:solidFill>
-          <a:ln w="12700">
-            <a:solidFill>
-              <a:srgbClr val="ED7D31"/>
-            </a:solidFill>
-            <a:prstDash val="solid"/>
-          </a:ln>
-        </p:spPr>
-      </p:sp>
-      <p:sp>
-        <p:nvSpPr>
-          <p:cNvPr id="14" name="Text 12"/>
-          <p:cNvSpPr txBox="1"/>
-          <p:nvPr/>
-        </p:nvSpPr>
-        <p:spPr>
-          <a:xfrm>
-            <a:off x="6400800" y="1371600"/>
-            <a:ext cx="4983480" cy="502920"/>
-          </a:xfrm>
-          <a:prstGeom prst="rect">
-            <a:avLst/>
-          </a:prstGeom>
-          <a:noFill/>
-          <a:ln/>
-        </p:spPr>
-        <p:txBody>
-          <a:bodyPr wrap="square" lIns="0" tIns="0" rIns="0" bIns="0" rtlCol="0" anchor="ctr"/>
-          <a:lstStyle/>
-          <a:p>
-            <a:pPr indent="0" marL="0">
-              <a:buNone/>
-            </a:pPr>
-            <a:r>
-              <a:rPr lang="en-US" sz="2200" b="1" dirty="0">
-                <a:solidFill>
-                  <a:srgbClr val="ED7D31"/>
-                </a:solidFill>
-              </a:rPr>
-              <a:t>2. Thinking longer is expensive</a:t>
-            </a:r>
-            <a:endParaRPr lang="en-US" sz="2200" dirty="0"/>
-          </a:p>
-        </p:txBody>
-      </p:sp>
-      <p:sp>
-        <p:nvSpPr>
-          <p:cNvPr id="15" name="Text 13"/>
-          <p:cNvSpPr txBox="1"/>
-          <p:nvPr/>
-        </p:nvSpPr>
-        <p:spPr>
-          <a:xfrm>
-            <a:off x="6400800" y="1828800"/>
-            <a:ext cx="5029200" cy="274320"/>
-          </a:xfrm>
-          <a:prstGeom prst="rect">
-            <a:avLst/>
-          </a:prstGeom>
-          <a:noFill/>
-          <a:ln/>
-        </p:spPr>
-        <p:txBody>
-          <a:bodyPr wrap="square" lIns="0" tIns="0" rIns="0" bIns="0" rtlCol="0" anchor="ctr"/>
-          <a:lstStyle/>
-          <a:p>
-            <a:pPr indent="0" marL="0">
-              <a:buNone/>
-            </a:pPr>
-            <a:r>
-              <a:rPr lang="en-US" sz="1300" dirty="0">
-                <a:solidFill>
-                  <a:schemeClr val="tx2"/>
-                </a:solidFill>
-              </a:rPr>
-              <a:t>311 contest problems (gpt-oss-120b), by effort:</a:t>
-            </a:r>
-            <a:endParaRPr lang="en-US" sz="1300" dirty="0"/>
-          </a:p>
-        </p:txBody>
-      </p:sp>
-      <p:sp>
-        <p:nvSpPr>
-          <p:cNvPr id="16" name="Text 14"/>
-          <p:cNvSpPr txBox="1"/>
-          <p:nvPr/>
-        </p:nvSpPr>
-        <p:spPr>
-          <a:xfrm>
-            <a:off x="6355080" y="2194560"/>
-            <a:ext cx="822960" cy="365760"/>
-          </a:xfrm>
-          <a:prstGeom prst="rect">
-            <a:avLst/>
-          </a:prstGeom>
-          <a:noFill/>
-          <a:ln/>
-        </p:spPr>
-        <p:txBody>
-          <a:bodyPr wrap="square" lIns="0" tIns="0" rIns="0" bIns="0" rtlCol="0" anchor="ctr"/>
-          <a:lstStyle/>
-          <a:p>
-            <a:pPr algn="r" indent="0" marL="0">
-              <a:buNone/>
-            </a:pPr>
-            <a:r>
-              <a:rPr lang="en-US" sz="1500" dirty="0">
-                <a:solidFill>
-                  <a:schemeClr val="tx1"/>
-                </a:solidFill>
-              </a:rPr>
-              <a:t>medium</a:t>
-            </a:r>
-            <a:endParaRPr lang="en-US" sz="1500" dirty="0"/>
-          </a:p>
-        </p:txBody>
-      </p:sp>
-      <p:sp>
-        <p:nvSpPr>
-          <p:cNvPr id="17" name="effort medium"/>
-          <p:cNvSpPr/>
-          <p:nvPr/>
-        </p:nvSpPr>
-        <p:spPr>
-          <a:xfrm>
-            <a:off x="7269480" y="2258568"/>
-            <a:ext cx="619726" cy="274320"/>
-          </a:xfrm>
-          <a:prstGeom prst="rect">
-            <a:avLst/>
-          </a:prstGeom>
-          <a:solidFill>
-            <a:srgbClr val="A5A5A5"/>
-          </a:solidFill>
-          <a:ln w="6350">
-            <a:solidFill>
-              <a:srgbClr val="A5A5A5"/>
-            </a:solidFill>
-            <a:prstDash val="solid"/>
-          </a:ln>
-        </p:spPr>
-      </p:sp>
-      <p:sp>
-        <p:nvSpPr>
-          <p:cNvPr id="18" name="Text 16"/>
-          <p:cNvSpPr txBox="1"/>
-          <p:nvPr/>
-        </p:nvSpPr>
-        <p:spPr>
-          <a:xfrm>
-            <a:off x="7980646" y="2194560"/>
-            <a:ext cx="1737360" cy="365760"/>
-          </a:xfrm>
-          <a:prstGeom prst="rect">
-            <a:avLst/>
-          </a:prstGeom>
-          <a:noFill/>
-          <a:ln/>
-        </p:spPr>
-        <p:txBody>
-          <a:bodyPr wrap="square" lIns="0" tIns="0" rIns="0" bIns="0" rtlCol="0" anchor="ctr"/>
-          <a:lstStyle/>
-          <a:p>
-            <a:pPr indent="0" marL="0">
-              <a:buNone/>
-            </a:pPr>
-            <a:r>
-              <a:rPr lang="en-US" sz="1300" b="1" dirty="0">
-                <a:solidFill>
-                  <a:srgbClr val="595959"/>
-                </a:solidFill>
-              </a:rPr>
-              <a:t>57% · 6.8k tokens</a:t>
-            </a:r>
-            <a:endParaRPr lang="en-US" sz="1300" dirty="0"/>
-          </a:p>
-        </p:txBody>
-      </p:sp>
-      <p:sp>
-        <p:nvSpPr>
-          <p:cNvPr id="19" name="Text 17"/>
-          <p:cNvSpPr txBox="1"/>
-          <p:nvPr/>
-        </p:nvSpPr>
-        <p:spPr>
-          <a:xfrm>
-            <a:off x="6355080" y="2651760"/>
-            <a:ext cx="822960" cy="365760"/>
-          </a:xfrm>
-          <a:prstGeom prst="rect">
-            <a:avLst/>
-          </a:prstGeom>
-          <a:noFill/>
-          <a:ln/>
-        </p:spPr>
-        <p:txBody>
-          <a:bodyPr wrap="square" lIns="0" tIns="0" rIns="0" bIns="0" rtlCol="0" anchor="ctr"/>
-          <a:lstStyle/>
-          <a:p>
-            <a:pPr algn="r" indent="0" marL="0">
-              <a:buNone/>
-            </a:pPr>
-            <a:r>
-              <a:rPr lang="en-US" sz="1500" dirty="0">
-                <a:solidFill>
-                  <a:schemeClr val="tx1"/>
-                </a:solidFill>
-              </a:rPr>
-              <a:t>high</a:t>
-            </a:r>
-            <a:endParaRPr lang="en-US" sz="1500" dirty="0"/>
-          </a:p>
-        </p:txBody>
-      </p:sp>
-      <p:sp>
-        <p:nvSpPr>
-          <p:cNvPr id="20" name="effort high"/>
-          <p:cNvSpPr/>
-          <p:nvPr/>
-        </p:nvSpPr>
-        <p:spPr>
-          <a:xfrm>
-            <a:off x="7269480" y="2715768"/>
-            <a:ext cx="2743200" cy="274320"/>
-          </a:xfrm>
-          <a:prstGeom prst="rect">
-            <a:avLst/>
-          </a:prstGeom>
-          <a:solidFill>
-            <a:srgbClr val="ED7D31"/>
-          </a:solidFill>
-          <a:ln w="6350">
-            <a:solidFill>
-              <a:srgbClr val="ED7D31"/>
-            </a:solidFill>
-            <a:prstDash val="solid"/>
-          </a:ln>
-        </p:spPr>
-      </p:sp>
-      <p:sp>
-        <p:nvSpPr>
-          <p:cNvPr id="21" name="Text 19"/>
-          <p:cNvSpPr txBox="1"/>
-          <p:nvPr/>
-        </p:nvSpPr>
-        <p:spPr>
-          <a:xfrm>
-            <a:off x="10104120" y="2651760"/>
-            <a:ext cx="1737360" cy="365760"/>
-          </a:xfrm>
-          <a:prstGeom prst="rect">
-            <a:avLst/>
-          </a:prstGeom>
-          <a:noFill/>
-          <a:ln/>
-        </p:spPr>
-        <p:txBody>
-          <a:bodyPr wrap="square" lIns="0" tIns="0" rIns="0" bIns="0" rtlCol="0" anchor="ctr"/>
-          <a:lstStyle/>
-          <a:p>
-            <a:pPr indent="0" marL="0">
-              <a:buNone/>
-            </a:pPr>
-            <a:r>
-              <a:rPr lang="en-US" sz="1300" b="1" dirty="0">
-                <a:solidFill>
-                  <a:srgbClr val="ED7D31"/>
-                </a:solidFill>
-              </a:rPr>
-              <a:t>66% · 30k tokens</a:t>
-            </a:r>
-            <a:endParaRPr lang="en-US" sz="1300" dirty="0"/>
-          </a:p>
-        </p:txBody>
-      </p:sp>
-      <p:sp>
-        <p:nvSpPr>
-          <p:cNvPr id="22" name="Text 20"/>
-          <p:cNvSpPr txBox="1"/>
-          <p:nvPr/>
-        </p:nvSpPr>
-        <p:spPr>
-          <a:xfrm>
-            <a:off x="6400800" y="3108960"/>
-            <a:ext cx="5029200" cy="777240"/>
-          </a:xfrm>
-          <a:prstGeom prst="rect">
-            <a:avLst/>
-          </a:prstGeom>
-          <a:noFill/>
-          <a:ln/>
-        </p:spPr>
-        <p:txBody>
-          <a:bodyPr wrap="square" lIns="0" tIns="0" rIns="0" bIns="0" rtlCol="0" anchor="ctr"/>
-          <a:lstStyle/>
-          <a:p>
-            <a:pPr indent="0" marL="0">
-              <a:buNone/>
-            </a:pPr>
-            <a:r>
-              <a:rPr lang="en-US" sz="2800" b="1" dirty="0">
-                <a:solidFill>
-                  <a:srgbClr val="ED7D31"/>
-                </a:solidFill>
-              </a:rPr>
-              <a:t>4.4× tokens</a:t>
-            </a:r>
-            <a:pPr indent="0" marL="0">
-              <a:buNone/>
-            </a:pPr>
-            <a:r>
-              <a:rPr lang="en-US" sz="1500" dirty="0">
-                <a:solidFill>
-                  <a:schemeClr val="tx1"/>
-                </a:solidFill>
-              </a:rPr>
-              <a:t>  for only 9 more points</a:t>
-            </a:r>
-            <a:endParaRPr lang="en-US" sz="1600" dirty="0"/>
-          </a:p>
-        </p:txBody>
-      </p:sp>
-      <p:sp>
-        <p:nvSpPr>
-          <p:cNvPr id="23" name="Text 21"/>
-          <p:cNvSpPr txBox="1"/>
-          <p:nvPr/>
-        </p:nvSpPr>
-        <p:spPr>
-          <a:xfrm>
-            <a:off x="548640" y="4206240"/>
-            <a:ext cx="1828800" cy="457200"/>
-          </a:xfrm>
-          <a:prstGeom prst="rect">
-            <a:avLst/>
-          </a:prstGeom>
-          <a:noFill/>
-          <a:ln/>
-        </p:spPr>
-        <p:txBody>
-          <a:bodyPr wrap="square" lIns="0" tIns="0" rIns="0" bIns="0" rtlCol="0" anchor="ctr"/>
-          <a:lstStyle/>
-          <a:p>
-            <a:pPr indent="0" marL="0">
-              <a:buNone/>
-            </a:pPr>
-            <a:r>
-              <a:rPr lang="en-US" sz="1600" b="1" dirty="0">
-                <a:solidFill>
-                  <a:schemeClr val="tx1"/>
-                </a:solidFill>
-              </a:rPr>
-              <a:t>Why it matters:</a:t>
-            </a:r>
-            <a:endParaRPr lang="en-US" sz="1600" dirty="0"/>
-          </a:p>
-        </p:txBody>
-      </p:sp>
-      <p:sp>
-        <p:nvSpPr>
-          <p:cNvPr id="24" name="box agents already write"/>
-          <p:cNvSpPr/>
-          <p:nvPr/>
-        </p:nvSpPr>
-        <p:spPr>
-          <a:xfrm>
-            <a:off x="2377440" y="4206240"/>
-            <a:ext cx="2971800" cy="457200"/>
-          </a:xfrm>
-          <a:prstGeom prst="roundRect">
-            <a:avLst>
-              <a:gd name="adj" fmla="val 12000"/>
-            </a:avLst>
-          </a:prstGeom>
-          <a:solidFill>
-            <a:srgbClr val="F2F2F2"/>
-          </a:solidFill>
-          <a:ln w="9525">
-            <a:solidFill>
-              <a:srgbClr val="BFBFBF"/>
-            </a:solidFill>
-            <a:prstDash val="solid"/>
-          </a:ln>
-        </p:spPr>
-      </p:sp>
-      <p:sp>
-        <p:nvSpPr>
-          <p:cNvPr id="25" name="Text 23"/>
-          <p:cNvSpPr txBox="1"/>
-          <p:nvPr/>
-        </p:nvSpPr>
-        <p:spPr>
-          <a:xfrm>
-            <a:off x="2450592" y="4206240"/>
-            <a:ext cx="2825496" cy="457200"/>
-          </a:xfrm>
-          <a:prstGeom prst="rect">
-            <a:avLst/>
-          </a:prstGeom>
-          <a:noFill/>
-          <a:ln/>
-        </p:spPr>
-        <p:txBody>
-          <a:bodyPr wrap="square" lIns="0" tIns="0" rIns="0" bIns="0" rtlCol="0" anchor="ctr"/>
-          <a:lstStyle/>
-          <a:p>
-            <a:pPr algn="ctr" indent="0" marL="0">
-              <a:buNone/>
-            </a:pPr>
-            <a:r>
-              <a:rPr lang="en-US" sz="1500" dirty="0">
-                <a:solidFill>
-                  <a:schemeClr val="tx1"/>
-                </a:solidFill>
-              </a:rPr>
-              <a:t>agents already write this code</a:t>
-            </a:r>
-            <a:endParaRPr lang="en-US" sz="1500" dirty="0"/>
-          </a:p>
-        </p:txBody>
-      </p:sp>
-      <p:sp>
-        <p:nvSpPr>
-          <p:cNvPr id="26" name="box tokens = cost and wa"/>
-          <p:cNvSpPr/>
-          <p:nvPr/>
-        </p:nvSpPr>
-        <p:spPr>
-          <a:xfrm>
-            <a:off x="5486400" y="4206240"/>
-            <a:ext cx="2971800" cy="457200"/>
-          </a:xfrm>
-          <a:prstGeom prst="roundRect">
-            <a:avLst>
-              <a:gd name="adj" fmla="val 12000"/>
-            </a:avLst>
-          </a:prstGeom>
-          <a:solidFill>
-            <a:srgbClr val="F2F2F2"/>
-          </a:solidFill>
-          <a:ln w="9525">
-            <a:solidFill>
-              <a:srgbClr val="BFBFBF"/>
-            </a:solidFill>
-            <a:prstDash val="solid"/>
-          </a:ln>
-        </p:spPr>
-      </p:sp>
-      <p:sp>
-        <p:nvSpPr>
-          <p:cNvPr id="27" name="Text 25"/>
-          <p:cNvSpPr txBox="1"/>
-          <p:nvPr/>
-        </p:nvSpPr>
-        <p:spPr>
-          <a:xfrm>
-            <a:off x="5559552" y="4206240"/>
-            <a:ext cx="2825496" cy="457200"/>
-          </a:xfrm>
-          <a:prstGeom prst="rect">
-            <a:avLst/>
-          </a:prstGeom>
-          <a:noFill/>
-          <a:ln/>
-        </p:spPr>
-        <p:txBody>
-          <a:bodyPr wrap="square" lIns="0" tIns="0" rIns="0" bIns="0" rtlCol="0" anchor="ctr"/>
-          <a:lstStyle/>
-          <a:p>
-            <a:pPr algn="ctr" indent="0" marL="0">
-              <a:buNone/>
-            </a:pPr>
-            <a:r>
-              <a:rPr lang="en-US" sz="1500" dirty="0">
-                <a:solidFill>
-                  <a:schemeClr val="tx1"/>
-                </a:solidFill>
-              </a:rPr>
-              <a:t>tokens = cost and waiting time</a:t>
-            </a:r>
-            <a:endParaRPr lang="en-US" sz="1500" dirty="0"/>
-          </a:p>
-        </p:txBody>
-      </p:sp>
-      <p:sp>
-        <p:nvSpPr>
-          <p:cNvPr id="28" name="box most teams have one "/>
-          <p:cNvSpPr/>
-          <p:nvPr/>
-        </p:nvSpPr>
-        <p:spPr>
-          <a:xfrm>
-            <a:off x="8595360" y="4206240"/>
-            <a:ext cx="2971800" cy="457200"/>
-          </a:xfrm>
-          <a:prstGeom prst="roundRect">
-            <a:avLst>
-              <a:gd name="adj" fmla="val 12000"/>
-            </a:avLst>
-          </a:prstGeom>
-          <a:solidFill>
-            <a:srgbClr val="F2F2F2"/>
-          </a:solidFill>
-          <a:ln w="9525">
-            <a:solidFill>
-              <a:srgbClr val="BFBFBF"/>
-            </a:solidFill>
-            <a:prstDash val="solid"/>
-          </a:ln>
-        </p:spPr>
-      </p:sp>
-      <p:sp>
-        <p:nvSpPr>
-          <p:cNvPr id="29" name="Text 27"/>
-          <p:cNvSpPr txBox="1"/>
-          <p:nvPr/>
-        </p:nvSpPr>
-        <p:spPr>
-          <a:xfrm>
-            <a:off x="8668512" y="4206240"/>
-            <a:ext cx="2825496" cy="457200"/>
-          </a:xfrm>
-          <a:prstGeom prst="rect">
-            <a:avLst/>
-          </a:prstGeom>
-          <a:noFill/>
-          <a:ln/>
-        </p:spPr>
-        <p:txBody>
-          <a:bodyPr wrap="square" lIns="0" tIns="0" rIns="0" bIns="0" rtlCol="0" anchor="ctr"/>
-          <a:lstStyle/>
-          <a:p>
-            <a:pPr algn="ctr" indent="0" marL="0">
-              <a:buNone/>
-            </a:pPr>
-            <a:r>
-              <a:rPr lang="en-US" sz="1500" dirty="0">
-                <a:solidFill>
-                  <a:schemeClr val="tx1"/>
-                </a:solidFill>
-              </a:rPr>
-              <a:t>most teams have one 24 GB GPU</a:t>
-            </a:r>
-            <a:endParaRPr lang="en-US" sz="1500" dirty="0"/>
-          </a:p>
-        </p:txBody>
-      </p:sp>
-      <p:sp>
-        <p:nvSpPr>
-          <p:cNvPr id="30" name="our question"/>
-          <p:cNvSpPr/>
-          <p:nvPr/>
-        </p:nvSpPr>
-        <p:spPr>
-          <a:xfrm>
-            <a:off x="548640" y="4892040"/>
-            <a:ext cx="11064240" cy="1097280"/>
-          </a:xfrm>
-          <a:prstGeom prst="roundRect">
-            <a:avLst>
-              <a:gd name="adj" fmla="val 6667"/>
-            </a:avLst>
-          </a:prstGeom>
-          <a:solidFill>
-            <a:srgbClr val="DEEBF7"/>
-          </a:solidFill>
-          <a:ln w="9525">
-            <a:solidFill>
-              <a:srgbClr val="BDD7EE"/>
-            </a:solidFill>
-            <a:prstDash val="solid"/>
-          </a:ln>
-        </p:spPr>
-      </p:sp>
-      <p:sp>
-        <p:nvSpPr>
-          <p:cNvPr id="31" name="Text 29"/>
-          <p:cNvSpPr txBox="1"/>
-          <p:nvPr/>
-        </p:nvSpPr>
-        <p:spPr>
-          <a:xfrm>
-            <a:off x="777240" y="4983480"/>
-            <a:ext cx="3931920" cy="548640"/>
-          </a:xfrm>
-          <a:prstGeom prst="rect">
-            <a:avLst/>
-          </a:prstGeom>
-          <a:noFill/>
-          <a:ln/>
-        </p:spPr>
-        <p:txBody>
-          <a:bodyPr wrap="square" lIns="0" tIns="0" rIns="0" bIns="0" rtlCol="0" anchor="ctr"/>
-          <a:lstStyle/>
-          <a:p>
-            <a:pPr indent="0" marL="0">
-              <a:buNone/>
-            </a:pPr>
-            <a:r>
-              <a:rPr lang="en-US" sz="2000" b="1" dirty="0">
-                <a:solidFill>
-                  <a:srgbClr val="4472C4"/>
-                </a:solidFill>
-              </a:rPr>
-              <a:t>Where should extra effort go?</a:t>
-            </a:r>
-            <a:endParaRPr lang="en-US" sz="2000" dirty="0"/>
-          </a:p>
-        </p:txBody>
-      </p:sp>
-      <p:sp>
-        <p:nvSpPr>
-          <p:cNvPr id="32" name="option a missing fact"/>
-          <p:cNvSpPr/>
-          <p:nvPr/>
-        </p:nvSpPr>
-        <p:spPr>
-          <a:xfrm>
-            <a:off x="4846320" y="5029200"/>
-            <a:ext cx="2057400" cy="457200"/>
-          </a:xfrm>
-          <a:prstGeom prst="roundRect">
-            <a:avLst>
-              <a:gd name="adj" fmla="val 40000"/>
-            </a:avLst>
-          </a:prstGeom>
-          <a:solidFill>
-            <a:srgbClr val="E2F0D9"/>
-          </a:solidFill>
-          <a:ln w="12700">
-            <a:solidFill>
-              <a:srgbClr val="38761D"/>
-            </a:solidFill>
-            <a:prstDash val="solid"/>
-          </a:ln>
-        </p:spPr>
-      </p:sp>
-      <p:sp>
-        <p:nvSpPr>
-          <p:cNvPr id="33" name="Text 31"/>
-          <p:cNvSpPr txBox="1"/>
-          <p:nvPr/>
-        </p:nvSpPr>
-        <p:spPr>
-          <a:xfrm>
-            <a:off x="4846320" y="5029200"/>
-            <a:ext cx="2057400" cy="457200"/>
-          </a:xfrm>
-          <a:prstGeom prst="rect">
-            <a:avLst/>
-          </a:prstGeom>
-          <a:noFill/>
-          <a:ln/>
-        </p:spPr>
-        <p:txBody>
-          <a:bodyPr wrap="square" lIns="0" tIns="0" rIns="0" bIns="0" rtlCol="0" anchor="ctr"/>
-          <a:lstStyle/>
-          <a:p>
-            <a:pPr algn="ctr" indent="0" marL="0">
-              <a:buNone/>
-            </a:pPr>
-            <a:r>
-              <a:rPr lang="en-US" sz="1600" b="1" dirty="0">
-                <a:solidFill>
-                  <a:srgbClr val="38761D"/>
-                </a:solidFill>
-              </a:rPr>
-              <a:t>a missing fact</a:t>
-            </a:r>
-            <a:endParaRPr lang="en-US" sz="1600" dirty="0"/>
-          </a:p>
-        </p:txBody>
-      </p:sp>
-      <p:sp>
-        <p:nvSpPr>
-          <p:cNvPr id="34" name="option a free check"/>
-          <p:cNvSpPr/>
-          <p:nvPr/>
-        </p:nvSpPr>
-        <p:spPr>
-          <a:xfrm>
-            <a:off x="7086600" y="5029200"/>
-            <a:ext cx="2057400" cy="457200"/>
-          </a:xfrm>
-          <a:prstGeom prst="roundRect">
-            <a:avLst>
-              <a:gd name="adj" fmla="val 40000"/>
-            </a:avLst>
-          </a:prstGeom>
-          <a:solidFill>
-            <a:srgbClr val="E2F0D9"/>
-          </a:solidFill>
-          <a:ln w="12700">
-            <a:solidFill>
-              <a:srgbClr val="38761D"/>
-            </a:solidFill>
-            <a:prstDash val="solid"/>
-          </a:ln>
-        </p:spPr>
-      </p:sp>
-      <p:sp>
-        <p:nvSpPr>
-          <p:cNvPr id="35" name="Text 33"/>
-          <p:cNvSpPr txBox="1"/>
-          <p:nvPr/>
-        </p:nvSpPr>
-        <p:spPr>
-          <a:xfrm>
-            <a:off x="7086600" y="5029200"/>
-            <a:ext cx="2057400" cy="457200"/>
-          </a:xfrm>
-          <a:prstGeom prst="rect">
-            <a:avLst/>
-          </a:prstGeom>
-          <a:noFill/>
-          <a:ln/>
-        </p:spPr>
-        <p:txBody>
-          <a:bodyPr wrap="square" lIns="0" tIns="0" rIns="0" bIns="0" rtlCol="0" anchor="ctr"/>
-          <a:lstStyle/>
-          <a:p>
-            <a:pPr algn="ctr" indent="0" marL="0">
-              <a:buNone/>
-            </a:pPr>
-            <a:r>
-              <a:rPr lang="en-US" sz="1600" b="1" dirty="0">
-                <a:solidFill>
-                  <a:srgbClr val="38761D"/>
-                </a:solidFill>
-              </a:rPr>
-              <a:t>a free check</a:t>
-            </a:r>
-            <a:endParaRPr lang="en-US" sz="1600" dirty="0"/>
-          </a:p>
-        </p:txBody>
-      </p:sp>
-      <p:sp>
-        <p:nvSpPr>
-          <p:cNvPr id="36" name="option more thinking"/>
-          <p:cNvSpPr/>
-          <p:nvPr/>
-        </p:nvSpPr>
-        <p:spPr>
-          <a:xfrm>
-            <a:off x="9326880" y="5029200"/>
-            <a:ext cx="2057400" cy="457200"/>
-          </a:xfrm>
-          <a:prstGeom prst="roundRect">
-            <a:avLst>
-              <a:gd name="adj" fmla="val 40000"/>
-            </a:avLst>
-          </a:prstGeom>
-          <a:solidFill>
-            <a:srgbClr val="FADBD8"/>
-          </a:solidFill>
-          <a:ln w="12700">
-            <a:solidFill>
-              <a:srgbClr val="C00000"/>
-            </a:solidFill>
-            <a:prstDash val="solid"/>
-          </a:ln>
-        </p:spPr>
-      </p:sp>
-      <p:sp>
-        <p:nvSpPr>
-          <p:cNvPr id="37" name="Text 35"/>
-          <p:cNvSpPr txBox="1"/>
-          <p:nvPr/>
-        </p:nvSpPr>
-        <p:spPr>
-          <a:xfrm>
-            <a:off x="9326880" y="5029200"/>
-            <a:ext cx="2057400" cy="457200"/>
-          </a:xfrm>
-          <a:prstGeom prst="rect">
-            <a:avLst/>
-          </a:prstGeom>
-          <a:noFill/>
-          <a:ln/>
-        </p:spPr>
-        <p:txBody>
-          <a:bodyPr wrap="square" lIns="0" tIns="0" rIns="0" bIns="0" rtlCol="0" anchor="ctr"/>
-          <a:lstStyle/>
-          <a:p>
-            <a:pPr algn="ctr" indent="0" marL="0">
-              <a:buNone/>
-            </a:pPr>
-            <a:r>
-              <a:rPr lang="en-US" sz="1600" b="1" dirty="0">
-                <a:solidFill>
-                  <a:srgbClr val="C00000"/>
-                </a:solidFill>
-              </a:rPr>
-              <a:t>more thinking</a:t>
-            </a:r>
-            <a:endParaRPr lang="en-US" sz="1600" dirty="0"/>
-          </a:p>
-        </p:txBody>
-      </p:sp>
-      <p:sp>
-        <p:nvSpPr>
-          <p:cNvPr id="38" name="Text 36"/>
-          <p:cNvSpPr txBox="1"/>
-          <p:nvPr/>
-        </p:nvSpPr>
-        <p:spPr>
-          <a:xfrm>
-            <a:off x="777240" y="5532120"/>
-            <a:ext cx="10607040" cy="384048"/>
-          </a:xfrm>
-          <a:prstGeom prst="rect">
-            <a:avLst/>
-          </a:prstGeom>
-          <a:noFill/>
-          <a:ln/>
-        </p:spPr>
-        <p:txBody>
-          <a:bodyPr wrap="square" lIns="0" tIns="0" rIns="0" bIns="0" rtlCol="0" anchor="ctr"/>
-          <a:lstStyle/>
-          <a:p>
-            <a:pPr indent="0" marL="0">
-              <a:buNone/>
-            </a:pPr>
-            <a:r>
-              <a:rPr lang="en-US" sz="1400" dirty="0">
-                <a:solidFill>
-                  <a:schemeClr val="tx2"/>
-                </a:solidFill>
-              </a:rPr>
-              <a:t>We test each on geometry, routing, scheduling, contest, word problems, math and proofs, counting accuracy and tokens.</a:t>
-            </a:r>
-            <a:endParaRPr lang="en-US" sz="1400" dirty="0"/>
           </a:p>
         </p:txBody>
       </p:sp>

</xml_diff>

<commit_message>
Talk slide 7 as a picture: the usual way → ours, row by row with icons, and a three-step timeline
Co-Authored-By: Claude Opus 5.5 (1M context) <noreply@anthropic.com>
</commit_message>
<xml_diff>
--- a/PROPOSAL_slides.pptx
+++ b/PROPOSAL_slides.pptx
@@ -130,7 +130,7 @@
   <p:extLst>
     <p:ext uri="{521415D9-36F7-43E2-AB2F-B90AF26B5E84}">
       <p14:sectionLst xmlns:p14="http://schemas.microsoft.com/office/powerpoint/2010/main">
-        <p14:section name="Talk" id="{298371d4-f61f-bc80-9cfb-01b32169ac2e}">
+        <p14:section name="Talk" id="{c52e557a-031b-b634-1906-d56a308b9f11}">
           <p14:sldIdLst>
             <p14:sldId id="256"/>
             <p14:sldId id="257"/>
@@ -142,7 +142,7 @@
             <p14:sldId id="263"/>
           </p14:sldIdLst>
         </p14:section>
-        <p14:section name="Extra pages" id="{c0f5dbd1-06e1-085a-fa2a-39b1032e9e5f}">
+        <p14:section name="Extra pages" id="{90bfc3ca-3763-af4f-2037-5b63ae2b8020}">
           <p14:sldIdLst>
             <p14:sldId id="264"/>
             <p14:sldId id="265"/>
@@ -3234,7 +3234,7 @@
           <a:p>
             <a:r>
               <a:rPr lang="en-US" dirty="0"/>
-              <a:t>(30 s) What is new: prior work spends compute by difficulty or trains a model to decide when to think; we decide with a free execution check after giving a fact, with no training. Prior work retrieves manuals or distils a teacher's programs checked against answers; our facts are the model's own checked programs. And without training, an 8B model on one GPU matches a fine-tuned specialist. Next: replicate on held-out data and run the closest baselines, find facts for every problem type, and release the recipe. Takeaway: give the missing fact first, and think only where a free check fails. Thank you.</a:t>
+              <a:t>(30 s) What is new, compared with the usual way. Usually more compute goes to hard-looking problems, or a model is trained to decide when to think; we think only when a free check fails, with no training: 87 versus 74%. Usually models get the manual, or a teacher's programs checked against answers; we give one fact, the model's own checked program, with no answers. And instead of fine-tuning a specialist, an untrained 8B model on one GPU gets the same 69.5%. Next: replicate on held-out data and run the closest baselines, find facts for every problem type, and release the report, code and recipe. Takeaway: give the missing fact first, and think only where a free check fails. Thank you.</a:t>
             </a:r>
             <a:endParaRPr lang="en-US" dirty="0"/>
           </a:p>
@@ -31972,7 +31972,7 @@
                   <a:schemeClr val="tx1"/>
                 </a:solidFill>
               </a:rPr>
-              <a:t>What is new, and our plan</a:t>
+              <a:t>What is new, and what is next</a:t>
             </a:r>
             <a:endParaRPr lang="en-US" sz="3600" dirty="0"/>
           </a:p>
@@ -31980,18 +31980,90 @@
       </p:sp>
       <p:sp>
         <p:nvSpPr>
-          <p:cNvPr id="3" name="new"/>
+          <p:cNvPr id="3" name="Text 1"/>
+          <p:cNvSpPr txBox="1"/>
+          <p:nvPr/>
+        </p:nvSpPr>
+        <p:spPr>
+          <a:xfrm>
+            <a:off x="548640" y="1188720"/>
+            <a:ext cx="4846320" cy="365760"/>
+          </a:xfrm>
+          <a:prstGeom prst="rect">
+            <a:avLst/>
+          </a:prstGeom>
+          <a:noFill/>
+          <a:ln/>
+        </p:spPr>
+        <p:txBody>
+          <a:bodyPr wrap="square" lIns="0" tIns="0" rIns="0" bIns="0" rtlCol="0" anchor="ctr"/>
+          <a:lstStyle/>
+          <a:p>
+            <a:pPr algn="ctr" indent="0" marL="0">
+              <a:buNone/>
+            </a:pPr>
+            <a:r>
+              <a:rPr lang="en-US" sz="1600" b="1" dirty="0">
+                <a:solidFill>
+                  <a:srgbClr val="7F7F7F"/>
+                </a:solidFill>
+              </a:rPr>
+              <a:t>The usual way</a:t>
+            </a:r>
+            <a:endParaRPr lang="en-US" sz="1600" dirty="0"/>
+          </a:p>
+        </p:txBody>
+      </p:sp>
+      <p:sp>
+        <p:nvSpPr>
+          <p:cNvPr id="4" name="Text 2"/>
+          <p:cNvSpPr txBox="1"/>
+          <p:nvPr/>
+        </p:nvSpPr>
+        <p:spPr>
+          <a:xfrm>
+            <a:off x="6766560" y="1188720"/>
+            <a:ext cx="4846320" cy="365760"/>
+          </a:xfrm>
+          <a:prstGeom prst="rect">
+            <a:avLst/>
+          </a:prstGeom>
+          <a:noFill/>
+          <a:ln/>
+        </p:spPr>
+        <p:txBody>
+          <a:bodyPr wrap="square" lIns="0" tIns="0" rIns="0" bIns="0" rtlCol="0" anchor="ctr"/>
+          <a:lstStyle/>
+          <a:p>
+            <a:pPr algn="ctr" indent="0" marL="0">
+              <a:buNone/>
+            </a:pPr>
+            <a:r>
+              <a:rPr lang="en-US" sz="1600" b="1" dirty="0">
+                <a:solidFill>
+                  <a:srgbClr val="4472C4"/>
+                </a:solidFill>
+              </a:rPr>
+              <a:t>Ours</a:t>
+            </a:r>
+            <a:endParaRPr lang="en-US" sz="1600" dirty="0"/>
+          </a:p>
+        </p:txBody>
+      </p:sp>
+      <p:sp>
+        <p:nvSpPr>
+          <p:cNvPr id="5" name="box "/>
           <p:cNvSpPr/>
           <p:nvPr/>
         </p:nvSpPr>
         <p:spPr>
           <a:xfrm>
-            <a:off x="548640" y="1234440"/>
-            <a:ext cx="5440680" cy="3246120"/>
+            <a:off x="548640" y="1600200"/>
+            <a:ext cx="4846320" cy="685800"/>
           </a:xfrm>
           <a:prstGeom prst="roundRect">
             <a:avLst>
-              <a:gd name="adj" fmla="val 2254"/>
+              <a:gd name="adj" fmla="val 8000"/>
             </a:avLst>
           </a:prstGeom>
           <a:solidFill>
@@ -31999,7 +32071,7 @@
           </a:solidFill>
           <a:ln w="9525">
             <a:solidFill>
-              <a:srgbClr val="D9D9D9"/>
+              <a:srgbClr val="BFBFBF"/>
             </a:solidFill>
             <a:prstDash val="solid"/>
           </a:ln>
@@ -32007,14 +32079,14 @@
       </p:sp>
       <p:sp>
         <p:nvSpPr>
-          <p:cNvPr id="4" name="Text 2"/>
-          <p:cNvSpPr txBox="1"/>
-          <p:nvPr/>
-        </p:nvSpPr>
-        <p:spPr>
-          <a:xfrm>
-            <a:off x="777240" y="1325880"/>
-            <a:ext cx="4983480" cy="457200"/>
+          <p:cNvPr id="6" name="Text 4"/>
+          <p:cNvSpPr txBox="1"/>
+          <p:nvPr/>
+        </p:nvSpPr>
+        <p:spPr>
+          <a:xfrm>
+            <a:off x="621792" y="1600200"/>
+            <a:ext cx="4700016" cy="685800"/>
           </a:xfrm>
           <a:prstGeom prst="rect">
             <a:avLst/>
@@ -32026,172 +32098,85 @@
           <a:bodyPr wrap="square" lIns="0" tIns="0" rIns="0" bIns="0" rtlCol="0" anchor="ctr"/>
           <a:lstStyle/>
           <a:p>
+            <a:pPr algn="ctr" indent="0" marL="0">
+              <a:buNone/>
+            </a:pPr>
+            <a:endParaRPr lang="en-US" sz="1500" dirty="0"/>
+          </a:p>
+        </p:txBody>
+      </p:sp>
+      <p:pic>
+        <p:nvPicPr>
+          <p:cNvPr id="7" name="usual icon 0" descr="/NAS/SJ/POSTECH/nlp/figs/icons/brain.png">    </p:cNvPr>
+          <p:cNvPicPr>
+            <a:picLocks noChangeAspect="1"/>
+          </p:cNvPicPr>
+          <p:nvPr/>
+        </p:nvPicPr>
+        <p:blipFill>
+          <a:blip r:embed="rId1"/>
+          <a:stretch>
+            <a:fillRect/>
+          </a:stretch>
+        </p:blipFill>
+        <p:spPr>
+          <a:xfrm>
+            <a:off x="685800" y="1737360"/>
+            <a:ext cx="411480" cy="411480"/>
+          </a:xfrm>
+          <a:prstGeom prst="rect">
+            <a:avLst/>
+          </a:prstGeom>
+        </p:spPr>
+      </p:pic>
+      <p:sp>
+        <p:nvSpPr>
+          <p:cNvPr id="8" name="Text 5"/>
+          <p:cNvSpPr txBox="1"/>
+          <p:nvPr/>
+        </p:nvSpPr>
+        <p:spPr>
+          <a:xfrm>
+            <a:off x="1234440" y="1600200"/>
+            <a:ext cx="4069080" cy="685800"/>
+          </a:xfrm>
+          <a:prstGeom prst="rect">
+            <a:avLst/>
+          </a:prstGeom>
+          <a:noFill/>
+          <a:ln/>
+        </p:spPr>
+        <p:txBody>
+          <a:bodyPr wrap="square" lIns="0" tIns="0" rIns="0" bIns="0" rtlCol="0" anchor="ctr"/>
+          <a:lstStyle/>
+          <a:p>
             <a:pPr indent="0" marL="0">
               <a:buNone/>
             </a:pPr>
             <a:r>
-              <a:rPr lang="en-US" sz="1800" b="1" dirty="0">
-                <a:solidFill>
-                  <a:srgbClr val="4472C4"/>
-                </a:solidFill>
-              </a:rPr>
-              <a:t>New compared with prior work</a:t>
-            </a:r>
-            <a:endParaRPr lang="en-US" sz="1800" dirty="0"/>
-          </a:p>
-        </p:txBody>
-      </p:sp>
-      <p:sp>
-        <p:nvSpPr>
-          <p:cNvPr id="5" name="Text 3"/>
-          <p:cNvSpPr txBox="1"/>
-          <p:nvPr/>
-        </p:nvSpPr>
-        <p:spPr>
-          <a:xfrm>
-            <a:off x="777240" y="1828800"/>
-            <a:ext cx="5029200" cy="2606040"/>
-          </a:xfrm>
-          <a:prstGeom prst="rect">
-            <a:avLst/>
-          </a:prstGeom>
-          <a:noFill/>
-          <a:ln/>
-        </p:spPr>
-        <p:txBody>
-          <a:bodyPr wrap="square" lIns="635" tIns="635" rIns="635" bIns="635" rtlCol="0" anchor="t"/>
-          <a:lstStyle/>
-          <a:p>
-            <a:pPr marL="342900" indent="-342900">
-              <a:spcAft>
-                <a:spcPts val="800"/>
-              </a:spcAft>
-              <a:buSzPct val="100000"/>
-              <a:buChar char="•"/>
-            </a:pPr>
-            <a:r>
               <a:rPr lang="en-US" sz="1500" dirty="0">
                 <a:solidFill>
-                  <a:schemeClr val="tx1"/>
-                </a:solidFill>
-              </a:rPr>
-              <a:t>Prior work spends compute by difficulty or trains a switch; we decide with a free check after a fact, no training (87% vs 74%)</a:t>
+                  <a:srgbClr val="404040"/>
+                </a:solidFill>
+              </a:rPr>
+              <a:t>think more on hard-looking problems, or train when to think</a:t>
             </a:r>
             <a:endParaRPr lang="en-US" sz="1500" dirty="0"/>
           </a:p>
-          <a:p>
-            <a:pPr marL="342900" indent="-342900">
-              <a:spcAft>
-                <a:spcPts val="800"/>
-              </a:spcAft>
-              <a:buSzPct val="100000"/>
-              <a:buChar char="•"/>
-            </a:pPr>
-            <a:r>
-              <a:rPr lang="en-US" sz="1500" dirty="0">
-                <a:solidFill>
-                  <a:schemeClr val="tx1"/>
-                </a:solidFill>
-              </a:rPr>
-              <a:t>Prior work retrieves manuals or distils teacher programs checked against answers; our facts are the model's own checked programs</a:t>
-            </a:r>
-            <a:endParaRPr lang="en-US" sz="1500" dirty="0"/>
-          </a:p>
-          <a:p>
-            <a:pPr marL="342900" indent="-342900">
-              <a:spcAft>
-                <a:spcPts val="800"/>
-              </a:spcAft>
-              <a:buSzPct val="100000"/>
-              <a:buChar char="•"/>
-            </a:pPr>
-            <a:r>
-              <a:rPr lang="en-US" sz="1500" dirty="0">
-                <a:solidFill>
-                  <a:schemeClr val="tx1"/>
-                </a:solidFill>
-              </a:rPr>
-              <a:t>No training: Qwen3-8B on one GPU matches the fine-tuned ORLM-8B (69.5% vs 69.5%)</a:t>
-            </a:r>
-            <a:endParaRPr lang="en-US" sz="1500" dirty="0"/>
-          </a:p>
-        </p:txBody>
-      </p:sp>
-      <p:sp>
-        <p:nvSpPr>
-          <p:cNvPr id="6" name="plan"/>
+        </p:txBody>
+      </p:sp>
+      <p:sp>
+        <p:nvSpPr>
+          <p:cNvPr id="9" name="arrow 0"/>
           <p:cNvSpPr/>
           <p:nvPr/>
         </p:nvSpPr>
         <p:spPr>
           <a:xfrm>
-            <a:off x="6172200" y="1234440"/>
-            <a:ext cx="5440680" cy="3246120"/>
-          </a:xfrm>
-          <a:prstGeom prst="roundRect">
-            <a:avLst>
-              <a:gd name="adj" fmla="val 2254"/>
-            </a:avLst>
-          </a:prstGeom>
-          <a:solidFill>
-            <a:srgbClr val="F2F2F2"/>
-          </a:solidFill>
-          <a:ln w="9525">
-            <a:solidFill>
-              <a:srgbClr val="D9D9D9"/>
-            </a:solidFill>
-            <a:prstDash val="solid"/>
-          </a:ln>
-        </p:spPr>
-      </p:sp>
-      <p:sp>
-        <p:nvSpPr>
-          <p:cNvPr id="7" name="Text 5"/>
-          <p:cNvSpPr txBox="1"/>
-          <p:nvPr/>
-        </p:nvSpPr>
-        <p:spPr>
-          <a:xfrm>
-            <a:off x="6400800" y="1325880"/>
-            <a:ext cx="4983480" cy="457200"/>
-          </a:xfrm>
-          <a:prstGeom prst="rect">
-            <a:avLst/>
-          </a:prstGeom>
-          <a:noFill/>
-          <a:ln/>
-        </p:spPr>
-        <p:txBody>
-          <a:bodyPr wrap="square" lIns="0" tIns="0" rIns="0" bIns="0" rtlCol="0" anchor="ctr"/>
-          <a:lstStyle/>
-          <a:p>
-            <a:pPr indent="0" marL="0">
-              <a:buNone/>
-            </a:pPr>
-            <a:r>
-              <a:rPr lang="en-US" sz="1800" b="1" dirty="0">
-                <a:solidFill>
-                  <a:srgbClr val="4472C4"/>
-                </a:solidFill>
-              </a:rPr>
-              <a:t>Plan until the final report</a:t>
-            </a:r>
-            <a:endParaRPr lang="en-US" sz="1800" dirty="0"/>
-          </a:p>
-        </p:txBody>
-      </p:sp>
-      <p:sp>
-        <p:nvSpPr>
-          <p:cNvPr id="8" name="plan 1"/>
-          <p:cNvSpPr/>
-          <p:nvPr/>
-        </p:nvSpPr>
-        <p:spPr>
-          <a:xfrm>
-            <a:off x="6400800" y="1920240"/>
-            <a:ext cx="457200" cy="457200"/>
-          </a:xfrm>
-          <a:prstGeom prst="ellipse">
+            <a:off x="5577840" y="1755648"/>
+            <a:ext cx="1005840" cy="384048"/>
+          </a:xfrm>
+          <a:prstGeom prst="rightArrow">
             <a:avLst/>
           </a:prstGeom>
           <a:solidFill>
@@ -32207,14 +32192,41 @@
       </p:sp>
       <p:sp>
         <p:nvSpPr>
-          <p:cNvPr id="9" name="Text 7"/>
-          <p:cNvSpPr txBox="1"/>
-          <p:nvPr/>
-        </p:nvSpPr>
-        <p:spPr>
-          <a:xfrm>
-            <a:off x="6400800" y="1920240"/>
-            <a:ext cx="457200" cy="457200"/>
+          <p:cNvPr id="10" name="box "/>
+          <p:cNvSpPr/>
+          <p:nvPr/>
+        </p:nvSpPr>
+        <p:spPr>
+          <a:xfrm>
+            <a:off x="6766560" y="1600200"/>
+            <a:ext cx="4846320" cy="685800"/>
+          </a:xfrm>
+          <a:prstGeom prst="roundRect">
+            <a:avLst>
+              <a:gd name="adj" fmla="val 8000"/>
+            </a:avLst>
+          </a:prstGeom>
+          <a:solidFill>
+            <a:srgbClr val="DEEBF7"/>
+          </a:solidFill>
+          <a:ln w="9525">
+            <a:solidFill>
+              <a:srgbClr val="BFBFBF"/>
+            </a:solidFill>
+            <a:prstDash val="solid"/>
+          </a:ln>
+        </p:spPr>
+      </p:sp>
+      <p:sp>
+        <p:nvSpPr>
+          <p:cNvPr id="11" name="Text 8"/>
+          <p:cNvSpPr txBox="1"/>
+          <p:nvPr/>
+        </p:nvSpPr>
+        <p:spPr>
+          <a:xfrm>
+            <a:off x="6839712" y="1600200"/>
+            <a:ext cx="4700016" cy="685800"/>
           </a:xfrm>
           <a:prstGeom prst="rect">
             <a:avLst/>
@@ -32229,49 +32241,180 @@
             <a:pPr algn="ctr" indent="0" marL="0">
               <a:buNone/>
             </a:pPr>
-            <a:r>
-              <a:rPr lang="en-US" sz="1700" b="1" dirty="0">
-                <a:solidFill>
-                  <a:srgbClr val="FFFFFF"/>
-                </a:solidFill>
-              </a:rPr>
-              <a:t>1</a:t>
-            </a:r>
-            <a:endParaRPr lang="en-US" sz="1700" dirty="0"/>
-          </a:p>
-        </p:txBody>
-      </p:sp>
-      <p:sp>
-        <p:nvSpPr>
-          <p:cNvPr id="10" name="Text 8"/>
-          <p:cNvSpPr txBox="1"/>
-          <p:nvPr/>
-        </p:nvSpPr>
-        <p:spPr>
-          <a:xfrm>
-            <a:off x="6995160" y="1874520"/>
-            <a:ext cx="4480560" cy="731520"/>
-          </a:xfrm>
-          <a:prstGeom prst="rect">
-            <a:avLst/>
-          </a:prstGeom>
-          <a:noFill/>
-          <a:ln/>
-        </p:spPr>
-        <p:txBody>
-          <a:bodyPr wrap="square" lIns="0" tIns="0" rIns="0" bIns="0" rtlCol="0" anchor="t"/>
+            <a:endParaRPr lang="en-US" sz="1500" dirty="0"/>
+          </a:p>
+        </p:txBody>
+      </p:sp>
+      <p:pic>
+        <p:nvPicPr>
+          <p:cNvPr id="12" name="ours icon 0" descr="/NAS/SJ/POSTECH/nlp/figs/icons/check.png">    </p:cNvPr>
+          <p:cNvPicPr>
+            <a:picLocks noChangeAspect="1"/>
+          </p:cNvPicPr>
+          <p:nvPr/>
+        </p:nvPicPr>
+        <p:blipFill>
+          <a:blip r:embed="rId2"/>
+          <a:stretch>
+            <a:fillRect/>
+          </a:stretch>
+        </p:blipFill>
+        <p:spPr>
+          <a:xfrm>
+            <a:off x="6903720" y="1737360"/>
+            <a:ext cx="411480" cy="411480"/>
+          </a:xfrm>
+          <a:prstGeom prst="rect">
+            <a:avLst/>
+          </a:prstGeom>
+        </p:spPr>
+      </p:pic>
+      <p:sp>
+        <p:nvSpPr>
+          <p:cNvPr id="13" name="Text 9"/>
+          <p:cNvSpPr txBox="1"/>
+          <p:nvPr/>
+        </p:nvSpPr>
+        <p:spPr>
+          <a:xfrm>
+            <a:off x="7452360" y="1600200"/>
+            <a:ext cx="4069080" cy="685800"/>
+          </a:xfrm>
+          <a:prstGeom prst="rect">
+            <a:avLst/>
+          </a:prstGeom>
+          <a:noFill/>
+          <a:ln/>
+        </p:spPr>
+        <p:txBody>
+          <a:bodyPr wrap="square" lIns="0" tIns="0" rIns="0" bIns="0" rtlCol="0" anchor="ctr"/>
           <a:lstStyle/>
           <a:p>
             <a:pPr indent="0" marL="0">
               <a:buNone/>
             </a:pPr>
             <a:r>
+              <a:rPr lang="en-US" sz="1500" b="1" dirty="0">
+                <a:solidFill>
+                  <a:srgbClr val="1F3864"/>
+                </a:solidFill>
+              </a:rPr>
+              <a:t>think only when a free check fails; no training (87% vs 74%)</a:t>
+            </a:r>
+            <a:endParaRPr lang="en-US" sz="1500" dirty="0"/>
+          </a:p>
+        </p:txBody>
+      </p:sp>
+      <p:sp>
+        <p:nvSpPr>
+          <p:cNvPr id="14" name="box "/>
+          <p:cNvSpPr/>
+          <p:nvPr/>
+        </p:nvSpPr>
+        <p:spPr>
+          <a:xfrm>
+            <a:off x="548640" y="2423160"/>
+            <a:ext cx="4846320" cy="685800"/>
+          </a:xfrm>
+          <a:prstGeom prst="roundRect">
+            <a:avLst>
+              <a:gd name="adj" fmla="val 8000"/>
+            </a:avLst>
+          </a:prstGeom>
+          <a:solidFill>
+            <a:srgbClr val="F2F2F2"/>
+          </a:solidFill>
+          <a:ln w="9525">
+            <a:solidFill>
+              <a:srgbClr val="BFBFBF"/>
+            </a:solidFill>
+            <a:prstDash val="solid"/>
+          </a:ln>
+        </p:spPr>
+      </p:sp>
+      <p:sp>
+        <p:nvSpPr>
+          <p:cNvPr id="15" name="Text 11"/>
+          <p:cNvSpPr txBox="1"/>
+          <p:nvPr/>
+        </p:nvSpPr>
+        <p:spPr>
+          <a:xfrm>
+            <a:off x="621792" y="2423160"/>
+            <a:ext cx="4700016" cy="685800"/>
+          </a:xfrm>
+          <a:prstGeom prst="rect">
+            <a:avLst/>
+          </a:prstGeom>
+          <a:noFill/>
+          <a:ln/>
+        </p:spPr>
+        <p:txBody>
+          <a:bodyPr wrap="square" lIns="0" tIns="0" rIns="0" bIns="0" rtlCol="0" anchor="ctr"/>
+          <a:lstStyle/>
+          <a:p>
+            <a:pPr algn="ctr" indent="0" marL="0">
+              <a:buNone/>
+            </a:pPr>
+            <a:endParaRPr lang="en-US" sz="1500" dirty="0"/>
+          </a:p>
+        </p:txBody>
+      </p:sp>
+      <p:pic>
+        <p:nvPicPr>
+          <p:cNvPr id="16" name="usual icon 1" descr="/NAS/SJ/POSTECH/nlp/figs/icons/page.png">    </p:cNvPr>
+          <p:cNvPicPr>
+            <a:picLocks noChangeAspect="1"/>
+          </p:cNvPicPr>
+          <p:nvPr/>
+        </p:nvPicPr>
+        <p:blipFill>
+          <a:blip r:embed="rId3"/>
+          <a:stretch>
+            <a:fillRect/>
+          </a:stretch>
+        </p:blipFill>
+        <p:spPr>
+          <a:xfrm>
+            <a:off x="685800" y="2560320"/>
+            <a:ext cx="411480" cy="411480"/>
+          </a:xfrm>
+          <a:prstGeom prst="rect">
+            <a:avLst/>
+          </a:prstGeom>
+        </p:spPr>
+      </p:pic>
+      <p:sp>
+        <p:nvSpPr>
+          <p:cNvPr id="17" name="Text 12"/>
+          <p:cNvSpPr txBox="1"/>
+          <p:nvPr/>
+        </p:nvSpPr>
+        <p:spPr>
+          <a:xfrm>
+            <a:off x="1234440" y="2423160"/>
+            <a:ext cx="4069080" cy="685800"/>
+          </a:xfrm>
+          <a:prstGeom prst="rect">
+            <a:avLst/>
+          </a:prstGeom>
+          <a:noFill/>
+          <a:ln/>
+        </p:spPr>
+        <p:txBody>
+          <a:bodyPr wrap="square" lIns="0" tIns="0" rIns="0" bIns="0" rtlCol="0" anchor="ctr"/>
+          <a:lstStyle/>
+          <a:p>
+            <a:pPr indent="0" marL="0">
+              <a:buNone/>
+            </a:pPr>
+            <a:r>
               <a:rPr lang="en-US" sz="1500" dirty="0">
                 <a:solidFill>
-                  <a:schemeClr val="tx1"/>
-                </a:solidFill>
-              </a:rPr>
-              <a:t>Replicate on held-out data for 3 more models; run the closest baselines (STORM, AdaptThink)</a:t>
+                  <a:srgbClr val="404040"/>
+                </a:solidFill>
+              </a:rPr>
+              <a:t>give the manual, or a teacher's programs checked against answers</a:t>
             </a:r>
             <a:endParaRPr lang="en-US" sz="1500" dirty="0"/>
           </a:p>
@@ -32279,16 +32422,16 @@
       </p:sp>
       <p:sp>
         <p:nvSpPr>
-          <p:cNvPr id="11" name="plan 2"/>
+          <p:cNvPr id="18" name="arrow 1"/>
           <p:cNvSpPr/>
           <p:nvPr/>
         </p:nvSpPr>
         <p:spPr>
           <a:xfrm>
-            <a:off x="6400800" y="2761488"/>
-            <a:ext cx="457200" cy="457200"/>
-          </a:xfrm>
-          <a:prstGeom prst="ellipse">
+            <a:off x="5577840" y="2578608"/>
+            <a:ext cx="1005840" cy="384048"/>
+          </a:xfrm>
+          <a:prstGeom prst="rightArrow">
             <a:avLst/>
           </a:prstGeom>
           <a:solidFill>
@@ -32304,14 +32447,41 @@
       </p:sp>
       <p:sp>
         <p:nvSpPr>
-          <p:cNvPr id="12" name="Text 10"/>
-          <p:cNvSpPr txBox="1"/>
-          <p:nvPr/>
-        </p:nvSpPr>
-        <p:spPr>
-          <a:xfrm>
-            <a:off x="6400800" y="2761488"/>
-            <a:ext cx="457200" cy="457200"/>
+          <p:cNvPr id="19" name="box "/>
+          <p:cNvSpPr/>
+          <p:nvPr/>
+        </p:nvSpPr>
+        <p:spPr>
+          <a:xfrm>
+            <a:off x="6766560" y="2423160"/>
+            <a:ext cx="4846320" cy="685800"/>
+          </a:xfrm>
+          <a:prstGeom prst="roundRect">
+            <a:avLst>
+              <a:gd name="adj" fmla="val 8000"/>
+            </a:avLst>
+          </a:prstGeom>
+          <a:solidFill>
+            <a:srgbClr val="DEEBF7"/>
+          </a:solidFill>
+          <a:ln w="9525">
+            <a:solidFill>
+              <a:srgbClr val="BFBFBF"/>
+            </a:solidFill>
+            <a:prstDash val="solid"/>
+          </a:ln>
+        </p:spPr>
+      </p:sp>
+      <p:sp>
+        <p:nvSpPr>
+          <p:cNvPr id="20" name="Text 15"/>
+          <p:cNvSpPr txBox="1"/>
+          <p:nvPr/>
+        </p:nvSpPr>
+        <p:spPr>
+          <a:xfrm>
+            <a:off x="6839712" y="2423160"/>
+            <a:ext cx="4700016" cy="685800"/>
           </a:xfrm>
           <a:prstGeom prst="rect">
             <a:avLst/>
@@ -32326,49 +32496,180 @@
             <a:pPr algn="ctr" indent="0" marL="0">
               <a:buNone/>
             </a:pPr>
-            <a:r>
-              <a:rPr lang="en-US" sz="1700" b="1" dirty="0">
-                <a:solidFill>
-                  <a:srgbClr val="FFFFFF"/>
-                </a:solidFill>
-              </a:rPr>
-              <a:t>2</a:t>
-            </a:r>
-            <a:endParaRPr lang="en-US" sz="1700" dirty="0"/>
-          </a:p>
-        </p:txBody>
-      </p:sp>
-      <p:sp>
-        <p:nvSpPr>
-          <p:cNvPr id="13" name="Text 11"/>
-          <p:cNvSpPr txBox="1"/>
-          <p:nvPr/>
-        </p:nvSpPr>
-        <p:spPr>
-          <a:xfrm>
-            <a:off x="6995160" y="2715768"/>
-            <a:ext cx="4480560" cy="731520"/>
-          </a:xfrm>
-          <a:prstGeom prst="rect">
-            <a:avLst/>
-          </a:prstGeom>
-          <a:noFill/>
-          <a:ln/>
-        </p:spPr>
-        <p:txBody>
-          <a:bodyPr wrap="square" lIns="0" tIns="0" rIns="0" bIns="0" rtlCol="0" anchor="t"/>
+            <a:endParaRPr lang="en-US" sz="1500" dirty="0"/>
+          </a:p>
+        </p:txBody>
+      </p:sp>
+      <p:pic>
+        <p:nvPicPr>
+          <p:cNvPr id="21" name="ours icon 1" descr="/NAS/SJ/POSTECH/nlp/figs/icons/fact.png">    </p:cNvPr>
+          <p:cNvPicPr>
+            <a:picLocks noChangeAspect="1"/>
+          </p:cNvPicPr>
+          <p:nvPr/>
+        </p:nvPicPr>
+        <p:blipFill>
+          <a:blip r:embed="rId4"/>
+          <a:stretch>
+            <a:fillRect/>
+          </a:stretch>
+        </p:blipFill>
+        <p:spPr>
+          <a:xfrm>
+            <a:off x="6903720" y="2560320"/>
+            <a:ext cx="411480" cy="411480"/>
+          </a:xfrm>
+          <a:prstGeom prst="rect">
+            <a:avLst/>
+          </a:prstGeom>
+        </p:spPr>
+      </p:pic>
+      <p:sp>
+        <p:nvSpPr>
+          <p:cNvPr id="22" name="Text 16"/>
+          <p:cNvSpPr txBox="1"/>
+          <p:nvPr/>
+        </p:nvSpPr>
+        <p:spPr>
+          <a:xfrm>
+            <a:off x="7452360" y="2423160"/>
+            <a:ext cx="4069080" cy="685800"/>
+          </a:xfrm>
+          <a:prstGeom prst="rect">
+            <a:avLst/>
+          </a:prstGeom>
+          <a:noFill/>
+          <a:ln/>
+        </p:spPr>
+        <p:txBody>
+          <a:bodyPr wrap="square" lIns="0" tIns="0" rIns="0" bIns="0" rtlCol="0" anchor="ctr"/>
           <a:lstStyle/>
           <a:p>
             <a:pPr indent="0" marL="0">
               <a:buNone/>
             </a:pPr>
             <a:r>
+              <a:rPr lang="en-US" sz="1500" b="1" dirty="0">
+                <a:solidFill>
+                  <a:srgbClr val="1F3864"/>
+                </a:solidFill>
+              </a:rPr>
+              <a:t>give one fact: the model's own checked program; no answers</a:t>
+            </a:r>
+            <a:endParaRPr lang="en-US" sz="1500" dirty="0"/>
+          </a:p>
+        </p:txBody>
+      </p:sp>
+      <p:sp>
+        <p:nvSpPr>
+          <p:cNvPr id="23" name="box "/>
+          <p:cNvSpPr/>
+          <p:nvPr/>
+        </p:nvSpPr>
+        <p:spPr>
+          <a:xfrm>
+            <a:off x="548640" y="3246120"/>
+            <a:ext cx="4846320" cy="685800"/>
+          </a:xfrm>
+          <a:prstGeom prst="roundRect">
+            <a:avLst>
+              <a:gd name="adj" fmla="val 8000"/>
+            </a:avLst>
+          </a:prstGeom>
+          <a:solidFill>
+            <a:srgbClr val="F2F2F2"/>
+          </a:solidFill>
+          <a:ln w="9525">
+            <a:solidFill>
+              <a:srgbClr val="BFBFBF"/>
+            </a:solidFill>
+            <a:prstDash val="solid"/>
+          </a:ln>
+        </p:spPr>
+      </p:sp>
+      <p:sp>
+        <p:nvSpPr>
+          <p:cNvPr id="24" name="Text 18"/>
+          <p:cNvSpPr txBox="1"/>
+          <p:nvPr/>
+        </p:nvSpPr>
+        <p:spPr>
+          <a:xfrm>
+            <a:off x="621792" y="3246120"/>
+            <a:ext cx="4700016" cy="685800"/>
+          </a:xfrm>
+          <a:prstGeom prst="rect">
+            <a:avLst/>
+          </a:prstGeom>
+          <a:noFill/>
+          <a:ln/>
+        </p:spPr>
+        <p:txBody>
+          <a:bodyPr wrap="square" lIns="0" tIns="0" rIns="0" bIns="0" rtlCol="0" anchor="ctr"/>
+          <a:lstStyle/>
+          <a:p>
+            <a:pPr algn="ctr" indent="0" marL="0">
+              <a:buNone/>
+            </a:pPr>
+            <a:endParaRPr lang="en-US" sz="1500" dirty="0"/>
+          </a:p>
+        </p:txBody>
+      </p:sp>
+      <p:pic>
+        <p:nvPicPr>
+          <p:cNvPr id="25" name="usual icon 2" descr="/NAS/SJ/POSTECH/nlp/figs/icons/robot.png">    </p:cNvPr>
+          <p:cNvPicPr>
+            <a:picLocks noChangeAspect="1"/>
+          </p:cNvPicPr>
+          <p:nvPr/>
+        </p:nvPicPr>
+        <p:blipFill>
+          <a:blip r:embed="rId5"/>
+          <a:stretch>
+            <a:fillRect/>
+          </a:stretch>
+        </p:blipFill>
+        <p:spPr>
+          <a:xfrm>
+            <a:off x="685800" y="3383280"/>
+            <a:ext cx="411480" cy="411480"/>
+          </a:xfrm>
+          <a:prstGeom prst="rect">
+            <a:avLst/>
+          </a:prstGeom>
+        </p:spPr>
+      </p:pic>
+      <p:sp>
+        <p:nvSpPr>
+          <p:cNvPr id="26" name="Text 19"/>
+          <p:cNvSpPr txBox="1"/>
+          <p:nvPr/>
+        </p:nvSpPr>
+        <p:spPr>
+          <a:xfrm>
+            <a:off x="1234440" y="3246120"/>
+            <a:ext cx="4069080" cy="685800"/>
+          </a:xfrm>
+          <a:prstGeom prst="rect">
+            <a:avLst/>
+          </a:prstGeom>
+          <a:noFill/>
+          <a:ln/>
+        </p:spPr>
+        <p:txBody>
+          <a:bodyPr wrap="square" lIns="0" tIns="0" rIns="0" bIns="0" rtlCol="0" anchor="ctr"/>
+          <a:lstStyle/>
+          <a:p>
+            <a:pPr indent="0" marL="0">
+              <a:buNone/>
+            </a:pPr>
+            <a:r>
               <a:rPr lang="en-US" sz="1500" dirty="0">
                 <a:solidFill>
-                  <a:schemeClr val="tx1"/>
-                </a:solidFill>
-              </a:rPr>
-              <a:t>Find facts automatically for every problem type</a:t>
+                  <a:srgbClr val="404040"/>
+                </a:solidFill>
+              </a:rPr>
+              <a:t>fine-tune a specialist model (ORLM-8B)</a:t>
             </a:r>
             <a:endParaRPr lang="en-US" sz="1500" dirty="0"/>
           </a:p>
@@ -32376,16 +32677,16 @@
       </p:sp>
       <p:sp>
         <p:nvSpPr>
-          <p:cNvPr id="14" name="plan 3"/>
+          <p:cNvPr id="27" name="arrow 2"/>
           <p:cNvSpPr/>
           <p:nvPr/>
         </p:nvSpPr>
         <p:spPr>
           <a:xfrm>
-            <a:off x="6400800" y="3602736"/>
-            <a:ext cx="457200" cy="457200"/>
-          </a:xfrm>
-          <a:prstGeom prst="ellipse">
+            <a:off x="5577840" y="3401568"/>
+            <a:ext cx="1005840" cy="384048"/>
+          </a:xfrm>
+          <a:prstGeom prst="rightArrow">
             <a:avLst/>
           </a:prstGeom>
           <a:solidFill>
@@ -32401,90 +32702,18 @@
       </p:sp>
       <p:sp>
         <p:nvSpPr>
-          <p:cNvPr id="15" name="Text 13"/>
-          <p:cNvSpPr txBox="1"/>
-          <p:nvPr/>
-        </p:nvSpPr>
-        <p:spPr>
-          <a:xfrm>
-            <a:off x="6400800" y="3602736"/>
-            <a:ext cx="457200" cy="457200"/>
-          </a:xfrm>
-          <a:prstGeom prst="rect">
-            <a:avLst/>
-          </a:prstGeom>
-          <a:noFill/>
-          <a:ln/>
-        </p:spPr>
-        <p:txBody>
-          <a:bodyPr wrap="square" lIns="0" tIns="0" rIns="0" bIns="0" rtlCol="0" anchor="ctr"/>
-          <a:lstStyle/>
-          <a:p>
-            <a:pPr algn="ctr" indent="0" marL="0">
-              <a:buNone/>
-            </a:pPr>
-            <a:r>
-              <a:rPr lang="en-US" sz="1700" b="1" dirty="0">
-                <a:solidFill>
-                  <a:srgbClr val="FFFFFF"/>
-                </a:solidFill>
-              </a:rPr>
-              <a:t>3</a:t>
-            </a:r>
-            <a:endParaRPr lang="en-US" sz="1700" dirty="0"/>
-          </a:p>
-        </p:txBody>
-      </p:sp>
-      <p:sp>
-        <p:nvSpPr>
-          <p:cNvPr id="16" name="Text 14"/>
-          <p:cNvSpPr txBox="1"/>
-          <p:nvPr/>
-        </p:nvSpPr>
-        <p:spPr>
-          <a:xfrm>
-            <a:off x="6995160" y="3557016"/>
-            <a:ext cx="4480560" cy="731520"/>
-          </a:xfrm>
-          <a:prstGeom prst="rect">
-            <a:avLst/>
-          </a:prstGeom>
-          <a:noFill/>
-          <a:ln/>
-        </p:spPr>
-        <p:txBody>
-          <a:bodyPr wrap="square" lIns="0" tIns="0" rIns="0" bIns="0" rtlCol="0" anchor="t"/>
-          <a:lstStyle/>
-          <a:p>
-            <a:pPr indent="0" marL="0">
-              <a:buNone/>
-            </a:pPr>
-            <a:r>
-              <a:rPr lang="en-US" sz="1500" dirty="0">
-                <a:solidFill>
-                  <a:schemeClr val="tx1"/>
-                </a:solidFill>
-              </a:rPr>
-              <a:t>Final report, code and the recipe as a reusable tool</a:t>
-            </a:r>
-            <a:endParaRPr lang="en-US" sz="1500" dirty="0"/>
-          </a:p>
-        </p:txBody>
-      </p:sp>
-      <p:sp>
-        <p:nvSpPr>
-          <p:cNvPr id="17" name="takeaway"/>
+          <p:cNvPr id="28" name="box "/>
           <p:cNvSpPr/>
           <p:nvPr/>
         </p:nvSpPr>
         <p:spPr>
           <a:xfrm>
-            <a:off x="548640" y="4709160"/>
-            <a:ext cx="11064240" cy="868680"/>
+            <a:off x="6766560" y="3246120"/>
+            <a:ext cx="4846320" cy="685800"/>
           </a:xfrm>
           <a:prstGeom prst="roundRect">
             <a:avLst>
-              <a:gd name="adj" fmla="val 8421"/>
+              <a:gd name="adj" fmla="val 8000"/>
             </a:avLst>
           </a:prstGeom>
           <a:solidFill>
@@ -32492,7 +32721,7 @@
           </a:solidFill>
           <a:ln w="9525">
             <a:solidFill>
-              <a:srgbClr val="BDD7EE"/>
+              <a:srgbClr val="BFBFBF"/>
             </a:solidFill>
             <a:prstDash val="solid"/>
           </a:ln>
@@ -32500,14 +32729,14 @@
       </p:sp>
       <p:sp>
         <p:nvSpPr>
-          <p:cNvPr id="18" name="Text 16"/>
-          <p:cNvSpPr txBox="1"/>
-          <p:nvPr/>
-        </p:nvSpPr>
-        <p:spPr>
-          <a:xfrm>
-            <a:off x="777240" y="4709160"/>
-            <a:ext cx="10607040" cy="868680"/>
+          <p:cNvPr id="29" name="Text 22"/>
+          <p:cNvSpPr txBox="1"/>
+          <p:nvPr/>
+        </p:nvSpPr>
+        <p:spPr>
+          <a:xfrm>
+            <a:off x="6839712" y="3246120"/>
+            <a:ext cx="4700016" cy="685800"/>
           </a:xfrm>
           <a:prstGeom prst="rect">
             <a:avLst/>
@@ -32519,29 +32748,420 @@
           <a:bodyPr wrap="square" lIns="0" tIns="0" rIns="0" bIns="0" rtlCol="0" anchor="ctr"/>
           <a:lstStyle/>
           <a:p>
+            <a:pPr algn="ctr" indent="0" marL="0">
+              <a:buNone/>
+            </a:pPr>
+            <a:endParaRPr lang="en-US" sz="1500" dirty="0"/>
+          </a:p>
+        </p:txBody>
+      </p:sp>
+      <p:pic>
+        <p:nvPicPr>
+          <p:cNvPr id="30" name="ours icon 2" descr="/NAS/SJ/POSTECH/nlp/figs/icons/gpu.png">    </p:cNvPr>
+          <p:cNvPicPr>
+            <a:picLocks noChangeAspect="1"/>
+          </p:cNvPicPr>
+          <p:nvPr/>
+        </p:nvPicPr>
+        <p:blipFill>
+          <a:blip r:embed="rId6"/>
+          <a:stretch>
+            <a:fillRect/>
+          </a:stretch>
+        </p:blipFill>
+        <p:spPr>
+          <a:xfrm>
+            <a:off x="6903720" y="3383280"/>
+            <a:ext cx="411480" cy="411480"/>
+          </a:xfrm>
+          <a:prstGeom prst="rect">
+            <a:avLst/>
+          </a:prstGeom>
+        </p:spPr>
+      </p:pic>
+      <p:sp>
+        <p:nvSpPr>
+          <p:cNvPr id="31" name="Text 23"/>
+          <p:cNvSpPr txBox="1"/>
+          <p:nvPr/>
+        </p:nvSpPr>
+        <p:spPr>
+          <a:xfrm>
+            <a:off x="7452360" y="3246120"/>
+            <a:ext cx="4069080" cy="685800"/>
+          </a:xfrm>
+          <a:prstGeom prst="rect">
+            <a:avLst/>
+          </a:prstGeom>
+          <a:noFill/>
+          <a:ln/>
+        </p:spPr>
+        <p:txBody>
+          <a:bodyPr wrap="square" lIns="0" tIns="0" rIns="0" bIns="0" rtlCol="0" anchor="ctr"/>
+          <a:lstStyle/>
+          <a:p>
             <a:pPr indent="0" marL="0">
               <a:buNone/>
             </a:pPr>
             <a:r>
-              <a:rPr lang="en-US" sz="1800" b="1" dirty="0">
-                <a:solidFill>
-                  <a:srgbClr val="4472C4"/>
-                </a:solidFill>
-              </a:rPr>
-              <a:t>Takeaway: </a:t>
-            </a:r>
+              <a:rPr lang="en-US" sz="1500" b="1" dirty="0">
+                <a:solidFill>
+                  <a:srgbClr val="1F3864"/>
+                </a:solidFill>
+              </a:rPr>
+              <a:t>no training, one 24 GB GPU: the same 69.5%</a:t>
+            </a:r>
+            <a:endParaRPr lang="en-US" sz="1500" dirty="0"/>
+          </a:p>
+        </p:txBody>
+      </p:sp>
+      <p:sp>
+        <p:nvSpPr>
+          <p:cNvPr id="32" name="Text 24"/>
+          <p:cNvSpPr txBox="1"/>
+          <p:nvPr/>
+        </p:nvSpPr>
+        <p:spPr>
+          <a:xfrm>
+            <a:off x="548640" y="4114800"/>
+            <a:ext cx="11064240" cy="365760"/>
+          </a:xfrm>
+          <a:prstGeom prst="rect">
+            <a:avLst/>
+          </a:prstGeom>
+          <a:noFill/>
+          <a:ln/>
+        </p:spPr>
+        <p:txBody>
+          <a:bodyPr wrap="square" lIns="0" tIns="0" rIns="0" bIns="0" rtlCol="0" anchor="ctr"/>
+          <a:lstStyle/>
+          <a:p>
             <a:pPr indent="0" marL="0">
               <a:buNone/>
             </a:pPr>
             <a:r>
-              <a:rPr lang="en-US" sz="1800" dirty="0">
+              <a:rPr lang="en-US" sz="1600" b="1" dirty="0">
                 <a:solidFill>
                   <a:schemeClr val="tx1"/>
                 </a:solidFill>
               </a:rPr>
-              <a:t>give the missing fact first, and think only where a free check fails: more accurate, fewer tokens, one 24 GB GPU.</a:t>
-            </a:r>
-            <a:endParaRPr lang="en-US" sz="1800" dirty="0"/>
+              <a:t>Next, until the final report</a:t>
+            </a:r>
+            <a:endParaRPr lang="en-US" sz="1600" dirty="0"/>
+          </a:p>
+        </p:txBody>
+      </p:sp>
+      <p:sp>
+        <p:nvSpPr>
+          <p:cNvPr id="33" name="Shape 25"/>
+          <p:cNvSpPr/>
+          <p:nvPr/>
+        </p:nvSpPr>
+        <p:spPr>
+          <a:xfrm>
+            <a:off x="2194560" y="4800600"/>
+            <a:ext cx="7772400" cy="0"/>
+          </a:xfrm>
+          <a:prstGeom prst="line">
+            <a:avLst/>
+          </a:prstGeom>
+          <a:noFill/>
+          <a:ln w="38100">
+            <a:solidFill>
+              <a:srgbClr val="BFBFBF"/>
+            </a:solidFill>
+            <a:prstDash val="solid"/>
+          </a:ln>
+        </p:spPr>
+      </p:sp>
+      <p:sp>
+        <p:nvSpPr>
+          <p:cNvPr id="34" name="milestone 0"/>
+          <p:cNvSpPr/>
+          <p:nvPr/>
+        </p:nvSpPr>
+        <p:spPr>
+          <a:xfrm>
+            <a:off x="1920240" y="4526280"/>
+            <a:ext cx="548640" cy="548640"/>
+          </a:xfrm>
+          <a:prstGeom prst="ellipse">
+            <a:avLst/>
+          </a:prstGeom>
+          <a:solidFill>
+            <a:srgbClr val="FFFFFF"/>
+          </a:solidFill>
+          <a:ln w="25400">
+            <a:solidFill>
+              <a:srgbClr val="4472C4"/>
+            </a:solidFill>
+            <a:prstDash val="solid"/>
+          </a:ln>
+        </p:spPr>
+      </p:sp>
+      <p:pic>
+        <p:nvPicPr>
+          <p:cNvPr id="35" name="milestone icon 0" descr="/NAS/SJ/POSTECH/nlp/figs/icons/check.png">    </p:cNvPr>
+          <p:cNvPicPr>
+            <a:picLocks noChangeAspect="1"/>
+          </p:cNvPicPr>
+          <p:nvPr/>
+        </p:nvPicPr>
+        <p:blipFill>
+          <a:blip r:embed="rId7"/>
+          <a:stretch>
+            <a:fillRect/>
+          </a:stretch>
+        </p:blipFill>
+        <p:spPr>
+          <a:xfrm>
+            <a:off x="2020824" y="4626864"/>
+            <a:ext cx="347472" cy="347472"/>
+          </a:xfrm>
+          <a:prstGeom prst="rect">
+            <a:avLst/>
+          </a:prstGeom>
+        </p:spPr>
+      </p:pic>
+      <p:sp>
+        <p:nvSpPr>
+          <p:cNvPr id="36" name="Text 27"/>
+          <p:cNvSpPr txBox="1"/>
+          <p:nvPr/>
+        </p:nvSpPr>
+        <p:spPr>
+          <a:xfrm>
+            <a:off x="548640" y="5102352"/>
+            <a:ext cx="3291840" cy="502920"/>
+          </a:xfrm>
+          <a:prstGeom prst="rect">
+            <a:avLst/>
+          </a:prstGeom>
+          <a:noFill/>
+          <a:ln/>
+        </p:spPr>
+        <p:txBody>
+          <a:bodyPr wrap="square" lIns="0" tIns="0" rIns="0" bIns="0" rtlCol="0" anchor="t"/>
+          <a:lstStyle/>
+          <a:p>
+            <a:pPr algn="ctr" indent="0" marL="0">
+              <a:buNone/>
+            </a:pPr>
+            <a:r>
+              <a:rPr lang="en-US" sz="1500" dirty="0">
+                <a:solidFill>
+                  <a:schemeClr val="tx1"/>
+                </a:solidFill>
+              </a:rPr>
+              <a:t>replicate on held-out data; run the closest baselines</a:t>
+            </a:r>
+            <a:endParaRPr lang="en-US" sz="1500" dirty="0"/>
+          </a:p>
+        </p:txBody>
+      </p:sp>
+      <p:sp>
+        <p:nvSpPr>
+          <p:cNvPr id="37" name="milestone 1"/>
+          <p:cNvSpPr/>
+          <p:nvPr/>
+        </p:nvSpPr>
+        <p:spPr>
+          <a:xfrm>
+            <a:off x="5806440" y="4526280"/>
+            <a:ext cx="548640" cy="548640"/>
+          </a:xfrm>
+          <a:prstGeom prst="ellipse">
+            <a:avLst/>
+          </a:prstGeom>
+          <a:solidFill>
+            <a:srgbClr val="FFFFFF"/>
+          </a:solidFill>
+          <a:ln w="25400">
+            <a:solidFill>
+              <a:srgbClr val="4472C4"/>
+            </a:solidFill>
+            <a:prstDash val="solid"/>
+          </a:ln>
+        </p:spPr>
+      </p:sp>
+      <p:pic>
+        <p:nvPicPr>
+          <p:cNvPr id="38" name="milestone icon 1" descr="/NAS/SJ/POSTECH/nlp/figs/icons/fact.png">    </p:cNvPr>
+          <p:cNvPicPr>
+            <a:picLocks noChangeAspect="1"/>
+          </p:cNvPicPr>
+          <p:nvPr/>
+        </p:nvPicPr>
+        <p:blipFill>
+          <a:blip r:embed="rId8"/>
+          <a:stretch>
+            <a:fillRect/>
+          </a:stretch>
+        </p:blipFill>
+        <p:spPr>
+          <a:xfrm>
+            <a:off x="5907024" y="4626864"/>
+            <a:ext cx="347472" cy="347472"/>
+          </a:xfrm>
+          <a:prstGeom prst="rect">
+            <a:avLst/>
+          </a:prstGeom>
+        </p:spPr>
+      </p:pic>
+      <p:sp>
+        <p:nvSpPr>
+          <p:cNvPr id="39" name="Text 29"/>
+          <p:cNvSpPr txBox="1"/>
+          <p:nvPr/>
+        </p:nvSpPr>
+        <p:spPr>
+          <a:xfrm>
+            <a:off x="4434840" y="5102352"/>
+            <a:ext cx="3291840" cy="502920"/>
+          </a:xfrm>
+          <a:prstGeom prst="rect">
+            <a:avLst/>
+          </a:prstGeom>
+          <a:noFill/>
+          <a:ln/>
+        </p:spPr>
+        <p:txBody>
+          <a:bodyPr wrap="square" lIns="0" tIns="0" rIns="0" bIns="0" rtlCol="0" anchor="t"/>
+          <a:lstStyle/>
+          <a:p>
+            <a:pPr algn="ctr" indent="0" marL="0">
+              <a:buNone/>
+            </a:pPr>
+            <a:r>
+              <a:rPr lang="en-US" sz="1500" dirty="0">
+                <a:solidFill>
+                  <a:schemeClr val="tx1"/>
+                </a:solidFill>
+              </a:rPr>
+              <a:t>find facts for every problem type</a:t>
+            </a:r>
+            <a:endParaRPr lang="en-US" sz="1500" dirty="0"/>
+          </a:p>
+        </p:txBody>
+      </p:sp>
+      <p:sp>
+        <p:nvSpPr>
+          <p:cNvPr id="40" name="milestone 2"/>
+          <p:cNvSpPr/>
+          <p:nvPr/>
+        </p:nvSpPr>
+        <p:spPr>
+          <a:xfrm>
+            <a:off x="9692640" y="4526280"/>
+            <a:ext cx="548640" cy="548640"/>
+          </a:xfrm>
+          <a:prstGeom prst="ellipse">
+            <a:avLst/>
+          </a:prstGeom>
+          <a:solidFill>
+            <a:srgbClr val="FFFFFF"/>
+          </a:solidFill>
+          <a:ln w="25400">
+            <a:solidFill>
+              <a:srgbClr val="4472C4"/>
+            </a:solidFill>
+            <a:prstDash val="solid"/>
+          </a:ln>
+        </p:spPr>
+      </p:sp>
+      <p:pic>
+        <p:nvPicPr>
+          <p:cNvPr id="41" name="milestone icon 2" descr="/NAS/SJ/POSTECH/nlp/figs/icons/code.png">    </p:cNvPr>
+          <p:cNvPicPr>
+            <a:picLocks noChangeAspect="1"/>
+          </p:cNvPicPr>
+          <p:nvPr/>
+        </p:nvPicPr>
+        <p:blipFill>
+          <a:blip r:embed="rId9"/>
+          <a:stretch>
+            <a:fillRect/>
+          </a:stretch>
+        </p:blipFill>
+        <p:spPr>
+          <a:xfrm>
+            <a:off x="9793224" y="4626864"/>
+            <a:ext cx="347472" cy="347472"/>
+          </a:xfrm>
+          <a:prstGeom prst="rect">
+            <a:avLst/>
+          </a:prstGeom>
+        </p:spPr>
+      </p:pic>
+      <p:sp>
+        <p:nvSpPr>
+          <p:cNvPr id="42" name="Text 31"/>
+          <p:cNvSpPr txBox="1"/>
+          <p:nvPr/>
+        </p:nvSpPr>
+        <p:spPr>
+          <a:xfrm>
+            <a:off x="8321040" y="5102352"/>
+            <a:ext cx="3291840" cy="502920"/>
+          </a:xfrm>
+          <a:prstGeom prst="rect">
+            <a:avLst/>
+          </a:prstGeom>
+          <a:noFill/>
+          <a:ln/>
+        </p:spPr>
+        <p:txBody>
+          <a:bodyPr wrap="square" lIns="0" tIns="0" rIns="0" bIns="0" rtlCol="0" anchor="t"/>
+          <a:lstStyle/>
+          <a:p>
+            <a:pPr algn="ctr" indent="0" marL="0">
+              <a:buNone/>
+            </a:pPr>
+            <a:r>
+              <a:rPr lang="en-US" sz="1500" dirty="0">
+                <a:solidFill>
+                  <a:schemeClr val="tx1"/>
+                </a:solidFill>
+              </a:rPr>
+              <a:t>final report, code, and the recipe as a tool</a:t>
+            </a:r>
+            <a:endParaRPr lang="en-US" sz="1500" dirty="0"/>
+          </a:p>
+        </p:txBody>
+      </p:sp>
+      <p:sp>
+        <p:nvSpPr>
+          <p:cNvPr id="43" name="Text 32"/>
+          <p:cNvSpPr txBox="1"/>
+          <p:nvPr/>
+        </p:nvSpPr>
+        <p:spPr>
+          <a:xfrm>
+            <a:off x="548640" y="5669280"/>
+            <a:ext cx="11064240" cy="548640"/>
+          </a:xfrm>
+          <a:prstGeom prst="rect">
+            <a:avLst/>
+          </a:prstGeom>
+          <a:noFill/>
+          <a:ln/>
+        </p:spPr>
+        <p:txBody>
+          <a:bodyPr wrap="square" lIns="0" tIns="0" rIns="0" bIns="0" rtlCol="0" anchor="ctr"/>
+          <a:lstStyle/>
+          <a:p>
+            <a:pPr algn="ctr" indent="0" marL="0">
+              <a:buNone/>
+            </a:pPr>
+            <a:r>
+              <a:rPr lang="en-US" sz="2000" dirty="0">
+                <a:solidFill>
+                  <a:schemeClr val="tx1"/>
+                </a:solidFill>
+              </a:rPr>
+              <a:t>Takeaway: give the missing fact first, and think only where a free check fails</a:t>
+            </a:r>
+            <a:endParaRPr lang="en-US" sz="2000" dirty="0"/>
           </a:p>
         </p:txBody>
       </p:sp>

</xml_diff>

<commit_message>
Difficulty shown with well-known yardsticks instead of LeetCode: Codeforces ranks, AIME, IMO, classic OR baselines
Talk slide 3 tags and caption, the extra-page histogram (Codeforces rank bands), the reported-numbers
page (IMO gold medallist 25.9 / 30, average participant 15.2) and PROPOSAL / PROPOSAL_ko section 1.

Co-Authored-By: Claude Opus 5.5 (1M context) <noreply@anthropic.com>
</commit_message>
<xml_diff>
--- a/PROPOSAL_slides.pptx
+++ b/PROPOSAL_slides.pptx
@@ -130,7 +130,7 @@
   <p:extLst>
     <p:ext uri="{521415D9-36F7-43E2-AB2F-B90AF26B5E84}">
       <p14:sectionLst xmlns:p14="http://schemas.microsoft.com/office/powerpoint/2010/main">
-        <p14:section name="Talk" id="{c52e557a-031b-b634-1906-d56a308b9f11}">
+        <p14:section name="Talk" id="{2dbe0725-eeeb-2e60-fc6a-dfaacf90f1bf}">
           <p14:sldIdLst>
             <p14:sldId id="256"/>
             <p14:sldId id="257"/>
@@ -142,7 +142,7 @@
             <p14:sldId id="263"/>
           </p14:sldIdLst>
         </p14:section>
-        <p14:section name="Extra pages" id="{90bfc3ca-3763-af4f-2037-5b63ae2b8020}">
+        <p14:section name="Extra pages" id="{6915d2c4-6f2c-0777-0b99-47098fe540a1}">
           <p14:sldIdLst>
             <p14:sldId id="264"/>
             <p14:sldId id="265"/>
@@ -1474,7 +1474,7 @@
           <a:p>
             <a:r>
               <a:rPr lang="en-US" dirty="0"/>
-              <a:t>What the problems are: exact geometry from coordinates; real contest problems (CodeContests, Codeforces geometry, official hidden tests); routing and scheduling benchmarks (Solomon, OR-Library) that need a solver library and have no LeetCode equivalent; optimization word problems (NL4OPT, IndustryOR, MAMO); and competition math (MATH-500, AIME) and Lean proofs (miniF2F). LeetCode comparison is a rough community rule of thumb (Easy about Codeforces 800-1200, Medium 1200-1800, Hard 1800-2300). Our contest set: median rating 2200, 142 of 311 at 2400 or more (4 unrated not shown). gpt-oss-120b at high effort solves 89% of the easiest band and 48% of the 2400+ band; the generated geometry tasks resemble LeetCode 812 (Easy, triangle area) and 587 (Hard, convex hull) but must be exactly right on moved, turned and mirrored copies.</a:t>
+              <a:t>How hard, by well-known yardsticks. Contest problems: Codeforces ratings with the human rank at that level (Newbie up to 1199, Pupil 1200-1399, Specialist 1400-1599, Expert 1600-1899, Candidate Master 1900-2099, Master 2100-2299, International Master 2300-2399, Grandmaster 2400+); our median is 2200 (Master) and 142 of 311 are 2400+; 56 problems (18%) are solved by none of our 9 model settings. Routing: the Solomon VRPTW benchmark (1987); a simple greedy plan is valid on all 56 but 47.6% longer than the best known. Word problems: NL4OPT (a NeurIPS 2022 competition) is undergraduate OR-exercise level. Math: AIME invites at least the top 2.5% of AMC 10 and top 5% of AMC 12 takers. Proofs: on IMO-AG-30 an average IMO gold medallist solves 25.9 of 30 and an average participant 15.2 (AlphaGeometry paper). gpt-oss-120b at high effort solves 89% of the easiest contest band and 48% of the 2400+ band.</a:t>
             </a:r>
             <a:endParaRPr lang="en-US" dirty="0"/>
           </a:p>
@@ -2882,7 +2882,7 @@
           <a:p>
             <a:r>
               <a:rPr lang="en-US" dirty="0"/>
-              <a:t>(25 s) We test five kinds of computational math: exact geometry, real Codeforces contest problems, routing and scheduling benchmarks that need a solver library, optimization word problems, and competition math and proofs. Next to coding tests: the geometry tasks are like LeetCode easy to hard, but must be exact on moved copies; our contest problems have a median Codeforces rating of 2200, LeetCode Hard, and almost half are harder than any LeetCode problem; routing has no LeetCode equivalent at all.</a:t>
+              <a:t>(25 s) We test five kinds of computational math, and here is how hard they are by well-known yardsticks. Exact geometry uses textbook algorithms, but must be right on moved and turned copies. Our contest problems are Codeforces problems at the level of Master to Grandmaster players; 18% are solved by none of our nine model setups. Routing is a classic operations-research benchmark where a simple greedy plan is 48% worse than the best known. Word problems are operations-research course exercises. And competition math goes up to AIME, taken by the top few percent of AMC students, and olympiad proofs, where an IMO gold medallist solves about 26 of 30 geometry problems.</a:t>
             </a:r>
             <a:endParaRPr lang="en-US" dirty="0"/>
           </a:p>
@@ -3322,7 +3322,7 @@
           <a:p>
             <a:r>
               <a:rPr lang="en-US" dirty="0"/>
-              <a:t>End of the 5-minute talk; 5 minutes of questions follow. Extra pages (slides 9-24): 9 Setup and fairness; 10 Contest problems on the LeetCode scale; 11 Two versions, in detail; 12 The examples check, in detail; 13 Facts without a human, in detail; 14 One fact helps small models most; 15 Reuse a checked program; 16 All policies, cost vs accuracy; 17 It pays off: small GPU, 30 labels; 18 Compared with published methods; 19 Related research map; 20 Numbers reported in papers; 21 Proofs need a specialized model; 22 Where the recipe stops; 23 All findings at a glance; 24 Words we use. Likely questions: why not GPT or Claude (open models only, cost and reproducibility); is the hand-written fact cheating (the automatic fact matches it); is the difference real (3 seeds, pre-registered); bigger model vs this recipe (small GPU page).</a:t>
+              <a:t>End of the 5-minute talk; 5 minutes of questions follow. Extra pages (slides 9-24): 9 Setup and fairness; 10 How hard: contest ranks, exams; 11 Two versions, in detail; 12 The examples check, in detail; 13 Facts without a human, in detail; 14 One fact helps small models most; 15 Reuse a checked program; 16 All policies, cost vs accuracy; 17 It pays off: small GPU, 30 labels; 18 Compared with published methods; 19 Related research map; 20 Numbers reported in papers; 21 Proofs need a specialized model; 22 Where the recipe stops; 23 All findings at a glance; 24 Words we use. Likely questions: why not GPT or Claude (open models only, cost and reproducibility); is the hand-written fact cheating (the automatic fact matches it); is the difference real (3 seeds, pre-registered); bigger model vs this recipe (small GPU page).</a:t>
             </a:r>
             <a:endParaRPr lang="en-US" dirty="0"/>
           </a:p>
@@ -4366,7 +4366,7 @@
                   <a:schemeClr val="tx1"/>
                 </a:solidFill>
               </a:rPr>
-              <a:t>Extra: our problems, and how hard they are next to LeetCode</a:t>
+              <a:t>Extra: how hard, by contest ranks and exams</a:t>
             </a:r>
             <a:endParaRPr lang="en-US" sz="3600" dirty="0"/>
           </a:p>
@@ -4547,14 +4547,14 @@
               <a:buNone/>
             </a:pPr>
             <a:r>
-              <a:rPr lang="en-US" sz="1200" b="1" dirty="0">
+              <a:rPr lang="en-US" sz="1250" b="1" dirty="0">
                 <a:solidFill>
                   <a:srgbClr val="4472C4"/>
                 </a:solidFill>
               </a:rPr>
-              <a:t>≈ LeetCode Easy–Hard (#812, #587)</a:t>
-            </a:r>
-            <a:endParaRPr lang="en-US" sz="1200" dirty="0"/>
+              <a:t>textbook algorithms, exact on every copy</a:t>
+            </a:r>
+            <a:endParaRPr lang="en-US" sz="1250" dirty="0"/>
           </a:p>
         </p:txBody>
       </p:sp>
@@ -4733,14 +4733,14 @@
               <a:buNone/>
             </a:pPr>
             <a:r>
-              <a:rPr lang="en-US" sz="1200" b="1" dirty="0">
+              <a:rPr lang="en-US" sz="1250" b="1" dirty="0">
                 <a:solidFill>
                   <a:srgbClr val="C00000"/>
                 </a:solidFill>
               </a:rPr>
-              <a:t>mostly LeetCode Hard or harder</a:t>
-            </a:r>
-            <a:endParaRPr lang="en-US" sz="1200" dirty="0"/>
+              <a:t>Codeforces Master to Grandmaster level</a:t>
+            </a:r>
+            <a:endParaRPr lang="en-US" sz="1250" dirty="0"/>
           </a:p>
         </p:txBody>
       </p:sp>
@@ -4919,14 +4919,14 @@
               <a:buNone/>
             </a:pPr>
             <a:r>
-              <a:rPr lang="en-US" sz="1200" b="1" dirty="0">
+              <a:rPr lang="en-US" sz="1250" b="1" dirty="0">
                 <a:solidFill>
                   <a:srgbClr val="ED7D31"/>
                 </a:solidFill>
               </a:rPr>
-              <a:t>no LeetCode match: needs a solver</a:t>
-            </a:r>
-            <a:endParaRPr lang="en-US" sz="1200" dirty="0"/>
+              <a:t>classic OR benchmark: a greedy plan is 48% worse</a:t>
+            </a:r>
+            <a:endParaRPr lang="en-US" sz="1250" dirty="0"/>
           </a:p>
         </p:txBody>
       </p:sp>
@@ -5105,14 +5105,14 @@
               <a:buNone/>
             </a:pPr>
             <a:r>
-              <a:rPr lang="en-US" sz="1200" b="1" dirty="0">
+              <a:rPr lang="en-US" sz="1250" b="1" dirty="0">
                 <a:solidFill>
                   <a:srgbClr val="38761D"/>
                 </a:solidFill>
               </a:rPr>
-              <a:t>school level, but the solver API is hard</a:t>
-            </a:r>
-            <a:endParaRPr lang="en-US" sz="1200" dirty="0"/>
+              <a:t>OR-course exercises (NL4OPT, NeurIPS 2022)</a:t>
+            </a:r>
+            <a:endParaRPr lang="en-US" sz="1250" dirty="0"/>
           </a:p>
         </p:txBody>
       </p:sp>
@@ -5291,14 +5291,14 @@
               <a:buNone/>
             </a:pPr>
             <a:r>
-              <a:rPr lang="en-US" sz="1200" b="1" dirty="0">
+              <a:rPr lang="en-US" sz="1250" b="1" dirty="0">
                 <a:solidFill>
                   <a:srgbClr val="595959"/>
                 </a:solidFill>
               </a:rPr>
-              <a:t>not a coding test</a:t>
-            </a:r>
-            <a:endParaRPr lang="en-US" sz="1200" dirty="0"/>
+              <a:t>AIME: top ~5% of AMC; IMO gold: 25.9/30</a:t>
+            </a:r>
+            <a:endParaRPr lang="en-US" sz="1250" dirty="0"/>
           </a:p>
         </p:txBody>
       </p:sp>
@@ -5332,7 +5332,7 @@
                   <a:schemeClr val="tx1"/>
                 </a:solidFill>
               </a:rPr>
-              <a:t>Our 311 contest problems on the LeetCode scale (Codeforces rating; rough rule of thumb)</a:t>
+              <a:t>Our 311 contest problems by Codeforces rating, with the human rank at that level</a:t>
             </a:r>
             <a:endParaRPr lang="en-US" sz="1500" dirty="0"/>
           </a:p>
@@ -5340,7 +5340,7 @@
       </p:sp>
       <p:sp>
         <p:nvSpPr>
-          <p:cNvPr id="34" name="zone LeetCode Easy"/>
+          <p:cNvPr id="34" name="zone Newbie"/>
           <p:cNvSpPr/>
           <p:nvPr/>
         </p:nvSpPr>
@@ -5393,7 +5393,7 @@
                   <a:schemeClr val="tx1"/>
                 </a:solidFill>
               </a:rPr>
-              <a:t>LeetCode Easy</a:t>
+              <a:t>Newbie</a:t>
             </a:r>
             <a:endParaRPr lang="en-US" sz="1300" dirty="0"/>
           </a:p>
@@ -5401,14 +5401,14 @@
       </p:sp>
       <p:sp>
         <p:nvSpPr>
-          <p:cNvPr id="36" name="zone Medium"/>
+          <p:cNvPr id="36" name="zone Pupil, Specialist"/>
           <p:cNvSpPr/>
           <p:nvPr/>
         </p:nvSpPr>
         <p:spPr>
           <a:xfrm>
             <a:off x="2403566" y="4983480"/>
-            <a:ext cx="2233749" cy="347472"/>
+            <a:ext cx="1489166" cy="347472"/>
           </a:xfrm>
           <a:prstGeom prst="rect">
             <a:avLst/>
@@ -5433,7 +5433,7 @@
         <p:spPr>
           <a:xfrm>
             <a:off x="2403566" y="4983480"/>
-            <a:ext cx="2233749" cy="347472"/>
+            <a:ext cx="1489166" cy="347472"/>
           </a:xfrm>
           <a:prstGeom prst="rect">
             <a:avLst/>
@@ -5454,7 +5454,7 @@
                   <a:schemeClr val="tx1"/>
                 </a:solidFill>
               </a:rPr>
-              <a:t>Medium</a:t>
+              <a:t>Pupil, Specialist</a:t>
             </a:r>
             <a:endParaRPr lang="en-US" sz="1300" dirty="0"/>
           </a:p>
@@ -5462,13 +5462,13 @@
       </p:sp>
       <p:sp>
         <p:nvSpPr>
-          <p:cNvPr id="38" name="zone Hard"/>
+          <p:cNvPr id="38" name="zone Expert, Cand. Master"/>
           <p:cNvSpPr/>
           <p:nvPr/>
         </p:nvSpPr>
         <p:spPr>
           <a:xfrm>
-            <a:off x="4637314" y="4983480"/>
+            <a:off x="3892731" y="4983480"/>
             <a:ext cx="1861457" cy="347472"/>
           </a:xfrm>
           <a:prstGeom prst="rect">
@@ -5493,7 +5493,7 @@
         </p:nvSpPr>
         <p:spPr>
           <a:xfrm>
-            <a:off x="4637314" y="4983480"/>
+            <a:off x="3892731" y="4983480"/>
             <a:ext cx="1861457" cy="347472"/>
           </a:xfrm>
           <a:prstGeom prst="rect">
@@ -5515,7 +5515,7 @@
                   <a:schemeClr val="tx1"/>
                 </a:solidFill>
               </a:rPr>
-              <a:t>Hard</a:t>
+              <a:t>Expert, Cand. Master</a:t>
             </a:r>
             <a:endParaRPr lang="en-US" sz="1300" dirty="0"/>
           </a:p>
@@ -5523,14 +5523,75 @@
       </p:sp>
       <p:sp>
         <p:nvSpPr>
-          <p:cNvPr id="40" name="zone harder than LeetCode"/>
+          <p:cNvPr id="40" name="zone Master, Int. Master"/>
           <p:cNvSpPr/>
           <p:nvPr/>
         </p:nvSpPr>
         <p:spPr>
           <a:xfrm>
-            <a:off x="6498771" y="4983480"/>
-            <a:ext cx="4839789" cy="347472"/>
+            <a:off x="5754189" y="4983480"/>
+            <a:ext cx="1116874" cy="347472"/>
+          </a:xfrm>
+          <a:prstGeom prst="rect">
+            <a:avLst/>
+          </a:prstGeom>
+          <a:solidFill>
+            <a:srgbClr val="F8CBAD"/>
+          </a:solidFill>
+          <a:ln w="12700">
+            <a:solidFill>
+              <a:srgbClr val="FFFFFF"/>
+            </a:solidFill>
+            <a:prstDash val="solid"/>
+          </a:ln>
+        </p:spPr>
+      </p:sp>
+      <p:sp>
+        <p:nvSpPr>
+          <p:cNvPr id="41" name="Text 34"/>
+          <p:cNvSpPr txBox="1"/>
+          <p:nvPr/>
+        </p:nvSpPr>
+        <p:spPr>
+          <a:xfrm>
+            <a:off x="5754189" y="4983480"/>
+            <a:ext cx="1116874" cy="347472"/>
+          </a:xfrm>
+          <a:prstGeom prst="rect">
+            <a:avLst/>
+          </a:prstGeom>
+          <a:noFill/>
+          <a:ln/>
+        </p:spPr>
+        <p:txBody>
+          <a:bodyPr wrap="square" lIns="0" tIns="0" rIns="0" bIns="0" rtlCol="0" anchor="ctr"/>
+          <a:lstStyle/>
+          <a:p>
+            <a:pPr algn="ctr" indent="0" marL="0">
+              <a:buNone/>
+            </a:pPr>
+            <a:r>
+              <a:rPr lang="en-US" sz="1300" b="1" dirty="0">
+                <a:solidFill>
+                  <a:schemeClr val="tx1"/>
+                </a:solidFill>
+              </a:rPr>
+              <a:t>Master, Int. Master</a:t>
+            </a:r>
+            <a:endParaRPr lang="en-US" sz="1300" dirty="0"/>
+          </a:p>
+        </p:txBody>
+      </p:sp>
+      <p:sp>
+        <p:nvSpPr>
+          <p:cNvPr id="42" name="zone Grandmaster and above"/>
+          <p:cNvSpPr/>
+          <p:nvPr/>
+        </p:nvSpPr>
+        <p:spPr>
+          <a:xfrm>
+            <a:off x="6871063" y="4983480"/>
+            <a:ext cx="4467497" cy="347472"/>
           </a:xfrm>
           <a:prstGeom prst="rect">
             <a:avLst/>
@@ -5548,14 +5609,14 @@
       </p:sp>
       <p:sp>
         <p:nvSpPr>
-          <p:cNvPr id="41" name="Text 34"/>
-          <p:cNvSpPr txBox="1"/>
-          <p:nvPr/>
-        </p:nvSpPr>
-        <p:spPr>
-          <a:xfrm>
-            <a:off x="6498771" y="4983480"/>
-            <a:ext cx="4839789" cy="347472"/>
+          <p:cNvPr id="43" name="Text 36"/>
+          <p:cNvSpPr txBox="1"/>
+          <p:nvPr/>
+        </p:nvSpPr>
+        <p:spPr>
+          <a:xfrm>
+            <a:off x="6871063" y="4983480"/>
+            <a:ext cx="4467497" cy="347472"/>
           </a:xfrm>
           <a:prstGeom prst="rect">
             <a:avLst/>
@@ -5576,7 +5637,7 @@
                   <a:schemeClr val="tx1"/>
                 </a:solidFill>
               </a:rPr>
-              <a:t>harder than LeetCode</a:t>
+              <a:t>Grandmaster and above</a:t>
             </a:r>
             <a:endParaRPr lang="en-US" sz="1300" dirty="0"/>
           </a:p>
@@ -5584,7 +5645,7 @@
       </p:sp>
       <p:sp>
         <p:nvSpPr>
-          <p:cNvPr id="42" name="rating 800"/>
+          <p:cNvPr id="44" name="rating 800"/>
           <p:cNvSpPr/>
           <p:nvPr/>
         </p:nvSpPr>
@@ -5609,7 +5670,7 @@
       </p:sp>
       <p:sp>
         <p:nvSpPr>
-          <p:cNvPr id="43" name="Text 36"/>
+          <p:cNvPr id="45" name="Text 38"/>
           <p:cNvSpPr txBox="1"/>
           <p:nvPr/>
         </p:nvSpPr>
@@ -5645,7 +5706,7 @@
       </p:sp>
       <p:sp>
         <p:nvSpPr>
-          <p:cNvPr id="44" name="Text 37"/>
+          <p:cNvPr id="46" name="Text 39"/>
           <p:cNvSpPr txBox="1"/>
           <p:nvPr/>
         </p:nvSpPr>
@@ -5681,7 +5742,7 @@
       </p:sp>
       <p:sp>
         <p:nvSpPr>
-          <p:cNvPr id="45" name="rating 1200"/>
+          <p:cNvPr id="47" name="rating 1200"/>
           <p:cNvSpPr/>
           <p:nvPr/>
         </p:nvSpPr>
@@ -5706,7 +5767,7 @@
       </p:sp>
       <p:sp>
         <p:nvSpPr>
-          <p:cNvPr id="46" name="Text 39"/>
+          <p:cNvPr id="48" name="Text 41"/>
           <p:cNvSpPr txBox="1"/>
           <p:nvPr/>
         </p:nvSpPr>
@@ -5742,7 +5803,7 @@
       </p:sp>
       <p:sp>
         <p:nvSpPr>
-          <p:cNvPr id="47" name="Text 40"/>
+          <p:cNvPr id="49" name="Text 42"/>
           <p:cNvSpPr txBox="1"/>
           <p:nvPr/>
         </p:nvSpPr>
@@ -5778,7 +5839,7 @@
       </p:sp>
       <p:sp>
         <p:nvSpPr>
-          <p:cNvPr id="48" name="rating 1600"/>
+          <p:cNvPr id="50" name="rating 1600"/>
           <p:cNvSpPr/>
           <p:nvPr/>
         </p:nvSpPr>
@@ -5803,7 +5864,7 @@
       </p:sp>
       <p:sp>
         <p:nvSpPr>
-          <p:cNvPr id="49" name="Text 42"/>
+          <p:cNvPr id="51" name="Text 44"/>
           <p:cNvSpPr txBox="1"/>
           <p:nvPr/>
         </p:nvSpPr>
@@ -5839,7 +5900,7 @@
       </p:sp>
       <p:sp>
         <p:nvSpPr>
-          <p:cNvPr id="50" name="Text 43"/>
+          <p:cNvPr id="52" name="Text 45"/>
           <p:cNvSpPr txBox="1"/>
           <p:nvPr/>
         </p:nvSpPr>
@@ -5875,7 +5936,7 @@
       </p:sp>
       <p:sp>
         <p:nvSpPr>
-          <p:cNvPr id="51" name="rating 2000"/>
+          <p:cNvPr id="53" name="rating 2000"/>
           <p:cNvSpPr/>
           <p:nvPr/>
         </p:nvSpPr>
@@ -5900,7 +5961,7 @@
       </p:sp>
       <p:sp>
         <p:nvSpPr>
-          <p:cNvPr id="52" name="Text 45"/>
+          <p:cNvPr id="54" name="Text 47"/>
           <p:cNvSpPr txBox="1"/>
           <p:nvPr/>
         </p:nvSpPr>
@@ -5936,7 +5997,7 @@
       </p:sp>
       <p:sp>
         <p:nvSpPr>
-          <p:cNvPr id="53" name="Text 46"/>
+          <p:cNvPr id="55" name="Text 48"/>
           <p:cNvSpPr txBox="1"/>
           <p:nvPr/>
         </p:nvSpPr>
@@ -5972,7 +6033,7 @@
       </p:sp>
       <p:sp>
         <p:nvSpPr>
-          <p:cNvPr id="54" name="rating 2400"/>
+          <p:cNvPr id="56" name="rating 2400"/>
           <p:cNvSpPr/>
           <p:nvPr/>
         </p:nvSpPr>
@@ -5997,7 +6058,7 @@
       </p:sp>
       <p:sp>
         <p:nvSpPr>
-          <p:cNvPr id="55" name="Text 48"/>
+          <p:cNvPr id="57" name="Text 50"/>
           <p:cNvSpPr txBox="1"/>
           <p:nvPr/>
         </p:nvSpPr>
@@ -6033,7 +6094,7 @@
       </p:sp>
       <p:sp>
         <p:nvSpPr>
-          <p:cNvPr id="56" name="Text 49"/>
+          <p:cNvPr id="58" name="Text 51"/>
           <p:cNvSpPr txBox="1"/>
           <p:nvPr/>
         </p:nvSpPr>
@@ -6069,7 +6130,7 @@
       </p:sp>
       <p:sp>
         <p:nvSpPr>
-          <p:cNvPr id="57" name="rating 2800"/>
+          <p:cNvPr id="59" name="rating 2800"/>
           <p:cNvSpPr/>
           <p:nvPr/>
         </p:nvSpPr>
@@ -6094,7 +6155,7 @@
       </p:sp>
       <p:sp>
         <p:nvSpPr>
-          <p:cNvPr id="58" name="Text 51"/>
+          <p:cNvPr id="60" name="Text 53"/>
           <p:cNvSpPr txBox="1"/>
           <p:nvPr/>
         </p:nvSpPr>
@@ -6130,7 +6191,7 @@
       </p:sp>
       <p:sp>
         <p:nvSpPr>
-          <p:cNvPr id="59" name="Text 52"/>
+          <p:cNvPr id="61" name="Text 54"/>
           <p:cNvSpPr txBox="1"/>
           <p:nvPr/>
         </p:nvSpPr>
@@ -6166,7 +6227,7 @@
       </p:sp>
       <p:sp>
         <p:nvSpPr>
-          <p:cNvPr id="60" name="rating 3200"/>
+          <p:cNvPr id="62" name="rating 3200"/>
           <p:cNvSpPr/>
           <p:nvPr/>
         </p:nvSpPr>
@@ -6191,7 +6252,7 @@
       </p:sp>
       <p:sp>
         <p:nvSpPr>
-          <p:cNvPr id="61" name="Text 54"/>
+          <p:cNvPr id="63" name="Text 56"/>
           <p:cNvSpPr txBox="1"/>
           <p:nvPr/>
         </p:nvSpPr>
@@ -6227,7 +6288,7 @@
       </p:sp>
       <p:sp>
         <p:nvSpPr>
-          <p:cNvPr id="62" name="Text 55"/>
+          <p:cNvPr id="64" name="Text 57"/>
           <p:cNvSpPr txBox="1"/>
           <p:nvPr/>
         </p:nvSpPr>
@@ -6263,7 +6324,7 @@
       </p:sp>
       <p:sp>
         <p:nvSpPr>
-          <p:cNvPr id="63" name="Text 56"/>
+          <p:cNvPr id="65" name="Text 58"/>
           <p:cNvSpPr txBox="1"/>
           <p:nvPr/>
         </p:nvSpPr>
@@ -6299,7 +6360,7 @@
       </p:sp>
       <p:sp>
         <p:nvSpPr>
-          <p:cNvPr id="64" name="Text 57"/>
+          <p:cNvPr id="66" name="Text 59"/>
           <p:cNvSpPr txBox="1"/>
           <p:nvPr/>
         </p:nvSpPr>
@@ -6327,7 +6388,7 @@
                   <a:schemeClr val="tx1"/>
                 </a:solidFill>
               </a:rPr>
-              <a:t>Median 2200 (LeetCode Hard); 46% are 2400+, where even gpt-oss-120b solves only 48%</a:t>
+              <a:t>Median 2200 = Master; 46% at Grandmaster level, where even gpt-oss-120b solves only 48%</a:t>
             </a:r>
             <a:endParaRPr lang="en-US" sz="2000" dirty="0"/>
           </a:p>
@@ -22305,7 +22366,7 @@
                   </a:tcPr>
                 </a:tc>
               </a:tr>
-              <a:tr h="548640">
+              <a:tr h="822960">
                 <a:tc>
                   <a:txBody>
                     <a:bodyPr/>
@@ -22378,7 +22439,7 @@
                             <a:schemeClr val="tx1"/>
                           </a:solidFill>
                         </a:rPr>
-                        <a:t>AlphaGeometry 25 of 30; its symbolic engine alone 14</a:t>
+                        <a:t>AlphaGeometry 25 of 30; its symbolic engine alone 14; average IMO gold medallist 25.9, average participant 15.2</a:t>
                       </a:r>
                       <a:endParaRPr lang="en-US" sz="1500" dirty="0"/>
                     </a:p>
@@ -27750,7 +27811,7 @@
                   <a:srgbClr val="4472C4"/>
                 </a:solidFill>
               </a:rPr>
-              <a:t>≈ LeetCode Easy–Hard</a:t>
+              <a:t>textbook algorithms, exact on every copy</a:t>
             </a:r>
             <a:endParaRPr lang="en-US" sz="1500" dirty="0"/>
           </a:p>
@@ -27936,7 +27997,7 @@
                   <a:srgbClr val="C00000"/>
                 </a:solidFill>
               </a:rPr>
-              <a:t>mostly LeetCode Hard or harder</a:t>
+              <a:t>Codeforces Master to Grandmaster level</a:t>
             </a:r>
             <a:endParaRPr lang="en-US" sz="1500" dirty="0"/>
           </a:p>
@@ -28122,7 +28183,7 @@
                   <a:srgbClr val="ED7D31"/>
                 </a:solidFill>
               </a:rPr>
-              <a:t>no LeetCode match: needs a solver</a:t>
+              <a:t>classic OR benchmark: greedy is 48% worse</a:t>
             </a:r>
             <a:endParaRPr lang="en-US" sz="1500" dirty="0"/>
           </a:p>
@@ -28308,7 +28369,7 @@
                   <a:srgbClr val="38761D"/>
                 </a:solidFill>
               </a:rPr>
-              <a:t>school level; the solver API is hard</a:t>
+              <a:t>OR-course exercises (NL4OPT)</a:t>
             </a:r>
             <a:endParaRPr lang="en-US" sz="1500" dirty="0"/>
           </a:p>
@@ -28494,7 +28555,7 @@
                   <a:srgbClr val="595959"/>
                 </a:solidFill>
               </a:rPr>
-              <a:t>not a coding test</a:t>
+              <a:t>AIME: top ~5% of AMC; IMO gold: 25.9/30</a:t>
             </a:r>
             <a:endParaRPr lang="en-US" sz="1500" dirty="0"/>
           </a:p>
@@ -28530,7 +28591,7 @@
                   <a:schemeClr val="tx1"/>
                 </a:solidFill>
               </a:rPr>
-              <a:t>Our contest problems: median rating 2200 (LeetCode Hard); 46% are harder than any LeetCode problem</a:t>
+              <a:t>Contest problems: median = Codeforces Master; 46% are at Grandmaster level</a:t>
             </a:r>
             <a:endParaRPr lang="en-US" sz="2000" dirty="0"/>
           </a:p>
@@ -33513,7 +33574,7 @@
                   <a:schemeClr val="tx1"/>
                 </a:solidFill>
               </a:rPr>
-              <a:t>Contest problems on the LeetCode scale</a:t>
+              <a:t>How hard: contest ranks, exams</a:t>
             </a:r>
             <a:endParaRPr lang="en-US" sz="1600" dirty="0"/>
           </a:p>

</xml_diff>

<commit_message>
Talk review: no speaker notes, one accuracy/cost picture, sources on the problem slide, next steps from the latest result
Co-Authored-By: Claude Opus 5.5 (1M context) <noreply@anthropic.com>
</commit_message>
<xml_diff>
--- a/PROPOSAL_slides.pptx
+++ b/PROPOSAL_slides.pptx
@@ -131,7 +131,7 @@
   <p:extLst>
     <p:ext uri="{521415D9-36F7-43E2-AB2F-B90AF26B5E84}">
       <p14:sectionLst xmlns:p14="http://schemas.microsoft.com/office/powerpoint/2010/main">
-        <p14:section name="Talk" id="{41e2911b-4d1c-0320-7d93-5664b30059cc}">
+        <p14:section name="Talk" id="{08773a7d-5793-30e4-9f29-fb073f5413a4}">
           <p14:sldIdLst>
             <p14:sldId id="256"/>
             <p14:sldId id="257"/>
@@ -144,7 +144,7 @@
             <p14:sldId id="264"/>
           </p14:sldIdLst>
         </p14:section>
-        <p14:section name="Extra pages" id="{5c551cb6-2d94-787f-a03c-51453e7eacee}">
+        <p14:section name="Extra pages" id="{558d307f-5103-4261-9172-397e35e6d885}">
           <p14:sldIdLst>
             <p14:sldId id="265"/>
             <p14:sldId id="266"/>
@@ -1388,7 +1388,7 @@
           <a:p>
             <a:r>
               <a:rPr lang="en-US" dirty="0"/>
-              <a:t>(5 s) Hello, we are Team 5. Our project: how to solve computational math with LLMs accurately and cheaply. The question is where the extra effort should go: a fact, a check, or more thinking.</a:t>
+              <a:t/>
             </a:r>
             <a:endParaRPr lang="en-US" dirty="0"/>
           </a:p>
@@ -1476,7 +1476,7 @@
           <a:p>
             <a:r>
               <a:rPr lang="en-US" dirty="0"/>
-              <a:t>How we test. Models: open models run locally (Qwen3 1.7B, 4B, 8B, 14B, 32B; Qwen3.6-35B-A3B; gpt-oss-20b and 120b; Goedel-Prover-V2-8B and DeepSeek-Prover-V2-7B for Lean). Benchmarks with exact answers. Every comparison changes one thing, is pre-registered (predictions written before the run, docs/prereg), replicated on 3 seeds, and reports output tokens per problem; published baselines are rerun in the same harness.</a:t>
+              <a:t/>
             </a:r>
             <a:endParaRPr lang="en-US" dirty="0"/>
           </a:p>
@@ -1564,7 +1564,7 @@
           <a:p>
             <a:r>
               <a:rPr lang="en-US" dirty="0"/>
-              <a:t>How hard, by well-known yardsticks. Contest problems: Codeforces ratings with the human rank at that level (Newbie up to 1199, Pupil 1200-1399, Specialist 1400-1599, Expert 1600-1899, Candidate Master 1900-2099, Master 2100-2299, International Master 2300-2399, Grandmaster 2400+); our median is 2200 (Master) and 142 of 311 are 2400+; 56 problems (18%) are solved by none of our 9 model settings. Routing: the Solomon VRPTW benchmark (1987); a simple greedy plan is valid on all 56 but 47.6% longer than the best known. Word problems: NL4OPT (a NeurIPS 2022 competition) is undergraduate OR-exercise level. Math: AIME invites at least the top 2.5% of AMC 10 and top 5% of AMC 12 takers. Proofs: on IMO-AG-30 an average IMO gold medallist solves 25.9 of 30 and an average participant 15.2 (AlphaGeometry paper). gpt-oss-120b at high effort solves 89% of the easiest contest band and 48% of the 2400+ band.</a:t>
+              <a:t/>
             </a:r>
             <a:endParaRPr lang="en-US" dirty="0"/>
           </a:p>
@@ -1652,7 +1652,7 @@
           <a:p>
             <a:r>
               <a:rPr lang="en-US" dirty="0"/>
-              <a:t>The example (Qwen3-14B, real output): the only difference between the two prompts is the toolbox, eight correct helper functions that the task does not need. We run the two finished programs ourselves. Program A prints 6, the right answer; program B builds its method on polar_sort and prints 0. The bars (Qwen3-32B, 108 generated geometry problems, mean of 3 runs; tokens = output tokens per problem, both cheap programs counted for the last row): with the helpers 59%, task only 77%, always thinking 98% at 5.9k tokens, and writing both cheap programs and thinking only when their answers differ 99% at 4.3k (27% fewer tokens; the pair differs on 37-53% of problems). It does not help when both programs share the mistake (gpt-oss-120b on contest problems).</a:t>
+              <a:t/>
             </a:r>
             <a:endParaRPr lang="en-US" dirty="0"/>
           </a:p>
@@ -1740,7 +1740,7 @@
           <a:p>
             <a:r>
               <a:rPr lang="en-US" dirty="0"/>
-              <a:t>Real gpt-oss-120b runs on Codeforces geometry problems. The examples are a free check: if the quick (medium-effort) program gets them right we submit it; if not, we pay for high effort. Examples can miss bugs (Find Color passed all 3 examples and failed hidden test 11), so the full policy also runs a quick brute-force comparison on small inputs. Result: 66.3% at 24.7k tokens per problem vs 66.2% at 30.1k for always high effort.</a:t>
+              <a:t/>
             </a:r>
             <a:endParaRPr lang="en-US" dirty="0"/>
           </a:p>
@@ -1828,7 +1828,7 @@
           <a:p>
             <a:r>
               <a:rPr lang="en-US" dirty="0"/>
-              <a:t>Real outputs, Qwen3-8B on MAMO easy-189 (gold 20000). Without a fact it writes solver.Objective().Minimize() and crashes (AttributeError). The fact is chosen automatically: its own shortest program from NL4OPT (a vans-and-trucks problem) that passed the label-free check (it runs and prints a value); no answers, no human. With it, both programs write solver.Minimize(10*x + 15*y + 20*z) and print 20000 (316 + 312 tokens), they agree, so no thinking is needed (thinking alone: 5,323 tokens). Chart: on the held-out MAMO the automatic fact matches the hand-written one (gpt-oss-20b within 1.2 points on 3 seeds). It stays within a problem family: a program of another problem type is 14-21 points below the hand-written fact on the optimization suite, and an introspected list of names hurts (Qwen3-32B 66.2 to 56.1%).</a:t>
+              <a:t/>
             </a:r>
             <a:endParaRPr lang="en-US" dirty="0"/>
           </a:p>
@@ -1916,7 +1916,7 @@
           <a:p>
             <a:r>
               <a:rPr lang="en-US" dirty="0"/>
-              <a:t>SIZE study. Without the snippet the 1.7B model invents OR-Tools attributes and almost never runs (0.1%); with six lines of exact usage it solves 44.5%. The gain shrinks as the model grows (+44, +31, +17, +8, +1 points). With the recipe (fact first, think only when the check fails), models that fit one 24 GB GPU match or beat Qwen3-32B: gpt-oss-20b 73.0% at 0.7k tokens vs Qwen3-32B with the fact and always thinking 72.0% at 5.5k; on the optimization suite Qwen3-14B (4-bit) 87-92% vs Qwen3-32B 79-85%. Below 14B the optimization suite stays at 47% or less.</a:t>
+              <a:t/>
             </a:r>
             <a:endParaRPr lang="en-US" dirty="0"/>
           </a:p>
@@ -2004,7 +2004,7 @@
           <a:p>
             <a:r>
               <a:rPr lang="en-US" dirty="0"/>
-              <a:t>Analogy for the 56 Solomon routing problems: each problem is like one day's orders. A: a new program per day is valid on 6 and 1 of 48 days in two runs (7%; drawn as 3), about 1.8k tokens each. B: draw 16 programs once, keep the one that gives valid plans on 8 practice days, reuse it: valid on 45 of 48 days (94%), 28k tokens in total. Reused programs also work on 200- and 400-customer problems; for a new rule (job-shop with release dates) editing the working program beats writing a new one (10% to 68-100%).</a:t>
+              <a:t/>
             </a:r>
             <a:endParaRPr lang="en-US" dirty="0"/>
           </a:p>
@@ -2092,7 +2092,7 @@
           <a:p>
             <a:r>
               <a:rPr lang="en-US" dirty="0"/>
-              <a:t>Right panel (MODEL, 63 model x task x seed cells; 0.5 points per 1k tokens): fact first, think on failure is the best fixed default (1.4 points from each cell's best policy; always thinking 8.4); choosing among 4 policies on 30 labelled problems of the new task cuts it to 0.6 (MAMO: 0.8-1.4). U1 / U1r / U2 (pre-registered). Qwen3-8B, Qwen3-32B and Qwen3.6 on the generated geometry and optimization suites, 624 problems, cure seed 1 shown; the order is the same on seeds 2 and 3. Thinking on the hardest-looking problems (difficulty-based allocation, as in compute-optimal scaling work) is even below thinking whenever the check fails. Giving the fact first and thinking only when the check fails is the most accurate and uses fewer tokens than any thinking policy; with automatically retrieved facts (BM25) it still reaches 84%.</a:t>
+              <a:t/>
             </a:r>
             <a:endParaRPr lang="en-US" dirty="0"/>
           </a:p>
@@ -2180,7 +2180,7 @@
           <a:p>
             <a:r>
               <a:rPr lang="en-US" dirty="0"/>
-              <a:t>Left: four ways to spend compute on the same 624 problems (Qwen3-8B, Qwen3-32B, Qwen3.6; same order on 3 seeds). Thinking on the hardest-looking problems, the compute-optimal scaling idea, gets 74% at 4.1k tokens; fact first and thinking only when the check fails gets 87% at 2.5k. Right: the fact needs no human (the model's own checked program for a similar problem: gpt-oss-20b 78.8% vs 78.9% hand-written on held-out MAMO); models that fit one 24 GB GPU match Qwen3-32B with the fact; 30 labelled problems choose the best policy for a new task (0.6 points from the best on average).</a:t>
+              <a:t/>
             </a:r>
             <a:endParaRPr lang="en-US" dirty="0"/>
           </a:p>
@@ -2268,7 +2268,7 @@
           <a:p>
             <a:r>
               <a:rPr lang="en-US" dirty="0"/>
-              <a:t>All baselines were run by us on our benchmarks. Models: U1 policies over Qwen3-8B / Qwen3-32B / Qwen3.6 (624 problems); contest geometry gpt-oss-120b (311); selection Qwen3-8B (300 geometry instances, 3 candidates); documentation Qwen3-32B on CVRP; tools Qwen3-32B on 5 geometry tasks; daily routing gpt-oss-120b on 48 held-out Solomon instances. Tokens are output tokens per problem. ORLM-LLaMA-3-8B was run in our harness on MAMO (863 held-out word problems; greedy 80.5 / 35.5% on Easy / Complex, as reported). More rows (MBR-exec, majority vote, DeepConf, Self-Debugging, Mixture-of-Thought cascade, BM25 retrieval) are in PROPOSAL.md section 6.</a:t>
+              <a:t/>
             </a:r>
             <a:endParaRPr lang="en-US" dirty="0"/>
           </a:p>
@@ -2356,7 +2356,7 @@
           <a:p>
             <a:r>
               <a:rPr lang="en-US" dirty="0"/>
-              <a:t>(25 s) We test five kinds of computational math, and here is how hard they are by well-known yardsticks. Exact geometry uses textbook algorithms, but must be right on moved and turned copies. Our contest problems are Codeforces problems at the level of Master to Grandmaster players; 18% are solved by none of our nine model setups. Routing is a classic operations-research benchmark where a simple greedy plan is 48% worse than the best known. Word problems are operations-research course exercises. And competition math goes up to AIME, taken by the top few percent of AMC students, and olympiad proofs, where an IMO gold medallist solves about 26 of 30 geometry problems.</a:t>
+              <a:t/>
             </a:r>
             <a:endParaRPr lang="en-US" dirty="0"/>
           </a:p>
@@ -2444,7 +2444,7 @@
           <a:p>
             <a:r>
               <a:rPr lang="en-US" dirty="0"/>
-              <a:t>Closest work per theme (details and how we differ: PROPOSAL.md section 6.1 and docs/notes/RELATED_WORK.md). Closest overall: OptiSkill (2609.22987) builds a skill bank from a strong teacher's programs validated against answers and routes it by problem type; our facts are the same small model's own programs chosen by a label-free check, and we show why routing by problem type is needed (a fact from another type costs 14-21 points). For when-to-think, Thinkless and AdaptThink train a switch with RL; we decide with an execution check after giving the fact; a same-backbone comparison with AdaptThink-7B is running.</a:t>
+              <a:t/>
             </a:r>
             <a:endParaRPr lang="en-US" dirty="0"/>
           </a:p>
@@ -2532,7 +2532,7 @@
           <a:p>
             <a:r>
               <a:rPr lang="en-US" dirty="0"/>
-              <a:t>Numbers as reported by the papers or model cards; our harness, prompts and graders differ (MAMO labels are noisy; reported ORLM numbers range 81.6-88.2% on Easy). ORLM-8B rerun in our harness gives 80.5 / 35.5%, close to its report. STORM-Qwen3-4B is being run in our harness. Goedel-Prover-V2-8B: 187 of 244 with 32 tries in our Lean setup vs 84.6% on its card. AlphaGeometry's DD+AR engine proves 12 of IMO-AG-30 here (14 in the paper; one problem does not parse in this engine version).</a:t>
+              <a:t/>
             </a:r>
             <a:endParaRPr lang="en-US" dirty="0"/>
           </a:p>
@@ -2620,7 +2620,7 @@
           <a:p>
             <a:r>
               <a:rPr lang="en-US" dirty="0"/>
-              <a:t>Real outputs. miniF2F mathd_numbertheory_34 (9^-1 mod 100 = 89). Qwen3-32B's 8 attempts all fail; they cite lemmas that do not exist, e.g. Nat.ModEq_iff_modEq. Goedel-Prover-V2-8B proves it by checking every x below 100 (interval_cases, then norm_num and omega). Specialized provers rarely invent names (6-7% of failed attempts vs 22-40%). For general models a verified proof of the most similar statement, thinking, or an inequality toolkit does not help; even for provers, revising from Lean's errors proves half as many as a fresh attempt (Goedel 11 vs 22 of 107). Geometry: AlphaGeometry's DD+AR engine alone proves 12 of IMO-AG-30 and 187 of JGEX-AG-231; LLM auxiliary points add 13 JGEX problems and only IMO 2014 P4 (d = midpoint of b c).</a:t>
+              <a:t/>
             </a:r>
             <a:endParaRPr lang="en-US" dirty="0"/>
           </a:p>
@@ -2708,7 +2708,7 @@
           <a:p>
             <a:r>
               <a:rPr lang="en-US" dirty="0"/>
-              <a:t>Updated 2026-10-19. Done since the last version: contest geometry and competition math on 24 GB GPUs, Qwen3.6 with the model card settings (headline unchanged), automatic facts and the held-out MAMO test, the policy model, proofs. Older notes: for Lean proofs an invented lemma stands for a missing proof step (similar-name feedback fixes 2.7%, a fresh try 3.2%); for PopQA thinking adds 1.8-5 points at 70-200 times the tokens, only for well-known facts. Checks leak, which caps every policy. Facts were hand-written; BM25 retrieval recovers most of the gain. Next: SIZE-CC (gpt-oss-20b on contest geometry with check-gated escalation), X1-SIZE (competition math for Qwen3-4B/8B/14B), automatic facts, a closed API model, final report.</a:t>
+              <a:t/>
             </a:r>
             <a:endParaRPr lang="en-US" dirty="0"/>
           </a:p>
@@ -2796,7 +2796,7 @@
           <a:p>
             <a:r>
               <a:rPr lang="en-US" dirty="0"/>
-              <a:t>One panel per result. Add the fact: routing 23% to 77-90% (thinking longer 3%, whole manual 7%). Small models gain most: Qwen3-1.7B 0% to 45%, Qwen3-32B 65% to 66% (word problems). Compare two versions: 99% at 4.3k tokens vs always thinking 98% at 5.9k; with 8 extra tools 59%. Think only on a failed check (gpt-oss-120b, contest): 66.3% at 24.7k vs 66.2% at 30.1k. Reuse: 94% of 48 routing days vs 7% with a new program per day; Dynamic Cheatsheet (DC, the model's own notes) 31-40%. All together: fact first then think on failure 87% at 2.5k vs 74% at 4.1k for thinking on the hardest-looking problems (Snell-style) and 83% for choosing the fix by failure type.</a:t>
+              <a:t/>
             </a:r>
             <a:endParaRPr lang="en-US" dirty="0"/>
           </a:p>
@@ -2884,7 +2884,7 @@
           <a:p>
             <a:r>
               <a:rPr lang="en-US" dirty="0"/>
-              <a:t>Plain definitions for the rest of the talk. Every result is reported as accuracy and tokens (cost).</a:t>
+              <a:t/>
             </a:r>
             <a:endParaRPr lang="en-US" dirty="0"/>
           </a:p>
@@ -2972,7 +2972,7 @@
           <a:p>
             <a:r>
               <a:rPr lang="en-US" dirty="0"/>
-              <a:t>(20 s) An LLM can answer a math problem in words, or write a program and let the computer do the arithmetic. Here Qwen3-8B is asked for twice the area of one shape, moved and turned. In words it says 436, 2944, 392 and 728; its program says 436 every time. So for computation, programs are the right tool. (Other ways, used later: call a solver library, or think longer first.)</a:t>
+              <a:t/>
             </a:r>
             <a:endParaRPr lang="en-US" dirty="0"/>
           </a:p>
@@ -3060,7 +3060,7 @@
           <a:p>
             <a:r>
               <a:rPr lang="en-US" dirty="0"/>
-              <a:t>(30 s) But two things go wrong. First, programs can be silently wrong: two programs for the same question, how many corners the rubber band around these points has; one prints 6, the other prints 0, with no error message. The only difference: the second prompt had some extra helper code. Second, thinking longer is expensive: on contest problems, thinking hard uses 4.4 times the tokens, drawn here as pages, for 9 more points. So our question: where should the extra effort go? A missing fact, a free check, or more thinking?</a:t>
+              <a:t/>
             </a:r>
             <a:endParaRPr lang="en-US" dirty="0"/>
           </a:p>
@@ -3148,7 +3148,7 @@
           <a:p>
             <a:r>
               <a:rPr lang="en-US" dirty="0"/>
-              <a:t>(35 s) Finding one. Qwen3-32B writes route-planning code with OR-Tools. Given the whole manual, it calls a function that sounds right but does not exist, and the program crashes. Given five lines with the exact call, it finds the best route. Out of 100 routing problems: 23 with nothing extra, only 3 when it thinks longer, 7 with the whole manual, and 77 to 90 with five exact lines. Thinking cannot supply a fact the model does not have.</a:t>
+              <a:t/>
             </a:r>
             <a:endParaRPr lang="en-US" dirty="0"/>
           </a:p>
@@ -3236,7 +3236,7 @@
           <a:p>
             <a:r>
               <a:rPr lang="en-US" dirty="0"/>
-              <a:t>(40 s) Finding two: thinking should be paid only when a free check fails. Check A uses the examples printed in every contest problem: 'Make a triangle!' passes them and is submitted; 'Arrow' fails one, so only it gets high effort. Same 66% as always thinking hard, 18% fewer tokens. Check B writes the program twice, with and without extra tools: if the answers differ, think. 99% vs 98%, with 27% fewer tokens. Neither check needs the answer.</a:t>
+              <a:t/>
             </a:r>
             <a:endParaRPr lang="en-US" dirty="0"/>
           </a:p>
@@ -3324,7 +3324,7 @@
           <a:p>
             <a:r>
               <a:rPr lang="en-US" dirty="0"/>
-              <a:t>(60 s) Together this gives our method, shown on one real word problem. Without a fact, the program calls a method that does not exist. The fact is found automatically: the model's own earlier program for another problem that passed the check, showing the right call. With it, two versions both print 20000, they agree, so we skip thinking and accept: 0.6 thousand tokens instead of 5.3 thousand. A problem of the same kind with new data reuses the checked program. Over 624 problems and 3 models: 87% at 2.5 thousand tokens, versus 74% at 4.1 thousand for the usual idea of thinking more on the hardest-looking problems. And the automatic fact matches a hand-written one on a benchmark we never used before: 79 versus 79%.</a:t>
+              <a:t/>
             </a:r>
             <a:endParaRPr lang="en-US" dirty="0"/>
           </a:p>
@@ -3412,7 +3412,7 @@
           <a:p>
             <a:r>
               <a:rPr lang="en-US" dirty="0"/>
-              <a:t>(30 s) What is new, compared with the usual way. Usually more compute goes to hard-looking problems, or a model is trained to decide when to think; we think only when a free check fails, with no training: 87 versus 74%. Usually models get the manual, or a teacher's programs checked against answers; we give one fact, the model's own checked program, with no answers. And instead of fine-tuning a specialist, an untrained 8B model on one GPU gets the same 69.5%. Next: replicate on held-out data and run the closest baselines, find facts for every problem type, and release the report, code and recipe. Takeaway: give the missing fact first, and think only where a free check fails. Thank you.</a:t>
+              <a:t/>
             </a:r>
             <a:endParaRPr lang="en-US" dirty="0"/>
           </a:p>
@@ -3500,7 +3500,7 @@
           <a:p>
             <a:r>
               <a:rPr lang="en-US" dirty="0"/>
-              <a:t>End of the 5-minute talk; 5 minutes of questions follow. Extra pages (slides 10-25): 10 Setup and fairness; 11 How hard: contest ranks, exams; 12 Two versions, in detail; 13 The examples check, in detail; 14 Facts without a human, in detail; 15 One fact helps small models most; 16 Reuse a checked program; 17 All policies, cost vs accuracy; 18 It pays off: small GPU, 30 labels; 19 Compared with published methods; 20 Related research map; 21 Numbers reported in papers; 22 Proofs need a specialized model; 23 Where the recipe stops; 24 All findings at a glance; 25 Words we use. Likely questions: why not GPT or Claude (open models only, cost and reproducibility); is the hand-written fact cheating (the automatic fact matches it); is the difference real (3 seeds, pre-registered); bigger model vs this recipe (small GPU page).</a:t>
+              <a:t/>
             </a:r>
             <a:endParaRPr lang="en-US" dirty="0"/>
           </a:p>
@@ -4393,7 +4393,7 @@
                   <a:srgbClr val="44546A"/>
                 </a:solidFill>
               </a:rPr>
-              <a:t>POSTECH CSED490E (Graduate NLP) · Team 5 · 5-minute proposal talk</a:t>
+              <a:t>POSTECH CSED490E (Graduate NLP) · Team 5</a:t>
             </a:r>
             <a:endParaRPr lang="en-US" sz="2200" dirty="0"/>
           </a:p>
@@ -18476,7 +18476,7 @@
                   <a:schemeClr val="tx1"/>
                 </a:solidFill>
               </a:rPr>
-              <a:t>AIME answers; Lean proofs</a:t>
+              <a:t>contest answers; machine-checked proofs</a:t>
             </a:r>
             <a:endParaRPr lang="en-US" sz="1500" dirty="0"/>
           </a:p>
@@ -18575,7 +18575,7 @@
                   <a:schemeClr val="tx1"/>
                 </a:solidFill>
               </a:rPr>
-              <a:t>Contest problems: median = Codeforces Master; 46% are at Grandmaster level</a:t>
+              <a:t>Open models (Qwen3, gpt-oss) on our own GPUs: we count exact answers and the tokens spent</a:t>
             </a:r>
             <a:endParaRPr lang="en-US" sz="2000" dirty="0"/>
           </a:p>
@@ -22714,7 +22714,7 @@
                   <a:schemeClr val="tx1"/>
                 </a:solidFill>
               </a:rPr>
-              <a:t>Repeat the held-out MAMO test for 3 more models (3 seeds)</a:t>
+              <a:t>Finish the held-out MAMO test (more models, 3 seeds)</a:t>
             </a:r>
             <a:endParaRPr lang="en-US" sz="1700" dirty="0"/>
           </a:p>
@@ -22732,7 +22732,7 @@
                   <a:schemeClr val="tx1"/>
                 </a:solidFill>
               </a:rPr>
-              <a:t>Automatic facts for each problem type</a:t>
+              <a:t>Errors no check catches: a perfect check adds only 1–3 points on word problems; the rest run but model the problem wrong</a:t>
             </a:r>
             <a:endParaRPr lang="en-US" sz="1700" dirty="0"/>
           </a:p>
@@ -22750,7 +22750,7 @@
                   <a:schemeClr val="tx1"/>
                 </a:solidFill>
               </a:rPr>
-              <a:t>Final report; a commercial model if available</a:t>
+              <a:t>Automatic facts for each problem type; final report</a:t>
             </a:r>
             <a:endParaRPr lang="en-US" sz="1700" dirty="0"/>
           </a:p>
@@ -26322,7 +26322,7 @@
                   <a:schemeClr val="tx1"/>
                 </a:solidFill>
               </a:rPr>
-              <a:t>One shape, moved, turned and flipped: the right answer never changes (436)</a:t>
+              <a:t>Qwen3-8B, asked for twice the area of one shape: moved, turned or flipped, it is always 436</a:t>
             </a:r>
             <a:endParaRPr lang="en-US" sz="1800" dirty="0"/>
           </a:p>
@@ -27081,11 +27081,11 @@
         <p:spPr>
           <a:xfrm>
             <a:off x="548640" y="1234440"/>
-            <a:ext cx="5440680" cy="3291840"/>
+            <a:ext cx="5440680" cy="3794760"/>
           </a:xfrm>
           <a:prstGeom prst="roundRect">
             <a:avLst>
-              <a:gd name="adj" fmla="val 2222"/>
+              <a:gd name="adj" fmla="val 1928"/>
             </a:avLst>
           </a:prstGeom>
           <a:solidFill>
@@ -27135,9 +27135,45 @@
           </a:p>
         </p:txBody>
       </p:sp>
+      <p:sp>
+        <p:nvSpPr>
+          <p:cNvPr id="5" name="Text 3"/>
+          <p:cNvSpPr txBox="1"/>
+          <p:nvPr/>
+        </p:nvSpPr>
+        <p:spPr>
+          <a:xfrm>
+            <a:off x="777240" y="1874520"/>
+            <a:ext cx="5029200" cy="365760"/>
+          </a:xfrm>
+          <a:prstGeom prst="rect">
+            <a:avLst/>
+          </a:prstGeom>
+          <a:noFill/>
+          <a:ln/>
+        </p:spPr>
+        <p:txBody>
+          <a:bodyPr wrap="square" lIns="0" tIns="0" rIns="0" bIns="0" rtlCol="0" anchor="ctr"/>
+          <a:lstStyle/>
+          <a:p>
+            <a:pPr indent="0" marL="0">
+              <a:buNone/>
+            </a:pPr>
+            <a:r>
+              <a:rPr lang="en-US" sz="1500" dirty="0">
+                <a:solidFill>
+                  <a:schemeClr val="tx1"/>
+                </a:solidFill>
+              </a:rPr>
+              <a:t>How many corners does the rubber band have?</a:t>
+            </a:r>
+            <a:endParaRPr lang="en-US" sz="1500" dirty="0"/>
+          </a:p>
+        </p:txBody>
+      </p:sp>
       <p:pic>
         <p:nvPicPr>
-          <p:cNvPr id="5" name="ten points and their hull" descr="10 points; the rubber band touches 6 of them">    </p:cNvPr>
+          <p:cNvPr id="6" name="ten points and their hull" descr="10 points; the rubber band touches 6 of them">    </p:cNvPr>
           <p:cNvPicPr>
             <a:picLocks noChangeAspect="1"/>
           </p:cNvPicPr>
@@ -27151,8 +27187,8 @@
         </p:blipFill>
         <p:spPr>
           <a:xfrm>
-            <a:off x="777240" y="1965960"/>
-            <a:ext cx="1737360" cy="1737360"/>
+            <a:off x="777240" y="2331720"/>
+            <a:ext cx="2011680" cy="2011680"/>
           </a:xfrm>
           <a:prstGeom prst="rect">
             <a:avLst/>
@@ -27161,14 +27197,14 @@
       </p:pic>
       <p:sp>
         <p:nvSpPr>
-          <p:cNvPr id="6" name="Text 3"/>
-          <p:cNvSpPr txBox="1"/>
-          <p:nvPr/>
-        </p:nvSpPr>
-        <p:spPr>
-          <a:xfrm>
-            <a:off x="685800" y="3749040"/>
-            <a:ext cx="1920240" cy="365760"/>
+          <p:cNvPr id="7" name="Text 4"/>
+          <p:cNvSpPr txBox="1"/>
+          <p:nvPr/>
+        </p:nvSpPr>
+        <p:spPr>
+          <a:xfrm>
+            <a:off x="685800" y="4389120"/>
+            <a:ext cx="2194560" cy="365760"/>
           </a:xfrm>
           <a:prstGeom prst="rect">
             <a:avLst/>
@@ -27197,14 +27233,14 @@
       </p:sp>
       <p:sp>
         <p:nvSpPr>
-          <p:cNvPr id="7" name="terminal"/>
+          <p:cNvPr id="8" name="terminal"/>
           <p:cNvSpPr/>
           <p:nvPr/>
         </p:nvSpPr>
         <p:spPr>
           <a:xfrm>
-            <a:off x="2697480" y="2057400"/>
-            <a:ext cx="3108960" cy="1554480"/>
+            <a:off x="2971800" y="2423160"/>
+            <a:ext cx="2834640" cy="1554480"/>
           </a:xfrm>
           <a:prstGeom prst="roundRect">
             <a:avLst>
@@ -27224,14 +27260,14 @@
       </p:sp>
       <p:sp>
         <p:nvSpPr>
-          <p:cNvPr id="8" name="Text 5"/>
-          <p:cNvSpPr txBox="1"/>
-          <p:nvPr/>
-        </p:nvSpPr>
-        <p:spPr>
-          <a:xfrm>
-            <a:off x="2880360" y="2103120"/>
-            <a:ext cx="2834640" cy="1463040"/>
+          <p:cNvPr id="9" name="Text 6"/>
+          <p:cNvSpPr txBox="1"/>
+          <p:nvPr/>
+        </p:nvSpPr>
+        <p:spPr>
+          <a:xfrm>
+            <a:off x="3154680" y="2468880"/>
+            <a:ext cx="2560320" cy="1463040"/>
           </a:xfrm>
           <a:prstGeom prst="rect">
             <a:avLst/>
@@ -27297,14 +27333,14 @@
       </p:sp>
       <p:sp>
         <p:nvSpPr>
-          <p:cNvPr id="9" name="Text 6"/>
-          <p:cNvSpPr txBox="1"/>
-          <p:nvPr/>
-        </p:nvSpPr>
-        <p:spPr>
-          <a:xfrm>
-            <a:off x="2697480" y="3703320"/>
-            <a:ext cx="3108960" cy="548640"/>
+          <p:cNvPr id="10" name="Text 7"/>
+          <p:cNvSpPr txBox="1"/>
+          <p:nvPr/>
+        </p:nvSpPr>
+        <p:spPr>
+          <a:xfrm>
+            <a:off x="2971800" y="4069080"/>
+            <a:ext cx="2834640" cy="548640"/>
           </a:xfrm>
           <a:prstGeom prst="rect">
             <a:avLst/>
@@ -27325,7 +27361,7 @@
                   <a:schemeClr val="tx2"/>
                 </a:solidFill>
               </a:rPr>
-              <a:t>B only had extra helper code in its prompt</a:t>
+              <a:t>B's prompt only added helper code (Qwen3-14B)</a:t>
             </a:r>
             <a:endParaRPr lang="en-US" sz="1400" dirty="0"/>
           </a:p>
@@ -27333,18 +27369,18 @@
       </p:sp>
       <p:sp>
         <p:nvSpPr>
-          <p:cNvPr id="10" name="pane 2. Thinking longer is expensive"/>
+          <p:cNvPr id="11" name="pane 2. Thinking longer is expensive"/>
           <p:cNvSpPr/>
           <p:nvPr/>
         </p:nvSpPr>
         <p:spPr>
           <a:xfrm>
             <a:off x="6172200" y="1234440"/>
-            <a:ext cx="5440680" cy="3291840"/>
+            <a:ext cx="5440680" cy="3794760"/>
           </a:xfrm>
           <a:prstGeom prst="roundRect">
             <a:avLst>
-              <a:gd name="adj" fmla="val 2222"/>
+              <a:gd name="adj" fmla="val 1928"/>
             </a:avLst>
           </a:prstGeom>
           <a:solidFill>
@@ -27360,7 +27396,7 @@
       </p:sp>
       <p:sp>
         <p:nvSpPr>
-          <p:cNvPr id="11" name="Text 8"/>
+          <p:cNvPr id="12" name="Text 9"/>
           <p:cNvSpPr txBox="1"/>
           <p:nvPr/>
         </p:nvSpPr>
@@ -27396,13 +27432,49 @@
       </p:sp>
       <p:sp>
         <p:nvSpPr>
-          <p:cNvPr id="12" name="Text 9"/>
-          <p:cNvSpPr txBox="1"/>
-          <p:nvPr/>
-        </p:nvSpPr>
-        <p:spPr>
-          <a:xfrm>
-            <a:off x="6400800" y="2057400"/>
+          <p:cNvPr id="13" name="Text 10"/>
+          <p:cNvSpPr txBox="1"/>
+          <p:nvPr/>
+        </p:nvSpPr>
+        <p:spPr>
+          <a:xfrm>
+            <a:off x="6400800" y="1874520"/>
+            <a:ext cx="5029200" cy="365760"/>
+          </a:xfrm>
+          <a:prstGeom prst="rect">
+            <a:avLst/>
+          </a:prstGeom>
+          <a:noFill/>
+          <a:ln/>
+        </p:spPr>
+        <p:txBody>
+          <a:bodyPr wrap="square" lIns="0" tIns="0" rIns="0" bIns="0" rtlCol="0" anchor="ctr"/>
+          <a:lstStyle/>
+          <a:p>
+            <a:pPr indent="0" marL="0">
+              <a:buNone/>
+            </a:pPr>
+            <a:r>
+              <a:rPr lang="en-US" sz="1500" dirty="0">
+                <a:solidFill>
+                  <a:schemeClr val="tx1"/>
+                </a:solidFill>
+              </a:rPr>
+              <a:t>311 contest problems, gpt-oss-120b · 1 page ≈ 700 tokens</a:t>
+            </a:r>
+            <a:endParaRPr lang="en-US" sz="1500" dirty="0"/>
+          </a:p>
+        </p:txBody>
+      </p:sp>
+      <p:sp>
+        <p:nvSpPr>
+          <p:cNvPr id="14" name="Text 11"/>
+          <p:cNvSpPr txBox="1"/>
+          <p:nvPr/>
+        </p:nvSpPr>
+        <p:spPr>
+          <a:xfrm>
+            <a:off x="6400800" y="2377440"/>
             <a:ext cx="1463040" cy="594360"/>
           </a:xfrm>
           <a:prstGeom prst="rect">
@@ -27446,7 +27518,7 @@
       </p:sp>
       <p:pic>
         <p:nvPicPr>
-          <p:cNvPr id="13" name="normal page 0" descr="/NAS/SJ/POSTECH/nlp/figs/icons/page.png">    </p:cNvPr>
+          <p:cNvPr id="15" name="normal page 0" descr="/NAS/SJ/POSTECH/nlp/figs/icons/page.png">    </p:cNvPr>
           <p:cNvPicPr>
             <a:picLocks noChangeAspect="1"/>
           </p:cNvPicPr>
@@ -27460,7 +27532,7 @@
         </p:blipFill>
         <p:spPr>
           <a:xfrm>
-            <a:off x="7909560" y="2075688"/>
+            <a:off x="7909560" y="2395728"/>
             <a:ext cx="182880" cy="201168"/>
           </a:xfrm>
           <a:prstGeom prst="rect">
@@ -27470,7 +27542,7 @@
       </p:pic>
       <p:pic>
         <p:nvPicPr>
-          <p:cNvPr id="14" name="normal page 1" descr="/NAS/SJ/POSTECH/nlp/figs/icons/page.png">    </p:cNvPr>
+          <p:cNvPr id="16" name="normal page 1" descr="/NAS/SJ/POSTECH/nlp/figs/icons/page.png">    </p:cNvPr>
           <p:cNvPicPr>
             <a:picLocks noChangeAspect="1"/>
           </p:cNvPicPr>
@@ -27484,7 +27556,7 @@
         </p:blipFill>
         <p:spPr>
           <a:xfrm>
-            <a:off x="8101584" y="2075688"/>
+            <a:off x="8101584" y="2395728"/>
             <a:ext cx="182880" cy="201168"/>
           </a:xfrm>
           <a:prstGeom prst="rect">
@@ -27494,7 +27566,7 @@
       </p:pic>
       <p:pic>
         <p:nvPicPr>
-          <p:cNvPr id="15" name="normal page 2" descr="/NAS/SJ/POSTECH/nlp/figs/icons/page.png">    </p:cNvPr>
+          <p:cNvPr id="17" name="normal page 2" descr="/NAS/SJ/POSTECH/nlp/figs/icons/page.png">    </p:cNvPr>
           <p:cNvPicPr>
             <a:picLocks noChangeAspect="1"/>
           </p:cNvPicPr>
@@ -27508,7 +27580,7 @@
         </p:blipFill>
         <p:spPr>
           <a:xfrm>
-            <a:off x="8293608" y="2075688"/>
+            <a:off x="8293608" y="2395728"/>
             <a:ext cx="182880" cy="201168"/>
           </a:xfrm>
           <a:prstGeom prst="rect">
@@ -27518,7 +27590,7 @@
       </p:pic>
       <p:pic>
         <p:nvPicPr>
-          <p:cNvPr id="16" name="normal page 3" descr="/NAS/SJ/POSTECH/nlp/figs/icons/page.png">    </p:cNvPr>
+          <p:cNvPr id="18" name="normal page 3" descr="/NAS/SJ/POSTECH/nlp/figs/icons/page.png">    </p:cNvPr>
           <p:cNvPicPr>
             <a:picLocks noChangeAspect="1"/>
           </p:cNvPicPr>
@@ -27532,7 +27604,7 @@
         </p:blipFill>
         <p:spPr>
           <a:xfrm>
-            <a:off x="8485632" y="2075688"/>
+            <a:off x="8485632" y="2395728"/>
             <a:ext cx="182880" cy="201168"/>
           </a:xfrm>
           <a:prstGeom prst="rect">
@@ -27542,7 +27614,7 @@
       </p:pic>
       <p:pic>
         <p:nvPicPr>
-          <p:cNvPr id="17" name="normal page 4" descr="/NAS/SJ/POSTECH/nlp/figs/icons/page.png">    </p:cNvPr>
+          <p:cNvPr id="19" name="normal page 4" descr="/NAS/SJ/POSTECH/nlp/figs/icons/page.png">    </p:cNvPr>
           <p:cNvPicPr>
             <a:picLocks noChangeAspect="1"/>
           </p:cNvPicPr>
@@ -27556,7 +27628,7 @@
         </p:blipFill>
         <p:spPr>
           <a:xfrm>
-            <a:off x="8677656" y="2075688"/>
+            <a:off x="8677656" y="2395728"/>
             <a:ext cx="182880" cy="201168"/>
           </a:xfrm>
           <a:prstGeom prst="rect">
@@ -27566,7 +27638,7 @@
       </p:pic>
       <p:pic>
         <p:nvPicPr>
-          <p:cNvPr id="18" name="normal page 5" descr="/NAS/SJ/POSTECH/nlp/figs/icons/page.png">    </p:cNvPr>
+          <p:cNvPr id="20" name="normal page 5" descr="/NAS/SJ/POSTECH/nlp/figs/icons/page.png">    </p:cNvPr>
           <p:cNvPicPr>
             <a:picLocks noChangeAspect="1"/>
           </p:cNvPicPr>
@@ -27580,7 +27652,7 @@
         </p:blipFill>
         <p:spPr>
           <a:xfrm>
-            <a:off x="8869680" y="2075688"/>
+            <a:off x="8869680" y="2395728"/>
             <a:ext cx="182880" cy="201168"/>
           </a:xfrm>
           <a:prstGeom prst="rect">
@@ -27590,7 +27662,7 @@
       </p:pic>
       <p:pic>
         <p:nvPicPr>
-          <p:cNvPr id="19" name="normal page 6" descr="/NAS/SJ/POSTECH/nlp/figs/icons/page.png">    </p:cNvPr>
+          <p:cNvPr id="21" name="normal page 6" descr="/NAS/SJ/POSTECH/nlp/figs/icons/page.png">    </p:cNvPr>
           <p:cNvPicPr>
             <a:picLocks noChangeAspect="1"/>
           </p:cNvPicPr>
@@ -27604,7 +27676,7 @@
         </p:blipFill>
         <p:spPr>
           <a:xfrm>
-            <a:off x="9061704" y="2075688"/>
+            <a:off x="9061704" y="2395728"/>
             <a:ext cx="182880" cy="201168"/>
           </a:xfrm>
           <a:prstGeom prst="rect">
@@ -27614,7 +27686,7 @@
       </p:pic>
       <p:pic>
         <p:nvPicPr>
-          <p:cNvPr id="20" name="normal page 7" descr="/NAS/SJ/POSTECH/nlp/figs/icons/page.png">    </p:cNvPr>
+          <p:cNvPr id="22" name="normal page 7" descr="/NAS/SJ/POSTECH/nlp/figs/icons/page.png">    </p:cNvPr>
           <p:cNvPicPr>
             <a:picLocks noChangeAspect="1"/>
           </p:cNvPicPr>
@@ -27628,7 +27700,7 @@
         </p:blipFill>
         <p:spPr>
           <a:xfrm>
-            <a:off x="9253728" y="2075688"/>
+            <a:off x="9253728" y="2395728"/>
             <a:ext cx="182880" cy="201168"/>
           </a:xfrm>
           <a:prstGeom prst="rect">
@@ -27638,7 +27710,7 @@
       </p:pic>
       <p:pic>
         <p:nvPicPr>
-          <p:cNvPr id="21" name="normal page 8" descr="/NAS/SJ/POSTECH/nlp/figs/icons/page.png">    </p:cNvPr>
+          <p:cNvPr id="23" name="normal page 8" descr="/NAS/SJ/POSTECH/nlp/figs/icons/page.png">    </p:cNvPr>
           <p:cNvPicPr>
             <a:picLocks noChangeAspect="1"/>
           </p:cNvPicPr>
@@ -27652,7 +27724,7 @@
         </p:blipFill>
         <p:spPr>
           <a:xfrm>
-            <a:off x="9445752" y="2075688"/>
+            <a:off x="9445752" y="2395728"/>
             <a:ext cx="182880" cy="201168"/>
           </a:xfrm>
           <a:prstGeom prst="rect">
@@ -27662,7 +27734,7 @@
       </p:pic>
       <p:pic>
         <p:nvPicPr>
-          <p:cNvPr id="22" name="normal page 9" descr="/NAS/SJ/POSTECH/nlp/figs/icons/page.png">    </p:cNvPr>
+          <p:cNvPr id="24" name="normal page 9" descr="/NAS/SJ/POSTECH/nlp/figs/icons/page.png">    </p:cNvPr>
           <p:cNvPicPr>
             <a:picLocks noChangeAspect="1"/>
           </p:cNvPicPr>
@@ -27676,7 +27748,7 @@
         </p:blipFill>
         <p:spPr>
           <a:xfrm>
-            <a:off x="9637776" y="2075688"/>
+            <a:off x="9637776" y="2395728"/>
             <a:ext cx="182880" cy="201168"/>
           </a:xfrm>
           <a:prstGeom prst="rect">
@@ -27686,13 +27758,13 @@
       </p:pic>
       <p:sp>
         <p:nvSpPr>
-          <p:cNvPr id="23" name="Text 10"/>
-          <p:cNvSpPr txBox="1"/>
-          <p:nvPr/>
-        </p:nvSpPr>
-        <p:spPr>
-          <a:xfrm>
-            <a:off x="6400800" y="2743200"/>
+          <p:cNvPr id="25" name="Text 12"/>
+          <p:cNvSpPr txBox="1"/>
+          <p:nvPr/>
+        </p:nvSpPr>
+        <p:spPr>
+          <a:xfrm>
+            <a:off x="6400800" y="3063240"/>
             <a:ext cx="1463040" cy="594360"/>
           </a:xfrm>
           <a:prstGeom prst="rect">
@@ -27736,7 +27808,7 @@
       </p:sp>
       <p:pic>
         <p:nvPicPr>
-          <p:cNvPr id="24" name="think hard page 0" descr="/NAS/SJ/POSTECH/nlp/figs/icons/pagehot.png">    </p:cNvPr>
+          <p:cNvPr id="26" name="think hard page 0" descr="/NAS/SJ/POSTECH/nlp/figs/icons/pagehot.png">    </p:cNvPr>
           <p:cNvPicPr>
             <a:picLocks noChangeAspect="1"/>
           </p:cNvPicPr>
@@ -27750,7 +27822,7 @@
         </p:blipFill>
         <p:spPr>
           <a:xfrm>
-            <a:off x="7909560" y="2761488"/>
+            <a:off x="7909560" y="3081528"/>
             <a:ext cx="182880" cy="201168"/>
           </a:xfrm>
           <a:prstGeom prst="rect">
@@ -27760,7 +27832,7 @@
       </p:pic>
       <p:pic>
         <p:nvPicPr>
-          <p:cNvPr id="25" name="think hard page 1" descr="/NAS/SJ/POSTECH/nlp/figs/icons/pagehot.png">    </p:cNvPr>
+          <p:cNvPr id="27" name="think hard page 1" descr="/NAS/SJ/POSTECH/nlp/figs/icons/pagehot.png">    </p:cNvPr>
           <p:cNvPicPr>
             <a:picLocks noChangeAspect="1"/>
           </p:cNvPicPr>
@@ -27774,7 +27846,7 @@
         </p:blipFill>
         <p:spPr>
           <a:xfrm>
-            <a:off x="8101584" y="2761488"/>
+            <a:off x="8101584" y="3081528"/>
             <a:ext cx="182880" cy="201168"/>
           </a:xfrm>
           <a:prstGeom prst="rect">
@@ -27784,7 +27856,7 @@
       </p:pic>
       <p:pic>
         <p:nvPicPr>
-          <p:cNvPr id="26" name="think hard page 2" descr="/NAS/SJ/POSTECH/nlp/figs/icons/pagehot.png">    </p:cNvPr>
+          <p:cNvPr id="28" name="think hard page 2" descr="/NAS/SJ/POSTECH/nlp/figs/icons/pagehot.png">    </p:cNvPr>
           <p:cNvPicPr>
             <a:picLocks noChangeAspect="1"/>
           </p:cNvPicPr>
@@ -27798,7 +27870,7 @@
         </p:blipFill>
         <p:spPr>
           <a:xfrm>
-            <a:off x="8293608" y="2761488"/>
+            <a:off x="8293608" y="3081528"/>
             <a:ext cx="182880" cy="201168"/>
           </a:xfrm>
           <a:prstGeom prst="rect">
@@ -27808,7 +27880,7 @@
       </p:pic>
       <p:pic>
         <p:nvPicPr>
-          <p:cNvPr id="27" name="think hard page 3" descr="/NAS/SJ/POSTECH/nlp/figs/icons/pagehot.png">    </p:cNvPr>
+          <p:cNvPr id="29" name="think hard page 3" descr="/NAS/SJ/POSTECH/nlp/figs/icons/pagehot.png">    </p:cNvPr>
           <p:cNvPicPr>
             <a:picLocks noChangeAspect="1"/>
           </p:cNvPicPr>
@@ -27822,7 +27894,7 @@
         </p:blipFill>
         <p:spPr>
           <a:xfrm>
-            <a:off x="8485632" y="2761488"/>
+            <a:off x="8485632" y="3081528"/>
             <a:ext cx="182880" cy="201168"/>
           </a:xfrm>
           <a:prstGeom prst="rect">
@@ -27832,7 +27904,7 @@
       </p:pic>
       <p:pic>
         <p:nvPicPr>
-          <p:cNvPr id="28" name="think hard page 4" descr="/NAS/SJ/POSTECH/nlp/figs/icons/pagehot.png">    </p:cNvPr>
+          <p:cNvPr id="30" name="think hard page 4" descr="/NAS/SJ/POSTECH/nlp/figs/icons/pagehot.png">    </p:cNvPr>
           <p:cNvPicPr>
             <a:picLocks noChangeAspect="1"/>
           </p:cNvPicPr>
@@ -27846,7 +27918,7 @@
         </p:blipFill>
         <p:spPr>
           <a:xfrm>
-            <a:off x="8677656" y="2761488"/>
+            <a:off x="8677656" y="3081528"/>
             <a:ext cx="182880" cy="201168"/>
           </a:xfrm>
           <a:prstGeom prst="rect">
@@ -27856,7 +27928,7 @@
       </p:pic>
       <p:pic>
         <p:nvPicPr>
-          <p:cNvPr id="29" name="think hard page 5" descr="/NAS/SJ/POSTECH/nlp/figs/icons/pagehot.png">    </p:cNvPr>
+          <p:cNvPr id="31" name="think hard page 5" descr="/NAS/SJ/POSTECH/nlp/figs/icons/pagehot.png">    </p:cNvPr>
           <p:cNvPicPr>
             <a:picLocks noChangeAspect="1"/>
           </p:cNvPicPr>
@@ -27870,7 +27942,7 @@
         </p:blipFill>
         <p:spPr>
           <a:xfrm>
-            <a:off x="8869680" y="2761488"/>
+            <a:off x="8869680" y="3081528"/>
             <a:ext cx="182880" cy="201168"/>
           </a:xfrm>
           <a:prstGeom prst="rect">
@@ -27880,7 +27952,7 @@
       </p:pic>
       <p:pic>
         <p:nvPicPr>
-          <p:cNvPr id="30" name="think hard page 6" descr="/NAS/SJ/POSTECH/nlp/figs/icons/pagehot.png">    </p:cNvPr>
+          <p:cNvPr id="32" name="think hard page 6" descr="/NAS/SJ/POSTECH/nlp/figs/icons/pagehot.png">    </p:cNvPr>
           <p:cNvPicPr>
             <a:picLocks noChangeAspect="1"/>
           </p:cNvPicPr>
@@ -27894,7 +27966,7 @@
         </p:blipFill>
         <p:spPr>
           <a:xfrm>
-            <a:off x="9061704" y="2761488"/>
+            <a:off x="9061704" y="3081528"/>
             <a:ext cx="182880" cy="201168"/>
           </a:xfrm>
           <a:prstGeom prst="rect">
@@ -27904,7 +27976,7 @@
       </p:pic>
       <p:pic>
         <p:nvPicPr>
-          <p:cNvPr id="31" name="think hard page 7" descr="/NAS/SJ/POSTECH/nlp/figs/icons/pagehot.png">    </p:cNvPr>
+          <p:cNvPr id="33" name="think hard page 7" descr="/NAS/SJ/POSTECH/nlp/figs/icons/pagehot.png">    </p:cNvPr>
           <p:cNvPicPr>
             <a:picLocks noChangeAspect="1"/>
           </p:cNvPicPr>
@@ -27918,7 +27990,7 @@
         </p:blipFill>
         <p:spPr>
           <a:xfrm>
-            <a:off x="9253728" y="2761488"/>
+            <a:off x="9253728" y="3081528"/>
             <a:ext cx="182880" cy="201168"/>
           </a:xfrm>
           <a:prstGeom prst="rect">
@@ -27928,7 +28000,7 @@
       </p:pic>
       <p:pic>
         <p:nvPicPr>
-          <p:cNvPr id="32" name="think hard page 8" descr="/NAS/SJ/POSTECH/nlp/figs/icons/pagehot.png">    </p:cNvPr>
+          <p:cNvPr id="34" name="think hard page 8" descr="/NAS/SJ/POSTECH/nlp/figs/icons/pagehot.png">    </p:cNvPr>
           <p:cNvPicPr>
             <a:picLocks noChangeAspect="1"/>
           </p:cNvPicPr>
@@ -27942,7 +28014,7 @@
         </p:blipFill>
         <p:spPr>
           <a:xfrm>
-            <a:off x="9445752" y="2761488"/>
+            <a:off x="9445752" y="3081528"/>
             <a:ext cx="182880" cy="201168"/>
           </a:xfrm>
           <a:prstGeom prst="rect">
@@ -27952,7 +28024,7 @@
       </p:pic>
       <p:pic>
         <p:nvPicPr>
-          <p:cNvPr id="33" name="think hard page 9" descr="/NAS/SJ/POSTECH/nlp/figs/icons/pagehot.png">    </p:cNvPr>
+          <p:cNvPr id="35" name="think hard page 9" descr="/NAS/SJ/POSTECH/nlp/figs/icons/pagehot.png">    </p:cNvPr>
           <p:cNvPicPr>
             <a:picLocks noChangeAspect="1"/>
           </p:cNvPicPr>
@@ -27966,7 +28038,7 @@
         </p:blipFill>
         <p:spPr>
           <a:xfrm>
-            <a:off x="9637776" y="2761488"/>
+            <a:off x="9637776" y="3081528"/>
             <a:ext cx="182880" cy="201168"/>
           </a:xfrm>
           <a:prstGeom prst="rect">
@@ -27976,7 +28048,7 @@
       </p:pic>
       <p:pic>
         <p:nvPicPr>
-          <p:cNvPr id="34" name="think hard page 10" descr="/NAS/SJ/POSTECH/nlp/figs/icons/pagehot.png">    </p:cNvPr>
+          <p:cNvPr id="36" name="think hard page 10" descr="/NAS/SJ/POSTECH/nlp/figs/icons/pagehot.png">    </p:cNvPr>
           <p:cNvPicPr>
             <a:picLocks noChangeAspect="1"/>
           </p:cNvPicPr>
@@ -27990,7 +28062,7 @@
         </p:blipFill>
         <p:spPr>
           <a:xfrm>
-            <a:off x="9829800" y="2761488"/>
+            <a:off x="9829800" y="3081528"/>
             <a:ext cx="182880" cy="201168"/>
           </a:xfrm>
           <a:prstGeom prst="rect">
@@ -28000,7 +28072,7 @@
       </p:pic>
       <p:pic>
         <p:nvPicPr>
-          <p:cNvPr id="35" name="think hard page 11" descr="/NAS/SJ/POSTECH/nlp/figs/icons/pagehot.png">    </p:cNvPr>
+          <p:cNvPr id="37" name="think hard page 11" descr="/NAS/SJ/POSTECH/nlp/figs/icons/pagehot.png">    </p:cNvPr>
           <p:cNvPicPr>
             <a:picLocks noChangeAspect="1"/>
           </p:cNvPicPr>
@@ -28014,7 +28086,7 @@
         </p:blipFill>
         <p:spPr>
           <a:xfrm>
-            <a:off x="10021824" y="2761488"/>
+            <a:off x="10021824" y="3081528"/>
             <a:ext cx="182880" cy="201168"/>
           </a:xfrm>
           <a:prstGeom prst="rect">
@@ -28024,7 +28096,7 @@
       </p:pic>
       <p:pic>
         <p:nvPicPr>
-          <p:cNvPr id="36" name="think hard page 12" descr="/NAS/SJ/POSTECH/nlp/figs/icons/pagehot.png">    </p:cNvPr>
+          <p:cNvPr id="38" name="think hard page 12" descr="/NAS/SJ/POSTECH/nlp/figs/icons/pagehot.png">    </p:cNvPr>
           <p:cNvPicPr>
             <a:picLocks noChangeAspect="1"/>
           </p:cNvPicPr>
@@ -28038,7 +28110,7 @@
         </p:blipFill>
         <p:spPr>
           <a:xfrm>
-            <a:off x="10213848" y="2761488"/>
+            <a:off x="10213848" y="3081528"/>
             <a:ext cx="182880" cy="201168"/>
           </a:xfrm>
           <a:prstGeom prst="rect">
@@ -28048,7 +28120,7 @@
       </p:pic>
       <p:pic>
         <p:nvPicPr>
-          <p:cNvPr id="37" name="think hard page 13" descr="/NAS/SJ/POSTECH/nlp/figs/icons/pagehot.png">    </p:cNvPr>
+          <p:cNvPr id="39" name="think hard page 13" descr="/NAS/SJ/POSTECH/nlp/figs/icons/pagehot.png">    </p:cNvPr>
           <p:cNvPicPr>
             <a:picLocks noChangeAspect="1"/>
           </p:cNvPicPr>
@@ -28062,7 +28134,7 @@
         </p:blipFill>
         <p:spPr>
           <a:xfrm>
-            <a:off x="10405872" y="2761488"/>
+            <a:off x="10405872" y="3081528"/>
             <a:ext cx="182880" cy="201168"/>
           </a:xfrm>
           <a:prstGeom prst="rect">
@@ -28072,7 +28144,7 @@
       </p:pic>
       <p:pic>
         <p:nvPicPr>
-          <p:cNvPr id="38" name="think hard page 14" descr="/NAS/SJ/POSTECH/nlp/figs/icons/pagehot.png">    </p:cNvPr>
+          <p:cNvPr id="40" name="think hard page 14" descr="/NAS/SJ/POSTECH/nlp/figs/icons/pagehot.png">    </p:cNvPr>
           <p:cNvPicPr>
             <a:picLocks noChangeAspect="1"/>
           </p:cNvPicPr>
@@ -28086,7 +28158,7 @@
         </p:blipFill>
         <p:spPr>
           <a:xfrm>
-            <a:off x="10597896" y="2761488"/>
+            <a:off x="10597896" y="3081528"/>
             <a:ext cx="182880" cy="201168"/>
           </a:xfrm>
           <a:prstGeom prst="rect">
@@ -28096,7 +28168,7 @@
       </p:pic>
       <p:pic>
         <p:nvPicPr>
-          <p:cNvPr id="39" name="think hard page 15" descr="/NAS/SJ/POSTECH/nlp/figs/icons/pagehot.png">    </p:cNvPr>
+          <p:cNvPr id="41" name="think hard page 15" descr="/NAS/SJ/POSTECH/nlp/figs/icons/pagehot.png">    </p:cNvPr>
           <p:cNvPicPr>
             <a:picLocks noChangeAspect="1"/>
           </p:cNvPicPr>
@@ -28110,7 +28182,7 @@
         </p:blipFill>
         <p:spPr>
           <a:xfrm>
-            <a:off x="10789920" y="2761488"/>
+            <a:off x="10789920" y="3081528"/>
             <a:ext cx="182880" cy="201168"/>
           </a:xfrm>
           <a:prstGeom prst="rect">
@@ -28120,7 +28192,7 @@
       </p:pic>
       <p:pic>
         <p:nvPicPr>
-          <p:cNvPr id="40" name="think hard page 16" descr="/NAS/SJ/POSTECH/nlp/figs/icons/pagehot.png">    </p:cNvPr>
+          <p:cNvPr id="42" name="think hard page 16" descr="/NAS/SJ/POSTECH/nlp/figs/icons/pagehot.png">    </p:cNvPr>
           <p:cNvPicPr>
             <a:picLocks noChangeAspect="1"/>
           </p:cNvPicPr>
@@ -28134,7 +28206,7 @@
         </p:blipFill>
         <p:spPr>
           <a:xfrm>
-            <a:off x="10981944" y="2761488"/>
+            <a:off x="10981944" y="3081528"/>
             <a:ext cx="182880" cy="201168"/>
           </a:xfrm>
           <a:prstGeom prst="rect">
@@ -28144,7 +28216,7 @@
       </p:pic>
       <p:pic>
         <p:nvPicPr>
-          <p:cNvPr id="41" name="think hard page 17" descr="/NAS/SJ/POSTECH/nlp/figs/icons/pagehot.png">    </p:cNvPr>
+          <p:cNvPr id="43" name="think hard page 17" descr="/NAS/SJ/POSTECH/nlp/figs/icons/pagehot.png">    </p:cNvPr>
           <p:cNvPicPr>
             <a:picLocks noChangeAspect="1"/>
           </p:cNvPicPr>
@@ -28158,7 +28230,7 @@
         </p:blipFill>
         <p:spPr>
           <a:xfrm>
-            <a:off x="11173968" y="2761488"/>
+            <a:off x="11173968" y="3081528"/>
             <a:ext cx="182880" cy="201168"/>
           </a:xfrm>
           <a:prstGeom prst="rect">
@@ -28168,7 +28240,7 @@
       </p:pic>
       <p:pic>
         <p:nvPicPr>
-          <p:cNvPr id="42" name="think hard page 18" descr="/NAS/SJ/POSTECH/nlp/figs/icons/pagehot.png">    </p:cNvPr>
+          <p:cNvPr id="44" name="think hard page 18" descr="/NAS/SJ/POSTECH/nlp/figs/icons/pagehot.png">    </p:cNvPr>
           <p:cNvPicPr>
             <a:picLocks noChangeAspect="1"/>
           </p:cNvPicPr>
@@ -28182,7 +28254,7 @@
         </p:blipFill>
         <p:spPr>
           <a:xfrm>
-            <a:off x="7909560" y="2980944"/>
+            <a:off x="7909560" y="3300984"/>
             <a:ext cx="182880" cy="201168"/>
           </a:xfrm>
           <a:prstGeom prst="rect">
@@ -28192,7 +28264,7 @@
       </p:pic>
       <p:pic>
         <p:nvPicPr>
-          <p:cNvPr id="43" name="think hard page 19" descr="/NAS/SJ/POSTECH/nlp/figs/icons/pagehot.png">    </p:cNvPr>
+          <p:cNvPr id="45" name="think hard page 19" descr="/NAS/SJ/POSTECH/nlp/figs/icons/pagehot.png">    </p:cNvPr>
           <p:cNvPicPr>
             <a:picLocks noChangeAspect="1"/>
           </p:cNvPicPr>
@@ -28206,7 +28278,7 @@
         </p:blipFill>
         <p:spPr>
           <a:xfrm>
-            <a:off x="8101584" y="2980944"/>
+            <a:off x="8101584" y="3300984"/>
             <a:ext cx="182880" cy="201168"/>
           </a:xfrm>
           <a:prstGeom prst="rect">
@@ -28216,7 +28288,7 @@
       </p:pic>
       <p:pic>
         <p:nvPicPr>
-          <p:cNvPr id="44" name="think hard page 20" descr="/NAS/SJ/POSTECH/nlp/figs/icons/pagehot.png">    </p:cNvPr>
+          <p:cNvPr id="46" name="think hard page 20" descr="/NAS/SJ/POSTECH/nlp/figs/icons/pagehot.png">    </p:cNvPr>
           <p:cNvPicPr>
             <a:picLocks noChangeAspect="1"/>
           </p:cNvPicPr>
@@ -28230,7 +28302,7 @@
         </p:blipFill>
         <p:spPr>
           <a:xfrm>
-            <a:off x="8293608" y="2980944"/>
+            <a:off x="8293608" y="3300984"/>
             <a:ext cx="182880" cy="201168"/>
           </a:xfrm>
           <a:prstGeom prst="rect">
@@ -28240,7 +28312,7 @@
       </p:pic>
       <p:pic>
         <p:nvPicPr>
-          <p:cNvPr id="45" name="think hard page 21" descr="/NAS/SJ/POSTECH/nlp/figs/icons/pagehot.png">    </p:cNvPr>
+          <p:cNvPr id="47" name="think hard page 21" descr="/NAS/SJ/POSTECH/nlp/figs/icons/pagehot.png">    </p:cNvPr>
           <p:cNvPicPr>
             <a:picLocks noChangeAspect="1"/>
           </p:cNvPicPr>
@@ -28254,7 +28326,7 @@
         </p:blipFill>
         <p:spPr>
           <a:xfrm>
-            <a:off x="8485632" y="2980944"/>
+            <a:off x="8485632" y="3300984"/>
             <a:ext cx="182880" cy="201168"/>
           </a:xfrm>
           <a:prstGeom prst="rect">
@@ -28264,7 +28336,7 @@
       </p:pic>
       <p:pic>
         <p:nvPicPr>
-          <p:cNvPr id="46" name="think hard page 22" descr="/NAS/SJ/POSTECH/nlp/figs/icons/pagehot.png">    </p:cNvPr>
+          <p:cNvPr id="48" name="think hard page 22" descr="/NAS/SJ/POSTECH/nlp/figs/icons/pagehot.png">    </p:cNvPr>
           <p:cNvPicPr>
             <a:picLocks noChangeAspect="1"/>
           </p:cNvPicPr>
@@ -28278,7 +28350,7 @@
         </p:blipFill>
         <p:spPr>
           <a:xfrm>
-            <a:off x="8677656" y="2980944"/>
+            <a:off x="8677656" y="3300984"/>
             <a:ext cx="182880" cy="201168"/>
           </a:xfrm>
           <a:prstGeom prst="rect">
@@ -28288,7 +28360,7 @@
       </p:pic>
       <p:pic>
         <p:nvPicPr>
-          <p:cNvPr id="47" name="think hard page 23" descr="/NAS/SJ/POSTECH/nlp/figs/icons/pagehot.png">    </p:cNvPr>
+          <p:cNvPr id="49" name="think hard page 23" descr="/NAS/SJ/POSTECH/nlp/figs/icons/pagehot.png">    </p:cNvPr>
           <p:cNvPicPr>
             <a:picLocks noChangeAspect="1"/>
           </p:cNvPicPr>
@@ -28302,7 +28374,7 @@
         </p:blipFill>
         <p:spPr>
           <a:xfrm>
-            <a:off x="8869680" y="2980944"/>
+            <a:off x="8869680" y="3300984"/>
             <a:ext cx="182880" cy="201168"/>
           </a:xfrm>
           <a:prstGeom prst="rect">
@@ -28312,7 +28384,7 @@
       </p:pic>
       <p:pic>
         <p:nvPicPr>
-          <p:cNvPr id="48" name="think hard page 24" descr="/NAS/SJ/POSTECH/nlp/figs/icons/pagehot.png">    </p:cNvPr>
+          <p:cNvPr id="50" name="think hard page 24" descr="/NAS/SJ/POSTECH/nlp/figs/icons/pagehot.png">    </p:cNvPr>
           <p:cNvPicPr>
             <a:picLocks noChangeAspect="1"/>
           </p:cNvPicPr>
@@ -28326,7 +28398,7 @@
         </p:blipFill>
         <p:spPr>
           <a:xfrm>
-            <a:off x="9061704" y="2980944"/>
+            <a:off x="9061704" y="3300984"/>
             <a:ext cx="182880" cy="201168"/>
           </a:xfrm>
           <a:prstGeom prst="rect">
@@ -28336,7 +28408,7 @@
       </p:pic>
       <p:pic>
         <p:nvPicPr>
-          <p:cNvPr id="49" name="think hard page 25" descr="/NAS/SJ/POSTECH/nlp/figs/icons/pagehot.png">    </p:cNvPr>
+          <p:cNvPr id="51" name="think hard page 25" descr="/NAS/SJ/POSTECH/nlp/figs/icons/pagehot.png">    </p:cNvPr>
           <p:cNvPicPr>
             <a:picLocks noChangeAspect="1"/>
           </p:cNvPicPr>
@@ -28350,7 +28422,7 @@
         </p:blipFill>
         <p:spPr>
           <a:xfrm>
-            <a:off x="9253728" y="2980944"/>
+            <a:off x="9253728" y="3300984"/>
             <a:ext cx="182880" cy="201168"/>
           </a:xfrm>
           <a:prstGeom prst="rect">
@@ -28360,7 +28432,7 @@
       </p:pic>
       <p:pic>
         <p:nvPicPr>
-          <p:cNvPr id="50" name="think hard page 26" descr="/NAS/SJ/POSTECH/nlp/figs/icons/pagehot.png">    </p:cNvPr>
+          <p:cNvPr id="52" name="think hard page 26" descr="/NAS/SJ/POSTECH/nlp/figs/icons/pagehot.png">    </p:cNvPr>
           <p:cNvPicPr>
             <a:picLocks noChangeAspect="1"/>
           </p:cNvPicPr>
@@ -28374,7 +28446,7 @@
         </p:blipFill>
         <p:spPr>
           <a:xfrm>
-            <a:off x="9445752" y="2980944"/>
+            <a:off x="9445752" y="3300984"/>
             <a:ext cx="182880" cy="201168"/>
           </a:xfrm>
           <a:prstGeom prst="rect">
@@ -28384,7 +28456,7 @@
       </p:pic>
       <p:pic>
         <p:nvPicPr>
-          <p:cNvPr id="51" name="think hard page 27" descr="/NAS/SJ/POSTECH/nlp/figs/icons/pagehot.png">    </p:cNvPr>
+          <p:cNvPr id="53" name="think hard page 27" descr="/NAS/SJ/POSTECH/nlp/figs/icons/pagehot.png">    </p:cNvPr>
           <p:cNvPicPr>
             <a:picLocks noChangeAspect="1"/>
           </p:cNvPicPr>
@@ -28398,7 +28470,7 @@
         </p:blipFill>
         <p:spPr>
           <a:xfrm>
-            <a:off x="9637776" y="2980944"/>
+            <a:off x="9637776" y="3300984"/>
             <a:ext cx="182880" cy="201168"/>
           </a:xfrm>
           <a:prstGeom prst="rect">
@@ -28408,7 +28480,7 @@
       </p:pic>
       <p:pic>
         <p:nvPicPr>
-          <p:cNvPr id="52" name="think hard page 28" descr="/NAS/SJ/POSTECH/nlp/figs/icons/pagehot.png">    </p:cNvPr>
+          <p:cNvPr id="54" name="think hard page 28" descr="/NAS/SJ/POSTECH/nlp/figs/icons/pagehot.png">    </p:cNvPr>
           <p:cNvPicPr>
             <a:picLocks noChangeAspect="1"/>
           </p:cNvPicPr>
@@ -28422,7 +28494,7 @@
         </p:blipFill>
         <p:spPr>
           <a:xfrm>
-            <a:off x="9829800" y="2980944"/>
+            <a:off x="9829800" y="3300984"/>
             <a:ext cx="182880" cy="201168"/>
           </a:xfrm>
           <a:prstGeom prst="rect">
@@ -28432,7 +28504,7 @@
       </p:pic>
       <p:pic>
         <p:nvPicPr>
-          <p:cNvPr id="53" name="think hard page 29" descr="/NAS/SJ/POSTECH/nlp/figs/icons/pagehot.png">    </p:cNvPr>
+          <p:cNvPr id="55" name="think hard page 29" descr="/NAS/SJ/POSTECH/nlp/figs/icons/pagehot.png">    </p:cNvPr>
           <p:cNvPicPr>
             <a:picLocks noChangeAspect="1"/>
           </p:cNvPicPr>
@@ -28446,7 +28518,7 @@
         </p:blipFill>
         <p:spPr>
           <a:xfrm>
-            <a:off x="10021824" y="2980944"/>
+            <a:off x="10021824" y="3300984"/>
             <a:ext cx="182880" cy="201168"/>
           </a:xfrm>
           <a:prstGeom prst="rect">
@@ -28456,7 +28528,7 @@
       </p:pic>
       <p:pic>
         <p:nvPicPr>
-          <p:cNvPr id="54" name="think hard page 30" descr="/NAS/SJ/POSTECH/nlp/figs/icons/pagehot.png">    </p:cNvPr>
+          <p:cNvPr id="56" name="think hard page 30" descr="/NAS/SJ/POSTECH/nlp/figs/icons/pagehot.png">    </p:cNvPr>
           <p:cNvPicPr>
             <a:picLocks noChangeAspect="1"/>
           </p:cNvPicPr>
@@ -28470,7 +28542,7 @@
         </p:blipFill>
         <p:spPr>
           <a:xfrm>
-            <a:off x="10213848" y="2980944"/>
+            <a:off x="10213848" y="3300984"/>
             <a:ext cx="182880" cy="201168"/>
           </a:xfrm>
           <a:prstGeom prst="rect">
@@ -28480,7 +28552,7 @@
       </p:pic>
       <p:pic>
         <p:nvPicPr>
-          <p:cNvPr id="55" name="think hard page 31" descr="/NAS/SJ/POSTECH/nlp/figs/icons/pagehot.png">    </p:cNvPr>
+          <p:cNvPr id="57" name="think hard page 31" descr="/NAS/SJ/POSTECH/nlp/figs/icons/pagehot.png">    </p:cNvPr>
           <p:cNvPicPr>
             <a:picLocks noChangeAspect="1"/>
           </p:cNvPicPr>
@@ -28494,7 +28566,7 @@
         </p:blipFill>
         <p:spPr>
           <a:xfrm>
-            <a:off x="10405872" y="2980944"/>
+            <a:off x="10405872" y="3300984"/>
             <a:ext cx="182880" cy="201168"/>
           </a:xfrm>
           <a:prstGeom prst="rect">
@@ -28504,7 +28576,7 @@
       </p:pic>
       <p:pic>
         <p:nvPicPr>
-          <p:cNvPr id="56" name="think hard page 32" descr="/NAS/SJ/POSTECH/nlp/figs/icons/pagehot.png">    </p:cNvPr>
+          <p:cNvPr id="58" name="think hard page 32" descr="/NAS/SJ/POSTECH/nlp/figs/icons/pagehot.png">    </p:cNvPr>
           <p:cNvPicPr>
             <a:picLocks noChangeAspect="1"/>
           </p:cNvPicPr>
@@ -28518,7 +28590,7 @@
         </p:blipFill>
         <p:spPr>
           <a:xfrm>
-            <a:off x="10597896" y="2980944"/>
+            <a:off x="10597896" y="3300984"/>
             <a:ext cx="182880" cy="201168"/>
           </a:xfrm>
           <a:prstGeom prst="rect">
@@ -28528,7 +28600,7 @@
       </p:pic>
       <p:pic>
         <p:nvPicPr>
-          <p:cNvPr id="57" name="think hard page 33" descr="/NAS/SJ/POSTECH/nlp/figs/icons/pagehot.png">    </p:cNvPr>
+          <p:cNvPr id="59" name="think hard page 33" descr="/NAS/SJ/POSTECH/nlp/figs/icons/pagehot.png">    </p:cNvPr>
           <p:cNvPicPr>
             <a:picLocks noChangeAspect="1"/>
           </p:cNvPicPr>
@@ -28542,7 +28614,7 @@
         </p:blipFill>
         <p:spPr>
           <a:xfrm>
-            <a:off x="10789920" y="2980944"/>
+            <a:off x="10789920" y="3300984"/>
             <a:ext cx="182880" cy="201168"/>
           </a:xfrm>
           <a:prstGeom prst="rect">
@@ -28552,7 +28624,7 @@
       </p:pic>
       <p:pic>
         <p:nvPicPr>
-          <p:cNvPr id="58" name="think hard page 34" descr="/NAS/SJ/POSTECH/nlp/figs/icons/pagehot.png">    </p:cNvPr>
+          <p:cNvPr id="60" name="think hard page 34" descr="/NAS/SJ/POSTECH/nlp/figs/icons/pagehot.png">    </p:cNvPr>
           <p:cNvPicPr>
             <a:picLocks noChangeAspect="1"/>
           </p:cNvPicPr>
@@ -28566,7 +28638,7 @@
         </p:blipFill>
         <p:spPr>
           <a:xfrm>
-            <a:off x="10981944" y="2980944"/>
+            <a:off x="10981944" y="3300984"/>
             <a:ext cx="182880" cy="201168"/>
           </a:xfrm>
           <a:prstGeom prst="rect">
@@ -28576,7 +28648,7 @@
       </p:pic>
       <p:pic>
         <p:nvPicPr>
-          <p:cNvPr id="59" name="think hard page 35" descr="/NAS/SJ/POSTECH/nlp/figs/icons/pagehot.png">    </p:cNvPr>
+          <p:cNvPr id="61" name="think hard page 35" descr="/NAS/SJ/POSTECH/nlp/figs/icons/pagehot.png">    </p:cNvPr>
           <p:cNvPicPr>
             <a:picLocks noChangeAspect="1"/>
           </p:cNvPicPr>
@@ -28590,7 +28662,7 @@
         </p:blipFill>
         <p:spPr>
           <a:xfrm>
-            <a:off x="11173968" y="2980944"/>
+            <a:off x="11173968" y="3300984"/>
             <a:ext cx="182880" cy="201168"/>
           </a:xfrm>
           <a:prstGeom prst="rect">
@@ -28600,7 +28672,7 @@
       </p:pic>
       <p:pic>
         <p:nvPicPr>
-          <p:cNvPr id="60" name="think hard page 36" descr="/NAS/SJ/POSTECH/nlp/figs/icons/pagehot.png">    </p:cNvPr>
+          <p:cNvPr id="62" name="think hard page 36" descr="/NAS/SJ/POSTECH/nlp/figs/icons/pagehot.png">    </p:cNvPr>
           <p:cNvPicPr>
             <a:picLocks noChangeAspect="1"/>
           </p:cNvPicPr>
@@ -28614,7 +28686,7 @@
         </p:blipFill>
         <p:spPr>
           <a:xfrm>
-            <a:off x="7909560" y="3200400"/>
+            <a:off x="7909560" y="3520440"/>
             <a:ext cx="182880" cy="201168"/>
           </a:xfrm>
           <a:prstGeom prst="rect">
@@ -28624,7 +28696,7 @@
       </p:pic>
       <p:pic>
         <p:nvPicPr>
-          <p:cNvPr id="61" name="think hard page 37" descr="/NAS/SJ/POSTECH/nlp/figs/icons/pagehot.png">    </p:cNvPr>
+          <p:cNvPr id="63" name="think hard page 37" descr="/NAS/SJ/POSTECH/nlp/figs/icons/pagehot.png">    </p:cNvPr>
           <p:cNvPicPr>
             <a:picLocks noChangeAspect="1"/>
           </p:cNvPicPr>
@@ -28638,7 +28710,7 @@
         </p:blipFill>
         <p:spPr>
           <a:xfrm>
-            <a:off x="8101584" y="3200400"/>
+            <a:off x="8101584" y="3520440"/>
             <a:ext cx="182880" cy="201168"/>
           </a:xfrm>
           <a:prstGeom prst="rect">
@@ -28648,7 +28720,7 @@
       </p:pic>
       <p:pic>
         <p:nvPicPr>
-          <p:cNvPr id="62" name="think hard page 38" descr="/NAS/SJ/POSTECH/nlp/figs/icons/pagehot.png">    </p:cNvPr>
+          <p:cNvPr id="64" name="think hard page 38" descr="/NAS/SJ/POSTECH/nlp/figs/icons/pagehot.png">    </p:cNvPr>
           <p:cNvPicPr>
             <a:picLocks noChangeAspect="1"/>
           </p:cNvPicPr>
@@ -28662,7 +28734,7 @@
         </p:blipFill>
         <p:spPr>
           <a:xfrm>
-            <a:off x="8293608" y="3200400"/>
+            <a:off x="8293608" y="3520440"/>
             <a:ext cx="182880" cy="201168"/>
           </a:xfrm>
           <a:prstGeom prst="rect">
@@ -28672,7 +28744,7 @@
       </p:pic>
       <p:pic>
         <p:nvPicPr>
-          <p:cNvPr id="63" name="think hard page 39" descr="/NAS/SJ/POSTECH/nlp/figs/icons/pagehot.png">    </p:cNvPr>
+          <p:cNvPr id="65" name="think hard page 39" descr="/NAS/SJ/POSTECH/nlp/figs/icons/pagehot.png">    </p:cNvPr>
           <p:cNvPicPr>
             <a:picLocks noChangeAspect="1"/>
           </p:cNvPicPr>
@@ -28686,7 +28758,7 @@
         </p:blipFill>
         <p:spPr>
           <a:xfrm>
-            <a:off x="8485632" y="3200400"/>
+            <a:off x="8485632" y="3520440"/>
             <a:ext cx="182880" cy="201168"/>
           </a:xfrm>
           <a:prstGeom prst="rect">
@@ -28696,7 +28768,7 @@
       </p:pic>
       <p:pic>
         <p:nvPicPr>
-          <p:cNvPr id="64" name="think hard page 40" descr="/NAS/SJ/POSTECH/nlp/figs/icons/pagehot.png">    </p:cNvPr>
+          <p:cNvPr id="66" name="think hard page 40" descr="/NAS/SJ/POSTECH/nlp/figs/icons/pagehot.png">    </p:cNvPr>
           <p:cNvPicPr>
             <a:picLocks noChangeAspect="1"/>
           </p:cNvPicPr>
@@ -28710,7 +28782,7 @@
         </p:blipFill>
         <p:spPr>
           <a:xfrm>
-            <a:off x="8677656" y="3200400"/>
+            <a:off x="8677656" y="3520440"/>
             <a:ext cx="182880" cy="201168"/>
           </a:xfrm>
           <a:prstGeom prst="rect">
@@ -28720,7 +28792,7 @@
       </p:pic>
       <p:pic>
         <p:nvPicPr>
-          <p:cNvPr id="65" name="think hard page 41" descr="/NAS/SJ/POSTECH/nlp/figs/icons/pagehot.png">    </p:cNvPr>
+          <p:cNvPr id="67" name="think hard page 41" descr="/NAS/SJ/POSTECH/nlp/figs/icons/pagehot.png">    </p:cNvPr>
           <p:cNvPicPr>
             <a:picLocks noChangeAspect="1"/>
           </p:cNvPicPr>
@@ -28734,7 +28806,7 @@
         </p:blipFill>
         <p:spPr>
           <a:xfrm>
-            <a:off x="8869680" y="3200400"/>
+            <a:off x="8869680" y="3520440"/>
             <a:ext cx="182880" cy="201168"/>
           </a:xfrm>
           <a:prstGeom prst="rect">
@@ -28744,7 +28816,7 @@
       </p:pic>
       <p:pic>
         <p:nvPicPr>
-          <p:cNvPr id="66" name="think hard page 42" descr="/NAS/SJ/POSTECH/nlp/figs/icons/pagehot.png">    </p:cNvPr>
+          <p:cNvPr id="68" name="think hard page 42" descr="/NAS/SJ/POSTECH/nlp/figs/icons/pagehot.png">    </p:cNvPr>
           <p:cNvPicPr>
             <a:picLocks noChangeAspect="1"/>
           </p:cNvPicPr>
@@ -28758,7 +28830,7 @@
         </p:blipFill>
         <p:spPr>
           <a:xfrm>
-            <a:off x="9061704" y="3200400"/>
+            <a:off x="9061704" y="3520440"/>
             <a:ext cx="182880" cy="201168"/>
           </a:xfrm>
           <a:prstGeom prst="rect">
@@ -28768,13 +28840,13 @@
       </p:pic>
       <p:sp>
         <p:nvSpPr>
-          <p:cNvPr id="67" name="Text 11"/>
-          <p:cNvSpPr txBox="1"/>
-          <p:nvPr/>
-        </p:nvSpPr>
-        <p:spPr>
-          <a:xfrm>
-            <a:off x="6400800" y="3794760"/>
+          <p:cNvPr id="69" name="Text 13"/>
+          <p:cNvSpPr txBox="1"/>
+          <p:nvPr/>
+        </p:nvSpPr>
+        <p:spPr>
+          <a:xfrm>
+            <a:off x="6400800" y="4251960"/>
             <a:ext cx="5120640" cy="548640"/>
           </a:xfrm>
           <a:prstGeom prst="rect">
@@ -28802,12 +28874,12 @@
               <a:buNone/>
             </a:pPr>
             <a:r>
-              <a:rPr lang="en-US" sz="1500" dirty="0">
+              <a:rPr lang="en-US" sz="1700" dirty="0">
                 <a:solidFill>
                   <a:schemeClr val="tx1"/>
                 </a:solidFill>
               </a:rPr>
-              <a:t>  for 9 more points  (1 page ≈ 700 tokens)</a:t>
+              <a:t>  for 9 more points</a:t>
             </a:r>
             <a:endParaRPr lang="en-US" sz="1600" dirty="0"/>
           </a:p>
@@ -28815,13 +28887,13 @@
       </p:sp>
       <p:sp>
         <p:nvSpPr>
-          <p:cNvPr id="68" name="our question"/>
+          <p:cNvPr id="70" name="our question"/>
           <p:cNvSpPr/>
           <p:nvPr/>
         </p:nvSpPr>
         <p:spPr>
           <a:xfrm>
-            <a:off x="548640" y="4800600"/>
+            <a:off x="548640" y="5257800"/>
             <a:ext cx="11064240" cy="822960"/>
           </a:xfrm>
           <a:prstGeom prst="roundRect">
@@ -28842,13 +28914,13 @@
       </p:sp>
       <p:sp>
         <p:nvSpPr>
-          <p:cNvPr id="69" name="Text 13"/>
-          <p:cNvSpPr txBox="1"/>
-          <p:nvPr/>
-        </p:nvSpPr>
-        <p:spPr>
-          <a:xfrm>
-            <a:off x="777240" y="4800600"/>
+          <p:cNvPr id="71" name="Text 15"/>
+          <p:cNvSpPr txBox="1"/>
+          <p:nvPr/>
+        </p:nvSpPr>
+        <p:spPr>
+          <a:xfrm>
+            <a:off x="777240" y="5257800"/>
             <a:ext cx="5029200" cy="822960"/>
           </a:xfrm>
           <a:prstGeom prst="rect">
@@ -28878,13 +28950,13 @@
       </p:sp>
       <p:sp>
         <p:nvSpPr>
-          <p:cNvPr id="70" name="option a missing fact"/>
+          <p:cNvPr id="72" name="option a missing fact"/>
           <p:cNvSpPr/>
           <p:nvPr/>
         </p:nvSpPr>
         <p:spPr>
           <a:xfrm>
-            <a:off x="5715000" y="4956048"/>
+            <a:off x="5715000" y="5413248"/>
             <a:ext cx="1828800" cy="502920"/>
           </a:xfrm>
           <a:prstGeom prst="roundRect">
@@ -28905,7 +28977,7 @@
       </p:sp>
       <p:pic>
         <p:nvPicPr>
-          <p:cNvPr id="71" name="icon fact" descr="/NAS/SJ/POSTECH/nlp/figs/icons/fact.png">    </p:cNvPr>
+          <p:cNvPr id="73" name="icon fact" descr="/NAS/SJ/POSTECH/nlp/figs/icons/fact.png">    </p:cNvPr>
           <p:cNvPicPr>
             <a:picLocks noChangeAspect="1"/>
           </p:cNvPicPr>
@@ -28919,7 +28991,7 @@
         </p:blipFill>
         <p:spPr>
           <a:xfrm>
-            <a:off x="5824728" y="5038344"/>
+            <a:off x="5824728" y="5495544"/>
             <a:ext cx="329184" cy="329184"/>
           </a:xfrm>
           <a:prstGeom prst="rect">
@@ -28929,13 +29001,13 @@
       </p:pic>
       <p:sp>
         <p:nvSpPr>
-          <p:cNvPr id="72" name="Text 15"/>
-          <p:cNvSpPr txBox="1"/>
-          <p:nvPr/>
-        </p:nvSpPr>
-        <p:spPr>
-          <a:xfrm>
-            <a:off x="6217920" y="4956048"/>
+          <p:cNvPr id="74" name="Text 17"/>
+          <p:cNvSpPr txBox="1"/>
+          <p:nvPr/>
+        </p:nvSpPr>
+        <p:spPr>
+          <a:xfrm>
+            <a:off x="6217920" y="5413248"/>
             <a:ext cx="1325880" cy="502920"/>
           </a:xfrm>
           <a:prstGeom prst="rect">
@@ -28965,13 +29037,13 @@
       </p:sp>
       <p:sp>
         <p:nvSpPr>
-          <p:cNvPr id="73" name="option a free check"/>
+          <p:cNvPr id="75" name="option a free check"/>
           <p:cNvSpPr/>
           <p:nvPr/>
         </p:nvSpPr>
         <p:spPr>
           <a:xfrm>
-            <a:off x="7680960" y="4956048"/>
+            <a:off x="7680960" y="5413248"/>
             <a:ext cx="1828800" cy="502920"/>
           </a:xfrm>
           <a:prstGeom prst="roundRect">
@@ -28992,7 +29064,7 @@
       </p:sp>
       <p:pic>
         <p:nvPicPr>
-          <p:cNvPr id="74" name="icon check" descr="/NAS/SJ/POSTECH/nlp/figs/icons/check.png">    </p:cNvPr>
+          <p:cNvPr id="76" name="icon check" descr="/NAS/SJ/POSTECH/nlp/figs/icons/check.png">    </p:cNvPr>
           <p:cNvPicPr>
             <a:picLocks noChangeAspect="1"/>
           </p:cNvPicPr>
@@ -29006,7 +29078,7 @@
         </p:blipFill>
         <p:spPr>
           <a:xfrm>
-            <a:off x="7790688" y="5038344"/>
+            <a:off x="7790688" y="5495544"/>
             <a:ext cx="329184" cy="329184"/>
           </a:xfrm>
           <a:prstGeom prst="rect">
@@ -29016,13 +29088,13 @@
       </p:pic>
       <p:sp>
         <p:nvSpPr>
-          <p:cNvPr id="75" name="Text 17"/>
-          <p:cNvSpPr txBox="1"/>
-          <p:nvPr/>
-        </p:nvSpPr>
-        <p:spPr>
-          <a:xfrm>
-            <a:off x="8183880" y="4956048"/>
+          <p:cNvPr id="77" name="Text 19"/>
+          <p:cNvSpPr txBox="1"/>
+          <p:nvPr/>
+        </p:nvSpPr>
+        <p:spPr>
+          <a:xfrm>
+            <a:off x="8183880" y="5413248"/>
             <a:ext cx="1325880" cy="502920"/>
           </a:xfrm>
           <a:prstGeom prst="rect">
@@ -29052,13 +29124,13 @@
       </p:sp>
       <p:sp>
         <p:nvSpPr>
-          <p:cNvPr id="76" name="option more thinking"/>
+          <p:cNvPr id="78" name="option more thinking"/>
           <p:cNvSpPr/>
           <p:nvPr/>
         </p:nvSpPr>
         <p:spPr>
           <a:xfrm>
-            <a:off x="9646920" y="4956048"/>
+            <a:off x="9646920" y="5413248"/>
             <a:ext cx="1828800" cy="502920"/>
           </a:xfrm>
           <a:prstGeom prst="roundRect">
@@ -29079,7 +29151,7 @@
       </p:sp>
       <p:pic>
         <p:nvPicPr>
-          <p:cNvPr id="77" name="icon brain" descr="/NAS/SJ/POSTECH/nlp/figs/icons/brain.png">    </p:cNvPr>
+          <p:cNvPr id="79" name="icon brain" descr="/NAS/SJ/POSTECH/nlp/figs/icons/brain.png">    </p:cNvPr>
           <p:cNvPicPr>
             <a:picLocks noChangeAspect="1"/>
           </p:cNvPicPr>
@@ -29093,7 +29165,7 @@
         </p:blipFill>
         <p:spPr>
           <a:xfrm>
-            <a:off x="9756648" y="5038344"/>
+            <a:off x="9756648" y="5495544"/>
             <a:ext cx="329184" cy="329184"/>
           </a:xfrm>
           <a:prstGeom prst="rect">
@@ -29103,13 +29175,13 @@
       </p:pic>
       <p:sp>
         <p:nvSpPr>
-          <p:cNvPr id="78" name="Text 19"/>
-          <p:cNvSpPr txBox="1"/>
-          <p:nvPr/>
-        </p:nvSpPr>
-        <p:spPr>
-          <a:xfrm>
-            <a:off x="10149840" y="4956048"/>
+          <p:cNvPr id="80" name="Text 21"/>
+          <p:cNvSpPr txBox="1"/>
+          <p:nvPr/>
+        </p:nvSpPr>
+        <p:spPr>
+          <a:xfrm>
+            <a:off x="10149840" y="5413248"/>
             <a:ext cx="1325880" cy="502920"/>
           </a:xfrm>
           <a:prstGeom prst="rect">
@@ -30594,7 +30666,7 @@
         </p:nvSpPr>
         <p:spPr>
           <a:xfrm>
-            <a:off x="777240" y="3291840"/>
+            <a:off x="777240" y="3246120"/>
             <a:ext cx="4983480" cy="365760"/>
           </a:xfrm>
           <a:prstGeom prst="rect">
@@ -30611,12 +30683,48 @@
               <a:buNone/>
             </a:pPr>
             <a:r>
+              <a:rPr lang="en-US" sz="1500" b="1" dirty="0">
+                <a:solidFill>
+                  <a:schemeClr val="tx1"/>
+                </a:solidFill>
+              </a:rPr>
+              <a:t>311 contest problems (gpt-oss-120b)</a:t>
+            </a:r>
+            <a:endParaRPr lang="en-US" sz="1500" dirty="0"/>
+          </a:p>
+        </p:txBody>
+      </p:sp>
+      <p:sp>
+        <p:nvSpPr>
+          <p:cNvPr id="13" name="Text 10"/>
+          <p:cNvSpPr txBox="1"/>
+          <p:nvPr/>
+        </p:nvSpPr>
+        <p:spPr>
+          <a:xfrm>
+            <a:off x="2651760" y="3657600"/>
+            <a:ext cx="822960" cy="320040"/>
+          </a:xfrm>
+          <a:prstGeom prst="rect">
+            <a:avLst/>
+          </a:prstGeom>
+          <a:noFill/>
+          <a:ln/>
+        </p:spPr>
+        <p:txBody>
+          <a:bodyPr wrap="square" lIns="0" tIns="0" rIns="0" bIns="0" rtlCol="0" anchor="ctr"/>
+          <a:lstStyle/>
+          <a:p>
+            <a:pPr algn="ctr" indent="0" marL="0">
+              <a:buNone/>
+            </a:pPr>
+            <a:r>
               <a:rPr lang="en-US" sz="1400" dirty="0">
                 <a:solidFill>
-                  <a:schemeClr val="tx2"/>
-                </a:solidFill>
-              </a:rPr>
-              <a:t>311 contest problems (gpt-oss-120b), tokens per problem:</a:t>
+                  <a:srgbClr val="7F7F7F"/>
+                </a:solidFill>
+              </a:rPr>
+              <a:t>solved</a:t>
             </a:r>
             <a:endParaRPr lang="en-US" sz="1400" dirty="0"/>
           </a:p>
@@ -30624,14 +30732,14 @@
       </p:sp>
       <p:sp>
         <p:nvSpPr>
-          <p:cNvPr id="13" name="Text 10"/>
-          <p:cNvSpPr txBox="1"/>
-          <p:nvPr/>
-        </p:nvSpPr>
-        <p:spPr>
-          <a:xfrm>
-            <a:off x="777240" y="3703320"/>
-            <a:ext cx="2011680" cy="457200"/>
+          <p:cNvPr id="14" name="Text 11"/>
+          <p:cNvSpPr txBox="1"/>
+          <p:nvPr/>
+        </p:nvSpPr>
+        <p:spPr>
+          <a:xfrm>
+            <a:off x="3566160" y="3657600"/>
+            <a:ext cx="2194560" cy="320040"/>
           </a:xfrm>
           <a:prstGeom prst="rect">
             <a:avLst/>
@@ -30643,30 +30751,102 @@
           <a:bodyPr wrap="square" lIns="0" tIns="0" rIns="0" bIns="0" rtlCol="0" anchor="ctr"/>
           <a:lstStyle/>
           <a:p>
+            <a:pPr indent="0" marL="0">
+              <a:buNone/>
+            </a:pPr>
+            <a:r>
+              <a:rPr lang="en-US" sz="1400" dirty="0">
+                <a:solidFill>
+                  <a:srgbClr val="7F7F7F"/>
+                </a:solidFill>
+              </a:rPr>
+              <a:t>tokens per problem</a:t>
+            </a:r>
+            <a:endParaRPr lang="en-US" sz="1400" dirty="0"/>
+          </a:p>
+        </p:txBody>
+      </p:sp>
+      <p:sp>
+        <p:nvSpPr>
+          <p:cNvPr id="15" name="Text 12"/>
+          <p:cNvSpPr txBox="1"/>
+          <p:nvPr/>
+        </p:nvSpPr>
+        <p:spPr>
+          <a:xfrm>
+            <a:off x="777240" y="4023360"/>
+            <a:ext cx="1783080" cy="457200"/>
+          </a:xfrm>
+          <a:prstGeom prst="rect">
+            <a:avLst/>
+          </a:prstGeom>
+          <a:noFill/>
+          <a:ln/>
+        </p:spPr>
+        <p:txBody>
+          <a:bodyPr wrap="square" lIns="0" tIns="0" rIns="0" bIns="0" rtlCol="0" anchor="ctr"/>
+          <a:lstStyle/>
+          <a:p>
             <a:pPr algn="r" indent="0" marL="0">
               <a:buNone/>
             </a:pPr>
             <a:r>
-              <a:rPr lang="en-US" sz="1400" dirty="0">
+              <a:rPr lang="en-US" sz="1500" dirty="0">
                 <a:solidFill>
                   <a:schemeClr val="tx1"/>
                 </a:solidFill>
               </a:rPr>
               <a:t>always think hard</a:t>
             </a:r>
-            <a:endParaRPr lang="en-US" sz="1400" dirty="0"/>
-          </a:p>
-        </p:txBody>
-      </p:sp>
-      <p:sp>
-        <p:nvSpPr>
-          <p:cNvPr id="14" name="Check A: the problem's own examples always think hard"/>
+            <a:endParaRPr lang="en-US" sz="1500" dirty="0"/>
+          </a:p>
+        </p:txBody>
+      </p:sp>
+      <p:sp>
+        <p:nvSpPr>
+          <p:cNvPr id="16" name="Text 13"/>
+          <p:cNvSpPr txBox="1"/>
+          <p:nvPr/>
+        </p:nvSpPr>
+        <p:spPr>
+          <a:xfrm>
+            <a:off x="2651760" y="4023360"/>
+            <a:ext cx="822960" cy="457200"/>
+          </a:xfrm>
+          <a:prstGeom prst="rect">
+            <a:avLst/>
+          </a:prstGeom>
+          <a:noFill/>
+          <a:ln/>
+        </p:spPr>
+        <p:txBody>
+          <a:bodyPr wrap="square" lIns="0" tIns="0" rIns="0" bIns="0" rtlCol="0" anchor="ctr"/>
+          <a:lstStyle/>
+          <a:p>
+            <a:pPr algn="ctr" indent="0" marL="0">
+              <a:buNone/>
+            </a:pPr>
+            <a:r>
+              <a:rPr lang="en-US" sz="1700" b="1" dirty="0">
+                <a:solidFill>
+                  <a:srgbClr val="7F7F7F"/>
+                </a:solidFill>
+              </a:rPr>
+              <a:t>66.2%</a:t>
+            </a:r>
+            <a:endParaRPr lang="en-US" sz="1700" dirty="0"/>
+          </a:p>
+        </p:txBody>
+      </p:sp>
+      <p:sp>
+        <p:nvSpPr>
+          <p:cNvPr id="17" name="tokens always think hard"/>
           <p:cNvSpPr/>
           <p:nvPr/>
         </p:nvSpPr>
         <p:spPr>
           <a:xfrm>
-            <a:off x="2880360" y="3813048"/>
+            <a:off x="3566160" y="4123944"/>
             <a:ext cx="1463040" cy="256032"/>
           </a:xfrm>
           <a:prstGeom prst="rect">
@@ -30685,14 +30865,14 @@
       </p:sp>
       <p:sp>
         <p:nvSpPr>
-          <p:cNvPr id="15" name="Text 12"/>
-          <p:cNvSpPr txBox="1"/>
-          <p:nvPr/>
-        </p:nvSpPr>
-        <p:spPr>
-          <a:xfrm>
-            <a:off x="4434840" y="3703320"/>
-            <a:ext cx="1463040" cy="457200"/>
+          <p:cNvPr id="18" name="Text 15"/>
+          <p:cNvSpPr txBox="1"/>
+          <p:nvPr/>
+        </p:nvSpPr>
+        <p:spPr>
+          <a:xfrm>
+            <a:off x="5120640" y="4023360"/>
+            <a:ext cx="731520" cy="457200"/>
           </a:xfrm>
           <a:prstGeom prst="rect">
             <a:avLst/>
@@ -30713,7 +30893,7 @@
                   <a:srgbClr val="7F7F7F"/>
                 </a:solidFill>
               </a:rPr>
-              <a:t>66.2% · 30k</a:t>
+              <a:t>30k</a:t>
             </a:r>
             <a:endParaRPr lang="en-US" sz="1500" dirty="0"/>
           </a:p>
@@ -30721,14 +30901,14 @@
       </p:sp>
       <p:sp>
         <p:nvSpPr>
-          <p:cNvPr id="16" name="Text 13"/>
-          <p:cNvSpPr txBox="1"/>
-          <p:nvPr/>
-        </p:nvSpPr>
-        <p:spPr>
-          <a:xfrm>
-            <a:off x="777240" y="4251960"/>
-            <a:ext cx="2011680" cy="457200"/>
+          <p:cNvPr id="19" name="Text 16"/>
+          <p:cNvSpPr txBox="1"/>
+          <p:nvPr/>
+        </p:nvSpPr>
+        <p:spPr>
+          <a:xfrm>
+            <a:off x="777240" y="4553712"/>
+            <a:ext cx="1783080" cy="457200"/>
           </a:xfrm>
           <a:prstGeom prst="rect">
             <a:avLst/>
@@ -30744,27 +30924,63 @@
               <a:buNone/>
             </a:pPr>
             <a:r>
-              <a:rPr lang="en-US" sz="1400" dirty="0">
+              <a:rPr lang="en-US" sz="1500" dirty="0">
                 <a:solidFill>
                   <a:schemeClr val="tx1"/>
                 </a:solidFill>
               </a:rPr>
               <a:t>only on failure</a:t>
             </a:r>
-            <a:endParaRPr lang="en-US" sz="1400" dirty="0"/>
-          </a:p>
-        </p:txBody>
-      </p:sp>
-      <p:sp>
-        <p:nvSpPr>
-          <p:cNvPr id="17" name="Check A: the problem's own examples only on failure"/>
+            <a:endParaRPr lang="en-US" sz="1500" dirty="0"/>
+          </a:p>
+        </p:txBody>
+      </p:sp>
+      <p:sp>
+        <p:nvSpPr>
+          <p:cNvPr id="20" name="Text 17"/>
+          <p:cNvSpPr txBox="1"/>
+          <p:nvPr/>
+        </p:nvSpPr>
+        <p:spPr>
+          <a:xfrm>
+            <a:off x="2651760" y="4553712"/>
+            <a:ext cx="822960" cy="457200"/>
+          </a:xfrm>
+          <a:prstGeom prst="rect">
+            <a:avLst/>
+          </a:prstGeom>
+          <a:noFill/>
+          <a:ln/>
+        </p:spPr>
+        <p:txBody>
+          <a:bodyPr wrap="square" lIns="0" tIns="0" rIns="0" bIns="0" rtlCol="0" anchor="ctr"/>
+          <a:lstStyle/>
+          <a:p>
+            <a:pPr algn="ctr" indent="0" marL="0">
+              <a:buNone/>
+            </a:pPr>
+            <a:r>
+              <a:rPr lang="en-US" sz="1700" b="1" dirty="0">
+                <a:solidFill>
+                  <a:srgbClr val="4472C4"/>
+                </a:solidFill>
+              </a:rPr>
+              <a:t>66.3%</a:t>
+            </a:r>
+            <a:endParaRPr lang="en-US" sz="1700" dirty="0"/>
+          </a:p>
+        </p:txBody>
+      </p:sp>
+      <p:sp>
+        <p:nvSpPr>
+          <p:cNvPr id="21" name="tokens only on failure"/>
           <p:cNvSpPr/>
           <p:nvPr/>
         </p:nvSpPr>
         <p:spPr>
           <a:xfrm>
-            <a:off x="2880360" y="4361688"/>
-            <a:ext cx="1199693" cy="256032"/>
+            <a:off x="3566160" y="4654296"/>
+            <a:ext cx="1200568" cy="256032"/>
           </a:xfrm>
           <a:prstGeom prst="rect">
             <a:avLst/>
@@ -30782,14 +30998,14 @@
       </p:sp>
       <p:sp>
         <p:nvSpPr>
-          <p:cNvPr id="18" name="Text 15"/>
-          <p:cNvSpPr txBox="1"/>
-          <p:nvPr/>
-        </p:nvSpPr>
-        <p:spPr>
-          <a:xfrm>
-            <a:off x="4171493" y="4251960"/>
-            <a:ext cx="1463040" cy="457200"/>
+          <p:cNvPr id="22" name="Text 19"/>
+          <p:cNvSpPr txBox="1"/>
+          <p:nvPr/>
+        </p:nvSpPr>
+        <p:spPr>
+          <a:xfrm>
+            <a:off x="4858168" y="4553712"/>
+            <a:ext cx="731520" cy="457200"/>
           </a:xfrm>
           <a:prstGeom prst="rect">
             <a:avLst/>
@@ -30810,7 +31026,7 @@
                   <a:srgbClr val="4472C4"/>
                 </a:solidFill>
               </a:rPr>
-              <a:t>66.3% · 25k</a:t>
+              <a:t>25k</a:t>
             </a:r>
             <a:endParaRPr lang="en-US" sz="1500" dirty="0"/>
           </a:p>
@@ -30818,7 +31034,7 @@
       </p:sp>
       <p:sp>
         <p:nvSpPr>
-          <p:cNvPr id="19" name="Check B: two versions must agree"/>
+          <p:cNvPr id="23" name="Check B: two versions must agree"/>
           <p:cNvSpPr/>
           <p:nvPr/>
         </p:nvSpPr>
@@ -30845,7 +31061,7 @@
       </p:sp>
       <p:sp>
         <p:nvSpPr>
-          <p:cNvPr id="20" name="Text 17"/>
+          <p:cNvPr id="24" name="Text 21"/>
           <p:cNvSpPr txBox="1"/>
           <p:nvPr/>
         </p:nvSpPr>
@@ -30881,7 +31097,7 @@
       </p:sp>
       <p:sp>
         <p:nvSpPr>
-          <p:cNvPr id="21" name="box program A (task only"/>
+          <p:cNvPr id="25" name="box program A (task only"/>
           <p:cNvSpPr/>
           <p:nvPr/>
         </p:nvSpPr>
@@ -30908,7 +31124,7 @@
       </p:sp>
       <p:sp>
         <p:nvSpPr>
-          <p:cNvPr id="22" name="Text 19"/>
+          <p:cNvPr id="26" name="Text 23"/>
           <p:cNvSpPr txBox="1"/>
           <p:nvPr/>
         </p:nvSpPr>
@@ -30944,7 +31160,7 @@
       </p:sp>
       <p:sp>
         <p:nvSpPr>
-          <p:cNvPr id="23" name="box program B (+ helper "/>
+          <p:cNvPr id="27" name="box program B (+ helper "/>
           <p:cNvSpPr/>
           <p:nvPr/>
         </p:nvSpPr>
@@ -30971,7 +31187,7 @@
       </p:sp>
       <p:sp>
         <p:nvSpPr>
-          <p:cNvPr id="24" name="Text 21"/>
+          <p:cNvPr id="28" name="Text 25"/>
           <p:cNvSpPr txBox="1"/>
           <p:nvPr/>
         </p:nvSpPr>
@@ -31007,13 +31223,13 @@
       </p:sp>
       <p:sp>
         <p:nvSpPr>
-          <p:cNvPr id="25" name="Text 22"/>
-          <p:cNvSpPr txBox="1"/>
-          <p:nvPr/>
-        </p:nvSpPr>
-        <p:spPr>
-          <a:xfrm>
-            <a:off x="6400800" y="3291840"/>
+          <p:cNvPr id="29" name="Text 26"/>
+          <p:cNvSpPr txBox="1"/>
+          <p:nvPr/>
+        </p:nvSpPr>
+        <p:spPr>
+          <a:xfrm>
+            <a:off x="6400800" y="3246120"/>
             <a:ext cx="4983480" cy="365760"/>
           </a:xfrm>
           <a:prstGeom prst="rect">
@@ -31030,12 +31246,48 @@
               <a:buNone/>
             </a:pPr>
             <a:r>
+              <a:rPr lang="en-US" sz="1500" b="1" dirty="0">
+                <a:solidFill>
+                  <a:schemeClr val="tx1"/>
+                </a:solidFill>
+              </a:rPr>
+              <a:t>108 geometry problems (Qwen3-32B, 3 runs)</a:t>
+            </a:r>
+            <a:endParaRPr lang="en-US" sz="1500" dirty="0"/>
+          </a:p>
+        </p:txBody>
+      </p:sp>
+      <p:sp>
+        <p:nvSpPr>
+          <p:cNvPr id="30" name="Text 27"/>
+          <p:cNvSpPr txBox="1"/>
+          <p:nvPr/>
+        </p:nvSpPr>
+        <p:spPr>
+          <a:xfrm>
+            <a:off x="8275320" y="3657600"/>
+            <a:ext cx="822960" cy="320040"/>
+          </a:xfrm>
+          <a:prstGeom prst="rect">
+            <a:avLst/>
+          </a:prstGeom>
+          <a:noFill/>
+          <a:ln/>
+        </p:spPr>
+        <p:txBody>
+          <a:bodyPr wrap="square" lIns="0" tIns="0" rIns="0" bIns="0" rtlCol="0" anchor="ctr"/>
+          <a:lstStyle/>
+          <a:p>
+            <a:pPr algn="ctr" indent="0" marL="0">
+              <a:buNone/>
+            </a:pPr>
+            <a:r>
               <a:rPr lang="en-US" sz="1400" dirty="0">
                 <a:solidFill>
-                  <a:schemeClr val="tx2"/>
-                </a:solidFill>
-              </a:rPr>
-              <a:t>108 geometry problems (Qwen3-32B, 3 runs):</a:t>
+                  <a:srgbClr val="7F7F7F"/>
+                </a:solidFill>
+              </a:rPr>
+              <a:t>solved</a:t>
             </a:r>
             <a:endParaRPr lang="en-US" sz="1400" dirty="0"/>
           </a:p>
@@ -31043,14 +31295,14 @@
       </p:sp>
       <p:sp>
         <p:nvSpPr>
-          <p:cNvPr id="26" name="Text 23"/>
-          <p:cNvSpPr txBox="1"/>
-          <p:nvPr/>
-        </p:nvSpPr>
-        <p:spPr>
-          <a:xfrm>
-            <a:off x="6400800" y="3703320"/>
-            <a:ext cx="2011680" cy="457200"/>
+          <p:cNvPr id="31" name="Text 28"/>
+          <p:cNvSpPr txBox="1"/>
+          <p:nvPr/>
+        </p:nvSpPr>
+        <p:spPr>
+          <a:xfrm>
+            <a:off x="9189720" y="3657600"/>
+            <a:ext cx="2194560" cy="320040"/>
           </a:xfrm>
           <a:prstGeom prst="rect">
             <a:avLst/>
@@ -31062,30 +31314,102 @@
           <a:bodyPr wrap="square" lIns="0" tIns="0" rIns="0" bIns="0" rtlCol="0" anchor="ctr"/>
           <a:lstStyle/>
           <a:p>
+            <a:pPr indent="0" marL="0">
+              <a:buNone/>
+            </a:pPr>
+            <a:r>
+              <a:rPr lang="en-US" sz="1400" dirty="0">
+                <a:solidFill>
+                  <a:srgbClr val="7F7F7F"/>
+                </a:solidFill>
+              </a:rPr>
+              <a:t>tokens per problem</a:t>
+            </a:r>
+            <a:endParaRPr lang="en-US" sz="1400" dirty="0"/>
+          </a:p>
+        </p:txBody>
+      </p:sp>
+      <p:sp>
+        <p:nvSpPr>
+          <p:cNvPr id="32" name="Text 29"/>
+          <p:cNvSpPr txBox="1"/>
+          <p:nvPr/>
+        </p:nvSpPr>
+        <p:spPr>
+          <a:xfrm>
+            <a:off x="6400800" y="4023360"/>
+            <a:ext cx="1783080" cy="457200"/>
+          </a:xfrm>
+          <a:prstGeom prst="rect">
+            <a:avLst/>
+          </a:prstGeom>
+          <a:noFill/>
+          <a:ln/>
+        </p:spPr>
+        <p:txBody>
+          <a:bodyPr wrap="square" lIns="0" tIns="0" rIns="0" bIns="0" rtlCol="0" anchor="ctr"/>
+          <a:lstStyle/>
+          <a:p>
             <a:pPr algn="r" indent="0" marL="0">
               <a:buNone/>
             </a:pPr>
             <a:r>
-              <a:rPr lang="en-US" sz="1400" dirty="0">
+              <a:rPr lang="en-US" sz="1500" dirty="0">
                 <a:solidFill>
                   <a:schemeClr val="tx1"/>
                 </a:solidFill>
               </a:rPr>
               <a:t>always think</a:t>
             </a:r>
-            <a:endParaRPr lang="en-US" sz="1400" dirty="0"/>
-          </a:p>
-        </p:txBody>
-      </p:sp>
-      <p:sp>
-        <p:nvSpPr>
-          <p:cNvPr id="27" name="Check B: two versions must agree always think"/>
+            <a:endParaRPr lang="en-US" sz="1500" dirty="0"/>
+          </a:p>
+        </p:txBody>
+      </p:sp>
+      <p:sp>
+        <p:nvSpPr>
+          <p:cNvPr id="33" name="Text 30"/>
+          <p:cNvSpPr txBox="1"/>
+          <p:nvPr/>
+        </p:nvSpPr>
+        <p:spPr>
+          <a:xfrm>
+            <a:off x="8275320" y="4023360"/>
+            <a:ext cx="822960" cy="457200"/>
+          </a:xfrm>
+          <a:prstGeom prst="rect">
+            <a:avLst/>
+          </a:prstGeom>
+          <a:noFill/>
+          <a:ln/>
+        </p:spPr>
+        <p:txBody>
+          <a:bodyPr wrap="square" lIns="0" tIns="0" rIns="0" bIns="0" rtlCol="0" anchor="ctr"/>
+          <a:lstStyle/>
+          <a:p>
+            <a:pPr algn="ctr" indent="0" marL="0">
+              <a:buNone/>
+            </a:pPr>
+            <a:r>
+              <a:rPr lang="en-US" sz="1700" b="1" dirty="0">
+                <a:solidFill>
+                  <a:srgbClr val="7F7F7F"/>
+                </a:solidFill>
+              </a:rPr>
+              <a:t>98%</a:t>
+            </a:r>
+            <a:endParaRPr lang="en-US" sz="1700" dirty="0"/>
+          </a:p>
+        </p:txBody>
+      </p:sp>
+      <p:sp>
+        <p:nvSpPr>
+          <p:cNvPr id="34" name="tokens always think"/>
           <p:cNvSpPr/>
           <p:nvPr/>
         </p:nvSpPr>
         <p:spPr>
           <a:xfrm>
-            <a:off x="8503920" y="3813048"/>
+            <a:off x="9189720" y="4123944"/>
             <a:ext cx="1463040" cy="256032"/>
           </a:xfrm>
           <a:prstGeom prst="rect">
@@ -31104,14 +31428,14 @@
       </p:sp>
       <p:sp>
         <p:nvSpPr>
-          <p:cNvPr id="28" name="Text 25"/>
-          <p:cNvSpPr txBox="1"/>
-          <p:nvPr/>
-        </p:nvSpPr>
-        <p:spPr>
-          <a:xfrm>
-            <a:off x="10058400" y="3703320"/>
-            <a:ext cx="1463040" cy="457200"/>
+          <p:cNvPr id="35" name="Text 32"/>
+          <p:cNvSpPr txBox="1"/>
+          <p:nvPr/>
+        </p:nvSpPr>
+        <p:spPr>
+          <a:xfrm>
+            <a:off x="10744200" y="4023360"/>
+            <a:ext cx="731520" cy="457200"/>
           </a:xfrm>
           <a:prstGeom prst="rect">
             <a:avLst/>
@@ -31132,7 +31456,7 @@
                   <a:srgbClr val="7F7F7F"/>
                 </a:solidFill>
               </a:rPr>
-              <a:t>98% · 5.9k</a:t>
+              <a:t>5.9k</a:t>
             </a:r>
             <a:endParaRPr lang="en-US" sz="1500" dirty="0"/>
           </a:p>
@@ -31140,14 +31464,14 @@
       </p:sp>
       <p:sp>
         <p:nvSpPr>
-          <p:cNvPr id="29" name="Text 26"/>
-          <p:cNvSpPr txBox="1"/>
-          <p:nvPr/>
-        </p:nvSpPr>
-        <p:spPr>
-          <a:xfrm>
-            <a:off x="6400800" y="4251960"/>
-            <a:ext cx="2011680" cy="457200"/>
+          <p:cNvPr id="36" name="Text 33"/>
+          <p:cNvSpPr txBox="1"/>
+          <p:nvPr/>
+        </p:nvSpPr>
+        <p:spPr>
+          <a:xfrm>
+            <a:off x="6400800" y="4553712"/>
+            <a:ext cx="1783080" cy="457200"/>
           </a:xfrm>
           <a:prstGeom prst="rect">
             <a:avLst/>
@@ -31163,27 +31487,63 @@
               <a:buNone/>
             </a:pPr>
             <a:r>
-              <a:rPr lang="en-US" sz="1400" dirty="0">
+              <a:rPr lang="en-US" sz="1500" dirty="0">
                 <a:solidFill>
                   <a:schemeClr val="tx1"/>
                 </a:solidFill>
               </a:rPr>
               <a:t>only if they differ</a:t>
             </a:r>
-            <a:endParaRPr lang="en-US" sz="1400" dirty="0"/>
-          </a:p>
-        </p:txBody>
-      </p:sp>
-      <p:sp>
-        <p:nvSpPr>
-          <p:cNvPr id="30" name="Check B: two versions must agree only if they differ"/>
+            <a:endParaRPr lang="en-US" sz="1500" dirty="0"/>
+          </a:p>
+        </p:txBody>
+      </p:sp>
+      <p:sp>
+        <p:nvSpPr>
+          <p:cNvPr id="37" name="Text 34"/>
+          <p:cNvSpPr txBox="1"/>
+          <p:nvPr/>
+        </p:nvSpPr>
+        <p:spPr>
+          <a:xfrm>
+            <a:off x="8275320" y="4553712"/>
+            <a:ext cx="822960" cy="457200"/>
+          </a:xfrm>
+          <a:prstGeom prst="rect">
+            <a:avLst/>
+          </a:prstGeom>
+          <a:noFill/>
+          <a:ln/>
+        </p:spPr>
+        <p:txBody>
+          <a:bodyPr wrap="square" lIns="0" tIns="0" rIns="0" bIns="0" rtlCol="0" anchor="ctr"/>
+          <a:lstStyle/>
+          <a:p>
+            <a:pPr algn="ctr" indent="0" marL="0">
+              <a:buNone/>
+            </a:pPr>
+            <a:r>
+              <a:rPr lang="en-US" sz="1700" b="1" dirty="0">
+                <a:solidFill>
+                  <a:srgbClr val="4472C4"/>
+                </a:solidFill>
+              </a:rPr>
+              <a:t>99%</a:t>
+            </a:r>
+            <a:endParaRPr lang="en-US" sz="1700" dirty="0"/>
+          </a:p>
+        </p:txBody>
+      </p:sp>
+      <p:sp>
+        <p:nvSpPr>
+          <p:cNvPr id="38" name="tokens only if they differ"/>
           <p:cNvSpPr/>
           <p:nvPr/>
         </p:nvSpPr>
         <p:spPr>
           <a:xfrm>
-            <a:off x="8503920" y="4361688"/>
-            <a:ext cx="1068019" cy="256032"/>
+            <a:off x="9189720" y="4654296"/>
+            <a:ext cx="1066283" cy="256032"/>
           </a:xfrm>
           <a:prstGeom prst="rect">
             <a:avLst/>
@@ -31201,14 +31561,14 @@
       </p:sp>
       <p:sp>
         <p:nvSpPr>
-          <p:cNvPr id="31" name="Text 28"/>
-          <p:cNvSpPr txBox="1"/>
-          <p:nvPr/>
-        </p:nvSpPr>
-        <p:spPr>
-          <a:xfrm>
-            <a:off x="9663379" y="4251960"/>
-            <a:ext cx="1463040" cy="457200"/>
+          <p:cNvPr id="39" name="Text 36"/>
+          <p:cNvSpPr txBox="1"/>
+          <p:nvPr/>
+        </p:nvSpPr>
+        <p:spPr>
+          <a:xfrm>
+            <a:off x="10347443" y="4553712"/>
+            <a:ext cx="731520" cy="457200"/>
           </a:xfrm>
           <a:prstGeom prst="rect">
             <a:avLst/>
@@ -31229,7 +31589,7 @@
                   <a:srgbClr val="4472C4"/>
                 </a:solidFill>
               </a:rPr>
-              <a:t>99% · 4.3k</a:t>
+              <a:t>4.3k</a:t>
             </a:r>
             <a:endParaRPr lang="en-US" sz="1500" dirty="0"/>
           </a:p>
@@ -31237,7 +31597,7 @@
       </p:sp>
       <p:sp>
         <p:nvSpPr>
-          <p:cNvPr id="32" name="Text 29"/>
+          <p:cNvPr id="40" name="Text 37"/>
           <p:cNvSpPr txBox="1"/>
           <p:nvPr/>
         </p:nvSpPr>
@@ -32453,8 +32813,8 @@
         </p:nvSpPr>
         <p:spPr>
           <a:xfrm>
-            <a:off x="548640" y="4023360"/>
-            <a:ext cx="2011680" cy="438912"/>
+            <a:off x="2560320" y="3977640"/>
+            <a:ext cx="822960" cy="320040"/>
           </a:xfrm>
           <a:prstGeom prst="rect">
             <a:avLst/>
@@ -32466,31 +32826,139 @@
           <a:bodyPr wrap="square" lIns="0" tIns="0" rIns="0" bIns="0" rtlCol="0" anchor="ctr"/>
           <a:lstStyle/>
           <a:p>
+            <a:pPr algn="ctr" indent="0" marL="0">
+              <a:buNone/>
+            </a:pPr>
+            <a:r>
+              <a:rPr lang="en-US" sz="1400" dirty="0">
+                <a:solidFill>
+                  <a:srgbClr val="7F7F7F"/>
+                </a:solidFill>
+              </a:rPr>
+              <a:t>solved</a:t>
+            </a:r>
+            <a:endParaRPr lang="en-US" sz="1400" dirty="0"/>
+          </a:p>
+        </p:txBody>
+      </p:sp>
+      <p:sp>
+        <p:nvSpPr>
+          <p:cNvPr id="36" name="Text 32"/>
+          <p:cNvSpPr txBox="1"/>
+          <p:nvPr/>
+        </p:nvSpPr>
+        <p:spPr>
+          <a:xfrm>
+            <a:off x="3474720" y="3977640"/>
+            <a:ext cx="3474720" cy="320040"/>
+          </a:xfrm>
+          <a:prstGeom prst="rect">
+            <a:avLst/>
+          </a:prstGeom>
+          <a:noFill/>
+          <a:ln/>
+        </p:spPr>
+        <p:txBody>
+          <a:bodyPr wrap="square" lIns="0" tIns="0" rIns="0" bIns="0" rtlCol="0" anchor="ctr"/>
+          <a:lstStyle/>
+          <a:p>
+            <a:pPr indent="0" marL="0">
+              <a:buNone/>
+            </a:pPr>
+            <a:r>
+              <a:rPr lang="en-US" sz="1400" dirty="0">
+                <a:solidFill>
+                  <a:srgbClr val="7F7F7F"/>
+                </a:solidFill>
+              </a:rPr>
+              <a:t>tokens per problem</a:t>
+            </a:r>
+            <a:endParaRPr lang="en-US" sz="1400" dirty="0"/>
+          </a:p>
+        </p:txBody>
+      </p:sp>
+      <p:sp>
+        <p:nvSpPr>
+          <p:cNvPr id="37" name="Text 33"/>
+          <p:cNvSpPr txBox="1"/>
+          <p:nvPr/>
+        </p:nvSpPr>
+        <p:spPr>
+          <a:xfrm>
+            <a:off x="548640" y="4343400"/>
+            <a:ext cx="1920240" cy="457200"/>
+          </a:xfrm>
+          <a:prstGeom prst="rect">
+            <a:avLst/>
+          </a:prstGeom>
+          <a:noFill/>
+          <a:ln/>
+        </p:spPr>
+        <p:txBody>
+          <a:bodyPr wrap="square" lIns="0" tIns="0" rIns="0" bIns="0" rtlCol="0" anchor="ctr"/>
+          <a:lstStyle/>
+          <a:p>
             <a:pPr algn="r" indent="0" marL="0">
               <a:buNone/>
             </a:pPr>
             <a:r>
-              <a:rPr lang="en-US" sz="1600" dirty="0">
+              <a:rPr lang="en-US" sz="1500" dirty="0">
                 <a:solidFill>
                   <a:schemeClr val="tx1"/>
                 </a:solidFill>
               </a:rPr>
               <a:t>think on hardest</a:t>
             </a:r>
-            <a:endParaRPr lang="en-US" sz="1600" dirty="0"/>
-          </a:p>
-        </p:txBody>
-      </p:sp>
-      <p:sp>
-        <p:nvSpPr>
-          <p:cNvPr id="36" name="bar think on hardest"/>
+            <a:endParaRPr lang="en-US" sz="1500" dirty="0"/>
+          </a:p>
+        </p:txBody>
+      </p:sp>
+      <p:sp>
+        <p:nvSpPr>
+          <p:cNvPr id="38" name="Text 34"/>
+          <p:cNvSpPr txBox="1"/>
+          <p:nvPr/>
+        </p:nvSpPr>
+        <p:spPr>
+          <a:xfrm>
+            <a:off x="2560320" y="4343400"/>
+            <a:ext cx="822960" cy="457200"/>
+          </a:xfrm>
+          <a:prstGeom prst="rect">
+            <a:avLst/>
+          </a:prstGeom>
+          <a:noFill/>
+          <a:ln/>
+        </p:spPr>
+        <p:txBody>
+          <a:bodyPr wrap="square" lIns="0" tIns="0" rIns="0" bIns="0" rtlCol="0" anchor="ctr"/>
+          <a:lstStyle/>
+          <a:p>
+            <a:pPr algn="ctr" indent="0" marL="0">
+              <a:buNone/>
+            </a:pPr>
+            <a:r>
+              <a:rPr lang="en-US" sz="1700" b="1" dirty="0">
+                <a:solidFill>
+                  <a:srgbClr val="7F7F7F"/>
+                </a:solidFill>
+              </a:rPr>
+              <a:t>74%</a:t>
+            </a:r>
+            <a:endParaRPr lang="en-US" sz="1700" dirty="0"/>
+          </a:p>
+        </p:txBody>
+      </p:sp>
+      <p:sp>
+        <p:nvSpPr>
+          <p:cNvPr id="39" name="tokens think on hardest"/>
           <p:cNvSpPr/>
           <p:nvPr/>
         </p:nvSpPr>
         <p:spPr>
           <a:xfrm>
-            <a:off x="2697480" y="4105656"/>
-            <a:ext cx="2165299" cy="274320"/>
+            <a:off x="3474720" y="4443984"/>
+            <a:ext cx="2743200" cy="256032"/>
           </a:xfrm>
           <a:prstGeom prst="rect">
             <a:avLst/>
@@ -32508,14 +32976,14 @@
       </p:sp>
       <p:sp>
         <p:nvSpPr>
-          <p:cNvPr id="37" name="Text 33"/>
-          <p:cNvSpPr txBox="1"/>
-          <p:nvPr/>
-        </p:nvSpPr>
-        <p:spPr>
-          <a:xfrm>
-            <a:off x="4954219" y="4023360"/>
-            <a:ext cx="1463040" cy="438912"/>
+          <p:cNvPr id="40" name="Text 36"/>
+          <p:cNvSpPr txBox="1"/>
+          <p:nvPr/>
+        </p:nvSpPr>
+        <p:spPr>
+          <a:xfrm>
+            <a:off x="6309360" y="4343400"/>
+            <a:ext cx="731520" cy="457200"/>
           </a:xfrm>
           <a:prstGeom prst="rect">
             <a:avLst/>
@@ -32531,27 +32999,27 @@
               <a:buNone/>
             </a:pPr>
             <a:r>
-              <a:rPr lang="en-US" sz="1800" b="1" dirty="0">
+              <a:rPr lang="en-US" sz="1500" b="1" dirty="0">
                 <a:solidFill>
                   <a:srgbClr val="7F7F7F"/>
                 </a:solidFill>
               </a:rPr>
-              <a:t>74% · 4.1k</a:t>
-            </a:r>
-            <a:endParaRPr lang="en-US" sz="1800" dirty="0"/>
-          </a:p>
-        </p:txBody>
-      </p:sp>
-      <p:sp>
-        <p:nvSpPr>
-          <p:cNvPr id="38" name="Text 34"/>
-          <p:cNvSpPr txBox="1"/>
-          <p:nvPr/>
-        </p:nvSpPr>
-        <p:spPr>
-          <a:xfrm>
-            <a:off x="548640" y="4572000"/>
-            <a:ext cx="2011680" cy="438912"/>
+              <a:t>4.1k</a:t>
+            </a:r>
+            <a:endParaRPr lang="en-US" sz="1500" dirty="0"/>
+          </a:p>
+        </p:txBody>
+      </p:sp>
+      <p:sp>
+        <p:nvSpPr>
+          <p:cNvPr id="41" name="Text 37"/>
+          <p:cNvSpPr txBox="1"/>
+          <p:nvPr/>
+        </p:nvSpPr>
+        <p:spPr>
+          <a:xfrm>
+            <a:off x="548640" y="4873752"/>
+            <a:ext cx="1920240" cy="457200"/>
           </a:xfrm>
           <a:prstGeom prst="rect">
             <a:avLst/>
@@ -32567,27 +33035,63 @@
               <a:buNone/>
             </a:pPr>
             <a:r>
-              <a:rPr lang="en-US" sz="1600" dirty="0">
+              <a:rPr lang="en-US" sz="1500" dirty="0">
                 <a:solidFill>
                   <a:schemeClr val="tx1"/>
                 </a:solidFill>
               </a:rPr>
               <a:t>our method</a:t>
             </a:r>
-            <a:endParaRPr lang="en-US" sz="1600" dirty="0"/>
-          </a:p>
-        </p:txBody>
-      </p:sp>
-      <p:sp>
-        <p:nvSpPr>
-          <p:cNvPr id="39" name="bar our method"/>
+            <a:endParaRPr lang="en-US" sz="1500" dirty="0"/>
+          </a:p>
+        </p:txBody>
+      </p:sp>
+      <p:sp>
+        <p:nvSpPr>
+          <p:cNvPr id="42" name="Text 38"/>
+          <p:cNvSpPr txBox="1"/>
+          <p:nvPr/>
+        </p:nvSpPr>
+        <p:spPr>
+          <a:xfrm>
+            <a:off x="2560320" y="4873752"/>
+            <a:ext cx="822960" cy="457200"/>
+          </a:xfrm>
+          <a:prstGeom prst="rect">
+            <a:avLst/>
+          </a:prstGeom>
+          <a:noFill/>
+          <a:ln/>
+        </p:spPr>
+        <p:txBody>
+          <a:bodyPr wrap="square" lIns="0" tIns="0" rIns="0" bIns="0" rtlCol="0" anchor="ctr"/>
+          <a:lstStyle/>
+          <a:p>
+            <a:pPr algn="ctr" indent="0" marL="0">
+              <a:buNone/>
+            </a:pPr>
+            <a:r>
+              <a:rPr lang="en-US" sz="1700" b="1" dirty="0">
+                <a:solidFill>
+                  <a:srgbClr val="4472C4"/>
+                </a:solidFill>
+              </a:rPr>
+              <a:t>87%</a:t>
+            </a:r>
+            <a:endParaRPr lang="en-US" sz="1700" dirty="0"/>
+          </a:p>
+        </p:txBody>
+      </p:sp>
+      <p:sp>
+        <p:nvSpPr>
+          <p:cNvPr id="43" name="tokens our method"/>
           <p:cNvSpPr/>
           <p:nvPr/>
         </p:nvSpPr>
         <p:spPr>
           <a:xfrm>
-            <a:off x="2697480" y="4654296"/>
-            <a:ext cx="2545690" cy="274320"/>
+            <a:off x="3474720" y="4974336"/>
+            <a:ext cx="1672683" cy="256032"/>
           </a:xfrm>
           <a:prstGeom prst="rect">
             <a:avLst/>
@@ -32605,14 +33109,14 @@
       </p:sp>
       <p:sp>
         <p:nvSpPr>
-          <p:cNvPr id="40" name="Text 36"/>
-          <p:cNvSpPr txBox="1"/>
-          <p:nvPr/>
-        </p:nvSpPr>
-        <p:spPr>
-          <a:xfrm>
-            <a:off x="5334610" y="4572000"/>
-            <a:ext cx="1463040" cy="438912"/>
+          <p:cNvPr id="44" name="Text 40"/>
+          <p:cNvSpPr txBox="1"/>
+          <p:nvPr/>
+        </p:nvSpPr>
+        <p:spPr>
+          <a:xfrm>
+            <a:off x="5238843" y="4873752"/>
+            <a:ext cx="731520" cy="457200"/>
           </a:xfrm>
           <a:prstGeom prst="rect">
             <a:avLst/>
@@ -32628,20 +33132,20 @@
               <a:buNone/>
             </a:pPr>
             <a:r>
-              <a:rPr lang="en-US" sz="1800" b="1" dirty="0">
+              <a:rPr lang="en-US" sz="1500" b="1" dirty="0">
                 <a:solidFill>
                   <a:srgbClr val="4472C4"/>
                 </a:solidFill>
               </a:rPr>
-              <a:t>87% · 2.5k</a:t>
-            </a:r>
-            <a:endParaRPr lang="en-US" sz="1800" dirty="0"/>
-          </a:p>
-        </p:txBody>
-      </p:sp>
-      <p:sp>
-        <p:nvSpPr>
-          <p:cNvPr id="41" name="Text 37"/>
+              <a:t>2.5k</a:t>
+            </a:r>
+            <a:endParaRPr lang="en-US" sz="1500" dirty="0"/>
+          </a:p>
+        </p:txBody>
+      </p:sp>
+      <p:sp>
+        <p:nvSpPr>
+          <p:cNvPr id="45" name="Text 41"/>
           <p:cNvSpPr txBox="1"/>
           <p:nvPr/>
         </p:nvSpPr>
@@ -32677,7 +33181,7 @@
       </p:sp>
       <p:sp>
         <p:nvSpPr>
-          <p:cNvPr id="42" name="Text 38"/>
+          <p:cNvPr id="46" name="Text 42"/>
           <p:cNvSpPr txBox="1"/>
           <p:nvPr/>
         </p:nvSpPr>
@@ -32713,7 +33217,7 @@
       </p:sp>
       <p:sp>
         <p:nvSpPr>
-          <p:cNvPr id="43" name="Text 39"/>
+          <p:cNvPr id="47" name="Text 43"/>
           <p:cNvSpPr txBox="1"/>
           <p:nvPr/>
         </p:nvSpPr>
@@ -32749,7 +33253,7 @@
       </p:sp>
       <p:sp>
         <p:nvSpPr>
-          <p:cNvPr id="44" name="Text 40"/>
+          <p:cNvPr id="48" name="Text 44"/>
           <p:cNvSpPr txBox="1"/>
           <p:nvPr/>
         </p:nvSpPr>
@@ -32785,7 +33289,7 @@
       </p:sp>
       <p:sp>
         <p:nvSpPr>
-          <p:cNvPr id="45" name="Text 41"/>
+          <p:cNvPr id="49" name="Text 45"/>
           <p:cNvSpPr txBox="1"/>
           <p:nvPr/>
         </p:nvSpPr>
@@ -33902,7 +34406,7 @@
                   <a:schemeClr val="tx1"/>
                 </a:solidFill>
               </a:rPr>
-              <a:t>replicate on held-out data; run the closest baselines</a:t>
+              <a:t>finish the held-out test on more models</a:t>
             </a:r>
             <a:endParaRPr lang="en-US" sz="1500" dirty="0"/>
           </a:p>
@@ -33935,7 +34439,7 @@
       </p:sp>
       <p:pic>
         <p:nvPicPr>
-          <p:cNvPr id="38" name="milestone icon 1" descr="/NAS/SJ/POSTECH/nlp/figs/icons/fact.png">    </p:cNvPr>
+          <p:cNvPr id="38" name="milestone icon 1" descr="/NAS/SJ/POSTECH/nlp/figs/icons/warn.png">    </p:cNvPr>
           <p:cNvPicPr>
             <a:picLocks noChangeAspect="1"/>
           </p:cNvPicPr>
@@ -33987,7 +34491,7 @@
                   <a:schemeClr val="tx1"/>
                 </a:solidFill>
               </a:rPr>
-              <a:t>find facts for every problem type</a:t>
+              <a:t>errors no check catches: programs that run but model the problem wrong</a:t>
             </a:r>
             <a:endParaRPr lang="en-US" sz="1500" dirty="0"/>
           </a:p>
@@ -34072,7 +34576,7 @@
                   <a:schemeClr val="tx1"/>
                 </a:solidFill>
               </a:rPr>
-              <a:t>final report, code, and the recipe as a tool</a:t>
+              <a:t>facts for every problem type; report and code</a:t>
             </a:r>
             <a:endParaRPr lang="en-US" sz="1500" dirty="0"/>
           </a:p>

</xml_diff>

<commit_message>
Talk: a visible cause for each choice on the problem slide, choice pills from the title on, plainer step labels
Co-Authored-By: Claude Opus 5.5 (1M context) <noreply@anthropic.com>
</commit_message>
<xml_diff>
--- a/PROPOSAL_slides.pptx
+++ b/PROPOSAL_slides.pptx
@@ -131,7 +131,7 @@
   <p:extLst>
     <p:ext uri="{521415D9-36F7-43E2-AB2F-B90AF26B5E84}">
       <p14:sectionLst xmlns:p14="http://schemas.microsoft.com/office/powerpoint/2010/main">
-        <p14:section name="Talk" id="{08773a7d-5793-30e4-9f29-fb073f5413a4}">
+        <p14:section name="Talk" id="{3ef14f55-547f-df8f-d578-6415f8e47458}">
           <p14:sldIdLst>
             <p14:sldId id="256"/>
             <p14:sldId id="257"/>
@@ -144,7 +144,7 @@
             <p14:sldId id="264"/>
           </p14:sldIdLst>
         </p14:section>
-        <p14:section name="Extra pages" id="{558d307f-5103-4261-9172-397e35e6d885}">
+        <p14:section name="Extra pages" id="{8610699a-0dd9-ff48-98e7-57b5e371f3f1}">
           <p14:sldIdLst>
             <p14:sldId id="265"/>
             <p14:sldId id="266"/>
@@ -4396,6 +4396,267 @@
               <a:t>POSTECH CSED490E (Graduate NLP) · Team 5</a:t>
             </a:r>
             <a:endParaRPr lang="en-US" sz="2200" dirty="0"/>
+          </a:p>
+        </p:txBody>
+      </p:sp>
+      <p:sp>
+        <p:nvSpPr>
+          <p:cNvPr id="4" name="choice a missing fact"/>
+          <p:cNvSpPr/>
+          <p:nvPr/>
+        </p:nvSpPr>
+        <p:spPr>
+          <a:xfrm>
+            <a:off x="3145536" y="4892040"/>
+            <a:ext cx="1874520" cy="502920"/>
+          </a:xfrm>
+          <a:prstGeom prst="roundRect">
+            <a:avLst>
+              <a:gd name="adj" fmla="val 36364"/>
+            </a:avLst>
+          </a:prstGeom>
+          <a:solidFill>
+            <a:srgbClr val="E2F0D9"/>
+          </a:solidFill>
+          <a:ln w="12700">
+            <a:solidFill>
+              <a:srgbClr val="38761D"/>
+            </a:solidFill>
+            <a:prstDash val="solid"/>
+          </a:ln>
+        </p:spPr>
+      </p:sp>
+      <p:pic>
+        <p:nvPicPr>
+          <p:cNvPr id="5" name="choice icon fact" descr="/NAS/SJ/POSTECH/nlp/figs/icons/fact.png">    </p:cNvPr>
+          <p:cNvPicPr>
+            <a:picLocks noChangeAspect="1"/>
+          </p:cNvPicPr>
+          <p:nvPr/>
+        </p:nvPicPr>
+        <p:blipFill>
+          <a:blip r:embed="rId1"/>
+          <a:stretch>
+            <a:fillRect/>
+          </a:stretch>
+        </p:blipFill>
+        <p:spPr>
+          <a:xfrm>
+            <a:off x="3255264" y="4978908"/>
+            <a:ext cx="329184" cy="329184"/>
+          </a:xfrm>
+          <a:prstGeom prst="rect">
+            <a:avLst/>
+          </a:prstGeom>
+        </p:spPr>
+      </p:pic>
+      <p:sp>
+        <p:nvSpPr>
+          <p:cNvPr id="6" name="Text 3"/>
+          <p:cNvSpPr txBox="1"/>
+          <p:nvPr/>
+        </p:nvSpPr>
+        <p:spPr>
+          <a:xfrm>
+            <a:off x="3648456" y="4892040"/>
+            <a:ext cx="1371600" cy="502920"/>
+          </a:xfrm>
+          <a:prstGeom prst="rect">
+            <a:avLst/>
+          </a:prstGeom>
+          <a:noFill/>
+          <a:ln/>
+        </p:spPr>
+        <p:txBody>
+          <a:bodyPr wrap="square" lIns="0" tIns="0" rIns="0" bIns="0" rtlCol="0" anchor="ctr"/>
+          <a:lstStyle/>
+          <a:p>
+            <a:pPr indent="0" marL="0">
+              <a:buNone/>
+            </a:pPr>
+            <a:r>
+              <a:rPr lang="en-US" sz="1500" b="1" dirty="0">
+                <a:solidFill>
+                  <a:srgbClr val="38761D"/>
+                </a:solidFill>
+              </a:rPr>
+              <a:t>a missing fact</a:t>
+            </a:r>
+            <a:endParaRPr lang="en-US" sz="1500" dirty="0"/>
+          </a:p>
+        </p:txBody>
+      </p:sp>
+      <p:sp>
+        <p:nvSpPr>
+          <p:cNvPr id="7" name="choice a free check"/>
+          <p:cNvSpPr/>
+          <p:nvPr/>
+        </p:nvSpPr>
+        <p:spPr>
+          <a:xfrm>
+            <a:off x="5157216" y="4892040"/>
+            <a:ext cx="1874520" cy="502920"/>
+          </a:xfrm>
+          <a:prstGeom prst="roundRect">
+            <a:avLst>
+              <a:gd name="adj" fmla="val 36364"/>
+            </a:avLst>
+          </a:prstGeom>
+          <a:solidFill>
+            <a:srgbClr val="E2F0D9"/>
+          </a:solidFill>
+          <a:ln w="12700">
+            <a:solidFill>
+              <a:srgbClr val="38761D"/>
+            </a:solidFill>
+            <a:prstDash val="solid"/>
+          </a:ln>
+        </p:spPr>
+      </p:sp>
+      <p:pic>
+        <p:nvPicPr>
+          <p:cNvPr id="8" name="choice icon check" descr="/NAS/SJ/POSTECH/nlp/figs/icons/check.png">    </p:cNvPr>
+          <p:cNvPicPr>
+            <a:picLocks noChangeAspect="1"/>
+          </p:cNvPicPr>
+          <p:nvPr/>
+        </p:nvPicPr>
+        <p:blipFill>
+          <a:blip r:embed="rId2"/>
+          <a:stretch>
+            <a:fillRect/>
+          </a:stretch>
+        </p:blipFill>
+        <p:spPr>
+          <a:xfrm>
+            <a:off x="5266944" y="4978908"/>
+            <a:ext cx="329184" cy="329184"/>
+          </a:xfrm>
+          <a:prstGeom prst="rect">
+            <a:avLst/>
+          </a:prstGeom>
+        </p:spPr>
+      </p:pic>
+      <p:sp>
+        <p:nvSpPr>
+          <p:cNvPr id="9" name="Text 5"/>
+          <p:cNvSpPr txBox="1"/>
+          <p:nvPr/>
+        </p:nvSpPr>
+        <p:spPr>
+          <a:xfrm>
+            <a:off x="5660136" y="4892040"/>
+            <a:ext cx="1371600" cy="502920"/>
+          </a:xfrm>
+          <a:prstGeom prst="rect">
+            <a:avLst/>
+          </a:prstGeom>
+          <a:noFill/>
+          <a:ln/>
+        </p:spPr>
+        <p:txBody>
+          <a:bodyPr wrap="square" lIns="0" tIns="0" rIns="0" bIns="0" rtlCol="0" anchor="ctr"/>
+          <a:lstStyle/>
+          <a:p>
+            <a:pPr indent="0" marL="0">
+              <a:buNone/>
+            </a:pPr>
+            <a:r>
+              <a:rPr lang="en-US" sz="1500" b="1" dirty="0">
+                <a:solidFill>
+                  <a:srgbClr val="38761D"/>
+                </a:solidFill>
+              </a:rPr>
+              <a:t>a free check</a:t>
+            </a:r>
+            <a:endParaRPr lang="en-US" sz="1500" dirty="0"/>
+          </a:p>
+        </p:txBody>
+      </p:sp>
+      <p:sp>
+        <p:nvSpPr>
+          <p:cNvPr id="10" name="choice more thinking"/>
+          <p:cNvSpPr/>
+          <p:nvPr/>
+        </p:nvSpPr>
+        <p:spPr>
+          <a:xfrm>
+            <a:off x="7168896" y="4892040"/>
+            <a:ext cx="1874520" cy="502920"/>
+          </a:xfrm>
+          <a:prstGeom prst="roundRect">
+            <a:avLst>
+              <a:gd name="adj" fmla="val 36364"/>
+            </a:avLst>
+          </a:prstGeom>
+          <a:solidFill>
+            <a:srgbClr val="FADBD8"/>
+          </a:solidFill>
+          <a:ln w="12700">
+            <a:solidFill>
+              <a:srgbClr val="C00000"/>
+            </a:solidFill>
+            <a:prstDash val="solid"/>
+          </a:ln>
+        </p:spPr>
+      </p:sp>
+      <p:pic>
+        <p:nvPicPr>
+          <p:cNvPr id="11" name="choice icon brain" descr="/NAS/SJ/POSTECH/nlp/figs/icons/brain.png">    </p:cNvPr>
+          <p:cNvPicPr>
+            <a:picLocks noChangeAspect="1"/>
+          </p:cNvPicPr>
+          <p:nvPr/>
+        </p:nvPicPr>
+        <p:blipFill>
+          <a:blip r:embed="rId3"/>
+          <a:stretch>
+            <a:fillRect/>
+          </a:stretch>
+        </p:blipFill>
+        <p:spPr>
+          <a:xfrm>
+            <a:off x="7278624" y="4978908"/>
+            <a:ext cx="329184" cy="329184"/>
+          </a:xfrm>
+          <a:prstGeom prst="rect">
+            <a:avLst/>
+          </a:prstGeom>
+        </p:spPr>
+      </p:pic>
+      <p:sp>
+        <p:nvSpPr>
+          <p:cNvPr id="12" name="Text 7"/>
+          <p:cNvSpPr txBox="1"/>
+          <p:nvPr/>
+        </p:nvSpPr>
+        <p:spPr>
+          <a:xfrm>
+            <a:off x="7671816" y="4892040"/>
+            <a:ext cx="1371600" cy="502920"/>
+          </a:xfrm>
+          <a:prstGeom prst="rect">
+            <a:avLst/>
+          </a:prstGeom>
+          <a:noFill/>
+          <a:ln/>
+        </p:spPr>
+        <p:txBody>
+          <a:bodyPr wrap="square" lIns="0" tIns="0" rIns="0" bIns="0" rtlCol="0" anchor="ctr"/>
+          <a:lstStyle/>
+          <a:p>
+            <a:pPr indent="0" marL="0">
+              <a:buNone/>
+            </a:pPr>
+            <a:r>
+              <a:rPr lang="en-US" sz="1500" b="1" dirty="0">
+                <a:solidFill>
+                  <a:srgbClr val="C00000"/>
+                </a:solidFill>
+              </a:rPr>
+              <a:t>more thinking</a:t>
+            </a:r>
+            <a:endParaRPr lang="en-US" sz="1500" dirty="0"/>
           </a:p>
         </p:txBody>
       </p:sp>
@@ -24739,7 +25000,7 @@
                   <a:schemeClr val="tx1"/>
                 </a:solidFill>
               </a:rPr>
-              <a:t>own notes (DC)</a:t>
+              <a:t>own notes</a:t>
             </a:r>
             <a:endParaRPr lang="en-US" sz="1300" dirty="0"/>
           </a:p>
@@ -24747,7 +25008,7 @@
       </p:sp>
       <p:sp>
         <p:nvSpPr>
-          <p:cNvPr id="57" name="Reuse a checked program own notes (DC)"/>
+          <p:cNvPr id="57" name="Reuse a checked program own notes"/>
           <p:cNvSpPr/>
           <p:nvPr/>
         </p:nvSpPr>
@@ -27074,7 +27335,7 @@
       </p:sp>
       <p:sp>
         <p:nvSpPr>
-          <p:cNvPr id="3" name="pane 1. Programs can be silently wrong"/>
+          <p:cNvPr id="3" name="pane 1. Programs fail, often silently"/>
           <p:cNvSpPr/>
           <p:nvPr/>
         </p:nvSpPr>
@@ -27129,7 +27390,7 @@
                   <a:srgbClr val="C00000"/>
                 </a:solidFill>
               </a:rPr>
-              <a:t>1. Programs can be silently wrong</a:t>
+              <a:t>1. Programs fail, often silently</a:t>
             </a:r>
             <a:endParaRPr lang="en-US" sz="2200" dirty="0"/>
           </a:p>
@@ -27187,8 +27448,8 @@
         </p:blipFill>
         <p:spPr>
           <a:xfrm>
-            <a:off x="777240" y="2331720"/>
-            <a:ext cx="2011680" cy="2011680"/>
+            <a:off x="868680" y="2286000"/>
+            <a:ext cx="1828800" cy="1828800"/>
           </a:xfrm>
           <a:prstGeom prst="rect">
             <a:avLst/>
@@ -27203,8 +27464,8 @@
         </p:nvSpPr>
         <p:spPr>
           <a:xfrm>
-            <a:off x="685800" y="4389120"/>
-            <a:ext cx="2194560" cy="365760"/>
+            <a:off x="685800" y="4114800"/>
+            <a:ext cx="2194560" cy="320040"/>
           </a:xfrm>
           <a:prstGeom prst="rect">
             <a:avLst/>
@@ -27239,12 +27500,12 @@
         </p:nvSpPr>
         <p:spPr>
           <a:xfrm>
-            <a:off x="2971800" y="2423160"/>
-            <a:ext cx="2834640" cy="1554480"/>
+            <a:off x="2971800" y="2331720"/>
+            <a:ext cx="2834640" cy="1417320"/>
           </a:xfrm>
           <a:prstGeom prst="roundRect">
             <a:avLst>
-              <a:gd name="adj" fmla="val 2941"/>
+              <a:gd name="adj" fmla="val 3226"/>
             </a:avLst>
           </a:prstGeom>
           <a:solidFill>
@@ -27266,8 +27527,8 @@
         </p:nvSpPr>
         <p:spPr>
           <a:xfrm>
-            <a:off x="3154680" y="2468880"/>
-            <a:ext cx="2560320" cy="1463040"/>
+            <a:off x="3154680" y="2331720"/>
+            <a:ext cx="2560320" cy="1417320"/>
           </a:xfrm>
           <a:prstGeom prst="rect">
             <a:avLst/>
@@ -27339,7 +27600,7 @@
         </p:nvSpPr>
         <p:spPr>
           <a:xfrm>
-            <a:off x="2971800" y="4069080"/>
+            <a:off x="2971800" y="3794760"/>
             <a:ext cx="2834640" cy="548640"/>
           </a:xfrm>
           <a:prstGeom prst="rect">
@@ -27369,7 +27630,43 @@
       </p:sp>
       <p:sp>
         <p:nvSpPr>
-          <p:cNvPr id="11" name="pane 2. Thinking longer is expensive"/>
+          <p:cNvPr id="11" name="Text 8"/>
+          <p:cNvSpPr txBox="1"/>
+          <p:nvPr/>
+        </p:nvSpPr>
+        <p:spPr>
+          <a:xfrm>
+            <a:off x="777240" y="4526280"/>
+            <a:ext cx="5029200" cy="365760"/>
+          </a:xfrm>
+          <a:prstGeom prst="rect">
+            <a:avLst/>
+          </a:prstGeom>
+          <a:noFill/>
+          <a:ln/>
+        </p:spPr>
+        <p:txBody>
+          <a:bodyPr wrap="square" lIns="0" tIns="0" rIns="0" bIns="0" rtlCol="0" anchor="ctr"/>
+          <a:lstStyle/>
+          <a:p>
+            <a:pPr indent="0" marL="0">
+              <a:buNone/>
+            </a:pPr>
+            <a:r>
+              <a:rPr lang="en-US" sz="1500" b="1" dirty="0">
+                <a:solidFill>
+                  <a:srgbClr val="C00000"/>
+                </a:solidFill>
+              </a:rPr>
+              <a:t>✗ or it crashes on a library function that does not exist</a:t>
+            </a:r>
+            <a:endParaRPr lang="en-US" sz="1500" dirty="0"/>
+          </a:p>
+        </p:txBody>
+      </p:sp>
+      <p:sp>
+        <p:nvSpPr>
+          <p:cNvPr id="12" name="pane 2. Thinking longer is expensive"/>
           <p:cNvSpPr/>
           <p:nvPr/>
         </p:nvSpPr>
@@ -27396,7 +27693,7 @@
       </p:sp>
       <p:sp>
         <p:nvSpPr>
-          <p:cNvPr id="12" name="Text 9"/>
+          <p:cNvPr id="13" name="Text 10"/>
           <p:cNvSpPr txBox="1"/>
           <p:nvPr/>
         </p:nvSpPr>
@@ -27432,7 +27729,7 @@
       </p:sp>
       <p:sp>
         <p:nvSpPr>
-          <p:cNvPr id="13" name="Text 10"/>
+          <p:cNvPr id="14" name="Text 11"/>
           <p:cNvSpPr txBox="1"/>
           <p:nvPr/>
         </p:nvSpPr>
@@ -27468,7 +27765,7 @@
       </p:sp>
       <p:sp>
         <p:nvSpPr>
-          <p:cNvPr id="14" name="Text 11"/>
+          <p:cNvPr id="15" name="Text 12"/>
           <p:cNvSpPr txBox="1"/>
           <p:nvPr/>
         </p:nvSpPr>
@@ -27518,7 +27815,7 @@
       </p:sp>
       <p:pic>
         <p:nvPicPr>
-          <p:cNvPr id="15" name="normal page 0" descr="/NAS/SJ/POSTECH/nlp/figs/icons/page.png">    </p:cNvPr>
+          <p:cNvPr id="16" name="normal page 0" descr="/NAS/SJ/POSTECH/nlp/figs/icons/page.png">    </p:cNvPr>
           <p:cNvPicPr>
             <a:picLocks noChangeAspect="1"/>
           </p:cNvPicPr>
@@ -27542,7 +27839,7 @@
       </p:pic>
       <p:pic>
         <p:nvPicPr>
-          <p:cNvPr id="16" name="normal page 1" descr="/NAS/SJ/POSTECH/nlp/figs/icons/page.png">    </p:cNvPr>
+          <p:cNvPr id="17" name="normal page 1" descr="/NAS/SJ/POSTECH/nlp/figs/icons/page.png">    </p:cNvPr>
           <p:cNvPicPr>
             <a:picLocks noChangeAspect="1"/>
           </p:cNvPicPr>
@@ -27566,7 +27863,7 @@
       </p:pic>
       <p:pic>
         <p:nvPicPr>
-          <p:cNvPr id="17" name="normal page 2" descr="/NAS/SJ/POSTECH/nlp/figs/icons/page.png">    </p:cNvPr>
+          <p:cNvPr id="18" name="normal page 2" descr="/NAS/SJ/POSTECH/nlp/figs/icons/page.png">    </p:cNvPr>
           <p:cNvPicPr>
             <a:picLocks noChangeAspect="1"/>
           </p:cNvPicPr>
@@ -27590,7 +27887,7 @@
       </p:pic>
       <p:pic>
         <p:nvPicPr>
-          <p:cNvPr id="18" name="normal page 3" descr="/NAS/SJ/POSTECH/nlp/figs/icons/page.png">    </p:cNvPr>
+          <p:cNvPr id="19" name="normal page 3" descr="/NAS/SJ/POSTECH/nlp/figs/icons/page.png">    </p:cNvPr>
           <p:cNvPicPr>
             <a:picLocks noChangeAspect="1"/>
           </p:cNvPicPr>
@@ -27614,7 +27911,7 @@
       </p:pic>
       <p:pic>
         <p:nvPicPr>
-          <p:cNvPr id="19" name="normal page 4" descr="/NAS/SJ/POSTECH/nlp/figs/icons/page.png">    </p:cNvPr>
+          <p:cNvPr id="20" name="normal page 4" descr="/NAS/SJ/POSTECH/nlp/figs/icons/page.png">    </p:cNvPr>
           <p:cNvPicPr>
             <a:picLocks noChangeAspect="1"/>
           </p:cNvPicPr>
@@ -27638,7 +27935,7 @@
       </p:pic>
       <p:pic>
         <p:nvPicPr>
-          <p:cNvPr id="20" name="normal page 5" descr="/NAS/SJ/POSTECH/nlp/figs/icons/page.png">    </p:cNvPr>
+          <p:cNvPr id="21" name="normal page 5" descr="/NAS/SJ/POSTECH/nlp/figs/icons/page.png">    </p:cNvPr>
           <p:cNvPicPr>
             <a:picLocks noChangeAspect="1"/>
           </p:cNvPicPr>
@@ -27662,7 +27959,7 @@
       </p:pic>
       <p:pic>
         <p:nvPicPr>
-          <p:cNvPr id="21" name="normal page 6" descr="/NAS/SJ/POSTECH/nlp/figs/icons/page.png">    </p:cNvPr>
+          <p:cNvPr id="22" name="normal page 6" descr="/NAS/SJ/POSTECH/nlp/figs/icons/page.png">    </p:cNvPr>
           <p:cNvPicPr>
             <a:picLocks noChangeAspect="1"/>
           </p:cNvPicPr>
@@ -27686,7 +27983,7 @@
       </p:pic>
       <p:pic>
         <p:nvPicPr>
-          <p:cNvPr id="22" name="normal page 7" descr="/NAS/SJ/POSTECH/nlp/figs/icons/page.png">    </p:cNvPr>
+          <p:cNvPr id="23" name="normal page 7" descr="/NAS/SJ/POSTECH/nlp/figs/icons/page.png">    </p:cNvPr>
           <p:cNvPicPr>
             <a:picLocks noChangeAspect="1"/>
           </p:cNvPicPr>
@@ -27710,7 +28007,7 @@
       </p:pic>
       <p:pic>
         <p:nvPicPr>
-          <p:cNvPr id="23" name="normal page 8" descr="/NAS/SJ/POSTECH/nlp/figs/icons/page.png">    </p:cNvPr>
+          <p:cNvPr id="24" name="normal page 8" descr="/NAS/SJ/POSTECH/nlp/figs/icons/page.png">    </p:cNvPr>
           <p:cNvPicPr>
             <a:picLocks noChangeAspect="1"/>
           </p:cNvPicPr>
@@ -27734,7 +28031,7 @@
       </p:pic>
       <p:pic>
         <p:nvPicPr>
-          <p:cNvPr id="24" name="normal page 9" descr="/NAS/SJ/POSTECH/nlp/figs/icons/page.png">    </p:cNvPr>
+          <p:cNvPr id="25" name="normal page 9" descr="/NAS/SJ/POSTECH/nlp/figs/icons/page.png">    </p:cNvPr>
           <p:cNvPicPr>
             <a:picLocks noChangeAspect="1"/>
           </p:cNvPicPr>
@@ -27758,7 +28055,7 @@
       </p:pic>
       <p:sp>
         <p:nvSpPr>
-          <p:cNvPr id="25" name="Text 12"/>
+          <p:cNvPr id="26" name="Text 13"/>
           <p:cNvSpPr txBox="1"/>
           <p:nvPr/>
         </p:nvSpPr>
@@ -27808,7 +28105,7 @@
       </p:sp>
       <p:pic>
         <p:nvPicPr>
-          <p:cNvPr id="26" name="think hard page 0" descr="/NAS/SJ/POSTECH/nlp/figs/icons/pagehot.png">    </p:cNvPr>
+          <p:cNvPr id="27" name="think hard page 0" descr="/NAS/SJ/POSTECH/nlp/figs/icons/pagehot.png">    </p:cNvPr>
           <p:cNvPicPr>
             <a:picLocks noChangeAspect="1"/>
           </p:cNvPicPr>
@@ -27832,7 +28129,7 @@
       </p:pic>
       <p:pic>
         <p:nvPicPr>
-          <p:cNvPr id="27" name="think hard page 1" descr="/NAS/SJ/POSTECH/nlp/figs/icons/pagehot.png">    </p:cNvPr>
+          <p:cNvPr id="28" name="think hard page 1" descr="/NAS/SJ/POSTECH/nlp/figs/icons/pagehot.png">    </p:cNvPr>
           <p:cNvPicPr>
             <a:picLocks noChangeAspect="1"/>
           </p:cNvPicPr>
@@ -27856,7 +28153,7 @@
       </p:pic>
       <p:pic>
         <p:nvPicPr>
-          <p:cNvPr id="28" name="think hard page 2" descr="/NAS/SJ/POSTECH/nlp/figs/icons/pagehot.png">    </p:cNvPr>
+          <p:cNvPr id="29" name="think hard page 2" descr="/NAS/SJ/POSTECH/nlp/figs/icons/pagehot.png">    </p:cNvPr>
           <p:cNvPicPr>
             <a:picLocks noChangeAspect="1"/>
           </p:cNvPicPr>
@@ -27880,7 +28177,7 @@
       </p:pic>
       <p:pic>
         <p:nvPicPr>
-          <p:cNvPr id="29" name="think hard page 3" descr="/NAS/SJ/POSTECH/nlp/figs/icons/pagehot.png">    </p:cNvPr>
+          <p:cNvPr id="30" name="think hard page 3" descr="/NAS/SJ/POSTECH/nlp/figs/icons/pagehot.png">    </p:cNvPr>
           <p:cNvPicPr>
             <a:picLocks noChangeAspect="1"/>
           </p:cNvPicPr>
@@ -27904,7 +28201,7 @@
       </p:pic>
       <p:pic>
         <p:nvPicPr>
-          <p:cNvPr id="30" name="think hard page 4" descr="/NAS/SJ/POSTECH/nlp/figs/icons/pagehot.png">    </p:cNvPr>
+          <p:cNvPr id="31" name="think hard page 4" descr="/NAS/SJ/POSTECH/nlp/figs/icons/pagehot.png">    </p:cNvPr>
           <p:cNvPicPr>
             <a:picLocks noChangeAspect="1"/>
           </p:cNvPicPr>
@@ -27928,7 +28225,7 @@
       </p:pic>
       <p:pic>
         <p:nvPicPr>
-          <p:cNvPr id="31" name="think hard page 5" descr="/NAS/SJ/POSTECH/nlp/figs/icons/pagehot.png">    </p:cNvPr>
+          <p:cNvPr id="32" name="think hard page 5" descr="/NAS/SJ/POSTECH/nlp/figs/icons/pagehot.png">    </p:cNvPr>
           <p:cNvPicPr>
             <a:picLocks noChangeAspect="1"/>
           </p:cNvPicPr>
@@ -27952,7 +28249,7 @@
       </p:pic>
       <p:pic>
         <p:nvPicPr>
-          <p:cNvPr id="32" name="think hard page 6" descr="/NAS/SJ/POSTECH/nlp/figs/icons/pagehot.png">    </p:cNvPr>
+          <p:cNvPr id="33" name="think hard page 6" descr="/NAS/SJ/POSTECH/nlp/figs/icons/pagehot.png">    </p:cNvPr>
           <p:cNvPicPr>
             <a:picLocks noChangeAspect="1"/>
           </p:cNvPicPr>
@@ -27976,7 +28273,7 @@
       </p:pic>
       <p:pic>
         <p:nvPicPr>
-          <p:cNvPr id="33" name="think hard page 7" descr="/NAS/SJ/POSTECH/nlp/figs/icons/pagehot.png">    </p:cNvPr>
+          <p:cNvPr id="34" name="think hard page 7" descr="/NAS/SJ/POSTECH/nlp/figs/icons/pagehot.png">    </p:cNvPr>
           <p:cNvPicPr>
             <a:picLocks noChangeAspect="1"/>
           </p:cNvPicPr>
@@ -28000,7 +28297,7 @@
       </p:pic>
       <p:pic>
         <p:nvPicPr>
-          <p:cNvPr id="34" name="think hard page 8" descr="/NAS/SJ/POSTECH/nlp/figs/icons/pagehot.png">    </p:cNvPr>
+          <p:cNvPr id="35" name="think hard page 8" descr="/NAS/SJ/POSTECH/nlp/figs/icons/pagehot.png">    </p:cNvPr>
           <p:cNvPicPr>
             <a:picLocks noChangeAspect="1"/>
           </p:cNvPicPr>
@@ -28024,7 +28321,7 @@
       </p:pic>
       <p:pic>
         <p:nvPicPr>
-          <p:cNvPr id="35" name="think hard page 9" descr="/NAS/SJ/POSTECH/nlp/figs/icons/pagehot.png">    </p:cNvPr>
+          <p:cNvPr id="36" name="think hard page 9" descr="/NAS/SJ/POSTECH/nlp/figs/icons/pagehot.png">    </p:cNvPr>
           <p:cNvPicPr>
             <a:picLocks noChangeAspect="1"/>
           </p:cNvPicPr>
@@ -28048,7 +28345,7 @@
       </p:pic>
       <p:pic>
         <p:nvPicPr>
-          <p:cNvPr id="36" name="think hard page 10" descr="/NAS/SJ/POSTECH/nlp/figs/icons/pagehot.png">    </p:cNvPr>
+          <p:cNvPr id="37" name="think hard page 10" descr="/NAS/SJ/POSTECH/nlp/figs/icons/pagehot.png">    </p:cNvPr>
           <p:cNvPicPr>
             <a:picLocks noChangeAspect="1"/>
           </p:cNvPicPr>
@@ -28072,7 +28369,7 @@
       </p:pic>
       <p:pic>
         <p:nvPicPr>
-          <p:cNvPr id="37" name="think hard page 11" descr="/NAS/SJ/POSTECH/nlp/figs/icons/pagehot.png">    </p:cNvPr>
+          <p:cNvPr id="38" name="think hard page 11" descr="/NAS/SJ/POSTECH/nlp/figs/icons/pagehot.png">    </p:cNvPr>
           <p:cNvPicPr>
             <a:picLocks noChangeAspect="1"/>
           </p:cNvPicPr>
@@ -28096,7 +28393,7 @@
       </p:pic>
       <p:pic>
         <p:nvPicPr>
-          <p:cNvPr id="38" name="think hard page 12" descr="/NAS/SJ/POSTECH/nlp/figs/icons/pagehot.png">    </p:cNvPr>
+          <p:cNvPr id="39" name="think hard page 12" descr="/NAS/SJ/POSTECH/nlp/figs/icons/pagehot.png">    </p:cNvPr>
           <p:cNvPicPr>
             <a:picLocks noChangeAspect="1"/>
           </p:cNvPicPr>
@@ -28120,7 +28417,7 @@
       </p:pic>
       <p:pic>
         <p:nvPicPr>
-          <p:cNvPr id="39" name="think hard page 13" descr="/NAS/SJ/POSTECH/nlp/figs/icons/pagehot.png">    </p:cNvPr>
+          <p:cNvPr id="40" name="think hard page 13" descr="/NAS/SJ/POSTECH/nlp/figs/icons/pagehot.png">    </p:cNvPr>
           <p:cNvPicPr>
             <a:picLocks noChangeAspect="1"/>
           </p:cNvPicPr>
@@ -28144,7 +28441,7 @@
       </p:pic>
       <p:pic>
         <p:nvPicPr>
-          <p:cNvPr id="40" name="think hard page 14" descr="/NAS/SJ/POSTECH/nlp/figs/icons/pagehot.png">    </p:cNvPr>
+          <p:cNvPr id="41" name="think hard page 14" descr="/NAS/SJ/POSTECH/nlp/figs/icons/pagehot.png">    </p:cNvPr>
           <p:cNvPicPr>
             <a:picLocks noChangeAspect="1"/>
           </p:cNvPicPr>
@@ -28168,7 +28465,7 @@
       </p:pic>
       <p:pic>
         <p:nvPicPr>
-          <p:cNvPr id="41" name="think hard page 15" descr="/NAS/SJ/POSTECH/nlp/figs/icons/pagehot.png">    </p:cNvPr>
+          <p:cNvPr id="42" name="think hard page 15" descr="/NAS/SJ/POSTECH/nlp/figs/icons/pagehot.png">    </p:cNvPr>
           <p:cNvPicPr>
             <a:picLocks noChangeAspect="1"/>
           </p:cNvPicPr>
@@ -28192,7 +28489,7 @@
       </p:pic>
       <p:pic>
         <p:nvPicPr>
-          <p:cNvPr id="42" name="think hard page 16" descr="/NAS/SJ/POSTECH/nlp/figs/icons/pagehot.png">    </p:cNvPr>
+          <p:cNvPr id="43" name="think hard page 16" descr="/NAS/SJ/POSTECH/nlp/figs/icons/pagehot.png">    </p:cNvPr>
           <p:cNvPicPr>
             <a:picLocks noChangeAspect="1"/>
           </p:cNvPicPr>
@@ -28216,7 +28513,7 @@
       </p:pic>
       <p:pic>
         <p:nvPicPr>
-          <p:cNvPr id="43" name="think hard page 17" descr="/NAS/SJ/POSTECH/nlp/figs/icons/pagehot.png">    </p:cNvPr>
+          <p:cNvPr id="44" name="think hard page 17" descr="/NAS/SJ/POSTECH/nlp/figs/icons/pagehot.png">    </p:cNvPr>
           <p:cNvPicPr>
             <a:picLocks noChangeAspect="1"/>
           </p:cNvPicPr>
@@ -28240,7 +28537,7 @@
       </p:pic>
       <p:pic>
         <p:nvPicPr>
-          <p:cNvPr id="44" name="think hard page 18" descr="/NAS/SJ/POSTECH/nlp/figs/icons/pagehot.png">    </p:cNvPr>
+          <p:cNvPr id="45" name="think hard page 18" descr="/NAS/SJ/POSTECH/nlp/figs/icons/pagehot.png">    </p:cNvPr>
           <p:cNvPicPr>
             <a:picLocks noChangeAspect="1"/>
           </p:cNvPicPr>
@@ -28264,7 +28561,7 @@
       </p:pic>
       <p:pic>
         <p:nvPicPr>
-          <p:cNvPr id="45" name="think hard page 19" descr="/NAS/SJ/POSTECH/nlp/figs/icons/pagehot.png">    </p:cNvPr>
+          <p:cNvPr id="46" name="think hard page 19" descr="/NAS/SJ/POSTECH/nlp/figs/icons/pagehot.png">    </p:cNvPr>
           <p:cNvPicPr>
             <a:picLocks noChangeAspect="1"/>
           </p:cNvPicPr>
@@ -28288,7 +28585,7 @@
       </p:pic>
       <p:pic>
         <p:nvPicPr>
-          <p:cNvPr id="46" name="think hard page 20" descr="/NAS/SJ/POSTECH/nlp/figs/icons/pagehot.png">    </p:cNvPr>
+          <p:cNvPr id="47" name="think hard page 20" descr="/NAS/SJ/POSTECH/nlp/figs/icons/pagehot.png">    </p:cNvPr>
           <p:cNvPicPr>
             <a:picLocks noChangeAspect="1"/>
           </p:cNvPicPr>
@@ -28312,7 +28609,7 @@
       </p:pic>
       <p:pic>
         <p:nvPicPr>
-          <p:cNvPr id="47" name="think hard page 21" descr="/NAS/SJ/POSTECH/nlp/figs/icons/pagehot.png">    </p:cNvPr>
+          <p:cNvPr id="48" name="think hard page 21" descr="/NAS/SJ/POSTECH/nlp/figs/icons/pagehot.png">    </p:cNvPr>
           <p:cNvPicPr>
             <a:picLocks noChangeAspect="1"/>
           </p:cNvPicPr>
@@ -28336,7 +28633,7 @@
       </p:pic>
       <p:pic>
         <p:nvPicPr>
-          <p:cNvPr id="48" name="think hard page 22" descr="/NAS/SJ/POSTECH/nlp/figs/icons/pagehot.png">    </p:cNvPr>
+          <p:cNvPr id="49" name="think hard page 22" descr="/NAS/SJ/POSTECH/nlp/figs/icons/pagehot.png">    </p:cNvPr>
           <p:cNvPicPr>
             <a:picLocks noChangeAspect="1"/>
           </p:cNvPicPr>
@@ -28360,7 +28657,7 @@
       </p:pic>
       <p:pic>
         <p:nvPicPr>
-          <p:cNvPr id="49" name="think hard page 23" descr="/NAS/SJ/POSTECH/nlp/figs/icons/pagehot.png">    </p:cNvPr>
+          <p:cNvPr id="50" name="think hard page 23" descr="/NAS/SJ/POSTECH/nlp/figs/icons/pagehot.png">    </p:cNvPr>
           <p:cNvPicPr>
             <a:picLocks noChangeAspect="1"/>
           </p:cNvPicPr>
@@ -28384,7 +28681,7 @@
       </p:pic>
       <p:pic>
         <p:nvPicPr>
-          <p:cNvPr id="50" name="think hard page 24" descr="/NAS/SJ/POSTECH/nlp/figs/icons/pagehot.png">    </p:cNvPr>
+          <p:cNvPr id="51" name="think hard page 24" descr="/NAS/SJ/POSTECH/nlp/figs/icons/pagehot.png">    </p:cNvPr>
           <p:cNvPicPr>
             <a:picLocks noChangeAspect="1"/>
           </p:cNvPicPr>
@@ -28408,7 +28705,7 @@
       </p:pic>
       <p:pic>
         <p:nvPicPr>
-          <p:cNvPr id="51" name="think hard page 25" descr="/NAS/SJ/POSTECH/nlp/figs/icons/pagehot.png">    </p:cNvPr>
+          <p:cNvPr id="52" name="think hard page 25" descr="/NAS/SJ/POSTECH/nlp/figs/icons/pagehot.png">    </p:cNvPr>
           <p:cNvPicPr>
             <a:picLocks noChangeAspect="1"/>
           </p:cNvPicPr>
@@ -28432,7 +28729,7 @@
       </p:pic>
       <p:pic>
         <p:nvPicPr>
-          <p:cNvPr id="52" name="think hard page 26" descr="/NAS/SJ/POSTECH/nlp/figs/icons/pagehot.png">    </p:cNvPr>
+          <p:cNvPr id="53" name="think hard page 26" descr="/NAS/SJ/POSTECH/nlp/figs/icons/pagehot.png">    </p:cNvPr>
           <p:cNvPicPr>
             <a:picLocks noChangeAspect="1"/>
           </p:cNvPicPr>
@@ -28456,7 +28753,7 @@
       </p:pic>
       <p:pic>
         <p:nvPicPr>
-          <p:cNvPr id="53" name="think hard page 27" descr="/NAS/SJ/POSTECH/nlp/figs/icons/pagehot.png">    </p:cNvPr>
+          <p:cNvPr id="54" name="think hard page 27" descr="/NAS/SJ/POSTECH/nlp/figs/icons/pagehot.png">    </p:cNvPr>
           <p:cNvPicPr>
             <a:picLocks noChangeAspect="1"/>
           </p:cNvPicPr>
@@ -28480,7 +28777,7 @@
       </p:pic>
       <p:pic>
         <p:nvPicPr>
-          <p:cNvPr id="54" name="think hard page 28" descr="/NAS/SJ/POSTECH/nlp/figs/icons/pagehot.png">    </p:cNvPr>
+          <p:cNvPr id="55" name="think hard page 28" descr="/NAS/SJ/POSTECH/nlp/figs/icons/pagehot.png">    </p:cNvPr>
           <p:cNvPicPr>
             <a:picLocks noChangeAspect="1"/>
           </p:cNvPicPr>
@@ -28504,7 +28801,7 @@
       </p:pic>
       <p:pic>
         <p:nvPicPr>
-          <p:cNvPr id="55" name="think hard page 29" descr="/NAS/SJ/POSTECH/nlp/figs/icons/pagehot.png">    </p:cNvPr>
+          <p:cNvPr id="56" name="think hard page 29" descr="/NAS/SJ/POSTECH/nlp/figs/icons/pagehot.png">    </p:cNvPr>
           <p:cNvPicPr>
             <a:picLocks noChangeAspect="1"/>
           </p:cNvPicPr>
@@ -28528,7 +28825,7 @@
       </p:pic>
       <p:pic>
         <p:nvPicPr>
-          <p:cNvPr id="56" name="think hard page 30" descr="/NAS/SJ/POSTECH/nlp/figs/icons/pagehot.png">    </p:cNvPr>
+          <p:cNvPr id="57" name="think hard page 30" descr="/NAS/SJ/POSTECH/nlp/figs/icons/pagehot.png">    </p:cNvPr>
           <p:cNvPicPr>
             <a:picLocks noChangeAspect="1"/>
           </p:cNvPicPr>
@@ -28552,7 +28849,7 @@
       </p:pic>
       <p:pic>
         <p:nvPicPr>
-          <p:cNvPr id="57" name="think hard page 31" descr="/NAS/SJ/POSTECH/nlp/figs/icons/pagehot.png">    </p:cNvPr>
+          <p:cNvPr id="58" name="think hard page 31" descr="/NAS/SJ/POSTECH/nlp/figs/icons/pagehot.png">    </p:cNvPr>
           <p:cNvPicPr>
             <a:picLocks noChangeAspect="1"/>
           </p:cNvPicPr>
@@ -28576,7 +28873,7 @@
       </p:pic>
       <p:pic>
         <p:nvPicPr>
-          <p:cNvPr id="58" name="think hard page 32" descr="/NAS/SJ/POSTECH/nlp/figs/icons/pagehot.png">    </p:cNvPr>
+          <p:cNvPr id="59" name="think hard page 32" descr="/NAS/SJ/POSTECH/nlp/figs/icons/pagehot.png">    </p:cNvPr>
           <p:cNvPicPr>
             <a:picLocks noChangeAspect="1"/>
           </p:cNvPicPr>
@@ -28600,7 +28897,7 @@
       </p:pic>
       <p:pic>
         <p:nvPicPr>
-          <p:cNvPr id="59" name="think hard page 33" descr="/NAS/SJ/POSTECH/nlp/figs/icons/pagehot.png">    </p:cNvPr>
+          <p:cNvPr id="60" name="think hard page 33" descr="/NAS/SJ/POSTECH/nlp/figs/icons/pagehot.png">    </p:cNvPr>
           <p:cNvPicPr>
             <a:picLocks noChangeAspect="1"/>
           </p:cNvPicPr>
@@ -28624,7 +28921,7 @@
       </p:pic>
       <p:pic>
         <p:nvPicPr>
-          <p:cNvPr id="60" name="think hard page 34" descr="/NAS/SJ/POSTECH/nlp/figs/icons/pagehot.png">    </p:cNvPr>
+          <p:cNvPr id="61" name="think hard page 34" descr="/NAS/SJ/POSTECH/nlp/figs/icons/pagehot.png">    </p:cNvPr>
           <p:cNvPicPr>
             <a:picLocks noChangeAspect="1"/>
           </p:cNvPicPr>
@@ -28648,7 +28945,7 @@
       </p:pic>
       <p:pic>
         <p:nvPicPr>
-          <p:cNvPr id="61" name="think hard page 35" descr="/NAS/SJ/POSTECH/nlp/figs/icons/pagehot.png">    </p:cNvPr>
+          <p:cNvPr id="62" name="think hard page 35" descr="/NAS/SJ/POSTECH/nlp/figs/icons/pagehot.png">    </p:cNvPr>
           <p:cNvPicPr>
             <a:picLocks noChangeAspect="1"/>
           </p:cNvPicPr>
@@ -28672,7 +28969,7 @@
       </p:pic>
       <p:pic>
         <p:nvPicPr>
-          <p:cNvPr id="62" name="think hard page 36" descr="/NAS/SJ/POSTECH/nlp/figs/icons/pagehot.png">    </p:cNvPr>
+          <p:cNvPr id="63" name="think hard page 36" descr="/NAS/SJ/POSTECH/nlp/figs/icons/pagehot.png">    </p:cNvPr>
           <p:cNvPicPr>
             <a:picLocks noChangeAspect="1"/>
           </p:cNvPicPr>
@@ -28696,7 +28993,7 @@
       </p:pic>
       <p:pic>
         <p:nvPicPr>
-          <p:cNvPr id="63" name="think hard page 37" descr="/NAS/SJ/POSTECH/nlp/figs/icons/pagehot.png">    </p:cNvPr>
+          <p:cNvPr id="64" name="think hard page 37" descr="/NAS/SJ/POSTECH/nlp/figs/icons/pagehot.png">    </p:cNvPr>
           <p:cNvPicPr>
             <a:picLocks noChangeAspect="1"/>
           </p:cNvPicPr>
@@ -28720,7 +29017,7 @@
       </p:pic>
       <p:pic>
         <p:nvPicPr>
-          <p:cNvPr id="64" name="think hard page 38" descr="/NAS/SJ/POSTECH/nlp/figs/icons/pagehot.png">    </p:cNvPr>
+          <p:cNvPr id="65" name="think hard page 38" descr="/NAS/SJ/POSTECH/nlp/figs/icons/pagehot.png">    </p:cNvPr>
           <p:cNvPicPr>
             <a:picLocks noChangeAspect="1"/>
           </p:cNvPicPr>
@@ -28744,7 +29041,7 @@
       </p:pic>
       <p:pic>
         <p:nvPicPr>
-          <p:cNvPr id="65" name="think hard page 39" descr="/NAS/SJ/POSTECH/nlp/figs/icons/pagehot.png">    </p:cNvPr>
+          <p:cNvPr id="66" name="think hard page 39" descr="/NAS/SJ/POSTECH/nlp/figs/icons/pagehot.png">    </p:cNvPr>
           <p:cNvPicPr>
             <a:picLocks noChangeAspect="1"/>
           </p:cNvPicPr>
@@ -28768,7 +29065,7 @@
       </p:pic>
       <p:pic>
         <p:nvPicPr>
-          <p:cNvPr id="66" name="think hard page 40" descr="/NAS/SJ/POSTECH/nlp/figs/icons/pagehot.png">    </p:cNvPr>
+          <p:cNvPr id="67" name="think hard page 40" descr="/NAS/SJ/POSTECH/nlp/figs/icons/pagehot.png">    </p:cNvPr>
           <p:cNvPicPr>
             <a:picLocks noChangeAspect="1"/>
           </p:cNvPicPr>
@@ -28792,7 +29089,7 @@
       </p:pic>
       <p:pic>
         <p:nvPicPr>
-          <p:cNvPr id="67" name="think hard page 41" descr="/NAS/SJ/POSTECH/nlp/figs/icons/pagehot.png">    </p:cNvPr>
+          <p:cNvPr id="68" name="think hard page 41" descr="/NAS/SJ/POSTECH/nlp/figs/icons/pagehot.png">    </p:cNvPr>
           <p:cNvPicPr>
             <a:picLocks noChangeAspect="1"/>
           </p:cNvPicPr>
@@ -28816,7 +29113,7 @@
       </p:pic>
       <p:pic>
         <p:nvPicPr>
-          <p:cNvPr id="68" name="think hard page 42" descr="/NAS/SJ/POSTECH/nlp/figs/icons/pagehot.png">    </p:cNvPr>
+          <p:cNvPr id="69" name="think hard page 42" descr="/NAS/SJ/POSTECH/nlp/figs/icons/pagehot.png">    </p:cNvPr>
           <p:cNvPicPr>
             <a:picLocks noChangeAspect="1"/>
           </p:cNvPicPr>
@@ -28840,7 +29137,7 @@
       </p:pic>
       <p:sp>
         <p:nvSpPr>
-          <p:cNvPr id="69" name="Text 13"/>
+          <p:cNvPr id="70" name="Text 14"/>
           <p:cNvSpPr txBox="1"/>
           <p:nvPr/>
         </p:nvSpPr>
@@ -28887,7 +29184,7 @@
       </p:sp>
       <p:sp>
         <p:nvSpPr>
-          <p:cNvPr id="70" name="our question"/>
+          <p:cNvPr id="71" name="our question"/>
           <p:cNvSpPr/>
           <p:nvPr/>
         </p:nvSpPr>
@@ -28914,7 +29211,7 @@
       </p:sp>
       <p:sp>
         <p:nvSpPr>
-          <p:cNvPr id="71" name="Text 15"/>
+          <p:cNvPr id="72" name="Text 16"/>
           <p:cNvSpPr txBox="1"/>
           <p:nvPr/>
         </p:nvSpPr>
@@ -28950,14 +29247,14 @@
       </p:sp>
       <p:sp>
         <p:nvSpPr>
-          <p:cNvPr id="72" name="option a missing fact"/>
+          <p:cNvPr id="73" name="choice a missing fact"/>
           <p:cNvSpPr/>
           <p:nvPr/>
         </p:nvSpPr>
         <p:spPr>
           <a:xfrm>
             <a:off x="5715000" y="5413248"/>
-            <a:ext cx="1828800" cy="502920"/>
+            <a:ext cx="1874520" cy="502920"/>
           </a:xfrm>
           <a:prstGeom prst="roundRect">
             <a:avLst>
@@ -28977,7 +29274,7 @@
       </p:sp>
       <p:pic>
         <p:nvPicPr>
-          <p:cNvPr id="73" name="icon fact" descr="/NAS/SJ/POSTECH/nlp/figs/icons/fact.png">    </p:cNvPr>
+          <p:cNvPr id="74" name="choice icon fact" descr="/NAS/SJ/POSTECH/nlp/figs/icons/fact.png">    </p:cNvPr>
           <p:cNvPicPr>
             <a:picLocks noChangeAspect="1"/>
           </p:cNvPicPr>
@@ -28991,7 +29288,7 @@
         </p:blipFill>
         <p:spPr>
           <a:xfrm>
-            <a:off x="5824728" y="5495544"/>
+            <a:off x="5824728" y="5500116"/>
             <a:ext cx="329184" cy="329184"/>
           </a:xfrm>
           <a:prstGeom prst="rect">
@@ -29001,14 +29298,14 @@
       </p:pic>
       <p:sp>
         <p:nvSpPr>
-          <p:cNvPr id="74" name="Text 17"/>
+          <p:cNvPr id="75" name="Text 18"/>
           <p:cNvSpPr txBox="1"/>
           <p:nvPr/>
         </p:nvSpPr>
         <p:spPr>
           <a:xfrm>
             <a:off x="6217920" y="5413248"/>
-            <a:ext cx="1325880" cy="502920"/>
+            <a:ext cx="1371600" cy="502920"/>
           </a:xfrm>
           <a:prstGeom prst="rect">
             <a:avLst/>
@@ -29037,14 +29334,14 @@
       </p:sp>
       <p:sp>
         <p:nvSpPr>
-          <p:cNvPr id="75" name="option a free check"/>
+          <p:cNvPr id="76" name="choice a free check"/>
           <p:cNvSpPr/>
           <p:nvPr/>
         </p:nvSpPr>
         <p:spPr>
           <a:xfrm>
             <a:off x="7680960" y="5413248"/>
-            <a:ext cx="1828800" cy="502920"/>
+            <a:ext cx="1874520" cy="502920"/>
           </a:xfrm>
           <a:prstGeom prst="roundRect">
             <a:avLst>
@@ -29064,7 +29361,7 @@
       </p:sp>
       <p:pic>
         <p:nvPicPr>
-          <p:cNvPr id="76" name="icon check" descr="/NAS/SJ/POSTECH/nlp/figs/icons/check.png">    </p:cNvPr>
+          <p:cNvPr id="77" name="choice icon check" descr="/NAS/SJ/POSTECH/nlp/figs/icons/check.png">    </p:cNvPr>
           <p:cNvPicPr>
             <a:picLocks noChangeAspect="1"/>
           </p:cNvPicPr>
@@ -29078,7 +29375,7 @@
         </p:blipFill>
         <p:spPr>
           <a:xfrm>
-            <a:off x="7790688" y="5495544"/>
+            <a:off x="7790688" y="5500116"/>
             <a:ext cx="329184" cy="329184"/>
           </a:xfrm>
           <a:prstGeom prst="rect">
@@ -29088,14 +29385,14 @@
       </p:pic>
       <p:sp>
         <p:nvSpPr>
-          <p:cNvPr id="77" name="Text 19"/>
+          <p:cNvPr id="78" name="Text 20"/>
           <p:cNvSpPr txBox="1"/>
           <p:nvPr/>
         </p:nvSpPr>
         <p:spPr>
           <a:xfrm>
             <a:off x="8183880" y="5413248"/>
-            <a:ext cx="1325880" cy="502920"/>
+            <a:ext cx="1371600" cy="502920"/>
           </a:xfrm>
           <a:prstGeom prst="rect">
             <a:avLst/>
@@ -29124,14 +29421,14 @@
       </p:sp>
       <p:sp>
         <p:nvSpPr>
-          <p:cNvPr id="78" name="option more thinking"/>
+          <p:cNvPr id="79" name="choice more thinking"/>
           <p:cNvSpPr/>
           <p:nvPr/>
         </p:nvSpPr>
         <p:spPr>
           <a:xfrm>
             <a:off x="9646920" y="5413248"/>
-            <a:ext cx="1828800" cy="502920"/>
+            <a:ext cx="1874520" cy="502920"/>
           </a:xfrm>
           <a:prstGeom prst="roundRect">
             <a:avLst>
@@ -29151,7 +29448,7 @@
       </p:sp>
       <p:pic>
         <p:nvPicPr>
-          <p:cNvPr id="79" name="icon brain" descr="/NAS/SJ/POSTECH/nlp/figs/icons/brain.png">    </p:cNvPr>
+          <p:cNvPr id="80" name="choice icon brain" descr="/NAS/SJ/POSTECH/nlp/figs/icons/brain.png">    </p:cNvPr>
           <p:cNvPicPr>
             <a:picLocks noChangeAspect="1"/>
           </p:cNvPicPr>
@@ -29165,7 +29462,7 @@
         </p:blipFill>
         <p:spPr>
           <a:xfrm>
-            <a:off x="9756648" y="5495544"/>
+            <a:off x="9756648" y="5500116"/>
             <a:ext cx="329184" cy="329184"/>
           </a:xfrm>
           <a:prstGeom prst="rect">
@@ -29175,14 +29472,14 @@
       </p:pic>
       <p:sp>
         <p:nvSpPr>
-          <p:cNvPr id="80" name="Text 21"/>
+          <p:cNvPr id="81" name="Text 22"/>
           <p:cNvSpPr txBox="1"/>
           <p:nvPr/>
         </p:nvSpPr>
         <p:spPr>
           <a:xfrm>
             <a:off x="10149840" y="5413248"/>
-            <a:ext cx="1325880" cy="502920"/>
+            <a:ext cx="1371600" cy="502920"/>
           </a:xfrm>
           <a:prstGeom prst="rect">
             <a:avLst/>
@@ -29319,18 +29616,18 @@
       </p:sp>
       <p:sp>
         <p:nvSpPr>
-          <p:cNvPr id="3" name="answer a missing fact"/>
+          <p:cNvPr id="3" name="choice a missing fact"/>
           <p:cNvSpPr/>
           <p:nvPr/>
         </p:nvSpPr>
         <p:spPr>
           <a:xfrm>
-            <a:off x="9646920" y="502920"/>
-            <a:ext cx="1874520" cy="457200"/>
+            <a:off x="9646920" y="475488"/>
+            <a:ext cx="1874520" cy="502920"/>
           </a:xfrm>
           <a:prstGeom prst="roundRect">
             <a:avLst>
-              <a:gd name="adj" fmla="val 40000"/>
+              <a:gd name="adj" fmla="val 36364"/>
             </a:avLst>
           </a:prstGeom>
           <a:solidFill>
@@ -29346,7 +29643,7 @@
       </p:sp>
       <p:pic>
         <p:nvPicPr>
-          <p:cNvPr id="4" name="answer icon fact" descr="/NAS/SJ/POSTECH/nlp/figs/icons/fact.png">    </p:cNvPr>
+          <p:cNvPr id="4" name="choice icon fact" descr="/NAS/SJ/POSTECH/nlp/figs/icons/fact.png">    </p:cNvPr>
           <p:cNvPicPr>
             <a:picLocks noChangeAspect="1"/>
           </p:cNvPicPr>
@@ -29360,7 +29657,7 @@
         </p:blipFill>
         <p:spPr>
           <a:xfrm>
-            <a:off x="9738360" y="566928"/>
+            <a:off x="9756648" y="562356"/>
             <a:ext cx="329184" cy="329184"/>
           </a:xfrm>
           <a:prstGeom prst="rect">
@@ -29376,8 +29673,8 @@
         </p:nvSpPr>
         <p:spPr>
           <a:xfrm>
-            <a:off x="10104120" y="502920"/>
-            <a:ext cx="1371600" cy="457200"/>
+            <a:off x="10149840" y="475488"/>
+            <a:ext cx="1371600" cy="502920"/>
           </a:xfrm>
           <a:prstGeom prst="rect">
             <a:avLst/>
@@ -30384,18 +30681,18 @@
       </p:sp>
       <p:sp>
         <p:nvSpPr>
-          <p:cNvPr id="3" name="answer a free check"/>
+          <p:cNvPr id="3" name="choice a free check"/>
           <p:cNvSpPr/>
           <p:nvPr/>
         </p:nvSpPr>
         <p:spPr>
           <a:xfrm>
-            <a:off x="9646920" y="502920"/>
-            <a:ext cx="1874520" cy="457200"/>
+            <a:off x="9646920" y="475488"/>
+            <a:ext cx="1874520" cy="502920"/>
           </a:xfrm>
           <a:prstGeom prst="roundRect">
             <a:avLst>
-              <a:gd name="adj" fmla="val 40000"/>
+              <a:gd name="adj" fmla="val 36364"/>
             </a:avLst>
           </a:prstGeom>
           <a:solidFill>
@@ -30411,7 +30708,7 @@
       </p:sp>
       <p:pic>
         <p:nvPicPr>
-          <p:cNvPr id="4" name="answer icon check" descr="/NAS/SJ/POSTECH/nlp/figs/icons/check.png">    </p:cNvPr>
+          <p:cNvPr id="4" name="choice icon check" descr="/NAS/SJ/POSTECH/nlp/figs/icons/check.png">    </p:cNvPr>
           <p:cNvPicPr>
             <a:picLocks noChangeAspect="1"/>
           </p:cNvPicPr>
@@ -30425,7 +30722,7 @@
         </p:blipFill>
         <p:spPr>
           <a:xfrm>
-            <a:off x="9738360" y="566928"/>
+            <a:off x="9756648" y="562356"/>
             <a:ext cx="329184" cy="329184"/>
           </a:xfrm>
           <a:prstGeom prst="rect">
@@ -30441,8 +30738,8 @@
         </p:nvSpPr>
         <p:spPr>
           <a:xfrm>
-            <a:off x="10104120" y="502920"/>
-            <a:ext cx="1371600" cy="457200"/>
+            <a:off x="10149840" y="475488"/>
+            <a:ext cx="1371600" cy="502920"/>
           </a:xfrm>
           <a:prstGeom prst="rect">
             <a:avLst/>
@@ -31625,7 +31922,7 @@
                   <a:schemeClr val="tx1"/>
                 </a:solidFill>
               </a:rPr>
-              <a:t>Same accuracy as always thinking, with 18–27% fewer tokens; no answers needed</a:t>
+              <a:t>Same accuracy as always thinking, 18–27% fewer tokens, and no answer key needed</a:t>
             </a:r>
             <a:endParaRPr lang="en-US" sz="2000" dirty="0"/>
           </a:p>
@@ -31741,18 +32038,18 @@
       </p:sp>
       <p:sp>
         <p:nvSpPr>
-          <p:cNvPr id="3" name="answer a missing fact"/>
+          <p:cNvPr id="3" name="choice a missing fact"/>
           <p:cNvSpPr/>
           <p:nvPr/>
         </p:nvSpPr>
         <p:spPr>
           <a:xfrm>
-            <a:off x="7680960" y="502920"/>
-            <a:ext cx="1874520" cy="457200"/>
+            <a:off x="7680960" y="475488"/>
+            <a:ext cx="1874520" cy="502920"/>
           </a:xfrm>
           <a:prstGeom prst="roundRect">
             <a:avLst>
-              <a:gd name="adj" fmla="val 40000"/>
+              <a:gd name="adj" fmla="val 36364"/>
             </a:avLst>
           </a:prstGeom>
           <a:solidFill>
@@ -31768,7 +32065,7 @@
       </p:sp>
       <p:pic>
         <p:nvPicPr>
-          <p:cNvPr id="4" name="answer icon fact" descr="/NAS/SJ/POSTECH/nlp/figs/icons/fact.png">    </p:cNvPr>
+          <p:cNvPr id="4" name="choice icon fact" descr="/NAS/SJ/POSTECH/nlp/figs/icons/fact.png">    </p:cNvPr>
           <p:cNvPicPr>
             <a:picLocks noChangeAspect="1"/>
           </p:cNvPicPr>
@@ -31782,7 +32079,7 @@
         </p:blipFill>
         <p:spPr>
           <a:xfrm>
-            <a:off x="7772400" y="566928"/>
+            <a:off x="7790688" y="562356"/>
             <a:ext cx="329184" cy="329184"/>
           </a:xfrm>
           <a:prstGeom prst="rect">
@@ -31798,8 +32095,8 @@
         </p:nvSpPr>
         <p:spPr>
           <a:xfrm>
-            <a:off x="8138160" y="502920"/>
-            <a:ext cx="1371600" cy="457200"/>
+            <a:off x="8183880" y="475488"/>
+            <a:ext cx="1371600" cy="502920"/>
           </a:xfrm>
           <a:prstGeom prst="rect">
             <a:avLst/>
@@ -31828,18 +32125,18 @@
       </p:sp>
       <p:sp>
         <p:nvSpPr>
-          <p:cNvPr id="6" name="answer a free check"/>
+          <p:cNvPr id="6" name="choice a free check"/>
           <p:cNvSpPr/>
           <p:nvPr/>
         </p:nvSpPr>
         <p:spPr>
           <a:xfrm>
-            <a:off x="9646920" y="502920"/>
-            <a:ext cx="1874520" cy="457200"/>
+            <a:off x="9646920" y="475488"/>
+            <a:ext cx="1874520" cy="502920"/>
           </a:xfrm>
           <a:prstGeom prst="roundRect">
             <a:avLst>
-              <a:gd name="adj" fmla="val 40000"/>
+              <a:gd name="adj" fmla="val 36364"/>
             </a:avLst>
           </a:prstGeom>
           <a:solidFill>
@@ -31855,7 +32152,7 @@
       </p:sp>
       <p:pic>
         <p:nvPicPr>
-          <p:cNvPr id="7" name="answer icon check" descr="/NAS/SJ/POSTECH/nlp/figs/icons/check.png">    </p:cNvPr>
+          <p:cNvPr id="7" name="choice icon check" descr="/NAS/SJ/POSTECH/nlp/figs/icons/check.png">    </p:cNvPr>
           <p:cNvPicPr>
             <a:picLocks noChangeAspect="1"/>
           </p:cNvPicPr>
@@ -31869,7 +32166,7 @@
         </p:blipFill>
         <p:spPr>
           <a:xfrm>
-            <a:off x="9738360" y="566928"/>
+            <a:off x="9756648" y="562356"/>
             <a:ext cx="329184" cy="329184"/>
           </a:xfrm>
           <a:prstGeom prst="rect">
@@ -31885,8 +32182,8 @@
         </p:nvSpPr>
         <p:spPr>
           <a:xfrm>
-            <a:off x="10104120" y="502920"/>
-            <a:ext cx="1371600" cy="457200"/>
+            <a:off x="10149840" y="475488"/>
+            <a:ext cx="1371600" cy="502920"/>
           </a:xfrm>
           <a:prstGeom prst="rect">
             <a:avLst/>
@@ -32601,7 +32898,7 @@
                   <a:schemeClr val="tx1"/>
                 </a:solidFill>
               </a:rPr>
-              <a:t>only if they differ</a:t>
+              <a:t>think only if the two differ</a:t>
             </a:r>
             <a:endParaRPr lang="en-US" sz="1400" dirty="0"/>
           </a:p>
@@ -32763,7 +33060,7 @@
                   <a:schemeClr val="tx1"/>
                 </a:solidFill>
               </a:rPr>
-              <a:t>same kind, new data</a:t>
+              <a:t>same kind, new data: no new tokens</a:t>
             </a:r>
             <a:endParaRPr lang="en-US" sz="1400" dirty="0"/>
           </a:p>
@@ -32907,7 +33204,7 @@
                   <a:schemeClr val="tx1"/>
                 </a:solidFill>
               </a:rPr>
-              <a:t>think on hardest</a:t>
+              <a:t>think on hardest-looking</a:t>
             </a:r>
             <a:endParaRPr lang="en-US" sz="1500" dirty="0"/>
           </a:p>
@@ -32951,7 +33248,7 @@
       </p:sp>
       <p:sp>
         <p:nvSpPr>
-          <p:cNvPr id="39" name="tokens think on hardest"/>
+          <p:cNvPr id="39" name="tokens think on hardest-looking"/>
           <p:cNvSpPr/>
           <p:nvPr/>
         </p:nvSpPr>
@@ -34007,7 +34304,7 @@
                   <a:srgbClr val="1F3864"/>
                 </a:solidFill>
               </a:rPr>
-              <a:t>give one fact: the model's own checked program; no answers</a:t>
+              <a:t>give one fact: the model's own checked program; no answer key</a:t>
             </a:r>
             <a:endParaRPr lang="en-US" sz="1500" dirty="0"/>
           </a:p>

</xml_diff>